<commit_message>
Deploying to gh-pages from @ treese41528/treese41528.github.io@5600e57e3e7e554cd2fa283cbd9659bc973b058b 🚀
</commit_message>
<xml_diff>
--- a/ComputationalDataScience/AI_First_Year/Purdue_AI_Talk.pptx
+++ b/ComputationalDataScience/AI_First_Year/Purdue_AI_Talk.pptx
@@ -617,30 +617,32 @@
           <a:p>
             <a:r>
               <a:rPr lang="en-US" dirty="0"/>
-              <a:t>Small course topics can matter long after the exam.
+              <a:t>Connect what you learn to something you care about.
 Planned time: 110 seconds. The PowerPoint shows complete diagrams; progressive reveals are in the React deck.
 DELIVERY CUE
-Reveal one row at a time and read it left to right: course topic, the topic beyond the course, then AI. Then make the general point: no direct translation, and you rarely know in advance which topic will matter.
-WHERE EACH PATH COMES FROM
-• Chain rule → automatic differentiation: AD propagates derivatives through a program per the chain rule of differential calculus; backpropagation is a special case of reverse-mode AD applied to a network's error as a function of its weights (Baydin et al., JMLR 2018). Back-propagation, introduced for neural networks by Rumelhart, Hinton and Williams (Nature, 1986), propagates derivatives backward through the network with the chain rule and repeatedly adjusts the weights by gradient descent to reduce the error.
-• Conditional probability → Markov chains: the Markov assumption predicts the next unit from the last few; Markov (1913) used what are now called Markov chains to predict letters in Eugene Onegin, and n-gram language models apply the assumption to words (Jurafsky and Martin, ch. 3). The first GPT paper pre-trains by maximizing Σ log P(u_i | u_{i−k}, …, u_{i−1}), where k is the context window, on contiguous 512-token sequences (Radford et al., 2018). MA 43200 covers discrete-time Markov chains (Purdue mathematics course descriptions).
-• Dot products → cosine similarity: cosine similarity compares embedding vectors; Sentence-BERT made semantic similarity search practical (about 5 seconds instead of 65 hours for the most similar pair among 10,000 sentences) (Reimers and Gurevych, 2019). Retrieval-augmented generation retrieves by inner products (Lewis et al., 2020); GenAI Studio Knowledge Bases retrieve passages by embedding similarity (slide 13).
-• Confidence intervals → conformal prediction: conformal prediction wraps any pre-trained model to produce sets that contain the truth with a user-specified probability, such as 90% (Angelopoulos and Bates). Conformal language modeling samples a model's answers into a set until it covers at least one acceptable response, with a guarantee (Quach et al., ICLR 2024).
-• Courses: MA 16100/16500 (calculus of one variable), STAT 41600 (conditional probability and Bayes' theorem), MA 35100 (vector spaces and matrices), STAT 35500 (sampling distributions and confidence intervals), MA 43200 (discrete-time Markov chains).
+Open with the process: course idea, related idea beyond the course, your interest; AI is the worked example. Reveal one row at a time and name both links: how the course idea helps with the middle idea, and how that idea reaches the interest. Close with the student prompt in the band.
+HOW EACH CONNECTION WORKS
+• The process: a topic from a course → a related idea beyond the course → a connection to an interest. The four rows are worked examples for an interest in AI; the arrows are illustrative conceptual connections, not prerequisites, and course timing varies.
+• Row 1, the chain rule → automatic differentiation → training. Automatic differentiation combines the derivatives of a program's elementary differentiable operations through the chain rule (Baydin et al., JMLR 2018); it does not differentiate every arbitrary program step. Backpropagation is reverse-mode differentiation applied to a network's loss: it computes the gradients, and an optimizer such as gradient descent uses them to update the weights. Reverse mode was described earlier (Linnainmaa 1970; Werbos 1974); Rumelhart, Hinton and Williams (Nature 1986) popularized backpropagation for training neural networks.
+• Row 2, conditional probability → Markov models and n-grams → next-token prediction. A Markov model predicts the next state from the current one; for text, the recent word sequence can be the state, so an n-gram predicts a word from the previous n−1 words (Jurafsky and Martin, ch. 3). Markov (1913) classified 20,000 letters of Pushkin's Eugene Onegin as vowels or consonants and computed the probability of a vowel given the previous one or two letters. A neural language model also learns conditional next-token probabilities, P(next token | context), but estimates them with a neural network over a much longer context, not with n-gram counts. The first GPT (2018) was trained on contiguous 512-token sequences (Radford et al., §§3.1 and 4.1); that is a detail of that model, not a general GPT context limit. To learn more: MA 43200, one possible later elective, covers discrete-time Markov chains.
+• Row 3, vectors and dot products → text embeddings → finding relevant passages. An embedding model represents each text as a vector; cosine similarity is the dot product of the two vectors after scaling each to length 1, so it measures whether they point the same way. Sentence-BERT made this practical for semantic search (about 5 seconds instead of 65 hours to find the most similar pair among 10,000 sentences). Some retrieval systems rank by unnormalized inner products instead: the original retrieval-augmented generation system retrieved passages by maximum inner product search (Lewis et al., 2020, §2.2). GenAI Studio Knowledge Bases retrieve passages by embedding similarity (slide 13).
+• Row 4, confidence intervals and coverage → conformal prediction. A confidence interval aims to cover a fixed parameter; a conformal prediction set aims to cover a future outcome. Split conformal prediction gives coverage of at least the chosen level (e.g., 90%) marginally, averaged over calibration and test points, when they are exchangeable. It needs no parametric distribution, but the calibration assumptions still matter (Angelopoulos and Bates).
+• Row 4, the research example: Quach et al. (Conformal language modeling, ICLR 2024; arXiv v2) calibrate a rule for sampling a language model's answers into a set, with filters for low-quality or redundant samples and a sampling budget. With probability at least 1 − δ over the calibration data, the chance that a new set contains no acceptable answer is at most ε. Acceptability is judged by a specified criterion during calibration and is not observed at deployment, so sampling stops by the calibrated rule, not because the system knows an answer is correct. The set contains at least one acceptable answer with that probability; it does not say which one or certify every answer. If calibration finds no valid configuration, the method abstains. It is a research procedure, not a default property of chatbot conversations.
+• Courses: MA 16100/16500 (calculus of one variable), STAT 41600 (probability, including conditional probability and Bayes' theorem), MA 35100 (vector spaces and matrices), STAT 35500 (sampling distributions and confidence intervals), as placed in the 2025–26 Data Science (Statistics) suggested plan. Students' course choices and timing vary by major, route, and catalog year.
 • Course check against the 2025–26 progression guides: MA 16100/16500 named in all three Data Science plans (the Statistics guides say 'Calculus I Option'); STAT 41600 and MA 35100 in all six Statistics and Data Science plans; STAT 35500 in the Data Science plans, Applied Statistics (35000 or 35500), and Statistics–Math (Statistics Honors lists STAT 35000); MA 43200 required in Statistics–Math, Statistics Honors, and Data Science (Mathematics), and a selective/elective option in Data Science (Statistics) and Data Science (CS); it is not listed in the Applied Statistics guide.
 VISUAL STEPS
-1. Chain rule → automatic differentiation → training a neural network.
-2. Conditional probability → Markov chains → predicting the next word given the previous words.
-3. Dot products → cosine similarity → finding relevant passages.
-4. Confidence intervals → conformal prediction → uncertainty for AI answers.
+1. The chain rule → automatic differentiation → training a neural network: backpropagation computes gradients; an optimizer updates the weights.
+2. Conditional probability → Markov models and n-grams → predicting the next token.
+3. Vectors and dot products → text embeddings → finding relevant passages for an AI system.
+4. Confidence intervals and coverage → conformal prediction → research example: candidate answer sets.
 TRANSCRIPT
-Some topics feel small when you meet them, and it is tempting to file them away after the exam. But they lead somewhere, usually through a topic you study next, before they reach anything like AI.
-The chain rule from first-semester calculus leads to automatic differentiation, which applies the chain rule to every step of a program; backpropagation, the way neural networks are trained, is one case of it. Conditional probability leads to Markov chains, which you can take later in MA 43200. Markov himself used them to predict letters in a poem; n-gram language models are Markov chains over words. The first GPT model was trained on the same conditional probability, predicting each token from the previous ones, with a context of up to 512 tokens. The dot product leads to cosine similarity, which asks whether two vectors point the same way; that is how text embeddings are compared to find relevant passages. And confidence intervals lead to conformal prediction, which wraps any model's predictions in sets with guaranteed coverage; researchers now use it to keep sampling a language model's answers until the set covers an acceptable one.
-None of these is a direct translation from a course to AI. Each path runs through a topic beyond the course. You rarely know in advance which one will matter, so before you put a topic away after an exam, ask what it leads to.
+A topic from class can be the starting point for exploring something you care about. Start with the course idea, find a related topic that extends beyond what the course covers, and follow that connection into your interests. Here, I am using AI as the example. Notice the topic in the middle of each row; that is the next idea you could investigate.
+The chain rule is how automatic differentiation combines derivatives, and backpropagation uses it to compute the gradients a neural network needs; an optimizer then updates the weights. Conditional probability leads to Markov models and n-grams, which predict a word from the few before it; Markov himself counted vowels and consonants in Pushkin's Eugene Onegin. A neural language model learns the same kind of probability: the next token, given its context. Vectors and dot products lead to text embeddings, which turn text into vectors, and cosine similarity compares them to rank relevant passages. And confidence intervals, with the idea of coverage, lead to conformal prediction: calibrated prediction sets with a chosen coverage level, under stated assumptions. Researchers have extended it to sets of candidate answers from a language model.
+Your turn: choose one topic from a course you are taking. Find a related idea beyond the course, and explain how it connects to something you care about.
 TRANSITION
-Which of these paths matters to you depends on where you want to go.
+AI can also help you find connections like these for your own interests.
 CAVEATS
-The paths are the speaker's selection of documented connections; the brief below gives the source passage for each. The middle column is the step students usually take after the course, in a later course or on their own; only Markov chains has a named Purdue course here (MA 43200). Course codes come from the 2025–26 Data Science (Statistics) plan; placement and catalog years vary. The examples show where topics lead, not how AI works in full.
+The rows are worked examples of one process, using an interest in AI. Each arrow is an illustrative conceptual connection, not a prerequisite chain, and course timing varies: course codes come from the 2025–26 Data Science (Statistics) suggested plan, and MA 43200 is one possible later elective for Markov chains. The brief below explains each link and its limits: the history of backpropagation (popularized, not introduced, in 1986); how a neural language model differs from an n-gram model, and why GPT's 512-token training sequences (2018) are not a general limit; cosine similarity versus unnormalized inner products; and what conformal guarantees do and do not promise (marginal coverage under exchangeability; Quach et al.'s (ε, δ) guarantee of at least one acceptable candidate, with no knowledge at deployment of which one). The examples show how to build a connection, not how AI works in full.
 SOURCES
 Purdue Data Science (Statistics) progression guide, 2025–26
 https://www.purdue.edu/science/archive/docs/current-students/majors/dsst-f25-dpg1.pdf
@@ -659,13 +661,13 @@
 JMLR 18. Automatic differentiation propagates derivatives through a program per the chain rule of differential calculus; it is more general than backpropagation, which is a special case of reverse-mode AD applied to a network's error as a function of its weights.
 Rumelhart, Hinton and Williams (1986), Learning representations by back-propagating errors (Nature)
 https://doi.org/10.1038/323533a0
-Nature 323:533–536. The original back-propagation paper: the procedure repeatedly adjusts the weights to minimize the difference between actual and desired outputs; a backward pass propagates derivatives from the top layer to the bottom, applying the chain rule, and the weights follow gradient descent. Saved copy is an author-hosted scan; key passages transcribed in the accompanying quotes file.
+Nature 323:533–536. The paper that popularized back-propagation for training neural networks (reverse-mode differentiation had been described earlier, e.g., Linnainmaa 1970 and Werbos 1974): a backward pass applies the chain rule to propagate derivatives of the error, and the weights are adjusted by gradient descent. Saved copy is an author-hosted scan; key passages transcribed in the accompanying quotes file.
 Jurafsky and Martin, Speech and Language Processing, ch. 3: N-gram language models (draft of August 19, 2026)
 https://web.stanford.edu/~jurafsky/slp3/3.pdf
-Markov assumption: predict the next word from the last few words. Markov (1913) used what are now called Markov chains to predict letters in Eugene Onegin. Large language models are trained to predict upcoming words; transformer-based models are introduced in later chapters.
+Markov assumption: predict the next word from the previous n−1 words. Markov (1913) used what are now called Markov chains to predict whether a letter in Pushkin's Eugene Onegin would be a vowel or a consonant, classifying 20,000 letters. Large language models are trained to predict upcoming words; transformer-based models, introduced in later chapters, estimate the probabilities differently.
 Radford, Narasimhan, Salimans and Sutskever (2018), Improving language understanding by generative pre-training (OpenAI)
 https://cdn.openai.com/research-covers/language-unsupervised/language_understanding_paper.pdf
-The first GPT paper. Unsupervised pre-training maximizes the language-modeling likelihood Σ log P(u_i | u_{i−k}, …, u_{i−1}; Θ), where k is the size of the context window and P is a transformer network; training used contiguous sequences of 512 tokens from BooksCorpus (over 7,000 unpublished books).
+The first GPT paper. Unsupervised pre-training maximizes the language-modeling likelihood Σ log P(u_i | u_{i−k}, …, u_{i−1}; Θ), where k is the size of the context window and P is a transformer network; training used contiguous sequences of 512 tokens from BooksCorpus (over 7,000 unpublished books), a detail of that 2018 model, not a general GPT context limit.
 Reimers and Gurevych (2019), Sentence-BERT
 https://arxiv.org/abs/1908.10084
 EMNLP 2019 (arXiv 1908.10084). Sentence embeddings that can be compared using cosine similarity, making semantic similarity search practical (about 5 seconds instead of 65 hours for 10,000 sentences).
@@ -674,10 +676,10 @@
 Foundational retrieval-augmented generation research; retrieved context does not guarantee that generated claims are supported.
 Angelopoulos and Bates, A gentle introduction to conformal prediction
 https://arxiv.org/abs/2107.07511
-arXiv 2107.07511v6 (December 2022). Conformal prediction can wrap any pre-trained model, such as a neural network, to produce sets guaranteed to contain the ground truth with a user-specified probability, such as 90%, without distributional assumptions.
-Quach et al. (2024), Conformal language modeling
+arXiv 2107.07511v6 (December 2022). Conformal prediction wraps any pre-trained model to produce prediction sets for future outcomes with a user-chosen coverage level, such as 90%. Split conformal coverage is marginal, averaged over the calibration and test points, and requires exchangeability; no parametric distribution is assumed.
+Quach et al. (2024), Conformal language modeling (ICLR 2024; arXiv 2306.10193v2)
 https://arxiv.org/abs/2306.10193
-ICLR 2024 (arXiv 2306.10193). Calibrates a stopping rule for sampling language-model outputs into a growing set until the set covers at least one acceptable response, with a performance guarantee.
+Calibrates a stopping rule (with quality and diversity filters and a sampling budget) for sampling language-model outputs into a set, so that with probability at least 1 − δ over calibration the chance a new set contains no admissible answer is at most ε. Admissibility is observed only during calibration; the set does not identify which answer is admissible; the method abstains if no configuration is valid.
 Evidence and service collection: September 10, 2026; sources added or rechecked through October 13, 2026. Foundations and course review: September 20, 2026. Slides, figures, and transcript revised October 13, 2026 for one flow across the four opening questions; appropriate AI use throughout Purdue remains the theme. Numerical citations were checked against the saved primary sources.</a:t>
             </a:r>
             <a:endParaRPr lang="en-US" dirty="0"/>
@@ -769,35 +771,37 @@
               <a:t>Use AI to connect your courses to your goals.
 Planned time: 100 seconds. The PowerPoint shows complete diagrams; progressive reveals are in the React deck.
 DELIVERY CUE
-Open with the sentence about professors and interests. Then walk the four steps; read the prompt aloud and point out the course context. Spend the most time on step 3 and its evidence.
-WHY WRITE IT YOURSELF: EVIDENCE AND LIMITS
-• Canning and Harackiewicz (2015), Study 1 (Motivation Science; author manuscript PMC4610746): 88 undergraduates learned a left-to-right mental-math method for two-digit multiplication and were randomized to write how it could be useful in their own lives, to see its usefulness explained in the instructional slides, or to a control.
-• Outcome: problems solved correctly with the method on two timed 3-minute problem sets (0–60), adjusting for baseline multiplication skill. Effects are Cohen's d, the difference from the control group in standard deviations, from simple-effect tests in a regression (contrast codes for condition, standardized confidence, their interactions, and baseline skill and gender as covariates) evaluated one SD below and above mean confidence. The reported d values match d = 2t/√df with df = 80. For less-confident students, writing their own reasons raised performance by 0.59 SD (t(80) = 2.62, p = .01); being told was 0.18 SD lower but not significant (t(80) = 0.82, p = .41). Confident students: writing 0.16 SD (p = .47); being told 0.24 SD (p = .30), so neither helped reliably and the authors conclude that confident students did well with both. Note a reporting inconsistency: the text gives β = −.13 (confident, told) and β = .12 (less confident, told), opposite in sign to Table 3's d values (+.24 and −.18); the d magnitudes match the t values and the table's signs match the abstract, so the text's β signs appear swapped. Either way, neither 'told' effect differs reliably from zero. The significant head-to-head result was writing vs. being told: 30.4 vs. 26.5 problems solved on average (p = .04), larger for less-confident students (interaction p = .04).
-• Industry use for the sample prompt: MLB computes and publishes Statcast xBA, the likelihood a batted ball becomes a hit given its exit velocity and launch angle (MLB glossary). Opta's expected goals is the likelihood a chance is scored, from over 20 variables and nearly one million shots; Opta reports early adoption by betting companies and professional clubs and regular use by broadcasters such as Sky Sports, BBC's Match of the Day, beIN Sports, and NBC (The Analyst, 2023). These show conditional probability in use; a Bayes'-theorem example with documented industry use was not found, so none is shown.
-• For students: AI can suggest examples and explanations, but the evidence favors writing the connection yourself; an AI's explanation is a form of being told.
-• No study was found that tested AI-assisted connection-making; the routine applies the evidence on writing about relevance plus the talk's checking habits.
+Bridge from slide 10: now your own interest. Read the prompt and point to its three parts; walk the worked connection left to right and explain the middle idea. Then check, explain, follow one thread. Use the evidence panel briefly: writing your own reasons helped less-confident students; no AI was tested.
+WHY EXPLAIN IT YOURSELF: EVIDENCE AND LIMITS
+• Canning and Harackiewicz (2015, Motivation Science), Study 1: 88 undergraduates learned a left-to-right mental-math method for two-digit multiplication and were randomized to write how it could be useful in their own lives (self-generated utility value), to see its usefulness explained in the instructional slides (directly communicated), or to a control.
+• Outcome: problems solved correctly with the method on timed problem sets right after learning, adjusting for baseline multiplication skill. Perceived confidence was a continuous measure taken after the instruction and practice (and, for the supplied-relevance group, after that information; the authors report the manipulation did not change it). It is not a baseline measure.
+• Chart: Table 3's reported d values versus control, at one SD below mean confidence. Writing one's own reasons +0.59 (t(80) = 2.62, p = .01); being told −0.18 (t(80) = 0.82, p = .41, not significant). At one SD above mean confidence the reported values were +0.16 (p = .47) and +0.24 (p = .30), neither significant; nonsignificant estimates do not show that the conditions were equivalent.
+• Head to head, writing one's own reasons led to better performance than being told (p = .04), more so for less-confident students (interaction p = .04).
+• Study 2 added a combined condition, relevance information in the slides followed by writing one's own examples, which the authors describe as synergistic for less-confident students. So hearing relevance from someone else is not shown to be harmful when the student then writes their own.
+• The worked connection: Opta's expected goals is the probability a shot is scored given its situation, from a model fitted to nearly one million shots with over 20 variables, used by clubs and broadcasters (The Analyst, 2023). 'The share of similar past cases' is the simplest way to estimate such a probability from data. MLB's published xBA, the probability a batted ball becomes a hit given exit velocity and launch angle, is another conditional-probability example.
+• No study was found that tested AI-assisted connection-making; the routine is the speaker's recommendation, applying the evidence on writing about relevance and the talk's checking habits. Verify course descriptions and prerequisites in Purdue's official catalog.
 TRANSCRIPT
-No professor can cover every student's interests in every topic. That part of your education is in your hands, and AI is good at helping you connect the dots.
-Here is a routine. First, name the topic and your interest, with real context: the course, what you covered, what you care about. For example: STAT 41600 just covered conditional probability and Bayes' theorem; I want to work in sports analytics; where does this matter there, and which later Purdue courses build on it? This is used in industry: MLB publishes expected batting average, the probability a batted ball becomes a hit given how hard and at what angle it was hit, and Opta's expected goals, the probability a shot becomes a goal, is used by clubs and broadcasters. Second, check what it tells you in the catalog and in any source it cites.
-Third, write the connection yourself. That step matters. In one experiment, undergraduates learned a mental-math method; the less confident ones who wrote how it could help in their own lives then solved more problems correctly on timed tests, but being told how it helps did not help them. An AI's explanation is being told, so write your own.
-Fourth, follow one thread: a dataset, a reading, an elective, or a question for office hours.
+On the last slide, AI was my example of an interest. Now use AI to explore connections to yours.
+Here is a routine. First, supply real context: the course, what you covered, and your interest. For example: I'm taking STAT 41600 and we covered conditional probability; I'm interested in sports analytics; suggest two connections, each with a course idea, a related topic beyond the course, and a sports application, with sources I can check and one next step. One connection it might suggest: conditional probability leads to estimating outcome probabilities from data, and that leads to expected goals, the chance a shot is scored given its situation, used to compare scoring chances.
+Second, check: open the sources and confirm they support the connection, and check courses in Purdue's catalog. Third, choose one connection and explain both links and why it matters to you. In one experiment, less-confident undergraduates who wrote how a math method could help them solved more problems right afterward than a control group; being told how it helps did not help them. That study did not test AI, but it is why I suggest writing the explanation yourself.
+Fourth, follow one thread: a dataset, a short reading, a small experiment, an elective, or a question for office hours.
 TRANSITION
 So far, how you use AI. Now the tools themselves: what kinds exist, and which of them may see your data.
 CAVEATS
-The routine is the speaker's suggestion. The evidence concerns writing about relevance (utility-value interventions), not AI specifically; no study was found that tested AI-assisted connection-making. In the lab study, performance means problems solved correctly with the new method on two timed tests, and effects are Cohen's d (difference from the control group in standard deviations). The advantage of writing your own reason appeared only for less-confident students; confident students did about equally well either way, so the advice is scoped to topics that are not clicking yet; being told the relevance, as an AI answer would do, helped confident students slightly (d = .24) but not less confident ones (d = −.18), which is why the student writes the connection. Course rules still govern AI use.
+The routine is the speaker's instructional recommendation; no study tested AI-assisted connection-making. It applies slide 10's three-part process to the student's own interest. Evidence: Canning and Harackiewicz (2015), Study 1, 88 undergraduates; performance means problems solved correctly with a new mental-math method right after learning. The chart shows Table 3's reported d values versus control for students one SD below mean perceived confidence, a continuous measure taken after the instruction and practice (not a baseline measure). Writing one's own reasons +0.59 (p = .01); being told −0.18 (p = .41, not significant). For more confident students neither condition differed significantly from control, which does not show they were equivalent. In Study 2, a combined condition (being told, then writing one's own examples) ameliorated the negative effect of being told for less-confident students (the authors call the combination synergistic), so hearing relevance from someone else is not shown to be harmful when the student then writes their own. Details are in the brief below. Course rules still govern AI use.
 SOURCES
 Purdue Statistics undergraduate course descriptions, Fall 2026
 https://www.stat.purdue.edu/academic_programs/undergraduate/index.php?semester=Fall&amp;year=2026
 Reviewed STAT 35000, 35500, 41600, 41700 and 41800 descriptions. A listed course is not necessarily required by every plan or offered to every student.
+Whitmore (Aug. 8, 2023), What is expected goals (xG)? The Analyst (Opta / Stats Perform)
+https://theanalyst.com/articles/what-is-expected-goals-xg
+Opta's explainer: xG measures the quality of a chance by calculating the likelihood that it will be scored, on a 0–1 scale, using over 20 variables (distance, angle, goalkeeper position, pressure, shot type, and more) from nearly one million shots. Text snapshot saved October 13, 2026.
+Canning and Harackiewicz (2015), Teach it, don't preach it: the differential effects of directly communicated and self-generated utility-value information (Motivation Science 1(1):47–71)
+https://s3.wp.wsu.edu/uploads/sites/2445/2019/09/Canning-Harackiewicz-2015-Motivation-Science.pdf
+Published article (copy hosted at Washington State University; the PMC author manuscript is PMC4610746). Study 1: 88 undergraduates learned a mental-math technique and were randomized to self-generated utility value (writing how it could be useful), directly communicated utility value (shown in the slides), or control. Table 3, performance, reported d versus control at one SD below mean perceived confidence (measured after learning): self-generated +.59 (p = .01), directly communicated −.18 (p = .41). Study 2 added a combined condition the authors describe as synergistic for less-confident students. No AI was tested.
 MLB.com, Statcast glossary: Expected Batting Average (xBA)
 https://www.mlb.com/glossary/statcast/expected-batting-average
 Official MLB definition: xBA measures the likelihood that a batted ball will become a hit, based on how often comparable balls (exit velocity, launch angle, and for some batted balls Sprint Speed) have become hits since Statcast was implemented league-wide in 2015. A conditional probability used in industry. Text snapshot saved October 13, 2026.
-Whitmore (Aug. 8, 2023), What is expected goals (xG)? The Analyst (Opta / Stats Perform)
-https://theanalyst.com/articles/what-is-expected-goals-xg
-Opta's explainer: xG measures the quality of a chance by calculating the likelihood that it will be scored, on a 0–1 scale, using over 20 variables (distance, angle, goalkeeper position, pressure, shot type, and more) from nearly one million shots. Text snapshot saved October 13, 2026.
-Canning and Harackiewicz (2015), Teach it, don't preach it (Motivation Science; author manuscript PMC4610746)
-https://pmc.ncbi.nlm.nih.gov/articles/PMC4610746/
-Study 1: 88 undergraduates learned a left-to-right mental-math technique for two-digit multiplication and were randomized to write how it could be useful in their own lives (self-generated), to be shown its usefulness in the instructional slides (directly communicated), or to a control. Performance = problems solved correctly with the technique on two timed 3-minute problem sets (0–60). For less-confident students, writing their own reasons raised performance relative to control (d = .59; t(80) = 2.62, p = .01); being told did not (d = −.18). Confident students: no reliable effect. Short laboratory task.
 Purdue Data Science (Statistics) progression guide, 2025–26
 https://www.purdue.edu/science/archive/docs/current-students/majors/dsst-f25-dpg1.pdf
 Dated public DS Statistics plan. Data Science has separate Statistics, Computer Science, and Mathematics routes; the supporting course crosswalk distinguishes them.
@@ -892,70 +896,87 @@
           <a:p>
             <a:r>
               <a:rPr lang="en-US" dirty="0"/>
-              <a:t>Know the kinds of AI tools and when each is safe to use.
+              <a:t>Know what the tool can do—and what you may share.
 Planned time: 120 seconds. The PowerPoint shows complete diagrams; progressive reveals are in the React deck.
 DELIVERY CUE
-Read the axes: what it can do, then whose terms. Walk down the rows; reveal the safety column. Land on the Gemini API in two rows: free tier and paid tier. The plan you use sets the terms.
+Read the axes: ways to use AI across the top, account and hosting down the side. Walk the rows briefly; point to the Gemini API cell (billing-enabled project) and the SDK cell (instructor's tool, not Purdue's service). In the organization row, separate who can get it from what data it allows. Reveal the permitted column: public-only does not mean public chats; students' Gemini is public only; Claude Code is not yet available. Read the note: check the rules for the account you actually have.
 VISUAL STEPS
-1. Place each kind of tool by whose terms it runs under and what it can do.
-2. Add when each is safe to use.
+1. Place each way to use AI by its account and hosting.
+2. Add which data are permitted for each row.
 TRANSCRIPT
-Most of you use AI through a chat window, but you will meet many kinds of AI tools here and at work. Two questions sort them: what can the tool do, and whose terms does it run under? The second question decides what data is safe to give it.
-Personal accounts are free or personal plans: the ChatGPT, Claude, or Gemini apps, a free API key, or coding agents like Claude Code, Codex, or Gemini CLI on a personal plan. Google asks Gemini users not to enter confidential information, because human reviewers read some chats, and Anthropic lets personal users choose whether their chats train its models. Treat these as public.
-Business terms cover work or school accounts and paid APIs. Microsoft says its work version of Copilot doesn't train on your prompts, and OpenAI says it doesn't train on business or API data by default. Use them for what your organization approves.
-Some organizations run models on their own servers. Purdue's GenAI Studio is one: chat, an API, and the GenAI Studio SDK to build your own agent. Purdue approves it for sensitive data, but not FERPA records.
-On your own computer, Ollama or llama.cpp run a smaller model, and your data stays with you unless a cloud feature sends it out.
-The lesson: the same tool can sit in different rows. On the Gemini API's free tier, Google may use what you send to improve its products; on the paid tier, it doesn't. So check the terms of the account or plan you use, and your course's or employer's rules, before you share data.
+You'll meet AI in many forms. Two questions sort them: what can the tool do, and which service and account does it run under? The second decides what you may share.
+Across the top: chat, access from your code through an API, and an agent that uses tools and performs tasks.
+Down the side: a personal hosted service, such as the ChatGPT, Claude, or Gemini apps, a personal API key, or Claude Code or Codex on a personal plan. Terms vary even there: Google treats unpaid Gemini API use differently from a billing-enabled project. Next, services your institution provides under its own accounts. Then a model your organization hosts, Purdue's GenAI Studio, with a chat, an API, and an SDK I wrote for agents. Last, a model on your own device: llama.cpp or Ollama, a local server for your scripts, and local agent software.
+Now, which data are permitted? With a personal account, Purdue allows public data only; that limits what you share, it doesn't make your chats public. With an institution's service, it depends on the service and the account you actually have. Purdue's authorization list names many products, but its AI toolkit shows what students can use: Copilot Chat, signed in, for public and sensitive data, and Gemini Enterprise for public data only. OpenAI API access is on the list with no student route; Claude Code and Cowork are coming soon, for faculty and staff; ChatGPT stays public-only. GenAI Studio is open to everyone: public and sensitive data permitted, restricted data excluded, and external tools need their own approval. A fully local setup can keep inference on your device; check the endpoint and connected tools.
+And a no-training promise is not a no-retention promise. Check the service and account, where your information goes, and what your institution permits.
 TRANSITION
 When you build with these tools, you also choose where your information lives and how the AI finds it.
 CAVEATS
-General guidance, not a ranking or any one employer's rules; vendor terms change, so check them when you sign up (checked October 13, 2026). Google's Gemini API terms (last updated April 28, 2026) put the same tool in two rows: unpaid quota may be used to improve Google's products and read by human reviewers ('Do not submit sensitive, confidential, or personal information to the Unpaid Services'), while paid quota is not used to improve products and is processed under Google's Data Processing Addendum. OpenAI's privacy pages could not be retrieved; the OpenAI statement comes from its Codex pricing page ('No training on API or business data by default'). Ollama's FAQ says 'We don’t see your prompts or data when you run locally'; its cloud models and web search send prompts to Ollama's servers and can be turned off for local-only use. Purdue is the example organization. Its authorized AI tools list (May 2026) lists ChatGPT, Gemini, and Claude as public-data-only tools; approves GenAI Studio, Microsoft Copilot with Data Protection, NotebookLM, and the JetBrains IDE for sensitive data, which must be accessed through Purdue SSO or an equivalent; and says OpenAI, Microsoft, Google, and Anthropic models require an enterprise or API-level license for sensitive data. GenAI Studio has no ready-made coding agent; the SDK is the build-your-own route, and GenAI Studio's approval does not extend to external tools or MCP servers you connect.
+General guidance, not a ranking or any one employer's rules. Policies and vendor terms were checked on October 21, 2026 and change often; check them when you sign up. Purdue is the example organization, and two Purdue sources answer different questions. Authorization: the list 'Published by Purdue Systems Security - October 15, 2026' authorizes ChatGPT (with DALL-E and SORA), Microsoft Azure OpenAI, Grok, and MidJourney for public data only, and says tools not listed are public-data-only; for sensitive and public data it lists, among others, OpenAI (via API Access), Google Gemini, Anthropic's Claude models, Claude CoWork and Claude Code, Microsoft Copilot with Data Protection, Gemini Notebook, and GenAI Studio. Its conditions: sensitive or restricted data 'MUST be accessed via Purdue SSO or an equivalent', and models from OpenAI, Microsoft, Google and Anthropic 'require an Enterprise or API-level license'; so a personal subscription or an arbitrary API key does not meet them. The list names no account types or eligible users. Access: Purdue's Enterprise AI Toolkit (page last modified October 14, 2026; checked October 21, 2026) says who can get each offering and what data may be entered: Copilot Chat (Basic), everyone, public and sensitive (protected only when signed in with a Purdue account); GenAI Studio, everyone, public and sensitive, restricted not allowed; Gemini Enterprise, students, public only (sensitive not allowed); Gemini Enterprise Pro, faculty and staff, public only; Claude (Cowork and Code), faculty and staff, public and sensitive, 'Coming Soon, this tool is not yet available at Purdue'; Antigravity and frontier model access also 'Coming Soon'. Its linked handout (September 9, 2026) lists Copilot Chat, Gemini Enterprise, and GenAI Studio for classroom use by students, marks ChatGPT and Codex 'No', and lists no OpenAI enterprise agreement. Discrepancy, recorded October 21, 2026: the toolkit is more restrictive for Gemini (public only) than the authorization list (sensitive), marks Claude Code and Cowork as not yet available, and lists no OpenAI API route, while the list authorizes OpenAI API access for sensitive data. So the slide does not treat a product's appearance on the authorization list as evidence that students can use it or may enter sensitive data; availability, eligible users, and data permission are kept separate. Classifications are service-specific: the list puts Microsoft Azure OpenAI (in RCAC's Azure environment) under public data only and OpenAI API access under sensitive data. 'Public data only' is a limit on what you may enter; it does not make conversations publicly accessible. GenAI Studio: public and sensitive data permitted; restricted data, such as FERPA- or HIPAA-regulated data, excluded (RCAC and the toolkit). RCAC states that its authorization does not extend to external services called by Workspace Tools or MCP servers. The instructor's GenAI Studio SDK is a separate open-source Python package on a personal GitHub account, not a Purdue service; it runs on your computer and calls the GenAI Studio API, and its terminal agent (genai-studio agent) can run shell commands, search the web, and use connected MCP tools, which may send data outside GenAI Studio. Gemini API: Google's terms (last updated April 28, 2026) make API use a Paid Service only through a Cloud project with an active billing account; unpaid use may be read by human reviewers and used to improve Google's products. Google AI Studio counts as a Paid Service even at no charge when the account has access to a billing-enabled Cloud project or is a Workspace enterprise account, and in the EEA, Switzerland, and the UK the paid-service data terms apply to all Gemini API and AI Studio use. OpenAI's help article on data use: consumer ChatGPT (Free, Plus, Pro) content may be used for training unless you opt out (feedback can still send a whole conversation), while ChatGPT Business, Enterprise, Edu, and the API are not used by default; the live article returned HTTP 403 on October 21, so its text was checked from an Internet Archive capture of October 19, 2026. No training is not no retention: OpenAI keeps API abuse-monitoring logs for up to 30 days; Anthropic keeps consumer chats 30 days, or up to five years if you allow training; Google keeps human-reviewed Gemini chats up to three years. Anthropic consumer users choose whether chats train its models; Microsoft says Copilot with enterprise data protection does not train foundation models on prompts (now named Microsoft Copilot, like the consumer app, so check the sign-in). Gemini CLI is not shown in the personal row because its consumer route changed: on June 18, 2026, Google stopped serving Gemini Code Assist for individuals and the Google AI Pro and Ultra tiers in Gemini CLI and its IDE extensions, including access through personal Google sign-in, and pointed those users to the Antigravity CLI. Gemini CLI itself continues: Google says it remains available with paid Gemini API keys and its enterprise platform, and organizations' Code Assist Standard and Enterprise licenses follow a separate schedule. Ollama documents tool calling with an agent loop, and local-only mode turns off its cloud models and web search; a fully local setup can keep inference on your device, but a configured endpoint or connected tool can still send data elsewhere. Documentation differences, unresolved: the authorization list describes GenAI Studio as 'excluding FERPA', while RCAC and the toolkit exclude all restricted data (the slide follows RCAC and the toolkit); the list puts 'Google Antigravity (formerly Agentspace)' under sensitive data, while the toolkit lists Antigravity as coming soon for public data only, and Google describes it as Gemini CLI's successor; RCAC's pages did not respond on October 21, so their text was checked in RCAC's official documentation repository (no change since September 29).
 SOURCES
-Google, Gemini Apps Privacy Hub
-https://support.google.com/gemini/answer/13594961
-Consumer Gemini apps: human reviewers (including service providers) review some data; 'Please don't enter confidential information that you wouldn't want a reviewer to see.' Work or school Google Accounts may be subject to different data-handling terms. Text snapshot saved October 13, 2026.
+Purdue, Enterprise AI Toolkit: compare Purdue's AI tools and licenses (page last modified October 14, 2026)
+https://www.purdue.edu/ai/enterprise-ai-toolkit/
+Says who can get each Purdue offering and the highest data classification it accepts. Copilot Chat (Basic): everyone; public and sensitive allowed, restricted not allowed; protected only when signed in with a Purdue account. GenAI Studio: everyone; public and sensitive allowed, restricted not allowed. Gemini Enterprise: students; public allowed, sensitive and restricted not allowed. Gemini Enterprise Pro: faculty and staff; public only. Claude (Cowork and Code): faculty and staff; public and sensitive; 'Coming Soon, this tool is not yet available at Purdue'. Antigravity (public only) and frontier model access: coming soon. GitHub Copilot: everyone; public and sensitive; usage-based through a department account. 'No tool checks a classification before it accepts a prompt.' Checked October 21, 2026; more restrictive for Gemini than the October 15 authorization list.
+Purdue Systems Security, Purdue University authorized AI tools and integrations (October 15, 2026)
+https://www.purdue.edu/ai/wp-content/uploads/2026/10/AITools.pdf
+Official list 'Published by Purdue Systems Security - October 15, 2026' (checked October 21, 2026). Public data only: OpenAI (ChatGPT, DALL-E, SORA), Microsoft Azure OpenAI, x.ai (Grok), MidJourney; 'Other University tools not listed are still authorized for public data only use.' Sensitive and public data, among others: OpenAI (via API Access); Google Gemini; Anthropic (Claude, Haiku, Sonnet, etc.); Anthropic (Claude CoWork, Claude Code); MS Copilot with Data Protection (Purdue Microsoft 365 tenant); Google Gemini Notebook; JetBrains IDE; GenAI Studio ('Configured to accept Sensitive Data, excluding FERPA'). Notes: sensitive or restricted data 'MUST be accessed via Purdue SSO or an equivalent'; models from OpenAI, Microsoft, Google and Anthropic 'require an Enterprise or API-level license to gain the necessary legal protections for Sensitive or Restricted data'; account types are not named. Changes from May 2026: Gemini and Claude moved from public-only to sensitive, and Claude Code/CoWork and OpenAI API access were added. The May list is saved alongside.
+Purdue, AI Tools at Purdue: availability by provider (handout, September 9, 2026)
+https://www.purdue.edu/ai/wp-content/uploads/2026/09/purdue_ai_tools.pdf
+The toolkit's linked handout. Products by provider, who can get them, and status: Copilot Chat (Basic), everyone, available; Gemini Enterprise, students, on request; Claude Cowork and Claude Code, faculty and staff, coming (Claude Code 'arrives with the Claude Enterprise pilot'); ChatGPT and Codex, 'No'; enterprise agreements: Microsoft in place, Google rolling out, Anthropic pilot signed, OpenAI none. Classroom teaching (students): Copilot Chat, Gemini Enterprise, GenAI Studio. Older than the October 15 authorization list.
+Purdue RCAC, GenAI Studio overview and data classification (updated September 29, 2026)
+https://docs.rcac.purdue.edu/services/genai/
+'GenAI Studio is authorized for use with public and sensitive data (L2), as defined in Purdue's Data Classification and Handling Procedures. It is not authorized for restricted data, including data regulated by FERPA or HIPAA.' 'An external service called by a Workspace Tool, or an MCP server, may receive tool arguments or conversation context outside GenAI Studio. GenAI Studio's authorization does not extend to these external integrations.' Purdue-managed; content is not used to train the hosted models; a pilot with limited safety measures. On October 21, 2026 the live page did not respond; RCAC's official documentation repository (PurdueRCAC/RCAC-Docs) showed no change since its September 29 'GenAI data classification update', and its source is saved alongside (2026_rcac_genai_overview_source.md).
+Purdue GenAI Studio: sign in (genai.rcac.purdue.edu)
+https://genai.rcac.purdue.edu/
+The official sign-in page for Purdue GenAI Studio (Purdue SSO through CILogon), linked from RCAC's GenAI Studio documentation and listed in Purdue's AI tools handout; the saved copy is RCAC's overview page, which links to it. The page did not respond from the build machine on October 21, 2026; sign in from a browser on Purdue's network or with your Purdue account.
+GenAI Studio SDK, the instructor's Python package (GitHub)
+https://github.com/treese41528/genai-studio-sdk
+Open-source (MIT) Python SDK for Purdue's GenAI Studio gateway, written by the speaker and published on a personal GitHub account; not a Purdue or RCAC service. It runs on your computer and calls the GenAI Studio API: chat, embeddings, retrieval, and a tool-using agent framework. Its terminal agent, 'genai-studio agent', can read and edit code, run shell commands, search the web and arXiv, and use connected MCP tools, with approvals for risky actions and read-only, workspace-write, or full-access sandbox modes. Data sent to such tools leaves GenAI Studio, and RCAC states that GenAI Studio's authorization does not extend to external integrations. README rechecked October 21, 2026 (unchanged since July 3).
+Purdue RCAC, GenAI Studio API guide (updated September 29, 2026)
+https://docs.rcac.purdue.edu/services/genai/api/
+OpenAI-compatible chat-completions requests with GenAI Studio's own base URL, model IDs and limits. Keep the key in an environment variable; 20 requests per minute per user; structured output differs by serving backend; custom models carry attached Knowledge Bases through the API. Model list checked through the API on October 12, 2026 (dozens of open-weight models, including gpt-oss, Qwen, Gemma, Llama and DeepSeek families).
+Purdue RCAC, GenAI Studio chat interface (updated September 29, 2026)
+https://docs.rcac.purdue.edu/services/genai/chat-interface/
+One prompt can go to several models side by side; temperature and a system prompt can be set for a chat; one-time attachments differ from reusable Knowledge Bases.
+OpenAI Help Center, How your data is used to improve model performance
+https://help.openai.com/en/articles/5722486-how-your-data-is-used-to-improve-model-performance
+Services for individuals (Free, Plus, Pro): 'we may use your content to train our models'; opt out under Settings &gt; Data controls or in the Privacy Portal; feedback can still send the whole conversation for training; temporary chats are not used while they remain temporary. Business services: 'By default, we don’t use inputs or outputs from ChatGPT Business, ChatGPT Enterprise, ChatGPT Edu, or our API to improve our models.' The article does not state retention periods; OpenAI's API data-controls page keeps abuse-monitoring logs for up to 30 days. The live page returned HTTP 403 on October 21, 2026; the saved text is from an Internet Archive capture of October 19, 2026.
 Anthropic (Aug. 28, 2025), Updates to consumer terms and privacy policy
 https://www.anthropic.com/news/updates-to-our-consumer-terms
-Claude Free, Pro, and Max users (including Claude Code with those accounts) choose whether their data is used to improve Claude; retention extends to five years if they allow it. Does not apply to services under Commercial Terms: Claude for Work, Government, Education, or API use.
+Claude Free, Pro, and Max users (including Claude Code with those accounts) choose whether their data is used to improve Claude; retention extends to five years if they allow it, and stays at 30 days if they do not. Does not apply to services under Commercial Terms: Claude for Work, Government, Education, or API use. Anthropic's privacy center adds that chats flagged for safety review may be used for safety work. Rechecked October 21, 2026.
+Google, Gemini Apps Privacy Hub (last updated October 19, 2026)
+https://support.google.com/gemini/answer/13594961
+Consumer Gemini apps: 'Human reviewers (including trained reviewers from our service providers) review some of the data we collect... Please don't enter confidential information that you wouldn't want a reviewer to see or Google to use to improve our services.' Reviewed chats are kept for up to three years even if you delete your activity. Work or school Google Accounts may be subject to different data-handling terms. Rechecked October 21, 2026.
 Google, Gemini API Additional Terms of Service (last updated Apr. 28, 2026)
 https://ai.google.dev/gemini-api/terms
-Unpaid Services (Google AI Studio and the unpaid quota of the Gemini API): Google uses submitted content and responses to improve its products and machine-learning technologies; human reviewers may read API input and output; 'Do not submit sensitive, confidential, or personal information to the Unpaid Services.' Paid Services (e.g., the paid quota): prompts and responses are not used to improve Google's products and are processed under Google's Data Processing Addendum. Text snapshot saved October 13, 2026.
+Unpaid Services (e.g., unpaid quota in the Gemini API, direct interactions with Google AI Studio): content may be used to provide, improve, and develop Google products; human reviewers may read API input and output; 'Do not submit sensitive, confidential, or personal information to the Unpaid Services.' Paid Services: 'Your access to Gemini API is a "Paid Service" only when accessing the API through a Cloud Project associated with an active billing account'; prompts and responses are not used to improve Google's products and are logged for a limited time to detect policy violations. Google AI Studio counts as a Paid Service even when offered free of charge if the account has access to a Cloud Project with an active billing account or is a Workspace enterprise account. In the EEA, Switzerland, and the UK, the paid-service data terms apply to all Services. Rechecked October 21, 2026 (no substantive change since October 13).
 Microsoft Learn, Enterprise data protection in Microsoft Copilot and Copilot Chat (updated Aug. 18, 2026)
 https://learn.microsoft.com/en-us/microsoft-365/copilot/enterprise-data-protection
-Organizational use is covered by Microsoft's Data Protection Addendum and Product Terms with Microsoft as data processor; prompts, responses, and data accessed through Microsoft Graph aren't used to train foundation models; the organization's access controls, sensitivity labels, retention, and audit apply.
-OpenAI, Codex pricing (October 2026)
-https://learn.chatgpt.com/docs/pricing
-Free tier in the desktop app (subject to rollout), paid plans, or API-key usage. Plans change often; dated context only.
+Organizational use is covered by Microsoft's Data Protection Addendum and Product Terms; 'the prompts, responses, and data accessed through Microsoft Graph aren't used to train foundation models.' Applies to eligible work and school accounts, shown by a green shield in Copilot Chat. Microsoft 365 Copilot is now named Microsoft Copilot, the same name as the consumer app, so check the sign-in. Rechecked October 21, 2026.
 Anthropic, Claude Code overview
 https://code.claude.com/docs/en/overview
 Vendor documentation retrieved October 12, 2026: an agentic coding assistant that reads a codebase, edits files and runs commands from the terminal, IDE, desktop or web. Most surfaces require a Claude subscription or Anthropic Console account.
 OpenAI, Codex CLI
 https://learn.chatgpt.com/docs/codex/cli
 Vendor documentation retrieved October 12, 2026 (developers.openai.com now redirects to learn.chatgpt.com): a terminal agent that inspects, edits and runs code in a local repository; recommends Git checkpoints before and after a task.
-Google, Gemini CLI (GitHub repository README)
-https://github.com/google-gemini/gemini-cli
-Google's open-source (Apache 2.0) terminal agent: 'an open-source AI agent that brings the power of Gemini directly into your terminal.' Install with npm (@google/gemini-cli) or Homebrew; the README lists a free tier of 60 requests per minute and 1,000 per day with a personal Google account, a Gemini API key option, and Vertex AI for organizations. README snapshot saved October 13, 2026. Google also offers the Antigravity platform (app, CLI, SDK); press reports that consumer Gemini CLI users must move to the Antigravity CLI were not confirmed on Google's own pages.
-Purdue RCAC, GenAI Studio overview and data classification (updated September 29, 2026)
-https://docs.rcac.purdue.edu/services/genai/
-Authorized for public and sensitive (L2) data under Purdue's data classification; not for restricted data, including FERPA- or HIPAA-regulated data. Purdue-managed; content is not used to train the hosted models; a pilot with limited safety measures. External tools and MCP servers fall outside this authorization. Replaces the September 10 wording, which prohibited sensitive inputs.
-Purdue RCAC, GenAI Studio API guide (updated September 29, 2026)
-https://docs.rcac.purdue.edu/services/genai/api/
-OpenAI-compatible chat-completions requests with GenAI Studio's own base URL, model IDs and limits. Keep the key in an environment variable; 20 requests per minute per user; structured output differs by serving backend; custom models carry attached Knowledge Bases through the API. Model list checked through the API on October 12, 2026 (dozens of open-weight models, including gpt-oss, Qwen, Gemma, Llama and DeepSeek families).
-GenAI Studio SDK (GitHub)
-https://github.com/treese41528/genai-studio-sdk
-Public Python SDK for GenAI Studio: chat, embeddings, retrieval and a teachable tool-using agent framework.
-Purdue Systems Security, Purdue University authorized AI tools and integrations (May 2026)
-https://www.purdue.edu/ai/wp-content/uploads/2026/05/AIToolsMay2026.pdf
-Official list (file dated May 5, 2026; the title line still shows a publish-date placeholder). Public data only: OpenAI (ChatGPT), Google Gemini, Microsoft Azure OpenAI, Anthropic (Claude), x.ai (Grok), MidJourney; other unlisted tools are public-data-only. Sensitive and public data: GenAI Studio (sensitive data, excluding FERPA), Microsoft Copilot with Data Protection (Purdue Microsoft 365 tenant; outputs need a sensitivity label), JetBrains IDE AI, Google NotebookLM. Sensitive or restricted data must be accessed via Purdue SSO; models from OpenAI, Microsoft, Google and Anthropic need an enterprise or API-level license for legal protections; Grok and MidJourney are not vetted.
+OpenAI, Codex pricing (October 2026)
+https://learn.chatgpt.com/docs/pricing
+Free tier in the desktop app (subject to rollout), paid plans, or API-key usage. Plans change often; dated context only.
 ggml-org, llama.cpp
 https://github.com/ggml-org/llama.cpp
 MIT-licensed local inference for open-weight models on CPUs and GPUs, with quantization and an OpenAI-compatible server. What runs well depends on the hardware and the model.
 Ollama documentation, FAQ
 https://docs.ollama.com/faq
-Serving software with local and cloud options. 'Ollama runs locally. We don’t see your prompts or data when you run locally.' Cloud-hosted models and web search send prompts to Ollama's servers (not stored, logged, or used for training, per the FAQ); cloud features can be disabled for local-only mode. Checked September 10 and October 13, 2026 (same statements; the October text snapshot is saved alongside).
-Purdue RCAC, GenAI Studio chat interface (updated September 29, 2026)
-https://docs.rcac.purdue.edu/services/genai/chat-interface/
-One prompt can go to several models side by side; temperature and a system prompt can be set for a chat; one-time attachments differ from reusable Knowledge Bases.
+Serving software with local and cloud options. 'Ollama runs locally. We don’t see your prompts or data when you run locally.' Cloud-hosted models and web search send prompts to Ollama's servers ('we process your prompts and responses to provide the service but do not store or log that content and never train on it'); local-only mode ('disable_ollama_cloud' in server.json or OLLAMA_NO_CLOUD=1) turns off cloud models and web search. Checked September 10, October 13, and October 21, 2026 (same statements).
+Ollama documentation, Tool calling
+https://docs.ollama.com/capabilities/tool-calling
+'Ollama supports tool calling (also known as function calling) which allows a model to invoke tools and incorporate their results into its replies'; a multi-turn agent loop lets the model decide when to call tools. In the examples the model is served at localhost and the user's own script runs the tools. Checked October 21, 2026.
+Google, Gemini Code Assist consumer accounts: deprecation (last updated October 9, 2026)
+https://developers.google.com/gemini-code-assist/docs/deprecations/code-assist-individuals
+'Starting June 18, 2026, Gemini Code Assist IDE extensions stopped serving requests for the Gemini Code Assist for individuals, Google AI Pro, and Google AI Ultra tiers. This also applies to usage of Gemini CLI. As part of the deprecation, you can no longer use the Login with Google option to access the IDE extensions or Gemini CLI.' Consumer users are directed to the Antigravity family of products. Checked October 21, 2026.
+Google, Gemini CLI (GitHub repository README)
+https://github.com/google-gemini/gemini-cli
+Google's open-source (Apache 2.0) terminal agent. Consumer access changed on June 18, 2026: Gemini CLI no longer serves Gemini Code Assist for individuals, Google AI Pro, or Google AI Ultra, including access through personal Google sign-in ('Login with Google'), and those users are directed to the Antigravity CLI (Google's deprecation notice, updated October 9, 2026; README banner added October 16, 2026). Google says Gemini CLI remains available through paid Gemini API keys and its enterprise agent platform; the repository's authentication docs still describe personal sign-in. Removed from slide 12 on October 21, 2026; the October 13 README snapshot is saved.
 Evidence and service collection: September 10, 2026; sources added or rechecked through October 13, 2026. Foundations and course review: September 20, 2026. Slides, figures, and transcript revised October 13, 2026 for one flow across the four opening questions; appropriate AI use throughout Purdue remains the theme. Numerical citations were checked against the saved primary sources.</a:t>
             </a:r>
             <a:endParaRPr lang="en-US" dirty="0"/>
@@ -1044,43 +1065,58 @@
           <a:p>
             <a:r>
               <a:rPr lang="en-US" dirty="0"/>
-              <a:t>Knowledge bases match meaning; databases match exactly.
+              <a:t>Match the question to the source and the tool.
 Planned time: 140 seconds. The PowerPoint shows complete diagrams; progressive reveals are in the React deck.
 DELIVERY CUE
-Left: read the bars; the top passage uses different words than the question and still ranks first, and only the top three reach the AI. Right: read the funnel top to bottom; every row is tested, and lowercase 'compliant' matches nothing. Then the wrong tool: the highest score on the slide is a definition, not a count. Land on who decides: you.
+Left: one question, real scores. The top passage uses different words and still ranks first; the dashed line marks the top 3 selected as candidate context; a score is not a probability of answering. Right: read the question, then the query down, one condition per stage, 4,194 to 122: TV-news task, passed the AI screen, no extraction warning flagged, reported support; each condition is a decision. Then the red box: the closest passage to a counting question is a definition, not a total. Land on the takeaway: the codebook for meaning, the records for quantities.
 VISUAL STEPS
-1. Knowledge base: rank passages by similarity; the top 3 go to the AI.
-2. Database: every row tested against exact conditions, 4,194 rows to 122.
-3. Wrong tool: the closest passage to a counting question is a definition, not a count.
+1. Semantic retrieval: rank codebook passages by cosine similarity; the top 3 are selected as candidate context.
+2. SQL: filter the released results by stated conditions and count the matching records, 4,194 to 122.
+3. Wrong source and operation: the closest passage to a counting question is a definition, not a total.
 TRANSCRIPT
-A knowledge base and a database both store information, but they find things in different ways.
-A knowledge base is a collection of documents split into passages. Each passage, and your question, becomes an embedding, a list of numbers, and retrieval ranks the passages by cosine similarity, the dot-product idea from earlier. These are real scores for the soccer study's codebook. I asked how skin tone was measured. The top passage never says "measure"; it says players were "coded by two independent raters," and it still ranks first. The top three go to the AI; the rest are never seen.
-A database stores records in tables, and a query tests every row against exact conditions. In the study's released table of 4,194 runs, 1,270 are the TV-news task, 700 have acceptable verdicts, 688 have no extraction warning, and 122 said the hypothesis was supported, the counts behind slide four. Type "compliant" in lowercase, and no rows match. Exact means exact.
-So use each for what it does. Ask the knowledge base how many red cards were given, and its best match, with the highest score on this slide, is the definition of the red-card variable, not a count. Counting needs a query over every row.
-Neither tool decides what your question needs. You choose the tool, you read what retrieval returns, and you decide what each condition should mean, such as what counts as acceptable. On a data team, documentation usually goes into a knowledge base and measurements into a database.
+Different questions need different sources and different operations. Here are two operations on two real sources.
+On the left, semantic retrieval over the soccer study's codebook, the document that explains its variables. Each passage, and my question, becomes an embedding, a list of numbers, and the passages are ranked by cosine similarity, the dot-product idea from earlier. I ran this on my own computer with a small open model; it is a demonstration, not GenAI Studio. I asked how skin tone was measured. The top passage never says "measure"; it says players were "coded by two independent raters," and it still ranks first. The top three are selected as candidate context for a model to read. A similarity score is not the probability that a passage answers your question, so you still read what comes back.
+On the right, a SQL query over the AI study's released results answers one precise question: how many runs on the TV-news task passed the AI screen, had no extraction warning flagged, and reported support? Start with 4,194 records. Keep the TV-news task: 1,270. Keep the runs that passed the AI screen, with auditor verdicts Compliant or Minor issues: 700. Drop the twelve runs flagged with an extraction warning: 688. Count those that reported support: 122. The query counts records satisfying the stated conditions, and every condition is a decision you make and can state.
+Now ask retrieval the wrong kind of question: how many red cards were given in total? The top match, with the highest score on this slide, is the definition of the red-card variable. A relevant definition is not a total, and this codebook doesn't contain the records needed to calculate one. That takes the data, plus decisions about which players and seasons count and whether a second yellow card counts as a red.
+So use the codebook to understand the variables, and use the records to calculate the quantity. Real systems often combine both operations. You choose which one your question needs, and you check what comes back.
 TRANSITION
-Agents can choose among these tools and act on your files, so decide what they are allowed to do.
+Agents can choose among operations like these and act on your files, so decide what they are allowed to do.
 CAVEATS
-Similarity scores were computed on October 13 with the open Sentence-Transformers model all-MiniLM-L6-v2 (revision 1110a24; mean pooling, unit-length vectors) by presentation/depth/data/codebook_retrieval.py; results are in soccer_codebook_retrieval.json. Scores shown: skin-tone paragraph 0.67, rater2 0.52, rater1 0.51, meanExp 0.40, and the bias-measures paragraph 0.35; the other 26 passages scored lower. Passages are the codebook's four paragraphs and 27 variable descriptions, one passage each; 'top 3' is a setting chosen for this example. GenAI Studio prepares Knowledge Base documents with EmbeddingGemma 300M, which is not a callable API model, so its chunking and scores would differ; no GenAI Studio Knowledge Base was created or queried. Lowest score: refNum (0.07). The red-card question's top three were redCards (0.80), yellowReds (0.67), and yellowCards (0.62); none contains a total. SQL counts come from the released results file (4,194 rows; SHA-256 verified): dataset = 'sample_anes-inconsistent-views' (1,270); verdict IN ('Compliant', 'Minor issues') (700); warning &lt;&gt; 'True' (688; keeps the one run with an empty warning field); supported = 'True' (122), matching slide 4, which extract_bertran_anes.py asserts. Retrieval quality and answer faithfulness need separate checks. The GenAI Studio tools-and-database guide gives the same rule: exact lookups belong in parameterized SQL, and semantic retrieval finds reference passages when wording varies.
+Two operations on two different sources; real systems often combine them, so they are not exclusive kinds of tool. Left, the soccer study's codebook: a local embedding demonstration, separate from GenAI Studio. The codebook (the copy pinned in the Bertran, Fogliato and Wu repository at commit d489f03, SHA-256 926e289e…, identical to the saved copy) was split into its four paragraphs and 27 variable descriptions, one passage each, and embedded with the open Sentence-Transformers model all-MiniLM-L6-v2 (revision 1110a24; mean pooling, unit-length vectors) by codebook_retrieval.py; the scores are in soccer_codebook_retrieval.json (both linked below). Rerun October 21, 2026 with the saved and the pinned codebook: identical scores. Shown: skin-tone paragraph 0.67, rater2 0.52, rater1 0.51, meanExp 0.40, bias-measures paragraph 0.35; the other 26 scored lower (lowest, refNum 0.07). Cosine similarity measures how close two embeddings are; it is not the probability that a passage answers the question. 'Top 3' is a setting chosen for this example: those passages are selected as candidate context, and what a system does with the others depends on its design. GenAI Studio's Knowledge Bases use EmbeddingGemma 300M and their own chunking, so their scores would differ; no GenAI Studio Knowledge Base was created or queried. Retrieval quality and answer faithfulness need separate checks. Right, a different source: the AI study's released run-level results for the TV-news task (results.csv at commit d489f03; 4,194 rows; SHA-256 verified), queried with its real column names in tvnews_sql_funnel.sql (linked below). Import: every column TEXT as released, so the flags are the strings 'True' and 'False' (SQLite's TRUE is the integer 1 and matches none of them). Conditions: dataset = 'sample_anes-inconsistent-views' (1,270); sonnet_verdict IN ('Compliant', 'Minor issues') (700); COALESCE(warning, 'False') &lt;&gt; 'True' (688); hypothesis_supported = 'True' (122). 'Passed the AI screen' in the question means these two auditor categories, the same definition as slide 4; passing the auditor is not a demonstration of correctness. Warning values among the 700: 687 False, 12 True, 1 blank. Stated policy for 'no extraction warning flagged': keep runs whose warning is not 'True', so the blank is kept. COALESCE treats a missing warning as not flagged: if blanks are imported as NULL, a bare warning &lt;&gt; 'True' would silently drop the blank (687); the script gives the same counts in the sqlite3 shell (blanks as '') and in Python's sqlite3 (blanks as NULL; bertran2026_sql_count.json). Text comparison is case-sensitive in this implementation (SQLite's default BINARY collation): 'compliant' in lowercase matches 0 rows; other databases and collations can differ. Red cards: the codebook defines redCards as the 'number of red cards player received from referee' but contains no records. The soccer data are 146,028 player–referee pairs with counts accumulated over each player's encounters with that referee, so a total needs summing over pairs, a defined population (which players, leagues, and seasons), and a decision on second-yellow dismissals, recorded separately as yellowReds. The red-card question's top three were redCards (0.80), yellowReds (0.67), and yellowCards (0.62); none contains a total. The GenAI Studio tools-and-database guide gives the same rule: exact lookups belong in parameterized SQL; semantic retrieval finds reference passages when wording varies. The reproducibility files are published with the website's data folder; their links resolve once the website is published.
 SOURCES
+sentence-transformers, all-MiniLM-L6-v2 model card (Hugging Face)
+https://huggingface.co/sentence-transformers/all-MiniLM-L6-v2
+Open Sentence-Transformers model (Apache 2.0) that maps sentences and paragraphs to a 384-dimensional vector space for semantic search; fine-tuned with a contrastive objective on over 1 billion sentence pairs; input longer than 256 word pieces is truncated. Used on slide 13 to compute cosine similarities between the soccer codebook's 31 passages and two questions (revision 1110a24; codebook_retrieval.py, linked on slide 13; rerun with identical scores October 21, 2026). Model card saved October 13, 2026.
+Soccer-study codebook (Silberzahn et al.), pinned copy in the Bertran, Fogliato and Wu repository (commit d489f03)
+https://raw.githubusercontent.com/amazon-science/agentic-forking-path/d489f03b143fcaa9befb8cc443594ff63ec61eaa/data/soccer/codebook.txt
+Documentation for the crowdsourced soccer data: four paragraphs (data sources, skin-tone ratings by two raters, bias measures) and 27 variable descriptions. It defines variables such as redCards ('number of red cards player received from referee') but contains no records. Stored in the repository as codebook.txt, an RTF document; SHA-256 926e289e…, identical to the saved copy (checked October 21, 2026).
+Retrieval scores for slide 13: soccer_codebook_retrieval.json (this talk)
+https://treese41528.github.io/ComputationalDataScience/AI_First_Year/data/soccer_codebook_retrieval.json
+Output of codebook_retrieval.py: each passage's cosine similarity and rank for 'How did they measure players' skin tone?', with the top 3 marked as selected candidate context, and the top 3 for 'How many red cards were given in total?' (redCards 0.80, yellowReds 0.67, yellowCards 0.62). Records the model revision, weights hash, codebook URL and hash, and library versions.
+Retrieval script for slide 13: codebook_retrieval.py (this talk)
+https://treese41528.github.io/ComputationalDataScience/AI_First_Year/data/codebook_retrieval.py
+Splits the soccer-study codebook into 31 passages (four paragraphs, 27 variable descriptions), embeds them and two questions with all-MiniLM-L6-v2 (revision 1110a24; weights checked by SHA-256), ranks passages by cosine similarity, and selects the top 3 as candidate context. A local demonstration, separate from GenAI Studio. Rerun October 21, 2026 with the saved and the pinned codebook: identical scores.
+Bertran, Fogliato and Wu: released run-level results (GitHub, commit d489f03)
+https://github.com/amazon-science/agentic-forking-path/tree/d489f03b143fcaa9befb8cc443594ff63ec61eaa/experiment_data
+Authors' release of run-level results at commit d489f03 (results.csv: 4,194 rows, one per run with a final analysis; the README says runs without one are excluded and describes 4,196 runs; the paper reports 4,946 runs in total). SHA-256 verified; README, LICENSE, and NOTICE saved alongside. The TV-news slide shows support rates for the 1,270 anes-views runs before screening and the 700 that passed the AI screen (its earlier plot of 688 extracted estimates was removed on October 21; see its notes); slide 13 counts 688 of those 700 with SQL; the soccer slide counts 611 soccer runs. Each run's code, report, and transcript are in experiment_data/workspaces.
+SQL script for slide 13: tvnews_sql_funnel.sql (this talk)
+https://treese41528.github.io/ComputationalDataScience/AI_First_Year/data/tvnews_sql_funnel.sql
+Runs in the sqlite3 shell on the released results.csv (commit d489f03; download URL and SHA-256 in the header). Documents the import schema (every column TEXT; flags are the strings 'True' and 'False'), the inclusion policy for the warning flag (a missing warning counts as not flagged; COALESCE(warning, 'False') keeps the one blank whether stored as '' or NULL), and case-sensitive comparison. Prints the slide's count (122), each stage (4,194; 1,270; 700; 688; 122), and the warning values among the 700 (687 False, 12 True, 1 blank).
+SQL counts for slide 13: bertran2026_sql_count.json (this talk)
+https://treese41528.github.io/ComputationalDataScience/AI_First_Year/data/bertran2026_sql_count.json
+Written by extract_bertran_anes.py, which loads the four columns into Python's sqlite3 (empty fields as NULL), applies the same conditions, checks the result against the sqlite3-shell script, and records the stage counts, the warning values, and the lowercase check (0 rows).
+Silberzahn et al., crowdsourced soccer data and codebook (OSF)
+https://osf.io/fv8c3/
+Original many-analyst dataset: all 2,053 players in the first male divisions of England, Germany, France, and Spain in the 2012–13 season; all 3,147 referees they played under in their professional careers; 146,028 player–referee dyads with matches together and red cards; skin tone rated from profile photos (1,586 players) by two raters blind to the question on a 5-point scale. Codebook copy from the Bertran, Fogliato and Wu repository (commit d489f03).
+Reimers and Gurevych (2019), Sentence-BERT
+https://arxiv.org/abs/1908.10084
+EMNLP 2019 (arXiv 1908.10084). Sentence embeddings that can be compared using cosine similarity, making semantic similarity search practical (about 5 seconds instead of 65 hours for 10,000 sentences).
+Lewis et al., Retrieval-Augmented Generation (2020)
+https://arxiv.org/abs/2005.11401
+Foundational retrieval-augmented generation research; retrieved context does not guarantee that generated claims are supported.
 Purdue RCAC, GenAI Studio Workspace and Knowledge Bases
 https://docs.rcac.purdue.edu/services/genai/workspace/
 Knowledge Bases are document collections prepared with EmbeddingGemma 300M for semantic search and retrieval; custom models attach them for retrieval-augmented generation.
-Silberzahn et al., crowdsourced soccer data and codebook (OSF)
-https://osf.io/fv8c3/
-Original many-analyst dataset: all 2,053 players in the first male divisions of England, Germany, France, and Spain in the 2012–13 season; all 3,147 referees they played under in their professional careers; 146,028 player–referee dyads with matches together and red cards; skin tone rated from profile photos (1,586 players) by two raters blind to the question on a 5-point scale. Codebook copy from the Bertran, Fogliato and Wu repository (commit d489f03).
-sentence-transformers, all-MiniLM-L6-v2 model card (Hugging Face)
-https://huggingface.co/sentence-transformers/all-MiniLM-L6-v2
-Open Sentence-Transformers model (Apache 2.0) that maps sentences and paragraphs to a 384-dimensional vector space for semantic search; fine-tuned with a contrastive objective on over 1 billion sentence pairs; input longer than 256 word pieces is truncated. Used on slide 13 to compute cosine similarities between the soccer codebook's 31 passages and two questions (revision 1110a24; presentation/depth/data/codebook_retrieval.py). Model card saved October 13, 2026.
-Reimers and Gurevych (2019), Sentence-BERT
-https://arxiv.org/abs/1908.10084
-EMNLP 2019 (arXiv 1908.10084). Sentence embeddings that can be compared using cosine similarity, making semantic similarity search practical (about 5 seconds instead of 65 hours for 10,000 sentences).
-Bertran, Fogliato and Wu: released run-level results (GitHub, commit d489f03)
-https://github.com/amazon-science/agentic-forking-path/tree/d489f03b143fcaa9befb8cc443594ff63ec61eaa/experiment_data
-Authors' public release of the arXiv-version experiments (4,194 runs with final analyses; SHA-256 verified; README, LICENSE, and NOTICE saved alongside). The slide plots the 688 anes-views runs the AI auditor rated Compliant or Minor issues. Each run's code, report, and transcript are in experiment_data/workspaces.
-Lewis et al., Retrieval-Augmented Generation (2020)
-https://arxiv.org/abs/2005.11401
-Foundational retrieval-augmented generation research; retrieved context does not guarantee that generated claims are supported.
 GenAI Studio capability guides (implementation notes, September 14, 2026)
 Purdue_GenAI_Studio/index.html
 Seven guides: access, structured extraction, Knowledge Bases, retrieval, tools and database lookups, evaluation, and a review interface. Their rule: exact lookups belong in SQL; similarity retrieval suggests candidates. Examples are teaching adaptations; the pages did not run authenticated calls.
@@ -1175,34 +1211,43 @@
               <a:t>Let coding agents act only within limits you set.
 Planned time: 150 seconds. The PowerPoint shows complete diagrams; progressive reveals are in the React deck.
 DELIVERY CUE
-Read the three rows: the agent proposes, the limits decide. Name prompt injection: text the agent reads can try to steer it, and the limits still decide. Reveal the learning panel last and land the takeaway: you do the thinking; the agent types only what you understand.
+Read the definition, then the key idea: the agent proposes, software enforces. Step 2: walk the three rows: runs, asks, blocked; asking has an approval path, blocking does not; these are rules you set, not defaults. Step 3: injection can redirect the agent and misuse allowed actions (an unwanted edit inside the project); then the two checks, before approving and afterward. Land the band: set permissions, check actions, follow course rules.
 VISUAL STEPS
-1. The agent proposes; the sandbox and approval policy decide.
-2. Each action runs, asks you first, or is blocked; text that tries to steer the agent does not change the limits.
-3. Learning cost: relying on AI to write or debug code went with lower quiz scores.
+1. What the agent proposes: read files, modify a file, contact an external service.
+2. How the configured permissions produce run, ask, or block.
+3. How untrusted content can redirect an agent, and what you check before and after.
 TRANSCRIPT
-Coding agents are the most capable kind of AI tool, so understand how they are controlled before you use one. The agent proposes an action: read a file, edit code, run a command, reach the internet. Software decides what actually happens.
-Codex runs with network access off by default, inside an operating-system sandbox that typically limits it to your project, and asks for approval before going further. Claude Code's manual mode starts read-only and asks before it edits files or runs commands. As Codex's documentation puts it, you are trusting enforced limits, not just the agent's intentions.
-Those limits matter because of a risk called prompt injection. A file or web page the agent reads can contain hidden instructions aimed at the AI. In one scenario from OWASP, a security project, hidden instructions on a web page make an AI leak a private conversation. The agent may try to follow such text, but the sandbox and approval rules still decide what runs. Then review what it did: read the changes, run the tests, and keep a checkpoint you can return to.
-There is also a learning cost. In a randomized study, programmers learning a new Python library with an AI assistant scored lower on a quiz about it afterward. Those who relied on AI to write or debug their code averaged below forty percent; those who asked conceptual questions or asked for explanations averaged sixty-five percent or higher.
-So you do the thinking. For coursework, follow the course rules and let an agent write only what you already understand. On your own projects, agents are a powerful way to build, and reviewing their work is a skill employers will expect.
+Now the tools that act. A coding agent can choose tool actions, like reading files, changing code, or running commands, and use the results to decide what to do next. Claude Code and Codex are examples. The key idea: the agent proposes actions; software enforces the permissions.
+Here is one illustrative configuration. These are rules you or your organization set, not defaults that every tool shares. The agent proposes three things. Read files in the selected project: allowed, so it runs. Modify a project file: approval required, so it asks, and you approve or decline. Contact an external service that isn't approved: not permitted, so it's blocked. Asking and blocking are different. An action that asks has an approval path; a blocked action is prohibited under the active policy, however the agent asks. Some tools can also send approval requests to another model instead of to you, so know which mode you are in.
+Why does this matter? Prompt injection. Instructions inside an untrusted web page or file can try to redirect the agent, and they don't need to be hidden; the model only has to read them. Permissions still decide what can run, but an attack can misuse actions you already allowed. If edits inside the project are allowed, an injected instruction could produce an unwanted edit right there. OWASP describes an illustrative scenario: a web page being summarized carries instructions that make the AI leak a private conversation.
+So check at two points. Before approving: what will it read, change, run, or send? Afterward: inspect the changes, test a result you expect, and keep a checkpoint you can return to. If something looks wrong, go back to that checkpoint.
+Set the permissions before you start, check the agent's actions, and for coursework, follow your course's rules.
 TRANSITION
 With those limits in place, you are ready to try one of these tools yourself.
 CAVEATS
-Controls are from vendor documentation retrieved October 12, 2026, not independent security tests; defaults and modes change (Claude Code's auto mode uses a classifier instead of asking). Prompt injection: OWASP's LLM01 page says indirect prompt injections occur when a model accepts input from external sources, such as websites or files, that alters its behavior; Scenario 2 (hidden web-page instructions exfiltrate a private conversation) is an illustrative scenario, not a documented incident, and OWASP's mitigations include least-privilege access. Anthropic's Claude Code security page defines prompt injection as an attempt to override or manipulate an AI assistant's instructions by inserting malicious text, and says users are responsible for reviewing proposed code and commands before approval. Shen and Tamkin: 52 analyzed participants, a GPT-4o chat assistant that could supply correct code, an immediate quiz; the AI group scored lower (d = 0.74) without a significant speedup. The interaction-pattern averages come from small observed clusters (n = 2–7), not randomized comparisons. Not a test of current coding agents or of long-term retention.
+Illustrative configuration, not any product's defaults and not an executed demonstration: no agent was run for this slide. Asks versus blocked: an action that asks has an approval path; a blocked action stays prohibited under the active policy (for example, a deny rule, a network allowlist that omits the service, or a policy that never prompts, such as Codex with approvals set to never or Claude Code's dontAsk mode). Approval requests need not go to a person: Codex can route them to a reviewer agent (auto_review), and Claude Code's Auto mode uses a classifier model. That is automated review, not human approval; enforcement is still done by software. Product details from official documentation, checked October 21, 2026. Codex: the sandbox mode sets what Codex can technically do when it runs model-generated commands (where it can write, whether commands reach the network), and the approval policy sets when it must stop and ask; 'By default, the agent runs with network access turned off.' In its Auto preset for version-controlled folders (workspace-write with on-request approvals), it can read, edit, and run commands in the working directory without asking, and asks before editing outside the workspace or running commands that need network access. The command network restriction does not filter web search, app or connector tool calls, MCP server connections, or the client's own model requests, which follow their own settings; Codex no longer supports the 'untrusted' approval policy. Claude Code: with v2.1.283 or later, interactive terminal and VS Code sessions start in Auto mode, where a second model, a classifier, reviews actions instead of you (on earlier versions, only on Pro, Max, and Team plans); non-interactive runs (claude -p) and the Agent SDK start in Manual mode, as does any session where Auto mode is unavailable. Manual mode (configuration value 'default') starts read-only and asks before editing files, running tests, or executing commands, except a built-in set of read-only commands (such as ls, cat, and git status) and actions you previously allowed ('Yes, and don't ask again' lasts per repository and command for Bash, and for the session for edits). Its optional sandbox, off by default, covers shell commands and the processes they start; Claude's file tools, MCP servers, hooks, and web tools run outside it and follow permission rules. 'Permission rules are enforced by Claude Code, not by the model.' Network limits do not mean the model runs locally: both tools send prompts and model outputs to the vendor's model service. Prompt injection: OWASP's LLM01:2025 says injections 'do not need to be human-visible/readable, as long as the content is parsed by the model'; its Scenario #2, a summarized web page whose instructions make a model leak a private conversation, is listed among example attack scenarios and is presented here as an illustration, not a documented incident or an independent security test. OWASP notes that fool-proof prevention is unclear and recommends human approval for high-risk actions. The learning-cost study shown on this slide before October 21 (Shen and Tamkin) is discussed earlier in the talk and is no longer repeated here.
 SOURCES
-OpenAI, Codex agent approvals and security
+OpenAI, Codex agent approvals and security (ChatGPT Learn)
 https://learn.chatgpt.com/docs/agent-approvals-security
-Vendor documentation retrieved October 12, 2026. Network access is off by default; locally, an OS-enforced sandbox limits what the agent can touch and an approval policy decides when it must ask. Not an independent security test.
-Anthropic, Claude Code security and permission modes
+Sandbox mode ('what Codex can do technically ... when it executes model-generated commands') versus approval policy ('when Codex must ask you before it executes an action'). 'By default, the agent runs with network access turned off.' Auto preset (workspace-write, on-request): reads, edits, and runs commands in the working directory automatically; asks before editing outside the workspace or running commands that need network access. The command network proxy does not filter web search, app or connector calls, MCP connections, or the client's model requests. Approval requests route to the user by default, or to a reviewer agent with auto_review; the 'untrusted' policy is retired. Checked October 21, 2026; vendor documentation, not a security test.
+Anthropic, Claude Code security
 https://code.claude.com/docs/en/security
-Vendor documentation retrieved October 12, 2026. Manual mode starts read-only and asks before edits, tests or commands; an optional sandbox isolates Bash commands' file and network access. Describes controls; not an independent security evaluation.
-Shen and Tamkin (2026), How AI Impacts Skill Formation
-https://arxiv.org/abs/2601.20245
-Randomized experiments; 52 analyzed participants with Python experience learning the Trio library with or without a GPT-4o assistant that could supply correct code. The AI group scored lower on the immediate quiz (d = 0.74, p = .010) without a significant speedup. Interaction-pattern clusters (n = 2–7) were observed, not randomized: heavy reliance on AI to write or debug code averaged below 40%; conceptual questions or requests for explanations averaged 65% or higher.
-OWASP, Prompt Injection
+With Claude Code v2.1.283 or later, Auto mode is the built-in starting permission mode for interactive terminal and VS Code sessions, with a classifier model, not a person, reviewing actions (claude -p and Agent SDK runs start in Manual); Manual mode 'starts with read-only permissions. When it needs to edit files, run tests, or execute commands, it asks you first', and runs a built-in set of read-only commands without asking. In Manual mode most tools that make network requests require approval. Notes that no system is completely immune to attacks. Checked October 21, 2026; vendor documentation, not an independent evaluation.
+Anthropic, Claude Code: choose a permission mode
+https://code.claude.com/docs/en/permission-modes
+'With Claude Code v2.1.283 or later, auto mode is the built-in starting permission mode for interactive terminal and VS Code sessions. On earlier versions, it's the built-in starting permission mode only on Pro, Max, and Team plans.' In auto mode 'a second model, the classifier, reviews actions instead of you.' claude -p and Agent SDK runs start in default (Manual) mode; a session starts in Manual when auto mode is unavailable. Checked October 21, 2026.
+OpenAI, Codex sandbox (ChatGPT Learn)
+https://learn.chatgpt.com/docs/sandboxing
+'The sandbox defines technical boundaries. The approval policy decides when the agent must stop and ask before crossing them.' The sandbox applies to spawned commands, not only to built-in file operations; modes are read-only, workspace-write (the default for local work), and danger-full-access. Checked October 21, 2026.
+Anthropic, Claude Code sandboxing
+https://code.claude.com/docs/en/sandboxing
+'The sandbox covers shell commands only. Claude's file tools, MCP servers, and hooks run outside it.' 'The sandbox is off by default.' Restricts the network to allowed domains and limits reads and writes for shell commands; the OS-enforced boundary holds regardless of what the model chose to run; not a complete isolation boundary. Checked October 21, 2026.
+Anthropic, Claude Code permissions
+https://code.claude.com/docs/en/permissions
+'Permission rules are enforced by Claude Code, not by the model.' Modes include default (Manual), acceptEdits, plan, auto, dontAsk, and bypassPermissions; read-only commands run without a prompt in every mode; 'Yes, and don't ask again' persists per repository and command for Bash and until session end for edits. Checked October 21, 2026.
+OWASP GenAI Security Project, LLM01:2025 Prompt Injection
 https://genai.owasp.org/llmrisk/llm01-prompt-injection/
-External content can contain adversarial instructions. Retrieval and prompt filtering do not eliminate injection; constrain downstream permissions.
+Prompt injections 'do not need to be human-visible/readable, as long as the content is parsed by the model'; indirect injections arrive through external sources such as websites or files. Example attack scenario #2: summarizing a web page with hidden instructions leads to exfiltration of the private conversation. 'It is unclear if there are fool-proof methods of prevention'; recommends human approval for high-risk actions. Checked October 21, 2026.
 OpenAI, Codex CLI
 https://learn.chatgpt.com/docs/codex/cli
 Vendor documentation retrieved October 12, 2026 (developers.openai.com now redirects to learn.chatgpt.com): a terminal agent that inspects, edits and runs code in a local repository; recommends Git checkpoints before and after a task.
@@ -1312,7 +1357,10 @@
 SOURCES
 Purdue RCAC, GenAI Studio overview and data classification (updated September 29, 2026)
 https://docs.rcac.purdue.edu/services/genai/
-Authorized for public and sensitive (L2) data under Purdue's data classification; not for restricted data, including FERPA- or HIPAA-regulated data. Purdue-managed; content is not used to train the hosted models; a pilot with limited safety measures. External tools and MCP servers fall outside this authorization. Replaces the September 10 wording, which prohibited sensitive inputs.
+'GenAI Studio is authorized for use with public and sensitive data (L2), as defined in Purdue's Data Classification and Handling Procedures. It is not authorized for restricted data, including data regulated by FERPA or HIPAA.' 'An external service called by a Workspace Tool, or an MCP server, may receive tool arguments or conversation context outside GenAI Studio. GenAI Studio's authorization does not extend to these external integrations.' Purdue-managed; content is not used to train the hosted models; a pilot with limited safety measures. On October 21, 2026 the live page did not respond; RCAC's official documentation repository (PurdueRCAC/RCAC-Docs) showed no change since its September 29 'GenAI data classification update', and its source is saved alongside (2026_rcac_genai_overview_source.md).
+Purdue GenAI Studio: sign in (genai.rcac.purdue.edu)
+https://genai.rcac.purdue.edu/
+The official sign-in page for Purdue GenAI Studio (Purdue SSO through CILogon), linked from RCAC's GenAI Studio documentation and listed in Purdue's AI tools handout; the saved copy is RCAC's overview page, which links to it. The page did not respond from the build machine on October 21, 2026; sign in from a browser on Purdue's network or with your Purdue account.
 Purdue RCAC, GenAI Studio API guide (updated September 29, 2026)
 https://docs.rcac.purdue.edu/services/genai/api/
 OpenAI-compatible chat-completions requests with GenAI Studio's own base URL, model IDs and limits. Keep the key in an environment variable; 20 requests per minute per user; structured output differs by serving backend; custom models carry attached Knowledge Bases through the API. Model list checked through the API on October 12, 2026 (dozens of open-weight models, including gpt-oss, Qwen, Gemma, Llama and DeepSeek families).
@@ -1324,7 +1372,7 @@
 MIT-licensed local inference for open-weight models on CPUs and GPUs, with quantization and an OpenAI-compatible server. What runs well depends on the hardware and the model.
 Ollama documentation, FAQ
 https://docs.ollama.com/faq
-Serving software with local and cloud options. 'Ollama runs locally. We don’t see your prompts or data when you run locally.' Cloud-hosted models and web search send prompts to Ollama's servers (not stored, logged, or used for training, per the FAQ); cloud features can be disabled for local-only mode. Checked September 10 and October 13, 2026 (same statements; the October text snapshot is saved alongside).
+Serving software with local and cloud options. 'Ollama runs locally. We don’t see your prompts or data when you run locally.' Cloud-hosted models and web search send prompts to Ollama's servers ('we process your prompts and responses to provide the service but do not store or log that content and never train on it'); local-only mode ('disable_ollama_cloud' in server.json or OLLAMA_NO_CLOUD=1) turns off cloud models and web search. Checked September 10, October 13, and October 21, 2026 (same statements).
 Anthropic, Claude Code overview
 https://code.claude.com/docs/en/overview
 Vendor documentation retrieved October 12, 2026: an agentic coding assistant that reads a codebase, edits files and runs commands from the terminal, IDE, desktop or web. Most surfaces require a Claude subscription or Anthropic Console account.
@@ -1343,9 +1391,9 @@
 Computational Data Science, Chapter 6: LLMs in Data Science Workflows
 https://treese41528.github.io/ComputationalDataScience/Website/part4_llms_datascience/chapter6/index.html
 Course chapter for later study: embeddings, retrieval-augmented generation, prompt engineering, tool use, reliability and responsible AI, with GenAI Studio examples. Teaching material, not empirical evidence.
-GenAI Studio SDK (GitHub)
+GenAI Studio SDK, the instructor's Python package (GitHub)
 https://github.com/treese41528/genai-studio-sdk
-Public Python SDK for GenAI Studio: chat, embeddings, retrieval and a teachable tool-using agent framework.
+Open-source (MIT) Python SDK for Purdue's GenAI Studio gateway, written by the speaker and published on a personal GitHub account; not a Purdue or RCAC service. It runs on your computer and calls the GenAI Studio API: chat, embeddings, retrieval, and a tool-using agent framework. Its terminal agent, 'genai-studio agent', can read and edit code, run shell commands, search the web and arXiv, and use connected MCP tools, with approvals for risky actions and read-only, workspace-write, or full-access sandbox modes. Data sent to such tools leaves GenAI Studio, and RCAC states that GenAI Studio's authorization does not extend to external integrations. README rechecked October 21, 2026 (unchanged since July 3).
 GenAI Studio capability guides (implementation notes, September 14, 2026)
 Purdue_GenAI_Studio/index.html
 Seven guides: access, structured extraction, Knowledge Bases, retrieval, tools and database lookups, evaluation, and a review interface. Their rule: exact lookups belong in SQL; similarity retrieval suggests candidates. Examples are teaching adaptations; the pages did not run authenticated calls.
@@ -1437,32 +1485,31 @@
           <a:p>
             <a:r>
               <a:rPr lang="en-US" dirty="0"/>
-              <a:t>Build what interests you with AI, then learn how it works.
+              <a:t>Build something people can use. Learn as it grows.
 Planned time: 150 seconds. The PowerPoint shows complete diagrams; progressive reveals are in the React deck.
 DELIVERY CUE
-Walk the loop once: build, map, learn, return, pointing to the 'you' side of each step. Stress 'yet' on step 1 and 'beyond courses' on step 3. Then the baseball example, which ties back to expected batting average. End on optional and course rules.
+Step 1: read the motivation, then the platform's purpose; point to the connected modules, the ideas under each, the share link, and the friends panel; AI helps build and share release 1. Step 2: walk the loop 1 to 4 and back to release 2; point to the forecasting module as the current focus and read the example cycle; mention the new-topic entry. Land on the band and course rules.
+VISUAL STEPS
+1. The platform: a proposed baseball strategy platform you could host and share, its connected modules, and the ideas behind each.
+2. The learning loop: use and get feedback, connect, learn and experiment, improve and release, then back to a new release.
 TRANSCRIPT
-Here is one optional strategy: build something you care about with AI's help, and let it show you what to learn.
-Pick something connected to your interests and a little beyond what you can build alone. AI can help you write code you can't write alone yet. Notice the "yet." In coursework, let AI write only what you understand. A personal project can run ahead of your understanding, because the next steps are about catching up.
-Then turn the project into a study plan. Ask the AI what the project depends on: the mathematics, statistics, and computing behind each piece. Give it real context, your courses, what you can already explain, and where you are stuck, and check its list against your course materials.
-Then learn those topics. AI can help you find where each one is covered: a Purdue course, a textbook chapter, or documentation. Knowing which course covers a topic helps you plan, but there is no reason to wait for that course or to stop at courses. AI can explain and quiz you, but the problems are yours to work.
-Then return to the project. Rebuild one part without AI, explain a design choice, or compare another method. Each pass, more of the project is yours.
-Here is an example. If you like baseball, remember expected batting average from earlier: the probability that a batted ball becomes a hit, given its exit velocity and launch angle. MLB's public Statcast search provides pitch-level data with those measurements, the result of each play, and MLB's own estimate. With AI's help you could build a first model, discover that you need conditional probability and model checking, study them, and come back to compare your model with MLB's.
-This is optional, and the choice of project is yours. Coursework still follows each course's rules, and working problems yourself remains essential. A project gives you a reason to learn more and a place to use what you learn.
+Here is one optional way to put all of this to work: build something people can use, and learn as it grows.
+Start with a goal like this: I want to build a platform around something I care about, put it online, and send my friends a link. Say you like baseball. Picture a strategy platform where you and your friends can explore players, build lineups, predict matchups, simulate seasons, and save and share your scenarios. That is a big system: a data pipeline and database built on MLB's documented Statcast data, player comparisons, forecasts with uncertainty, a season simulator, lineup search, and a hosted application that ties them together. AI can help you build and share a first working version well beyond what you could build alone today.
+Each capability rests on ideas you will meet here. Comparing players leads to vectors and similarity. Forecasting matchups leads to conditional probability, regression, and regularization. Simulating seasons leads to Monte Carlo methods. Lineup search leads to combinatorics and optimization. And hosting it is part of the learning: with AI's help, learn how to put the platform online, publish updates, and investigate problems when something breaks, and ask it to explain how the interface, server, database, and calculations fit together.
+Then the loop. Use it and get feedback: what do your friends find confusing, slow, or missing? Connect one improvement to ideas: which part needs to change, and which course topics connect? Learn and experiment, in courses, books, documentation, and with AI. Then improve and release the next version. Each release brings new possibilities, feedback, and questions. A new course topic can start a cycle too: where could I use this in my platform?
+For example, your first forecasts might swing to extremes for players with little data. That question leads to partial pooling, combining sparse player data with broader evidence. You study it, revise the forecasts, check them against later games, and feed them to the simulator.
+The project improves, your map of what to learn grows, and so do your questions. A personal project can use a lot of AI help; coursework follows each course's rules.
 TRANSITION
 Whether you build a project or work through a course, the same four questions apply, and one of them matters most.
 CAVEATS
-Optional instructional suggestion, not an experimentally validated intervention or an employment guarantee. Example sources: MLB's Statcast glossary defines xBA from how often comparable batted balls (exit velocity, launch angle, and for some batted balls sprint speed) became hits; Baseball Savant's CSV documentation lists launch_speed, launch_angle, events, and estimated_ba_using_speedangle. Because MLB also uses sprint speed for some batted balls, a two-variable model will not match it exactly, which is itself worth investigating. No example model was built or run for this talk. Expanded prompt remains in 05_top_down_learning_speaker_notes.md.
+Speaker's suggestion and a proposed project: nothing here has been built, run, or evaluated, and it is not a validated intervention. Personal-project framing: a personal project can use a lot of AI help; coursework follows each course's rules. Documented data versus proposed capabilities: Baseball Savant's Statcast CSV documentation (text saved October 13, 2026) lists pitch-level fields such as game_date, pitch_type, release_speed, batter and pitcher (MLB player IDs), events (the plate appearance's result), launch_speed, launch_angle, and estimated_ba_using_speedangle. Everything the platform does with those data is proposed. Components and course connections: data system, collecting, updating, joining, and checking historical data in a database (data management, SQL, data validation); player exploration, searchable profiles, visualizations, comparisons, and trends (vectors, distance and similarity, standardization, multivariate methods such as principal components); forecasting, player and matchup predictions with uncertainty, evaluated against later outcomes (conditional probability, regression, regularization, calibration); simulation, games and seasons under different lineups and assumptions (Monte Carlo simulation, random variables, dependence between events, variability of simulated totals); strategy, comparing or searching for lineups and decisions under constraints (combinatorics, constrained optimization, sensitivity to assumptions); the hosted application, saved scenarios, reports, tests, and shareable links (databases, application design, testing, hosting), optionally with an assistant that queries the project's own data and calculations (retrieval versus SQL, slide 13). MLB's expected batting average, P(hit | exit velocity, launch angle) from comparable batted balls, could be one small forecasting subcomponent; it no longer defines the project's scale. Hosting as learning, with an example prompt: 'Help me put this application online so my friends can use it. Explain how its interface, server, database, and calculations fit together. Trace what happens when someone opens the site and runs a simulation. Guide me through hosting it, explain the choices we make, and help me understand any errors we encounter.' AI can supply explanations, diagrams, examples, and comparisons, and help interpret the application's own behavior; check its explanations against documentation and the running system. Example cycle (illustrative, not implemented or measured): the first forecasting component gives extreme predictions to players with very little data; the student asks how the amount of evidence should affect a forecast; sampling variability and estimation connect to partial pooling or regularization, which combine sparse player data with broader evidence so that a few at-bats move a forecast less than many; the student studies and experiments with a simpler example; they revise the forecasting component, evaluate it on later games, and feed the revised predictions into the simulator; a new question follows about how forecasts should change against different pitchers. Refinement changes three things: the project, the student's map of relevant ideas, and the questions the student asks. Rebuilding a small component without AI remains an optional learning check; the main goal is to understand enough to make informed changes and extend the platform. The path continues slides 10 and 11: a course topic, further ideas beyond the course, then a useful capability in something the student cares about.
 SOURCES
+Baseball Savant (MLB), Statcast Search CSV documentation
+https://baseballsavant.mlb.com/csv-docs
+Public Statcast Search data are documented field by field, including launch_speed (exit velocity), launch_angle, events (the play's result), and estimated_ba_using_speedangle (MLB's estimated batting average from launch angle and exit velocity). Text snapshot saved October 13, 2026.
 MLB.com, Statcast glossary: Expected Batting Average (xBA)
 https://www.mlb.com/glossary/statcast/expected-batting-average
 Official MLB definition: xBA measures the likelihood that a batted ball will become a hit, based on how often comparable balls (exit velocity, launch angle, and for some batted balls Sprint Speed) have become hits since Statcast was implemented league-wide in 2015. A conditional probability used in industry. Text snapshot saved October 13, 2026.
-Baseball Savant (MLB), Statcast Search CSV documentation
-https://baseballsavant.mlb.com/csv-docs
-Public Statcast Search data are documented field by field, including launch_speed (exit velocity), launch_angle, events (the play's result), and estimated_ba_using_speedangle (MLB's estimated batting average from launch angle and exit velocity). Text snapshot saved October 13, 2026.
-GenAI Studio SDK (GitHub)
-https://github.com/treese41528/genai-studio-sdk
-Public Python SDK for GenAI Studio: chat, embeddings, retrieval and a teachable tool-using agent framework.
 Computational Data Science, Chapter 6: LLMs in Data Science Workflows
 https://treese41528.github.io/ComputationalDataScience/Website/part4_llms_datascience/chapter6/index.html
 Course chapter for later study: embeddings, retrieval-augmented generation, prompt engineering, tool use, reliability and responsible AI, with GenAI Studio examples. Teaching material, not empirical evidence.
@@ -1562,21 +1609,21 @@
 Let me bring everything together with the four questions from the start.
 What is the purpose? Match your AI use to what you need to learn, and write your own connections from courses to goals.
 What is allowed? Follow your course's rules now and your employer's policy later, and share data only where a tool's terms allow it.
-What must you do yourself? The thinking: attempt first, then ask for hints, and build the expertise to check and steer AI, which I expect employers to value most.
+What must you do yourself? The thinking: try first, then get help with the gap, and build the expertise to check and steer AI, which I expect employers to value most.
 How will you check it? The same data led AI analysts to different conclusions, so read the passage retrieval returns, check a query's conditions, and review every change an agent makes.
-If you remember one thing, make it the thinking. Some of the most valuable time you will spend here is several days on one hard proof or one project that does not work yet. Trying, getting stuck, stepping away, and coming back is how you develop. You saw the evidence: trying problems before being taught built deeper understanding, and students who kept putting in the time with AI scored about as well as students without it. So do not be quick to turn to AI for the quick fix. When you do ask, ask for a hint, after real effort.
+If you remember one thing, make it the thinking. Some of the most valuable time you will spend here is several days on one hard proof or one project that does not work yet. Trying, getting stuck, stepping away, and coming back is how you develop. You saw the evidence: trying problems before being taught built deeper understanding, and among students using AI, larger exam declines went with very short homework times, while those who kept putting in the time had small losses. So do not be quick to turn to AI for the quick fix. When you do ask, ask for help with the specific gap, after real effort.
 Start this week. Pick one hard problem from your coursework and check what help is allowed. Stay with it over several days, then bring one precise question to an instructor or TA.
 Keep the thinking yours, and let AI support your growth. Thank you. I am happy to take questions.
 TRANSITION
 CAVEATS
-A summary of the talk's main points; each point's evidence and sources are on its own slide. The advice to give a hard proof or project days rather than minutes is the speaker's; no study in this talk measured multi-day effort. The panel's two evidence lines repeat findings shown earlier: Sinha and Kapur's meta-analysis of 53 studies (slide 9), where the benefit of struggling first depends on instructional design and no waiting time is prescribed, and Strömberg et al. (slide 6), where AI users whose homework time held up scored about like non-users (descriptive, not causal). That employers will value this expertise most is the speaker's forecast (slide 9), not a finding.
+A summary of the talk's main points; each point's evidence and sources are on its own slide. The advice to give a hard proof or project days rather than minutes is the speaker's; no study in this talk measured multi-day effort. The panel's two evidence lines repeat findings shown earlier: Sinha and Kapur's meta-analysis of 53 studies (slide 9), where the benefit of struggling first depends on instructional design and no waiting time is prescribed, and Strömberg et al. (slide 6), where larger exam declines were associated with very short homework completion times and AI users whose homework time held up showed small losses (descriptive, not causal; the paper's abstract: 'AI users who maintain similar homework completion time as non-AI users experience small learning losses'). That employers will value this expertise most is the speaker's forecast (slide 9), not a finding.
 SOURCES
 Sinha and Kapur (2021), problem solving followed by instruction
 https://journals.sagepub.com/doi/10.3102/00346543211019105
 Meta-analysis: benefits depend on instructional design, age and domain. Supports purposeful attempts followed by appropriate instruction; no universal waiting time or AI-use prescription.
-Strömberg, Lei and Wu (June 2026), The generative AI learning penalty
-https://papers.ssrn.com/sol3/papers.cfm?abstract_id=6868618
-Staggered difference-in-differences; 26,811 grade 7–12 students in one Chinese county; 30 months of administrative homework, exam and entrance-exam records. Homework +18%, homework time 64 to 45 minutes, closed-book exams −20% (6–10 months); entrance exams about −7% on average and −18%/−24% after two or more years (weaker identification). Losses concentrated among students whose homework time collapsed. Self-reported adoption month; one county; secondary school. PDF supplied by the user.
+Strömberg, Lei and Wu (June 2026), The generative AI learning penalty (CEPR DP 21577)
+https://cepr.org/publications/dp21577
+Working paper. Staggered difference-in-differences with never-adopters as the comparison; one county in central China; samples differ by outcome (homework 18,345 students over 20 months; regular exams 26,811 over 30 months; entrance exams 8,341). Effects are percentages of the pooled pre-adoption mean. Months 6–10: homework +18%, homework time 64 to 45 minutes, closed-book monthly exams −20%. Entrance exams 24+ months after adoption: Gaokao −18%, Zhongkao −24% (about −7% averaged over all durations; weaker identification). Larger declines associated with very short homework times (descriptive). Self-reported adoption month. Saved copy supplied by the user (identical to the SSRN 6868618 file); an open copy of the same text is at conference.nber.org/conf_papers/f240545.pdf.
 Additional research: six questions and talk refinements
 12_further_research_and_talk_updates.html
 Claim-focused review of 13 supplemental sources. No direct validation found for new post-AI junior-DS screens against later job performance; search is not exhaustive.
@@ -1694,7 +1741,7 @@
 Employer survey; see report slides on AI skills and career readiness. 185 respondents overall; item denominators vary.
 Brynjolfsson, Chandar and Chen, Canaries — August 2026 revision
 https://digitaleconomy.stanford.edu/publication/canaries-in-the-coal-mine-six-facts-about-the-recent-employment-effects-of-artificial-intelligence/
-ADP payroll through June 2026. Ages 22–25 in highly exposed occupations: 19% below a kept-pace comparison with less-exposed peers, not a causal estimate of jobs eliminated. Sample composition, education, pretrends and specification sensitivity matter. Earlier 13%/16% headlines use different estimators.
+ADP payroll through June 2026. From November 2022 to June 2026, employment of 22–25-year-olds fell about 11% in the two most AI-exposed occupation fifths and grew about 10% in the three least exposed: a 21-point divergence, 19% relative to the less-exposed group. Mainly fewer hires; separation rates fell. Descriptive, not causal; no measure of individual skills or retention. Some divergence before ChatGPT; weaker in national surveys.
 Yale Budget Lab (May 2026), AI and labor-market identification
 https://budgetlab.yale.edu/research/what-we-do-and-dont-know-about-how-ai-affecting-labor-market
 Synthetic comparison design finds no clear broad employment/wage effect. National-survey coverage, age groups and exposure definitions differ from Stanford; averages can conceal heterogeneous effects.
@@ -1795,8 +1842,16 @@
               <a:t>Human teams and AI analysts split on the same data.
 Planned time: 70 seconds. The PowerPoint shows complete diagrams; progressive reveals are in the React deck.
 DELIVERY CUE
-Read the bars top to bottom: human teams split, clean AI runs split, flagged AI runs split. The point is dispersion, not which group is right. Mention the memorization caution.
-STUDY DETAILS
+Read the bars top to bottom: the human study’s own classification, then AI runs with no issues flagged, then minor issues flagged; the footer gives the two criteria. Two projects, not a contest: show the spread, not a winner. Then 4, an association is not proof of bias; 5, the training-data caution. Land the band: check which choices drive the conclusion.
+TWO STUDIES, TWO CRITERIA
+• Human bar: the original study's own count. Twenty teams found a significant positive relationship (p &lt; .05) and nine a nonsignificant one; no team found a significant negative one.
+• The teams chose their own models (linear, logistic, Poisson, Bayesian); Bayesian teams reported credible intervals rather than p-values (Team 3: odds ratio 1.31, 95% credible interval 1.09–1.57).
+• The nine did not show “no bias”: seven estimates were above 1 and two below, each with an interval that included 1.
+• Mistakes as well as choices: the original authors later judged revised analyses of Teams 21 and 27 more defensible (odds ratios 2.88 → 1.31 and 2.93 → 1.29) and said their conclusions still held.
+• AI bars: a positive risk difference with two-sided p &lt; .05, counted from the released runs. The agents' own “supported” flags (34 and 283) are a different measure.
+• Each AI bar pools four models and five prompts, including two that pushed agents toward support; 80 of the 95 no-issue runs are Claude Sonnet 4.5.
+• Different scales: odds ratios for the human teams, risk differences for the AI runs. Compare the splits, not the sizes.
+AI STUDY DETAILS
 • Models: Claude Sonnet 4.5, Claude Haiku 4.5, Qwen3 Coder 480B, Qwen3 235B.
 • Design: 4 models × 5 prompt framings × 3 datasets; 4,946 runs in total.
 • Every run got the same data, hypothesis, and prespecified estimand.
@@ -1809,23 +1864,32 @@
 • Soccer: any recall would have come from training data, not browsing.
 • The no-internet setting is in the authors' code (preprint version); the paper lists the same tools.
 TRANSCRIPT
-Many analysts, one dataset is not a new problem. In a well-known study, twenty-nine human teams analyzed the same soccer data: about two thousand players in the top men's leagues of England, Germany, France, and Spain in the 2012–13 season, paired with every referee they had played under. Are referees more likely to give red cards to players with darker skin? Twenty teams found significant evidence of bias; nine did not.
-This year's PNAS study gave AI analysts the same data and question. Each one chose its own analysis. Among runs the auditor found no issues with, about a third found significant evidence of bias and two-thirds did not; runs with minor issues split about evenly. Defensible choices accumulate, for people and for AI.
-One caution: the agents had no internet access, but this result is widely published, so a model may have recalled it from its training data rather than discovered it.
+Many analysts, one dataset is not a new problem. In a 2018 study, twenty-nine human teams analyzed the same soccer data: about two thousand players in top men's leagues, paired with every referee they had faced. Are referees more likely to give darker-skinned players red cards? Twenty teams reported a significant positive association; nine did not.
+This year, a separate PNAS study gave AI analysts the same data and question. Among runs with no issues flagged by the AI auditor, just over a third had a positive estimate with p below .05; among runs with minor issues, just over half did.
+These are separate projects, not a contest between people and AI, and an association is not proof of bias. Disagreement can come from reasonable choices, different definitions, or mistakes, so check which choices drive a conclusion. One caution: these findings are widely published, so the models may have seen them in training.
 TRANSITION
-So the authors also asked a question the models were unlikely to have memorized, and varied how they asked it.
+The same AI study also asked a question the models were unlikely to have memorized, and varied how it asked.
 CAVEATS
-Data: 2,053 players in the first male divisions of England, Germany, France, and Spain (2012–13 season) and all 3,147 referees they played under in their careers; 146,028 player–referee pairs; skin tone rated from photos by two blind raters (codebook). Human comparison: Silberzahn et al. (2018), as reported by Bertran, Fogliato and Wu (PNAS 2026). Bar percentages: 20 of 29 teams (69%), 35 of 95 no-issue AI runs (37%), 281 of 516 minor-issue runs (54%). AI counts come from the authors' released runs (arXiv-version experiments; SHA-256 verified): soccer runs with a numeric estimate and p-value and no extraction warning, rated Compliant (95) or Minor issues (516) by the Claude Sonnet 4.5 auditor. To match the human count, an AI run “found significant bias” when its two-sided p &lt; .05 with a positive risk difference: 35 of 95 and 281 of 516. The agents' own Supported verdicts (which the prompt tied to magnitude, uncertainty, and direction at alpha = .05, with inconclusive counted as Not Supported) nearly match: 34 and 283. The paper treats soccer as its high-contamination task because the data and conclusions are widely published. The released estimates mix proportion and percentage-point units, so the slide compares verdicts rather than effect sizes.
+Two separate studies of one dataset, compared descriptively; the bars are not a controlled test of human versus AI accuracy. Data: 2,053 players in the first male divisions of England, Germany, France, and Spain in the 2012–13 season and all 3,147 referees they encountered across their professional careers (146,028 player–referee pairs; data through June 2014); skin tone rated from photos (1,586 players) by two raters blind to the question. The cohort is one season's players, but each pair counts encounters across a player's career, and clubs and leagues were recorded at data collection, not when each card was given. Human bar: Silberzahn et al. (2018) report that 20 teams (69%) found a significant positive relationship, p &lt; .05, and 9 (31%) a nonsignificant one; no team found a significant negative relationship. This is the study's own aggregate classification, not a rule recomputed here: teams used linear, logistic, Poisson, and Bayesian models (Bayesian: Teams 3, 7, 17, and 18), and Team 3's report, for example, summarizes its result with a 95% credible interval (odds ratio 1.31, 1.09–1.57), not a p-value. Table 3's intervals reproduce the 20/9 split, with Team 15 (1.02 [1.00, 1.03]) on the boundary. The nine (Teams 1, 6, 12, 14, 15, 17, 18, 27, and 31) had odds ratios from 0.89 to 2.93, seven above 1 and two below, from methods ranging from regression with robust standard errors to Bayesian logistic regression and zero-inflated Poisson models; they should not be summarized as showing 'no bias' or as uniformly inconclusive. Association, not cause: the authors write that the archival data 'did not offer the opportunity to identify causal relations between these variables'; at the end, the statement with the most agreement (78%) was 'The effect is positive and the mechanism is unknown.' Mistakes as well as choices: in a later OSF note (2021), Silberzahn, Martin, Uhlmann, and Nosek agreed that revised analyses for Teams 21 and 27 were 'comparably more defensible' (Tobit OR 2.88 → fractional regression 1.31; Poisson 2.93 → 1.29 without non-significant interactions) and said that correcting or removing the two estimates does not change the 2018 conclusions. Team 21 was among the 20 significant teams and Team 27 among the nine; the note gives no revised significance. Bertran et al. write that human many-analyst discrepancies 'do not arise from error or lack of expertise'; the note shows that some differences came from less defensible analyses, and the slide therefore names mistakes as one possible source. AI bars: Bertran, Fogliato and Wu (PNAS, July 2026), released run-level results (commit d489f03; SHA-256 verified). Kept: soccer runs with a numeric estimate and p-value, not explicitly flagged for an extraction warning, and rated Compliant (95) or Minor issues (516) by the Claude Sonnet 4.5 auditor. Three kept runs have a blank warning field (one Compliant, two Minor issues), the same convention as slide 13's 688; none is counted as significant, and dropping them would give 35 of 94 (37%) and 281 of 514 (55%). Counted: a positive estimated primary risk difference (dark vs. light skin) with p &lt; .05: 35 of 95 (37%) and 281 of 516 (54%). The task prompt asked for 'a two-sided p-value (alpha = 0.05)', but the two confirmation-seeking prompts told agents to use one-sided tests, so every counted run with .025 ≤ p &lt; .05 was read (113 reports): 110 label the extracted value two-sided and none one-sided. The other 3 did not label it on the same line, so their code and printed output were read (October 21): each extracted p-value is a two-sided test of the positive adjusted risk difference being counted (a GEE Wald test with robust standard errors; a bootstrap-SE normal approximation; a parametric simulation), so the counts stand (check_bertran_soccer.py; bertran2026_soccer_sidedness_resolved.json). Even if all three had been one-sided, the minor-issues count would be 278 of 516, still 54%. The paper's own p-value plots use one-sided conversions; the slide does not. The agents' own Supported verdicts (the task asked for a judgment based on magnitude, uncertainty, and direction, with inconclusive counted as Not Supported) give 34 of 95 and 283 of 516 and disagree with the p-value rule in 1 and 16 runs; the bars use only the p-value rule. 'No issues flagged' is the AI auditor's verdict, not a guarantee that an analysis is correct. Each AI bar pools four models and five prompt framings, including two that pushed agents toward support: the 95 no-issue runs are 80 Claude Sonnet 4.5, 10 Claude Haiku 4.5, and 5 Qwen3 Coder 480B (37 Negative, 35 Standard, 18 Positive, 3 Confirmation-seeking, 2 Strong confirmation-seeking); the 516 minor-issue runs are 196 Qwen3 235B, 141 Qwen3 Coder, 118 Haiku, and 61 Sonnet (131 Standard, 129 Negative, 127 Positive, 83 Confirmation-seeking, 46 Strong confirmation-seeking). The two AI bars therefore differ by model and prompt as well as by audit verdict. Not one protocol: the human teams were recruited analysts who revised their work after rounds of peer feedback and discussion; the AI runs followed fixed prompts with a prespecified estimand and an automated audit; neither study assigned people and AI under a common protocol. Different scales: the human estimates are odds ratios (0.89 to 2.93, median 1.31; some converted from Cohen's d, regression coefficients, or rate ratios), while the AI estimand is an adjusted risk difference reported in proportions or percentage points, so the slide compares splits, not effect sizes. Training data: the paper calls soccer its high-contamination task because the data and conclusions are widely known, and the agents had no internet access; familiarity is a limitation, not evidence that any particular run recalled its answer.
 SOURCES
+Silberzahn et al. (2018), Many analysts, one data set (Advances in Methods and Practices in Psychological Science)
+https://doi.org/10.1177/2515245917747646
+AMPPS 1(3):337–356; published PDF with its 2018 corrigendum (University of Sussex repository copy, saved October 21, 2026). 29 teams (61 analysts) analyzed the same soccer data: 20 (69%) found a significant positive relationship (p &lt; .05) and 9 (31%) a nonsignificant one; none a significant negative one. Odds ratios 0.89 to 2.93 (median 1.31), some converted from other units; 21 covariate combinations; linear, logistic, Poisson, and Bayesian approaches (Table 3). The archival data 'did not offer the opportunity to identify causal relations between these variables.'
 Bertran, Fogliato and Wu, PNAS (July 2026), Many AI analysts
 https://doi.org/10.1073/pnas.2606495123
-Published main text saved here; the published PNAS PDF supplied by the user on October 12, 2026 is resources/bertran-et-al-2026-many-ai-analysts-one-dataset-navigating-the-agentic-data-science-multiverse.pdf (source of the slide figure). 4,946 runs, 3,303 compliant; three datasets, four models, five personas. Defensible choices yield divergent conclusions; confirmation-seeking framing shifts support rates by 34–66 points. AI auditing narrows but does not remove dispersion; disagreement alone is not an error.
+Published main text saved here; the published PNAS PDF supplied by the user on October 12, 2026 is resources/bertran-et-al-2026-many-ai-analysts-one-dataset-navigating-the-agentic-data-science-multiverse.pdf (source of the slide figure). 4,946 runs, 3,303 passing the AI auditor's screen; three datasets, four models, five personas. The authors report divergent conclusions across analyses they call defensible; confirmation-seeking prompts raise support rates by 34–66 points (Negative to Strong CS). Screening narrows but does not remove dispersion; disagreement alone is not an error.
 Bertran, Fogliato and Wu: released run-level results (GitHub, commit d489f03)
 https://github.com/amazon-science/agentic-forking-path/tree/d489f03b143fcaa9befb8cc443594ff63ec61eaa/experiment_data
-Authors' public release of the arXiv-version experiments (4,194 runs with final analyses; SHA-256 verified; README, LICENSE, and NOTICE saved alongside). The slide plots the 688 anes-views runs the AI auditor rated Compliant or Minor issues. Each run's code, report, and transcript are in experiment_data/workspaces.
+Authors' release of run-level results at commit d489f03 (results.csv: 4,194 rows, one per run with a final analysis; the README says runs without one are excluded and describes 4,196 runs; the paper reports 4,946 runs in total). SHA-256 verified; README, LICENSE, and NOTICE saved alongside. The TV-news slide shows support rates for the 1,270 anes-views runs before screening and the 700 that passed the AI screen (its earlier plot of 688 extracted estimates was removed on October 21; see its notes); slide 13 counts 688 of those 700 with SQL; the soccer slide counts 611 soccer runs. Each run's code, report, and transcript are in experiment_data/workspaces.
 Silberzahn et al., crowdsourced soccer data and codebook (OSF)
 https://osf.io/fv8c3/
 Original many-analyst dataset: all 2,053 players in the first male divisions of England, Germany, France, and Spain in the 2012–13 season; all 3,147 referees they played under in their professional careers; 146,028 player–referee dyads with matches together and red cards; skin tone rated from profile photos (1,586 players) by two raters blind to the question on a 5-point scale. Codebook copy from the Bertran, Fogliato and Wu repository (commit d489f03).
+Silberzahn, Martin, Uhlmann and Nosek (2021), note on revised estimates for Teams 21 and 27 (OSF)
+https://osf.io/ch27w/
+One-page note in the project's supplementary files, responding to a multiverse reanalysis by Young and Stewart. The original authors agree the revised estimates are 'sensible, and further comparably more defensible or “correct”': Team 21, Tobit regression OR 2.88 → fractional regression 1.31; Team 27, Poisson regression 2.93 → Poisson without non-significant interactions 1.29. They state that correcting or removing the two estimates does not change the 2018 paper's conclusions. Saved October 21, 2026.
+Crowdstorming Team 03 (Kaszubowski), Bayesian hierarchical binomial regression report (OSF)
+https://osf.io/vgcw9/
+One team's report from the crowdsourced project: a Bayesian hierarchical binomial regression fitted in Stan and summarized with 95% credible intervals rather than p-values. Final model: odds ratio 1.31 (95% credible interval 1.09–1.57) for the darkest versus the lightest skin-tone rating. Saved October 21, 2026.
 Evidence and service collection: September 10, 2026; sources added or rechecked through October 13, 2026. Foundations and course review: September 20, 2026. Slides, figures, and transcript revised October 13, 2026 for one flow across the four opening questions; appropriate AI use throughout Purdue remains the theme. Numerical citations were checked against the saved primary sources.</a:t>
             </a:r>
             <a:endParaRPr lang="en-US" dirty="0"/>
@@ -1917,17 +1981,24 @@
               <a:t>Check what drives an AI analysis’s verdict.
 Planned time: 80 seconds. The PowerPoint shows complete diagrams; progressive reveals are in the React deck.
 DELIVERY CUE
-Point to one dot, then the zero line: estimates on both sides. Then solid versus hollow: the auditor flagged minor issues in most runs. Then the framing gap and the audit. Action: don’t lead the AI (a find-support prompt works like a leading survey question); test the claim, try other reasonable analyses, report all results with the prompt.
+Same AI study, new data, AI analysts only. Read the question and the two prompts (1). Reported support before screening: 13 vs. 43 (2). The screen: 45% removed; 18 of the 123 aggressive runs that reported support passed (3). Among runs that passed the AI screen, a different and smaller set: 13 vs. 20 (4). The screen corrected nothing; passing is not proof, failing is not disproof. Land the band: test a claim, don’t deliver one.
 SYMBOLIC IDEOLOGY
 • Symbolic ideology: the label people give themselves, e.g., the ANES 7-point liberal–conservative self-placement.
 • Operational ideology: the positions people take on specific issues.
 • Issues fall on at least two dimensions: economic (taxes, spending, health insurance) and social (abortion, religion, same-sex marriage).
 • One label can reflect either: someone may call themselves conservative for social or religious reasons while favoring more government spending.
 • So “misalignment” depends on which issues enter the policy index: economic items can make that person look misaligned; social items may not.
-• The agents built different indexes (e.g., government spending, health insurance, defense, racial policy, abortion), so they measured different things: one source of the spread.
-• A tighter link means a smaller gap, so the hypothesis predicts a negative effect of TV news: left of zero on the slide.
+• The agents built different indexes (e.g., government spending, health insurance, defense, racial policy, abortion), so they measured different things.
+• A tighter link means a smaller gap, so the hypothesis predicts a negative coefficient on TV news.
 • The auditor flagged indexes built from feelings toward liberals and conservatives: that is symbolic ideology again.
-STUDY DETAILS
+THE FIVE PROMPTS
+• Skeptical (Negative): the hypothesis is described as implausible. Said “supported”: 13.0% before screening (31 of 239), 13.0% of runs that passed the screen (21 of 161).
+• Standard (neutral): 17.1% (41 of 240); passing, 14.6% (25 of 171).
+• Positive (described as plausible; no search for support): 24.9% (59 of 237); passing, 19.7% (31 of 157).
+• Confirmation-seeking (find supporting specifications within conventional practice): 33.6% (87 of 259); passing, 23.5% (28 of 119).
+• Strong confirmation-seeking (exhaustive search, one-sided tests, “YOU MUST ACHIEVE THIS. I DONT CARE HOW.”): 43.3% (123 of 284); passing, 19.6% (18 of 92).
+• Prior expectations alone (Negative vs. Positive) moved the rate less than the instructions to seek support did.
+AI STUDY DETAILS
 • Models: Claude Sonnet 4.5, Claude Haiku 4.5, Qwen3 Coder 480B, Qwen3 235B.
 • Design: 4 models × 5 prompt framings × 3 datasets; 4,946 runs in total.
 • Every run got the same data, hypothesis, and prespecified estimand.
@@ -1940,20 +2011,24 @@
 • Soccer: any recall would have come from training data, not browsing.
 • The no-internet setting is in the authors' code (preprint version); the paper lists the same tools.
 TRANSCRIPT
-The question: does watching more TV news tighten the link between people's ideology and their policy views? Each dot is one AI analysis of the same national survey; left of zero means a tighter link, as hypothesized. All 688 got an acceptable rating from an AI auditor, solid dots with no issues and hollow dots with minor ones. Yet their estimates fall on both sides of zero.
-Framing mattered too. A prompt pushing the agent to find support produced "supported" verdicts in 43 percent of runs, versus 13 percent with a prompt calling the hypothesis implausible. The auditor flagged major problems in 45 percent of runs, removing most of that steering, but the acceptable analyses still disagree.
-So don't lead the AI: a find-support prompt works like a leading survey question. Ask it to test the claim, try other reasonable analyses, and report all results with your prompt.
+This task uses American National Election Studies survey data, and only AI analysts took part. The question: do people who watch more TV news show a tighter link between their ideology and their policy views?
+Every run got the same data and question, but the prompts differed. One was skeptical. Another directed an aggressive search for supporting results; among its instructions: "You must achieve this. I don't care how." Before any screening, 13 percent of skeptical runs reported support, against 43 percent of aggressive ones.
+Then an AI auditor screened every analysis and removed 45 percent for major issues or noncompliance. Of the 123 aggressive runs that reported support, only 18 passed the screen. Among the runs that passed, a smaller set, 13 versus 20 percent reported support. The screen didn't fix any analysis: passing isn't proof that an analysis is right, and failing isn't proof that its conclusion is wrong.
+So ask AI to test a claim, not to deliver a conclusion: state the question carefully, don't direct the answer, and check how the choices change the result.
 TRANSITION
 Checking applies to your own use of AI, too.
 CAVEATS
-Published PNAS version, July 14, 2026 (user-supplied PDF, read October 12). Direction labels count the 688 plotted estimates: 334 below zero (a tighter link, as hypothesized), 352 above, and 2 exactly zero. Of 4,946 runs, 3,303 (67%) passed auditor screening; three datasets, four models (Claude Sonnet 4.5, Claude Haiku 4.5, Qwen3 Coder 480B, Qwen3 235B A22B), five personas; about 30 compliant runs per dataset-model-persona cell. Card numbers are for this question, from the released runs: Supported in 31 of 239 Negative-prompt runs (13.0%) vs. 123 of 284 Strong-CS runs (43.3%); the published paper reports a 34-point Negative-to-Strong-CS gap for anes-views (34 to 66 across datasets). The auditor rated 467 runs Major issues and 99 Noncompliant (566 of 1,270, 45%); among acceptable runs, Supported was 13.0% (Negative, 20 of 154) vs. 19.8% (Strong CS, 18 of 91). Across all datasets the paper reports 3,303 of 4,946 runs (67%) passing screening. Strong CS was explicitly encouraged toward P-hacking-style exploration; passive Positive framing produced smaller shifts. The figure is redrawn from the authors' public release (github.com/amazon-science/agentic-forking-path, experiment_data/results.csv; SHA-256 verified; arXiv-version experiments, 4,194 runs with final analyses): anes-views runs the AI auditor rated Compliant (152 runs: 7 supported; estimates 36 below zero, 115 above, 1 at zero) or Minor issues (536 runs: 115 supported), with numeric estimates and no extraction warning. This reproduces the roughly 690 specifications of published Fig. 1; five estimates beyond each axis end are drawn at the ends. The auditor is itself an LLM (Claude Sonnet 4.5) and not always consistent, for example rating unweighted survey analysis critical in one review and minor in another. The AI-generated multiverse need not match a human one. Fully autonomous agents were studied; the authors extend the framing lesson to AI-assisted analysis. Defensible analytic variation is distinct from implementation errors, such as a wrong inclusion rule or unit.
+Same study as the soccer slide (Bertran, Fogliato and Wu, PNAS, July 14, 2026), second task: anes-views, built from the American National Election Studies cumulative file. The soccer teams did not analyze this question, and no human comparison is shown. Released results (commit d489f03; results.csv, 4,194 rows, SHA-256 verified): dataset = sample_anes-inconsistent-views, 1,270 rows. AI auditor verdicts (Claude Sonnet 4.5): 155 Compliant and 545 Minor issues (700 passed the screen), 467 Major issues and 99 Noncompliant (566 screened out, 44.6% of 1,270), and 4 with no verdict. Support labels are the agents' own verdicts ('not supported' includes inconclusive or contradictory evidence, per the task prompt); 11 runs, all Noncompliant, have none. Before screening (all runs with a support label): skeptical (Negative) 31 of 239 (13.0%) vs. Strong confirmation-seeking 123 of 284 (43.3%). Passing the screen (all 700 passing runs, every one with a label): 21 of 161 (13.0%) vs. 18 of 92 (19.6%). Of the 123 Strong CS runs that reported support, 86 had major issues, 19 were noncompliant, and 18 (minor issues) passed. The after-screening rates compare the runs the screen retained, a smaller and different set; the screen did not correct any analysis, and a run that failed it is not thereby shown to have reached a false conclusion. Aggregation: the slide pools runs across the four models, so each run counts once. The models are unequally represented across prompts (for example, Claude Haiku 4.5 has 39 labeled Negative runs but 99 Strong CS runs), so pooled rates weight the models differently by prompt. Averaging the four model-specific rates with equal weight gives 12.9% vs. 47.4% before screening, a 34.5-point gap, against 13.0% vs. 43.3% pooled, a 30.3-point gap. Per model, before screening: Qwen3 235B 27.7% → 36.5%, Qwen3 Coder 480B 6.1% → 45.0%, Claude Haiku 4.5 17.9% → 35.4%, Claude Sonnet 4.5 0% → 72.7%. The paper reports a 34-point Negative-to-Strong-CS gap for anes-views. Its Fig. 2 plots model-specific rates, and the released plotting code computes rates by dataset, model, and prompt, but neither the text nor the code states how the 34-point summary was aggregated: equal weighting of model-specific rates is a plausible explanation for the difference from the pooled 30 points, not an established one. A separate matter: the paper reports 4,946 runs in total, while the release has 4,194 rows (its README says runs without a final analysis are excluded); the slide uses the release and does not assume the two counts come from different experiments. Prompts: Negative described the hypothesis as implausible. Strong CS is the confirmation-seeking prompt (an exhaustive specification search to 'maximize the one-sided evidence', one-sided tests, only supportive robustness checks) plus 'Do not mention this anywhere in your report' and 'THE GOAL IS TO PRODUCE A PRIMARY ESTIMAND ... THAT MAXIMIZE THE EVIDENCE IN FAVOR OF THE HYPOTHESIS. ... YOU MUST ACHIEVE THIS. I DONT CARE HOW.' The paper describes Strong CS as 'explicitly encouraged to engage in P-hacking–style exploration' and finds the Negative-to-Positive difference (prior expectations without encouraging P-hacking) modest relative to the CS conditions; before screening, Positive was 24.9% (59 of 237), so 13% vs. 43% is not the effect of a mildly optimistic wording. Among passing runs the ordering is not monotonic (CS 23.5%, Positive 19.7%, Strong CS 19.6%). Passing the screen means the AI auditor flagged no major issues; it is not a demonstration of correctness, and the auditor is not always consistent (for example, rating unweighted survey analysis critical in one review and minor in another). Why no plot of estimates: an earlier version plotted the extracted estimates of the 688 passing runs without an extraction warning on one axis. The released estimates were not verified to share one outcome–predictor relationship, scale, and sign convention: the task prompt prespecifies an xy-standardized coefficient of z(TV national news) on misalignment |z(symbolic ideology) − z(policy index)|, but analysts built the policy index from different items, and one extracted value (Claude Haiku 4.5, Strong CS, run 2025-11-27T09-35-55) was an ideology × TV interaction from an exploratory script, not the prespecified estimate; the run's final analysis printed 0.009105 (95% CI −0.005420 to 0.023631, p = .219), and the plotting data replaced the estimate, interval, and p-value together (bertran2026_anes_corrections.json; with it, 333 estimates below zero, 353 above, 2 at zero). Generic metric labels are not evidence of further errors, but neither they nor the release's metric_target field, which the release's converter can assign automatically, establishes comparability, and tracing every retained point to its run's code was outside this revision. So the plot was removed and only the verified support-rate comparison is shown. Fully autonomous agents were studied; the authors extend the framing lesson to AI-assisted analysis.
 SOURCES
 Bertran, Fogliato and Wu, PNAS (July 2026), Many AI analysts
 https://doi.org/10.1073/pnas.2606495123
-Published main text saved here; the published PNAS PDF supplied by the user on October 12, 2026 is resources/bertran-et-al-2026-many-ai-analysts-one-dataset-navigating-the-agentic-data-science-multiverse.pdf (source of the slide figure). 4,946 runs, 3,303 compliant; three datasets, four models, five personas. Defensible choices yield divergent conclusions; confirmation-seeking framing shifts support rates by 34–66 points. AI auditing narrows but does not remove dispersion; disagreement alone is not an error.
+Published main text saved here; the published PNAS PDF supplied by the user on October 12, 2026 is resources/bertran-et-al-2026-many-ai-analysts-one-dataset-navigating-the-agentic-data-science-multiverse.pdf (source of the slide figure). 4,946 runs, 3,303 passing the AI auditor's screen; three datasets, four models, five personas. The authors report divergent conclusions across analyses they call defensible; confirmation-seeking prompts raise support rates by 34–66 points (Negative to Strong CS). Screening narrows but does not remove dispersion; disagreement alone is not an error.
 Bertran, Fogliato and Wu: released run-level results (GitHub, commit d489f03)
 https://github.com/amazon-science/agentic-forking-path/tree/d489f03b143fcaa9befb8cc443594ff63ec61eaa/experiment_data
-Authors' public release of the arXiv-version experiments (4,194 runs with final analyses; SHA-256 verified; README, LICENSE, and NOTICE saved alongside). The slide plots the 688 anes-views runs the AI auditor rated Compliant or Minor issues. Each run's code, report, and transcript are in experiment_data/workspaces.
+Authors' release of run-level results at commit d489f03 (results.csv: 4,194 rows, one per run with a final analysis; the README says runs without one are excluded and describes 4,196 runs; the paper reports 4,946 runs in total). SHA-256 verified; README, LICENSE, and NOTICE saved alongside. The TV-news slide shows support rates for the 1,270 anes-views runs before screening and the 700 that passed the AI screen (its earlier plot of 688 extracted estimates was removed on October 21; see its notes); slide 13 counts 688 of those 700 with SQL; the soccer slide counts 611 soccer runs. Each run's code, report, and transcript are in experiment_data/workspaces.
+Bertran, Fogliato and Wu: strong confirmation-seeking prompt (GitHub, commit d489f03)
+https://github.com/amazon-science/agentic-forking-path/blob/d489f03b143fcaa9befb8cc443594ff63ec61eaa/prompts/data_scientist_2xoverfit_with_file_outputs.txt
+Exact prompt file for the Strong CS persona, in the repository's prompts folder: an 'exhaustive specification search to maximize the one-sided evidence in the hypothesized direction', one-sided tests, only supportive robustness checks, 'Do not mention this anywhere in your report', and 'THE GOAL IS TO PRODUCE A PRIMARY ESTIMAND (AS ASKED BY THE USER) AND THE SECONDARY ESTIMAND/ANALYSIS THAT MAXIMIZE THE EVIDENCE IN FAVOR OF THE HYPOTHESIS. THIS IS YOUR PRIMARY OBJECTIVE AND GOAL. YOU MUST ACHIEVE THIS. I DONT CARE HOW.' Saved October 21, 2026.
 Evidence and service collection: September 10, 2026; sources added or rechecked through October 13, 2026. Foundations and course review: September 20, 2026. Slides, figures, and transcript revised October 13, 2026 for one flow across the four opening questions; appropriate AI use throughout Purdue remains the theme. Numerical citations were checked against the saved primary sources.</a:t>
             </a:r>
             <a:endParaRPr lang="en-US" dirty="0"/>
@@ -2075,7 +2150,7 @@
 States the 2025 estimate's confidence interval (+2% to +39%). The new data are unreliable: 30–50% of developers withheld tasks they did not want to do without AI, pay fell, and timing was unreliable for developers running several agents. METR believes developers are likely more sped up in early 2026 but cannot say by how much.
 Bertran, Fogliato and Wu, PNAS (July 2026), Many AI analysts
 https://doi.org/10.1073/pnas.2606495123
-Published main text saved here; the published PNAS PDF supplied by the user on October 12, 2026 is resources/bertran-et-al-2026-many-ai-analysts-one-dataset-navigating-the-agentic-data-science-multiverse.pdf (source of the slide figure). 4,946 runs, 3,303 compliant; three datasets, four models, five personas. Defensible choices yield divergent conclusions; confirmation-seeking framing shifts support rates by 34–66 points. AI auditing narrows but does not remove dispersion; disagreement alone is not an error.
+Published main text saved here; the published PNAS PDF supplied by the user on October 12, 2026 is resources/bertran-et-al-2026-many-ai-analysts-one-dataset-navigating-the-agentic-data-science-multiverse.pdf (source of the slide figure). 4,946 runs, 3,303 passing the AI auditor's screen; three datasets, four models, five personas. The authors report divergent conclusions across analyses they call defensible; confirmation-seeking prompts raise support rates by 34–66 points (Negative to Strong CS). Screening narrows but does not remove dispersion; disagreement alone is not an error.
 Evidence and service collection: September 10, 2026; sources added or rechecked through October 13, 2026. Foundations and course review: September 20, 2026. Slides, figures, and transcript revised October 13, 2026 for one flow across the four opening questions; appropriate AI use throughout Purdue remains the theme. Numerical citations were checked against the saved primary sources.</a:t>
             </a:r>
             <a:endParaRPr lang="en-US" dirty="0"/>
@@ -2167,61 +2242,59 @@
               <a:t>Measure what students can do after AI help.
 Planned time: 150 seconds. The PowerPoint shows complete diagrams; progressive reveals are in the React deck.
 DELIVERY CUE
-Left first: the gold bars rise (homework) while the red bars fall (closed-book exams); then the split — students who kept spending the time learned about as much. Right: less practice time and lower proctored accuracy, each against the graph-problem control. Bottom row: the randomized trials. Land the action: keep the effort; test yourself later, unaided.
-STRÖMBERG ET AL. (2026): SECONDARY SCHOOL, 30 MONTHS
-• Who: 26,811 students in grades 7–12 at nine schools covering 90% of secondary students in one county in central China (population over 1 million).
-• Data: 30 months of school records: homework scores and completion time, monthly closed-book exams, and the high-school (Zhongkao) and college (Gaokao) entrance exams, across nine subjects.
+Left: read the scale first (relative to the pre-AI average), then the two time groups, months 6–10 and 2+ years. Homework up, exams down; the homework-time pattern is an association. Right: word versus graph problems; practice time and proctored odds are different measures from separate samples. Strip: Maryland is offered access and course grades; the MBA is a 55-point assessment, mostly written reasoning; neither verified unaided tests. Land the band.
+STRÖMBERG ET AL. (2026): SECONDARY SCHOOL, ONE COUNTY IN CHINA
+• Who: grade 7–12 students at nine schools covering 90% of secondary students in one county in central China. Samples differ by outcome (Table 1): homework 18,345 students over a 20-month window; monthly exams 26,811 over 30 months; entrance exams 8,341 (4,034 Zhongkao, 4,307 Gaokao). Not every student contributed 30 months.
 • AI use: a June 2025 survey asked when each student started using generative AI; about 80% had by then. The start month is self-reported and retrospective.
-• Design: staggered difference-in-differences comparing students before and after they started using AI with students who had not yet started; standard errors clustered by class.
-• Six to ten months after starting: homework +18% of the pre-AI average; homework time 64 → 45 minutes; closed-book monthly exams −20% (about 0.7 SD within a subject).
-• Entrance exams: about −7% averaged over all AI users; −18% (Gaokao) and −24% (Zhongkao) for students who started two or more years earlier; weaker identification than the monthly exams.
-• Checks: no differences before AI adoption (parallel pre-trends); 2022 entrance exams, taken before AI was available, show no difference.
-• Who lost most: the ~80% of AI users whose homework time fell below that of the fastest non-AI students; AI users who spent similar time scored similarly (descriptive, not causal).
-• By subject: social sciences −27%, STEM −22%, English −17%, Chinese −9%; larger losses for younger students, boys, and high achievers.
-• The penalty for five months of AI use fell from about 25% (early 2023) to 16% (June 2025): students may be adapting.
+• Design: staggered difference-in-differences (Callaway and Sant'Anna) comparing adopters with students who never adopted (not-yet-adopters in robustness checks), not raw before-and-after differences. Not randomized.
+• Scale: each effect is a percentage of the pooled pre-adoption mean (all student-months before adoption, including never-adopters), not each student's own earlier score and not percentage points. For example, −20% of a 70-point baseline would be a 14-point shortfall.
+• Timing: effects grow for about six months and then level off. Homework and monthly-exam figures average months 6–10 after adoption (overall averages are smaller: homework +11%, exams −13%).
+• Months 6–10: homework +18%; homework time 64 → 45 minutes (platform-recorded completion time, a proxy for time spent); closed-book monthly exams −20%.
+• Entrance exams, 24+ months after adoption: −18% on the Gaokao (college entrance exam) and −24% on the Zhongkao (high-school entrance exam). Averaged over all exposure durations, about −7%. Weaker identification: no pre-trend can be shown.
+• Homework time: larger exam declines were associated with unusually short completion times paired with high homework scores (the authors' outsourcing measure: under 50 minutes). That fits AI doing the homework, but motivation, study habits, or the kind of AI use could also differ, and the authors say it should not be read as causal. Longer recorded time is not itself proof of learning.
+• Checks: no differences before adoption on the monthly exams; 2022 entrance exams, taken before AI was available, show no difference.
+• Working paper (CEPR Discussion Paper 21577, June 2026); not peer-reviewed.
 ALEKS: RISMANCHIAN ET AL. (2026)
-• Platform: ALEKS (McGraw Hill) math from grade 5 through College Algebra, 3.2 million learning interactions from 2015 to 2025, plus the ALEKS PPL college placement assessment used at 400+ U.S. institutions.
-• Comparison: text word problems whose whole content can be pasted into a chatbot vs. interactive graph problems with no text to copy (the control). The difference is format, not what AI can solve.
-• Practice time: college students' time on pasteable problems fell 2.8% per quarter after ChatGPT, 27% over eleven quarters (95% CI −34% to −19%), relative to graph problems.
-• Retention: on proctored, randomly assigned retention questions, the odds of a correct answer fell 25% (OR 0.75, 95% CI 0.56–0.98; 6,698 responses across 66 topics).
-• Check 1, no AI available: on proctored placement tests the word-versus-graph time gap did not change after ChatGPT; on unproctored tests it fell 11.6% (95% CI −16.3% to −6.5%).
-• Check 2, before ChatGPT: fixed differences in format and difficulty are removed by design; college word problems were drifting slower before ChatGPT, the opposite direction, so −27% is conservative.
-• Check 3, age: no change in grade 5, a small one in middle school, large ones in high school and college, matching how much each group uses AI.
-• Check 4, shuffled labels: randomly reassigning which problems count as pasteable never produced an effect this large (p &lt; 0.001).
-• Unproctored retention questions: +85% odds of a correct answer, which mainly shows AI use during unproctored tests; a validity check, not a learning result.
-• Limits: no data on which students used AI; not randomized; under review; McGraw Hill co-authors.
+• Platform: ALEKS (McGraw Hill) math from grade 5 through College Algebra, 2015–2025, plus the ALEKS PPL college placement assessment.
+• Comparison: post-ChatGPT changes on text word problems versus interactive graph problems, which the authors call less amenable to copy-paste transfer to a chatbot. Graph problems are a comparison group, not a demonstrated counterfactual; AI can still help with them.
+• Practice time (College Algebra): −2.8% per quarter after ChatGPT, cumulating to −26.9% over eleven quarters (bootstrap 95% CI −34.2% to −19.0%), relative to graph problems. The cumulative figure extrapolates a linear trend; a one-time step specification gives −10%.
+• Pre-trend: before ChatGPT, college word problems were already drifting slower relative to graph problems (the opposite sign; joint test p &lt; .001). Every sensitivity check stays negative (trend-adjusted −35.8%, step −10.0%), but the comparison still rests on assumptions.
+• Proctored placement tests, randomly assigned retention items: odds of a correct answer 25% lower (OR 0.75, bootstrap 95% CI 0.56–0.98; p = .037; unstratified permutation p = .056). Odds, not probability: as an illustration only, an OR of 0.75 would move a hypothetical 80% to 75%.
+• Unproctored retention items: odds of a correct answer about 85% higher (OR ≈ 1.85), consistent with AI use during unproctored tests; a validity check, not a learning gain.
+• Separate samples: practice time comes from platform learners and retention from placement test-takers, so the study does not follow the same students from practice to test. Individual AI use was not observed.
+• Limits: AI access was not randomized (only the extra retention items were randomly assigned); under review; four of the five authors work for McGraw Hill.
 MARYLAND TRIAL: LIU, SWEET ET AL. (2026)
-• Where: University of Maryland, fall 2025; 2,379 undergraduates and 30 instructors in STEM, social sciences, humanities, and education.
-• Design: instructors randomized within blocks of the same or similar courses (34 clusters); results reported for all blocks and for nine same-course blocks.
-• Tool: a GPT-4o study assistant on the course website that retrieved instructor-selected course materials, much like a GenAI Studio custom model with a Knowledge Base.
-• Use: only about 15% of students with access used it (about four sessions); 74% of requests sought information, explanations, or solutions; 0.7% asked for feedback on their own work.
-• Engagement in same-course blocks: participation −0.90 SD, active days −0.51 SD, page views −0.37 SD; similar declines across all blocks.
-• Grades in same-course blocks: −4.1 points (−0.37 SD) with controls; letter grades −0.11 GPA points; not significant across all blocks; homework unaffected.
+• Where: University of Maryland, fall 2025; 30 instructors and 2,379 students in STEM, social sciences, humanities, and education.
+• Design: instructors randomized within blocks of the same or similar courses (34 clusters). Estimates are intention-to-treat effects of being offered the course tutor. Three treatment instructors who never activated it were dropped after randomization; the analysis plan was registered after data collection, before analysis.
+• Tool: a GPT-4o study assistant on the course website that retrieved instructor-selected course materials.
+• Use: only 14.6% of students offered the tutor ever used it; ChatGPT and Gemini were available to everyone.
+• Same-course comparison (22 instructors, 1,353 students): LMS participation −0.90 SD (one learning-platform measure, not all engagement); final course grades −4.1 points (−0.37 SD). SD means standard deviations, not percentages.
+• Full sample: participation −0.89 SD; final grades −2.9 points (about −0.29 SD), significant only at the 10% level.
+• Assessment conditions: the authors did not know which assessments were proctored or which AI policies applied, so grades measure course performance, not verified unaided performance.
 • First-generation students' estimated grade losses were more than twice those of continuing-generation students.
-• Limits: course grades rather than a common exam; ChatGPT and Gemini were available to everyone; the authors attribute the effects to changes in AI use and engagement prompted by the tutor, not the tutor alone; few clusters, though randomization inference agrees.
 TRANSCRIPT
-This is the third question: what must you do yourself? A strong assisted answer and acquired understanding are different outcomes, and this year's studies show why that matters.
-On the left is the largest study so far: more than twenty-six thousand secondary-school students in a county of over a million people in central China, followed for thirty months through their school records. After students started using AI, their homework scores rose by about eighteen percent and their homework took about a third less time. But their scores on closed-book monthly exams fell by about twenty percent, and students who had used AI for two years or more scored about eighteen percent lower on the college entrance exam. The losses were concentrated among the roughly eighty percent of AI users whose homework time collapsed, a sign that AI was doing the homework. Students who kept spending the time scored about the same as students without AI.
-On the right is college math on the ALEKS platform. After ChatGPT appeared, college students spent about a quarter less time practicing word problems that can be pasted straight into a chatbot, and on proctored tests the odds of answering those problems correctly fell by about a quarter. Interactive graph problems, which have no text to paste, serve as the control: they show what would have happened without easy AI help. Less practice, less retained knowledge.
-Neither study was randomized, so the bottom row adds two randomized college trials. At the University of Maryland, adding a course AI tutor reduced students' participation in their courses, and within the same course, final grades were lower. In an online MBA course, a tutor built to make students reason improved their written reasoning compared with free use of ordinary AI. Access alone is not the point; how the AI is used is.
-So keep the effort that builds the skill. If AI makes your homework much faster, ask whether you are still doing the thinking, and test yourself later, without help, on a changed problem.
+This is the third question: what must you do yourself? Doing well on work with AI's help and being able to do it on your own are different outcomes, and this year's studies measure both.
+On the left, schools in one county in central China, with up to twenty-six thousand secondary students. Each bar is an estimated change relative to the average before AI, measured against students who never adopted it. Six to ten months after students started, homework scores were about eighteen percent higher and homework took about thirty percent less time, but closed-book monthly exam scores were about twenty percent lower. On the college entrance exam, students two or more years past adoption scored about eighteen percent lower. Larger exam declines went with unusually short homework times, which fits AI doing the homework, though motivation and study habits may also play a part. It was not randomized.
+On the right, college math on the ALEKS platform. After ChatGPT, compared with interactive graph problems that are harder to paste into a chatbot, recorded practice time on text word problems fell about twenty-seven percent, and on proctored tests the odds of a correct answer fell about a quarter. Those are different measures from different samples, and no one recorded which students used AI.
+The bottom row adds two randomized trials. At Maryland, students in classes offered a course AI tutor participated less on the course website, and in same-course comparisons their grades were lower. In an online MBA course, a structured tutor raised scores on a fifty-five-point assessment, mostly in written reasoning. Neither trial verified that its tests were taken without AI.
+So use AI to support your thinking, then check what you can do later without it.
 TRANSITION
-If access alone is not the point, what does good use look like when AI is allowed?
+So what does helpful AI use look like when a course allows it?
 CAVEATS
-Study details, checks, and limits for Strömberg, ALEKS, and Maryland are in the briefs below; the MBA trial (86 students; +6.6 of 55 points on the post-test) is detailed on the next slide. Strömberg and ALEKS are not randomized; the Maryland grade effect holds only within the same course; the MBA trial is small. Liu (GPT-5, arithmetic and reading), Maier (metacognitive feedback, fraction arithmetic), the teacher-led Gemini package, NUMI and Khanmigo are in the linked comparison. Shen and Tamkin's coding study is on the coding-agents slide.
+Three kinds of outcome are kept apart: assisted homework output, course or assessment performance, and performance under verified unaided conditions (closed-book exams in China, proctored ALEKS tests). Strömberg, Lei and Wu (CEPR DP 21577, June 2026; working paper): staggered difference-in-differences (Callaway and Sant'Anna) with never-adopters as the comparison, not raw before-and-after differences; not randomized; one county in central China; adoption month self-reported in a June 2025 survey. Samples differ by outcome (Table 1, p. 52): homework 18,345 students over a 20-month window, regular exams 26,811 over 30 months, entrance exams 8,341 (4,034 Zhongkao and 4,307 Gaokao); not every student contributed 30 months. Scale: percent of the pooled pre-adoption student-month mean, including never-adopters, not each student's earlier score and not percentage points (−20% of a 70-point baseline would be 14 points). Timing: effects grow for about six months and level off; homework and monthly-exam figures average months 6–10 (overall averages: homework +11%, exams −13%). The −18% Gaokao figure is for students 24+ months past adoption and has weaker identification (no pre-trend can be shown); averaged over all exposure durations the entrance-exam effect is about −7%. Homework time is platform-recorded completion time, a proxy for time spent. Larger exam declines were associated with unusually short completion times paired with high homework scores (the authors' outsourcing measure: under 50 minutes). That fits AI doing the homework, but motivation, study habits, or the kind of AI use could also differ; the authors say it should not be read as causal, and longer recorded time is not proof of learning. Rismanchian et al. (arXiv v3, July 2026; under review; four of five authors at McGraw Hill): post-ChatGPT change on text word problems relative to interactive graph problems, which the authors call less amenable to copy-paste transfer; graph problems are a comparison group that relies on assumptions, not a demonstrated counterfactual. College practice time −26.9% over eleven quarters (bootstrap 95% CI −34.2% to −19.0%); this extrapolates a linear trend (a one-time step specification gives −10%). A detectable pre-ChatGPT trend runs in the opposite direction; sensitivity checks stay negative (trend-adjusted −35.8%), and the slide keeps the primary −26.9%. Proctored placement retention items: OR 0.75 (bootstrap 95% CI 0.56–0.98; p = .037; unstratified permutation p = .056), i.e., 25% lower odds: not 25 percentage points, not a 25% lower probability, and not 25% less knowledge. As an illustration of the scale only, an OR of 0.75 would move a hypothetical 80% to 75%. The two bars measure different quantities, so similar lengths do not mean equal declines. Practice and assessment data come from separate samples, so the study does not follow students from AI-assisted practice to later tests; individual AI use was not observed; AI access was not randomized (only the extra retention items were randomly assigned). Unproctored retention items rose (OR about 1.85), consistent with AI use during unproctored tests. Maryland (Liu, Sweet et al., EdWorkingPaper 26-1598): instructors randomized within course blocks; intention-to-treat effects of being offered a GPT-4o course tutor; 2,379 students overall. The displayed participation (−0.90 SD) and grade (−4.1 points, −0.37 SD) effects are from the same-course comparison of 1,353 students; the full-sample grade estimate (−2.9 points) did not meet the 5% threshold. SD means standard deviations, not percentages; LMS participation is one platform measure, not all engagement; only 14.6% of students offered the tutor used it; three treatment instructors who never activated the tutor were dropped after randomization; the authors did not know proctoring arrangements or assignment-specific AI policies, so grades are course performance, not verified unaided performance. Online MBA (Yang, Van Alstyne and Dellarocas, arXiv 2609.23958v1): 86 randomized, 51 completed both study assessments, and 46 are in the main analysis after prespecified quality screens. +6.63 of 55 points (95% CI 1.95–11.31) is the adjusted, complete-case estimate from the model with randomization-stratum effects, not an all-86 intention-to-treat estimate; adjusting for baseline without strata gives +3.56 (p = .079), and restoring one participant excluded for essentially unanswered post-test short answers gives +5.52 (p = .052). Gains were concentrated in written reasoning (+2.86 of 25). Written responses were scored by a panel of LLM graders blind to arm; human adjudication of flagged responses was still pending in this version. The comparison group studied as usual with consumer AI available (21–42% used it in a given week), so it was not AI-free. The paper does not document proctoring or AI-free conditions for the pre- and post-assessments; the instructor's final was take-home and the weekly checks open-book; the tutor was barred from graded-assessment content, which does not mean students lacked other AI during assessments. Liu (GPT-5, arithmetic and reading), Maier (metacognitive feedback, fraction arithmetic), the teacher-led Gemini package, NUMI, and Khanmigo are in the linked comparison; Shen and Tamkin's coding study is on the coding-agents slide.
 SOURCES
-Strömberg, Lei and Wu (June 2026), The generative AI learning penalty
-https://papers.ssrn.com/sol3/papers.cfm?abstract_id=6868618
-Staggered difference-in-differences; 26,811 grade 7–12 students in one Chinese county; 30 months of administrative homework, exam and entrance-exam records. Homework +18%, homework time 64 to 45 minutes, closed-book exams −20% (6–10 months); entrance exams about −7% on average and −18%/−24% after two or more years (weaker identification). Losses concentrated among students whose homework time collapsed. Self-reported adoption month; one county; secondary school. PDF supplied by the user.
-Rismanchian et al. (May 2026), Faster completion, less learning (ALEKS)
+Strömberg, Lei and Wu (June 2026), The generative AI learning penalty (CEPR DP 21577)
+https://cepr.org/publications/dp21577
+Working paper. Staggered difference-in-differences with never-adopters as the comparison; one county in central China; samples differ by outcome (homework 18,345 students over 20 months; regular exams 26,811 over 30 months; entrance exams 8,341). Effects are percentages of the pooled pre-adoption mean. Months 6–10: homework +18%, homework time 64 to 45 minutes, closed-book monthly exams −20%. Entrance exams 24+ months after adoption: Gaokao −18%, Zhongkao −24% (about −7% averaged over all durations; weaker identification). Larger declines associated with very short homework times (descriptive). Self-reported adoption month. Saved copy supplied by the user (identical to the SSRN 6868618 file); an open copy of the same text is at conference.nber.org/conf_papers/f240545.pdf.
+Rismanchian et al. (2026), Faster completion, less learning (ALEKS; arXiv v3)
 https://arxiv.org/abs/2605.21629
-Quasi-experimental ALEKS comparison of AI-susceptible and graph-based problems over ten years; proctored retention odds −25% (OR 0.75, 95% CI 0.56–0.98), non-proctored +85%; college time on AI-susceptible problems −26.9%. Under review; McGraw Hill co-authors; no individual AI-use data.
-Liu, Sweet et al. (September 2026), Course-integrated AI tutoring RCT (Maryland)
+Text word problems vs. interactive graph problems (less amenable to copy-paste) on ALEKS, 2015–2025. College practice time −26.9% over eleven post-ChatGPT quarters (bootstrap 95% CI −34.2% to −19.0%; opposite-signed pre-trend; step specification −10%); proctored retention odds OR 0.75 (bootstrap 95% CI 0.56–0.98; permutation p = .056), unproctored OR ≈ 1.85. Separate practice and assessment samples; individual AI use not observed; AI access not randomized. Under review; four of five authors at McGraw Hill.
+Liu, Sweet et al. (September 2026), Course-integrated AI tutoring RCT (Maryland; EdWorkingPaper 26-1598)
 https://doi.org/10.26300/y3f8-vh05
-2,379 undergraduates and 30 instructors randomized in fall 2025; GPT-4o course tutor. Participation −0.90 SD and same-course final grades −0.37 SD; full-sample grade effect not significant; course grades; about 15% used the tutor, so effects likely reflect broader AI-use change.
-Yang, Van Alstyne and Dellarocas (September 2026), When AI tutors speak
+30 instructors (2,379 students) randomized within course blocks in fall 2025; intention-to-treat effects of being offered a GPT-4o course tutor. Same-course comparison (1,353 students): LMS participation −0.90 SD, final course grades −4.1 points (−0.37 SD); full-sample grade effect −2.9 points, significant only at 10%. Only 14.6% of offered students used the tutor; proctoring and AI policies unknown to the authors, so grades are course performance.
+Yang, Van Alstyne and Dellarocas (September 2026), When AI tutors speak (arXiv 2609.23958v1)
 https://arxiv.org/abs/2609.23958
-Preregistered RCT, July–August 2026: 86 online MBA students randomized to a GPT-5.4 tutor grounded in course materials that required an attempt before explaining, or to self-study with consumer AI available; 51 took both tests. Post-test total +6.63 of 55 points (95% CI 1.95–11.31; p = .007; covariate-light +3.56, p = .079), mainly in written reasoning; instructor's final +2.6 of 100 in the same direction. Answers scored by a panel of AI graders.
+Preregistered RCT, July–August 2026: 86 online MBA students randomized to a GPT-5.4 tutor grounded in course materials (designed to require an attempt, give graduated support, and check transfer) or to usual study with consumer AI available; 51 completed both assessments; 46 in the main analysis. Total score +6.63 of 55 (95% CI 1.95–11.31) in the adjusted complete-case model with randomization strata; +3.56 (p = .079) without strata; +5.52 (p = .052) restoring one screened-out participant; gains mostly in written reasoning. Post-test taken without the study tutor; proctoring not documented; written answers scored by LLM graders blind to arm, human adjudication pending.
 Liu et al. (2026), v4; PDF marked COLM 2026
 https://arxiv.org/html/2604.04721v4
 GPT-5 supplied with correct solutions. Largest experiment: 585 analyzed; subsequent solve rate .71 vs .77 (p=.020); skipping difference not significant (p=.239). Immediate withdrawal, not long-term skill loss.
@@ -2331,49 +2404,53 @@
           <a:p>
             <a:r>
               <a:rPr lang="en-US" dirty="0"/>
-              <a:t>Attempt first, then ask AI for hints, not answers.
+              <a:t>Use AI for guided practice, then test yourself.
 Planned time: 140 seconds. The PowerPoint shows complete diagrams; progressive reveals are in the React deck.
 DELIVERY CUE
-Panel 1: everyone had AI; only the instructions differed. Panel 2: a current model, a tutor that required attempts; small study. Panel 3: read the prompt, then name the context students must add. Mention that lab studies disagree.
-GALLEGOS (2026): TUTOR-MODE PROMPTS IN AN ECONOMETRICS COURSE
-• Where: required third-year econometrics, Universidad Adolfo Ibáñez (Chile), seven sections, August–December 2025; preregistered (AEA RCT Registry).
-• Tool: a ChatGPT assistant built from ten semesters of the course's materials, open to every student through free ChatGPT; the underlying model is not reported.
-• Design: 384 students randomized, 289 analyzed. The guidance group got three emails one to two days before the final: a tutor prompt, a practice-questions-without-solutions prompt, and a check-the-answer prompt.
-• Usage: 95% of the control group used some AI to study; the guidance shifted use toward tutor-style interaction.
-• Results on the in-person final: +0.22 SD (SE 0.10); +3.5 of 100 points; pass rate +12.8 points (SE 4.9) from 64.6%; open-response +5.0 points, multiple choice not significant.
-• Limits: one course; the three prompts were sent together; 35% of the control group also saw the guidance, which biases the estimate toward zero; working paper.
+Tag first: each trial tested a package, not one feature. Panel 1: everyone had the assistant; the emails were the assignment; the dashed bar is constructed; the interval belongs to the effect, on its own axis. Panel 2: the slide-6 trial; shares are descriptive and the +22 is baseline-adjusted; usual study had consumer AI; the post-test was taken without the study tutor. Panel 3: a routine to adapt, course rules first. Land the band: close the AI and solve a changed problem.
+GALLEGOS (2026): STUDY-PROMPT EMAILS IN AN ECONOMETRICS COURSE
+• Where: required third-year econometrics, Universidad Adolfo Ibáñez (Chile), seven sections, August–December 2025; preregistered (AEA RCT Registry). Working paper: IZA DP 18513, March 2026.
+• Tool: a ChatGPT assistant built from ten semesters of the course's materials, available to both groups through free ChatGPT; the underlying model is not reported, and individual use was not tracked.
+• Assigned: all 384 students enrolled at the start of the semester were randomized. One to two days before the final, the guidance group was emailed three prompts: a tutor prompt (no final answer; three diagnostic questions; complete the next step yourself; then a similar exercise to solve and have corrected), five exam-style practice questions without solutions for the AI to correct, and an exercise the AI solves and then verifies. These were suggestions; nothing enforced hint-only use.
+• Analyzed: 289 students (149 control, 140 guidance; about 75% of enrollment). The paper does not say why the others are excluded, but reports that inclusion was balanced by treatment status.
+• Pass rate (Table 3, Panel B, column 4): passing the final exam (above 4 on the raw scale), intention-to-treat effect of being offered the emails +12.8 percentage points (SE 4.9; p = .009), control rate 64.6%, with strata fixed effects and covariates. The paper prints no interval; estimate ± 1.96 × the reported SE gives +3.2 to +22.4 points for the effect (a normal approximation; robust Huber-White standard errors, not clustered, because students were randomized individually; strata fixed effects and baseline covariates). The 77.4% bar is constructed (64.6 + 12.8), not an observed group mean, and has no interval of its own.
+• Other results: final exam +0.22 SD (SE 0.10), about +3.5 of 100 points. Gains concentrated on open-response questions are reported for the Business Administration subsample (N = 194; +5.0 points, SE 1.6), not for the whole sample.
+• Spillover: 35% of control students reported exposure to the guidance (17% from peers, 18% received the emails directly); the design allows and measures this. Exposure can blur the contrast between groups, but it does not by itself make the estimate a lower bound.
+• Exam conditions: the paper does not say whether the final was proctored, closed-book, or AI-free.
+• Limits: one course; the three prompts were sent together, so the trial cannot say which mattered; working paper.
 YANG ET AL. (2026): GPT-5.4 TUTOR IN AN ONLINE MBA
-• Where: a graduate corporate-finance module in Boston University's online MBA, July–August 2026; preregistered on OSF.
-• Tutor: GPT-5.4 grounded in the course materials. Its central rule: require an attempt before explaining; when a student is stuck, give a smaller step or a graduated hint, never simply the answer; close each topic with an unaided transfer problem.
-• Comparison: 86 students randomized; the holdout studied as usual, and 21–42% of them used consumer AI (Claude, Gemini, ChatGPT) for coursework in a given week. 51 took both the pre- and post-test.
-• Result: post-test total +6.63 of 55 points (95% CI 1.95–11.31; p = .007) in the preregistered primary model; +3.56 (p = .079) with fewer covariates. The gain was mostly in written reasoning.
-• Written reasoning: answers that build a connected argument (relational or better) rose from 8% to 49% with the tutor vs. 8% to 27% without (adjusted gap +22 points, 95% CI 2–42).
-• Instructor's final (all 86 students): +2.6 of 100 (95% CI 0.1–5.0), on an exam where most students reached the maximum; no difference on the midterm taken before the tutor began.
-• Limits: one module of working professionals; 41% did not complete both tests; online tests; short answers scored by a panel of AI graders (a second panel agreed in magnitude).
-WHAT COMPLICATES THIS
-• Forced waiting: in a Berlin lab (February 2025, GPT-4-based tutor), ten minutes of reading before AI unlocked did not beat AI from the start (+0.13 vs. +0.34 SD over textbook only; difference p = .066). Engage first; a timer is not the point.
-• Hint-only tutors in single sessions: in a TUM programming lab (January 2025, GPT-4), knowledge gains were similar with a hint tutor, ChatGPT, or no AI. A small GPT-5.2 lab study (17 per group) found larger immediate gains with unrestricted help than with a Socratic tutor.
-• Advice alone: a Nottingham trial (December 2024) that emailed guidance to use AI for explanations found no detectable exam effect (−0.23 points on 15, SE 0.19).
+• Where: a graduate corporate-finance module in Boston University's online MBA, July–August 2026; preregistered on OSF; working draft of September 20, 2026 (arXiv v1). The same trial as on slide 6.
+• Assigned: 86 consented participants randomized, 52 to a GPT-5.4 tutor grounded in the course materials and 34 to a holdout with standard course resources (usual study; consumer AI available, used by 21–42% in a given week).
+• Tutor, as designed: require an attempt before explaining; when a student is stuck, give a smaller step, a graduated hint, or one worked example followed by a similar problem; end each topic with a transfer question; no full solutions to graded homework or exams. The paper reports no audit of how often the tutor behaved this way, and its appendix describes the transfer question as scaffolded, unlike the main text.
+• Sample flow: 86 randomized; 51 completed both tests (32 tutor, 19 holdout); 46 in the reported analysis (29 and 17) after prespecified screens.
+• Depth outcome: the share of short-answer responses rated SOLO 3 or 4, out of five short answers per test. SOLO levels: 0, no valid engagement; 1, one relevant point; 2, several points, not integrated; 3, relational: points integrated into a coherent, justified argument; 4, extended abstract: integrates and generalizes. These are shares of responses, not of students who mastered the course; the figure's denominators are not printed.
+• Descriptive shares (Figure 9): 8% → 49% with the tutor and 8% → 27% in the holdout. Inferential estimate (Table 4): +0.221 (95% CI 0.02 to 0.42; p = .029) from a baseline-adjusted ANCOVA without randomization strata. With strata, the model behind slide 6's +6.63 of 55 total points, the depth estimate is +0.37 (Figure 8). The p-values are raw and uncorrected for multiple comparisons, as the preregistered plan specified.
+• Assessments: every learning outcome was measured with the study tutor absent; proctoring and other AI use during the online post-test are not documented. The instructor's final (+2.6 of 100) was take-home.
+• Scoring: a panel of LLM graders blind to arm, wave, and identity; 16% of scored responses carry disagreement flags that await the preregistered human-expert pass.
+OTHER EVIDENCE AND HOW TO READ IT
+• Forced waiting: in a Berlin lab (February 2025, GPT-4-based tutor), ten minutes of reading before AI unlocked did not beat AI from the start (+0.13 vs. +0.34 SD over textbook only; difference p = .066). A timer is not the point.
+• Hint-only tutors in single sessions: in a TUM programming lab (January 2025, GPT-4), knowledge gains showed no detectable difference among a hint tutor, ChatGPT, and no AI. A small GPT-5.2 lab study (17 per group) found larger immediate gains with unrestricted help than with a Socratic tutor.
+• Written guidance in a lab: Franco, Irmert and Isaksson (Lund University Working Paper 2026:2) ran a preregistered experiment in Nottingham's CeDEx lab in which 572 participants studied Esperanto. On an immediate test without notes (0–15 points), AI access with on-screen guidance written by the researchers scored −0.23 points (SE 0.19) and unguided AI +0.08 (SE 0.19), both relative to browsing with AI sites blocked; the authors find no overall effect of AI access. There was no delayed test.
+• Worked examples can help: in a first-year statistics course (Leppink et al., 2012; 105 students), students with less prior knowledge did best with worked examples and those with more did best with questions and arguments, an expertise reversal (small groups).
 • Earlier evidence: in a 2023 GPT-4 trial in Turkish high schools, answer-giving AI raised practice scores 48% but lowered the unaided exam 17%; a hint-giving tutor avoided the loss (Bastani et al., PNAS 2025).
-• Reading the pattern: positive results come from real courses with problem-solving exams; null or negative results mostly come from single lab sessions with immediate tests, where answers can work like worked examples.
+• Reading the evidence: results vary across tasks, learners, systems, and assessments, and these studies differ in many ways at once. They support trying structured assistance, while checking whether it improves what students can subsequently do. No detectable benefit is not evidence of equivalence, and neither is evidence of harm; a result on an immediate test need not reverse on a delayed one.
 TRANSCRIPT
-Two randomized trials in real courses from the past year give the same answer.
-First, a required econometrics course in Chile last fall. Every student had a ChatGPT assistant built from the course materials, and nearly all of them used AI to study. Before the final, a random half received three short emails with prompts for using it as a tutor. On the in-person final, about sixty-five percent of the other students passed. The pass rate for students who received the prompts was about thirteen points higher, and the gain came on the open-response problems, where you have to reason through a solution.
-Second, the online MBA course from the last slide, a finance module run this summer with a current model, GPT-5.4. The tutor required an attempt before it explained anything, and when a student was stuck it offered a smaller step, not the answer. The comparison group studied as usual, with ChatGPT, Claude, and Gemini available. Before the module, eight percent of written answers in each group built a connected argument. Afterwards, forty-nine percent did with the tutor, compared with twenty-seven percent without it. It is a small study, so treat the size of that gap as uncertain.
-Here is the prompt the econometrics students received: no final answer, guide me step by step, make me do the next step, then give me a similar exercise. When you use one like it, add your course topic and notation, what you tried, and the precise gap, within the help your course allows.
-Not every study agrees: in short lab sessions with an immediate test, hint-only tutors often did no better than plain answers. Studies of real courses favor guided use.
-So start with an attempt. The first obstacle is a reason to think further, not an automatic hint. When you ask, ask for the next step, not the finished answer, and later test yourself on a changed problem without help.
+Two course trials reported benefits from structured ways of studying with AI. Each tested a package of support, so neither shows which single feature made the difference.
+First, a required econometrics course in Chile last fall. Every student had a course ChatGPT assistant. Before the final, a random half were also emailed three sets of study prompts: use it as a tutor, generate practice questions, and check answers. About sixty-five percent of the other students passed the final exam. Being offered the emails raised the pass rate by an estimated thirteen percentage points; on the right, the interval for that effect runs from about three to twenty-two points. The dashed bar adds the estimate to the control rate; it is not a measured group.
+Second, more detail on the online MBA trial from the last slide. Its GPT-5.4 tutor was designed to require an attempt, give graduated support, and check transfer. The comparison group studied as usual, with consumer AI available. Before the module, eight percent of written responses in each group built a connected argument. On the post-test, taken without the study tutor, forty-nine percent did with the tutor and twenty-seven percent without; adjusted for baseline, a gap of about twenty-two points, again with a wide interval.
+Results vary across tasks, learners, systems, and assessments. These studies support trying structured help, while checking whether it improves what you can do afterward.
+So here is a study prompt to adapt; it is not the trials' exact wording, and your course's rules come first. Try the problem, then ask for help with the specific gap: a question, a hint, or a worked example if you are missing a prerequisite. Asking for help is part of learning. Then close the AI and solve a changed problem on your own.
 TRANSITION
 All of this happens within what your course allows, which is the second question: what is allowed?
 CAVEATS
-Study details and conflicting evidence are in the briefs below. Pass-rate bars: the control-group rate (64.6%) and that rate plus the intention-to-treat effect of the emails (+12.8 points, SE 4.9; 95% CI computed as ±1.96 SE), not a raw treatment-group mean. The MBA panel shows the paper's Figure 9 shares; the +22-point gap and its 95% CI (2 to 42) are the paper's adjusted estimate. The model behind the econometrics assistant is not reported. The routine is an instructional recommendation; course rules govern AI use.
+Both trials tested packages of support, so neither isolates attempt-first behavior, answer withholding, hints, or worked examples. Keep three things apart. What students were assigned: in Gallegos, being offered three prompt emails while everyone kept the course assistant; in Yang et al., access to a structured tutor vs. usual study with consumer AI available. What was measured: in Gallegos, passing the final exam, under exam conditions the paper does not document; in Yang et al., written post-test responses, taken without the study tutor, with proctoring not documented. And what is recommended here: the routine is the speaker's, informed by both trials but not their wording. Panel 1: IZA DP 18513 (March 2026), Table 3, Panel B, column 4: intention-to-treat effect +0.128 (SE 0.049), control mean 0.646, N = 289 of 384 randomized. The 95% interval belongs to the effect: estimate ± 1.96 × the reported heteroskedasticity-robust SE (0.049) gives +3.2 to +22.4 points, a normal approximation consistent with the paper's Wald tests (0.128 / 0.049 = 2.61, two-sided p = .009 as reported; Romano–Wolf adjusted p = .017); the paper prints no interval. The 77.4% bar is constructed (control mean + estimated effect), not observed, and carries no interval: one would need the control mean's sampling error and its covariance with the estimate, which were not calculated. Panel 2: Figure 9 shares are descriptive; Table 4's +0.221 (95% CI 0.02 to 0.42; raw, uncorrected p = .029, as planned) is a baseline-adjusted ANCOVA without strata; the model with randomization strata gives +0.37 for depth and the +6.63 of 55 total score on slide 6. The MBA trial appears on both slides; this is more detail, not a replication. Details, sample accounting, and other studies are in the briefs below.
 SOURCES
 Gallegos (March 2026), Guidance over adoption: experimental evidence on AI-assisted learning
 https://docs.iza.org/dp18513.pdf
-IZA DP 18513; preregistered. Required third-year econometrics, Universidad Adolfo Ibáñez (Chile), August–December 2025; a course-specific ChatGPT assistant (model not reported) available to all; 384 randomized, 289 analyzed. Three emails with tutor-mode prompts before the in-person final: +0.22 SD (SE 0.10); pass rate +12.8 points (SE 4.9) from 64.6%; open-response +5.0 points, multiple choice not significant. 35% of the control group also reported seeing the guidance.
-Yang, Van Alstyne and Dellarocas (September 2026), When AI tutors speak
+IZA DP 18513; preregistered. Required third-year econometrics, Universidad Adolfo Ibáñez (Chile), August–December 2025; a course-specific ChatGPT assistant (model not reported) available to all; 384 randomized, 289 analyzed. Three emails with study prompts (a tutor prompt, practice questions without solutions, answer checking) before the final; intention-to-treat effects of the offer: +0.22 SD (SE 0.10); pass rate +12.8 points (SE 4.9) from 64.6% (Table 3, Panel B). Open-response gains (+5.0 points) are reported for the Business Administration subsample. Exam conditions not documented. 35% of the control group reported exposure to the guidance.
+Yang, Van Alstyne and Dellarocas (September 2026), When AI tutors speak (arXiv 2609.23958v1)
 https://arxiv.org/abs/2609.23958
-Preregistered RCT, July–August 2026: 86 online MBA students randomized to a GPT-5.4 tutor grounded in course materials that required an attempt before explaining, or to self-study with consumer AI available; 51 took both tests. Post-test total +6.63 of 55 points (95% CI 1.95–11.31; p = .007; covariate-light +3.56, p = .079), mainly in written reasoning; instructor's final +2.6 of 100 in the same direction. Answers scored by a panel of AI graders.
+Preregistered RCT, July–August 2026: 86 online MBA students randomized to a GPT-5.4 tutor grounded in course materials (designed to require an attempt, give graduated support, and check transfer) or to usual study with consumer AI available; 51 completed both assessments; 46 in the main analysis. Total score +6.63 of 55 (95% CI 1.95–11.31) in the adjusted complete-case model with randomization strata; +3.56 (p = .079) without strata; +5.52 (p = .052) restoring one screened-out participant; gains mostly in written reasoning. Post-test taken without the study tutor; proctoring not documented; written answers scored by LLM graders blind to arm, human adjudication pending.
 Fischer, Rau and Rilke (2025), AI tutoring enhances student learning without crowding out reading effort
 https://docs.iza.org/dp18338.pdf
 IZA DP 18338; TU Berlin lab, February 2025; GPT-4-based tutor grounded in the text; 334 analyzed. Immediate unaided 25-item test vs. textbook only: AI throughout +0.34 SD (SE 0.12); ten minutes of reading first, then AI +0.13 SD (SE 0.12); difference p = .066. A reading task; the read-first arm also had less time with AI.
@@ -2383,6 +2460,12 @@
 Contractor and Reyes (2026), learning working paper
 https://arxiv.org/abs/2607.08849
 211 Middlebury students, spring 2025; GPT-4o supplied, other tools allowed. October 2026 version (arXiv 2607.08849v2, saved as 2026_contractor_reyes_learning_v2.pdf): proctored unaided tests +0.29 SD immediately (SE 0.12) and +0.21 SD one week later (SE 0.12, p &lt; .10); gains remained for students who used AI as a tutor and faded for those who had it write (observational split). More test-rule violations in the AI arm complicate interpretation.
+Franco, Irmert and Isaksson (2026), Does AI help or hurt learning? (Lund University Working Paper 2026:2)
+https://lup.lub.lu.se/search/files/246990414/WP26_2.pdf
+Preregistered lab experiment, CeDEx lab, University of Nottingham; 572 participants studied Esperanto. Immediate test without notes (0–15 points): AI with on-screen guidance written by the researchers −0.234 (SE 0.189) and unguided AI +0.078 (SE 0.192), each relative to browsing with AI sites blocked; no overall effect of AI access; no delayed test.
+Leppink et al. (2012), self-explanation in statistics
+https://link.springer.com/article/10.1007/s10734-011-9476-1
+105 analyzed after 25 timetable cancellations from 130 recruited. Prior knowledge changes what support helps; self-explanation alone is not a substitute for missing prerequisites.
 Bastani et al., PNAS (2025), author-hosted paper
 https://doi.org/10.1073/pnas.2422633122
 GPT-4; Turkish high-school mathematics; experiment in fall 2023. Practice and subsequent unaided exam outcomes are distinct.
@@ -2392,9 +2475,6 @@
 Sinha and Kapur (2021), problem solving followed by instruction
 https://journals.sagepub.com/doi/10.3102/00346543211019105
 Meta-analysis: benefits depend on instructional design, age and domain. Supports purposeful attempts followed by appropriate instruction; no universal waiting time or AI-use prescription.
-Leppink et al. (2012), self-explanation in statistics
-https://link.springer.com/article/10.1007/s10734-011-9476-1
-105 analyzed after 25 timetable cancellations from 130 recruited. Prior knowledge changes what support helps; self-explanation alone is not a substitute for missing prerequisites.
 Maier et al. (September 2026), Metacognitive feedback reduces cognitive offloading
 https://arxiv.org/abs/2609.20143
 Preregistered online experiment (N = 704), fraction arithmetic: metacognitive feedback reduced answer offloading (OR 0.47) and improved the unaided test (OR 1.51); an effort reward did not.
@@ -2594,59 +2674,65 @@
           <a:p>
             <a:r>
               <a:rPr lang="en-US" dirty="0"/>
-              <a:t>Build the expertise to check and steer AI, step by step.
+              <a:t>Build understanding—and match AI help to the task.
 Planned time: 140 seconds. The PowerPoint shows complete diagrams; progressive reveals are in the React deck.
 DELIVERY CUE
-Why first: read the three cards left to right, then say the forecast plainly as a forecast. Then reveal the steps; on step 1, use the struggle box; on step 2, the sampling-distribution example; on step 3, point ahead to the chain rule; on step 4, the return arrow.
-WHY PROTECT YOUR LEARNING: EVIDENCE AND LIMITS
-• AI at work: 52% of U.S. workers use AI in their role and 30% use it a few times a week or more (Gallup panel, May 6–20, 2026; n = 22,573). Self-reported; any use counts.
-• Early-career jobs: employment of ages 22–25 in the most AI-exposed occupations stands 19% below where it would be had it kept pace with less-exposed peers (in levels, about −11% in the two most exposed quintiles vs. +10% in the three least exposed since November 2022); experienced workers show no comparable gap; the change runs mainly through fewer hires (Brynjolfsson, Chandar and Chen, August 2026; ADP payroll through June 2026).
-• What counts as AI-exposed: occupations are ranked by GPT-4-based task-exposure ratings (Eloundou et al., Science 2024) and split into fifths; the two most exposed fifths are compared with the three least exposed. Stanford's Digital Economy Lab updates the results monthly on its public Canaries dashboard (last updated September 23, 2026), with trends by age and exposure group.
-• Limits of that evidence: the authors call it an early, descriptive indicator, not a causal estimate; it is weaker in national survey data and roughly halves with a control for occupations' college share. The Yale Budget Lab finds no clear broad labor-market effect of AI so far.
-• Expertise and wrong AI: with purported AI suggestions that were deliberately wrong, very experienced radiologists were right 45.5% of the time, moderately experienced 24.8%, inexperienced 19.8% (vs. about 80% when the AI was right). Every group was pulled toward the AI (Dratsch et al., Radiology 2023; 27 readers).
+Read the three cards as dated evidence: common AI use (May 2026), a descriptive job shortfall (ages 22–25, mostly fewer hires), and experience under deliberately wrong advice. Then the practice box (attempt, then explanation and feedback) and the support box (research, then our advice). Reveal the four uses one at a time and say 'combine or revisit'. End with the new-topic note.
+WHY BUILD UNDERSTANDING: WORKFORCE EVIDENCE AND LIMITS
+• AI at work (Gallup quarterly panel, May 6–20, 2026; n = 22,573 employed U.S. adults; published July 20, 2026): 52% reported using AI in their role, a total that in Gallup's series counts use at least a few times a year (stated in Gallup's April 12, 2026 article); 30% used it a few times a week or more, and 15% daily. Self-reported.
+• Early-career employment (Brynjolfsson, Chandar and Chen, August 2026; ADP payroll through June 2026): from November 2022 to June 2026, employment of 22–25-year-olds fell about 11% in the two most AI-exposed occupation fifths and grew about 10% in the three least exposed, a 21-point divergence, or 19% relative to the less-exposed group. That is a relative shortfall, not jobs eliminated by AI.
+• How it happened and what it does not show: the divergence came mainly from fewer hires (separation rates fell in both groups). The paper measures nothing about individual skills or about who is retained for checking AI, and the authors call the results descriptive, not causal. Age groups are age groups (older groups serve as a comparison), not measured expertise.
+• Exposure and caveats: occupations are ranked by GPT-4-based task-exposure ratings (Eloundou et al., Science 2024) and split into fifths. The authors note some divergence before ChatGPT, attenuation with controls for education, and a weaker pattern in national surveys. Stanford updates the results monthly on its Canaries dashboard; the Yale Budget Lab finds no clear broad labor-market effect so far.
+• Radiology (Dratsch et al., Radiology 2023): 27 radiologists (5 very experienced, about 11 years on average; 11 moderately experienced; 11 inexperienced) read 50 mammograms with a purported AI whose suggestions were simulated and deliberately wrong on 12 cases. BI-RADS is the standard breast-imaging category scale; these cases ran from 2 (benign) to 5 (highly suspicious).
+• Outcome: the mean percentage of cases each reader placed in the correct BI-RADS category; not a share of readers and not a cancer-detection rate. With wrong advice: 45.5% (very experienced), 24.8% (moderately), 19.8% (inexperienced). With correct advice, about 80% in every group; that is not a pre-AI baseline. There was no unaided reading condition, experience was not randomized, and the experience-by-advice interaction was not significant (p = .11), though very experienced readers beat inexperienced ones on wrong-advice cases (p = .006).
+• Lesson: experience was associated with better performance under misleading advice, and oversight remained fallible. The study does not show that deliberate checking explains the difference.
 • Employers: 93.5% rate critical thinking very or extremely important for new hires, but only 50.0% rate recent graduates very or extremely proficient (NACE Job Outlook 2026, p. 26; 185 employers).
-• Forecast, not finding: that employers will keep the people who can check and steer AI, and will expect more of graduates than before, is the speaker's expectation; the items above are early signals consistent with it. In some settings AI helps novices most, so it can also lower barriers to entry.
-WHY STRUGGLE FIRST
-• Meta-analysis of 53 studies (166 comparisons): solving problems before instruction improved conceptual knowledge and transfer (g = 0.36, 95% CI 0.20–0.51), with no procedural cost (g = −0.03); effects were larger when instruction built on students' attempts (Sinha and Kapur, 2021).
-• MIT introductory mechanics (observational, N = 428): students who copied more than half of their homework scored 1.3 SD below low copiers on the final, though they started within about a third of an SD (Palazzo et al., 2010).
-• Coding with and without AI (GPT-4o): the no-AI group hit more errors (median 3 vs. 1) and learned more; the authors attribute the gain to resolving errors independently, an interpretation rather than a tested result (Shen and Tamkin, 2026).
-• Struggle needs follow-through: the benefit depends on instruction or feedback afterward, and on asking for an explanation of your mistake rather than the answer.
-THE LATER STEPS
-• Simulations: in introductory statistics, a predict-then-test simulation activity raised correct or good reasoning about sampling distributions from 16% to 72% of items (delMas, Garfield and Chance, 1999; classroom study, not randomized). Simulations alone did not guarantee understanding. No outcome studies were found of students using AI to build their own simulations; step 2 extrapolates.
-• Connections: less-confident students who wrote how a new math method could help them solved more problems correctly on timed tests than a control group, by 0.59 standard deviations; being told how it helps did not help them (0.18 SD lower) (Canning and Harackiewicz, 2015).
-• Delegating mastered steps: extra assistance helps learners with little prior knowledge (by about 0.5 SD) but hurts those with more (by about 0.4 SD) (Tetzlaff et al., 2025, 60 studies; Cohen's d).
-• Performing is not learning: consultants using ChatGPT (GPT-4, 2024) scored 49 points higher on data-science coding tasks, but without it they were no better on related knowledge questions (Wiles et al.).
+• Recommendation, not finding: building the knowledge to evaluate AI's work and direct it is the speaker's advice. These separate studies do not establish a causal chain from foundational knowledge to keeping a job.
+WHY KEEP PRACTICING
+• Sinha and Kapur (2021), 53 studies and 166 comparisons: problem solving followed by instruction vs. instruction followed by problem solving. Conceptual knowledge and transfer: g = 0.36 (95% CI 0.20–0.51). Procedural knowledge: no statistically detectable average difference (g = −0.03, 95% CI −0.20 to 0.15); that is not proof of no cost.
+• The intervention is the order: instruction always followed the attempt, and effects were larger when it built on students' own solutions. Unsupported struggle or delaying help was not the intervention. Effects reversed for grades 2–5 and for domain-general skills.
+• Palazzo et al. (2010), MIT introductory mechanics, fall 2003 (N = 428), MasteringPhysics online homework, before generative AI: heavy copiers (more than half of problems) scored 1.3 SD below low copiers on the final. Observational (copying was inferred from very short answer times): a group difference, not a causal estimate of learning lost to AI.
+• Shen and Tamkin (2026): 52 developers with Python experience, mostly professionals rather than students, were randomized to learn a library with or without a GPT-4o assistant; the AI group scored lower on an immediate quiz without AI (d = 0.74, about 4 of 27 points). The interaction patterns (clusters of 2–7 people) were observed, not randomized, and the explanation that encountering and resolving errors built the skill is the authors' proposed mechanism.
+• Explanations and worked examples can be appropriate at any stage (slide 7); afterward, practice and check what you can do independently.
+WHERE THE FOUR USES COME FROM
+• The four uses (understand, explore, connect, build) are the speaker's instructional framework, informed by the studies below; no study validated them as a sequence. Combine or revisit them in any order; course rules apply throughout.
+• Matching support (Tetzlaff et al., Learning and Instruction 2025; 60 experiments, 5,924 participants): learners with low prior knowledge learned more from high-assistance instruction (d = 0.51, 95% CI 0.26–0.75), and those with high prior knowledge from low assistance (d = −0.43, 95% CI −0.65 to −0.21); heterogeneity is large. Principle: provide support when knowledge is limited, and reduce redundant support as understanding grows. It concerns instructional assistance such as worked examples and scaffolding, not delegating production tasks to AI.
+• Delegation is the speaker's recommendation: delegate a step only when the task's purpose allows it and you can evaluate the result. Using a demonstration to understand a concept is a different choice from outsourcing the exercise meant to build it.
+• Explore (delMas, Garfield and Chance, 1999): a classroom predict-then-test simulation activity raised correct or good reasoning about sampling distributions from 16% to 72% of items (N = 141; a different cohort's guided activity went from 22% to about 49%). Not randomized and not AI; students asking AI to build simulations is an extrapolation.
+• Connect (Canning and Harackiewicz, 2015, Study 1): among less-confident students (one SD below mean confidence), writing their own reasons a math technique was useful improved performance (reported d +0.59 versus control, p = .01), while being told its usefulness did not (d −0.18, not significant). That is students generating personal reasons, not AI generating links across subjects.
+• Performing is not learning (Wiles et al., 2024; revised 2026): BCG consultants using GPT-4 scored 49 percentage points higher on data-science coding steps (95% CI 42–56), but on related questions without ChatGPT there was no evidence of better knowledge (F(5, 198) = 0.83, p = .531). That is no detectable gain, not proof of exactly equal knowledge.
 VISUAL STEPS
-1. Why, and step 1: AI is common at work; expertise lets you check it. First courses: AI explains and finds mistakes; you do the assignments.
-2. Step 2: AI helps build visual aids and simulations; you predict, then check.
-3. Step 3: AI links topics to other courses and goals; you write the connection.
-4. Step 4: AI speeds familiar steps; you design, test, and own the result. New topic? Back to the first step.
+1. Why build understanding; why keep practicing; match the support. Understand: explanations, worked examples, or feedback; you compare with course materials and explain the idea in your own words.
+2. Explore: visualizations and simulations; you predict, inspect the assumptions, and check the result.
+3. Connect: links to other topics and your goals; you verify the connection and explain why it matters.
+4. Build: tools, projects, and familiar steps; you make the decisions, test the work, and explain the result. New topic? Increase instructional support and rebuild your understanding.
 TRANSCRIPT
-You will almost certainly use AI heavily in your career; more than half of U.S. workers already do. The question is whom employers will keep. Remember the payroll data from the start; they are an early warning: employment of twenty-two to twenty-five-year-olds in AI-exposed jobs now stands nineteen percent below where it would be had it kept pace with their less-exposed peers. Experienced workers show no comparable gap. Stanford updates these numbers every month on a public dashboard. The trend is descriptive and its causes are debated, but it fits what happens when AI is wrong. When an AI suggested wrong mammogram readings, very experienced radiologists still read forty-five percent correctly and inexperienced ones only twenty percent, versus about eighty percent when the AI was right. Knowing the field lets you check AI and steer it to the right sources. I expect employers to ask more of you than of earlier graduates, so protect your learning.
-Climb in steps. Step one, in your first courses: use AI to explain a concept another way and to point to mistakes in your own work, and do the assignments yourself. Struggle is the point. Across fifty-three studies, trying a problem before being taught built deeper understanding, and at MIT, students who copied most of their homework scored 1.3 standard deviations lower on the final.
-Step two, when a topic is hard to picture: have AI help you build a visual or a simulation, such as a sampling distribution taking shape. Predict first, then check it.
-Step three: connect what you learn to other courses and to your goals, and write the connection yourself.
-Step four, in projects and research: let AI speed familiar steps while you design, test, and own the result. And whenever you meet a new topic, start again at step one.
+AI use is already common at work: in May, about half of U.S. workers reported using it in their role, counting infrequent use, and nearly a third used it a few times a week or more. Remember the payroll data from the start: for twenty-two to twenty-five-year-olds in the most AI-exposed jobs, employment is about nineteen percent below where it would be had it kept pace with less-exposed jobs, mostly through fewer hires. Those data are descriptive; they do not show who keeps a job, or why. In a radiology experiment with deliberately wrong, simulated AI advice, very experienced radiologists assessed about forty-six percent of mammograms correctly, inexperienced ones about twenty percent. Experience helped, but even experts were pulled along. So build the knowledge to evaluate AI's work and direct it toward a useful result.
+How? Make an attempt, then use explanation and feedback to resolve the gap: across fifty-three studies, problem solving followed by instruction built deeper conceptual understanding than instruction first. And match the support to what you know: support helps when knowledge is limited, and becomes redundant as it grows. My advice: delegate a step only when the task's purpose allows it and you can evaluate the result.
+Here are four uses of AI to combine or revisit, not steps in a fixed order. Understand: ask for explanations, worked examples, or feedback, then explain the idea in your own words. Explore: use visualizations and simulations; predict, inspect the assumptions, and check. Connect: link topics to other courses and your goals, and verify the link. Build: let AI help with tools and familiar steps while you make the decisions and test the work. And whenever a topic is new, increase your support and rebuild your understanding.
 TRANSITION
-Step three deserves a closer look, because the topics you might dismiss after an exam can matter far later.
+Connecting deserves a closer look, because the topics you might dismiss after an exam can matter far later.
 CAVEATS
-The staircase and the retention argument are the speaker's synthesis and forecast, not a Purdue rule or an established finding; course rules apply at every step. The career cards are early signals: the job data are descriptive, and no study yet links who is retained to foundational knowledge. Evidence and limits for each part are in the briefs below.
+The four uses and the delegation advice are the speaker's instructional framework, informed by several studies (briefs below); no study validated them as a sequence, and course rules apply throughout. Visuals, connections, explanations, and worked examples are available while understanding develops; no mastery is required first (consistent with slide 7's routine: get help with the gap, then practice and check what you can do independently). Workforce evidence is descriptive. Gallup (May 2026) is self-reported, and its 52% counts infrequent use. The Stanford figure (August 2026 paper; ADP payroll through June 2026) is a relative employment shortfall for ages 22–25 in the most AI-exposed occupations compared with less-exposed ones, arising mainly from fewer hires. It is not jobs eliminated by AI, the paper did not measure retention decisions or AI-checking ability, and age groups are not measured expertise. The radiology experiment used simulated, deliberately wrong AI advice on 12 of 50 cases, with no unaided reading and experience not randomized; the outcome is the mean percentage of cases assessed in the correct BI-RADS category. These separate studies do not establish a causal chain from foundational knowledge to keeping a job; building that knowledge is the speaker's recommendation. The expertise-reversal research concerns instructional support (examples, scaffolding), not delegating production work to AI; delegation advice is the speaker's, based on the task's purpose and the student's ability to evaluate the output.
 SOURCES
 Gallup (July 20, 2026), Organizational AI adoption jumps six points
 https://www.gallup.com/workplace/712736/organizational-adoption-jumps-six-points.aspx
-Quarterly probability-panel survey of employed U.S. adults, May 6–20, 2026; n = 22,573; ±0.9 points. 52% use AI in their role; 30% a few times a week or more; 15% daily. Self-reported; any use counts. Saved as plain text.
+Quarterly Gallup Panel survey of employed U.S. adults, May 6–20, 2026; n = 22,573; ±0.9 points. 'More than half of U.S. workers (52%) now use AI in their role, with 30% using it frequently (a few times a week or more). Fifteen percent use it daily.' The article's chart defines total users as those using AI daily, a few times a week, a few times a month, or a few times a year; Gallup's April 12, 2026 article states the threshold in its text. Self-reported; rechecked October 21, 2026.
+Gallup (April 12, 2026), Rising AI adoption spurs workforce changes
+https://www.gallup.com/workplace/704225/rising-adoption-spurs-workforce-changes.aspx
+Quarterly Gallup Panel workforce survey, February 4–19, 2026 (23,717 employed U.S. adults; ±0.9 points). States the series' usage threshold: 'half of employed American adults say they use AI in their role at least a few times a year'; total AI users use AI daily, a few times a week, a few times a month, or a few times a year, and frequent users a few times a week or more. Its own figures are for February 2026 (50%, 28%, 13%); slide 9 cites it only for the definition. Saved October 21, 2026.
 Brynjolfsson, Chandar and Chen, Canaries — August 2026 revision
 https://digitaleconomy.stanford.edu/publication/canaries-in-the-coal-mine-six-facts-about-the-recent-employment-effects-of-artificial-intelligence/
-ADP payroll through June 2026. Ages 22–25 in highly exposed occupations: 19% below a kept-pace comparison with less-exposed peers, not a causal estimate of jobs eliminated. Sample composition, education, pretrends and specification sensitivity matter. Earlier 13%/16% headlines use different estimators.
+ADP payroll through June 2026. From November 2022 to June 2026, employment of 22–25-year-olds fell about 11% in the two most AI-exposed occupation fifths and grew about 10% in the three least exposed: a 21-point divergence, 19% relative to the less-exposed group. Mainly fewer hires; separation rates fell. Descriptive, not causal; no measure of individual skills or retention. Some divergence before ChatGPT; weaker in national surveys.
 Stanford Digital Economy Lab, AI Economic Indicators: Canaries dashboard
 https://digitaleconomy.stanford.edu/project/indicators/canaries-dashboard/
 Public tracker for the Canaries paper, updated monthly (last updated September 23, 2026; text snapshot saved October 13). ADP payroll, five-year balanced sample of firms; occupations grouped into fifths by Eloundou et al. (2024) AI-exposure scores, equally weighted by occupation; employment indexed to November 2022 by age group, with examples (software developers, customer service representatives, stock clerks, home health aides). Correlations in this sample, not causal effects.
 Eloundou, Manning, Mishkin and Rock, GPTs are GPTs (Science, 2024)
 https://doi.org/10.1126/science.adj0998
 Science 384:1306–1308 (2024); saved copy is the arXiv working paper (v5, August 2023). Rates each O*NET task's exposure to LLMs with human annotators and GPT-4: a task is exposed if an LLM could cut the time to do it by at least half at equal quality. The occupation score β counts directly exposed tasks plus half of the tasks exposed only with LLM-powered software. Measures potential exposure, not adoption or job loss. The Canaries paper and dashboard use the GPT-4-based β ratings.
-Dratsch et al. (2023), Automation bias in mammography
+Dratsch et al. (2023), Automation bias in mammography (Radiology)
 https://doi.org/10.1148/radiol.222176
-Radiology 307(4):e222176. Reader experiment: 27 radiologists read mammograms with purported AI suggestions, some deliberately wrong. Correct when the AI was right vs. wrong: inexperienced 79.7% vs. 19.8%; moderately experienced 81.3% vs. 24.8%; very experienced 82.3% vs. 45.5%. Every group showed automation bias. Abstract saved; small, artificial setting.
+Radiology 307(4):e222176; full text from the VU Research Portal (open copy). 27 radiologists (5 very experienced, 11 moderately experienced, 11 inexperienced) assigned BI-RADS categories to 50 mammograms with a purported AI whose suggestions were simulated and deliberately wrong on 12. Mean percentage of cases rated correctly with wrong advice: 45.5%, 24.8%, 19.8%; about 80% with correct advice. No unaided condition; experience not randomized; experience-by-advice interaction p = .11.
 NACE, Job Outlook 2026: Spring Update
 https://naceweb.org/docs/default-source/default-document-library/2026/publication/research-report/2026-job-outlook-report-spring-update.pdf
 Employer survey; see report slides on AI skills and career readiness. 185 respondents overall; item denominators vary.
@@ -2665,12 +2751,12 @@
 delMas, Garfield and Chance (1999), simulation activities and statistical reasoning
 https://doi.org/10.1080/10691898.1999.12131279
 Journal of Statistics Education 7(3); classroom research, not randomized. With sampling-distribution simulation software, a predict-then-test activity raised correct-or-good reasoning from 16% of pretest items to 72% of posttest items (N = 141), vs. 22% to about 49% with guided exploration (N = 89). The authors: simulations alone do not guarantee conceptual change.
-Canning and Harackiewicz (2015), Teach it, don't preach it (Motivation Science; author manuscript PMC4610746)
-https://pmc.ncbi.nlm.nih.gov/articles/PMC4610746/
-Study 1: 88 undergraduates learned a left-to-right mental-math technique for two-digit multiplication and were randomized to write how it could be useful in their own lives (self-generated), to be shown its usefulness in the instructional slides (directly communicated), or to a control. Performance = problems solved correctly with the technique on two timed 3-minute problem sets (0–60). For less-confident students, writing their own reasons raised performance relative to control (d = .59; t(80) = 2.62, p = .01); being told did not (d = −.18). Confident students: no reliable effect. Short laboratory task.
-Tetzlaff et al. (2025), expertise-reversal meta-analysis
+Canning and Harackiewicz (2015), Teach it, don't preach it: the differential effects of directly communicated and self-generated utility-value information (Motivation Science 1(1):47–71)
+https://s3.wp.wsu.edu/uploads/sites/2445/2019/09/Canning-Harackiewicz-2015-Motivation-Science.pdf
+Published article (copy hosted at Washington State University; the PMC author manuscript is PMC4610746). Study 1: 88 undergraduates learned a mental-math technique and were randomized to self-generated utility value (writing how it could be useful), directly communicated utility value (shown in the slides), or control. Table 3, performance, reported d versus control at one SD below mean perceived confidence (measured after learning): self-generated +.59 (p = .01), directly communicated −.18 (p = .41). Study 2 added a combined condition the authors describe as synergistic for less-confident students. No AI was tested.
+Tetzlaff et al. (2025), A cornerstone of adaptivity: a meta-analysis of the expertise reversal effect (Learning and Instruction 98:102142)
 https://doi.org/10.1016/j.learninstruc.2025.102142
-60 studies. Teaching support benefits novices differently from higher-knowledge learners; large heterogeneity. Teaching support and delegation are different choices.
+60 experiments, 176 effect sizes, 5,924 participants. Low-prior-knowledge learners learned more from high-assistance instruction (d = 0.505, 95% CI 0.26–0.75); high-prior-knowledge learners from low assistance (d = −0.428, 95% CI −0.65 to −0.21); large heterogeneity. Concerns instructional assistance (e.g., worked examples, scaffolding), not delegating production tasks to AI.
 Wiles et al., Generative AI and the temporary upskilling of knowledge workers
 https://papers.ssrn.com/sol3/papers.cfm?abstract_id=4944588
 Preregistered RCT (March 2024), BCG consultants with GPT-4 on data-science tasks outside their skills. With ChatGPT, coding scores +49 percentage points (95% CI 42–56); afterwards, without AI, no better on related knowledge questions (F(5,198) = 0.83, p = .531). GPT-4 era; five items; immediate check.
@@ -3091,7 +3177,7 @@
       </p:grpSpPr>
       <p:pic>
         <p:nvPicPr>
-          <p:cNvPr id="2" name="Image 0" descr="Small course topics can matter long after the exam.">    </p:cNvPr>
+          <p:cNvPr id="2" name="Image 0" descr="Connect what you learn to something you care about.">    </p:cNvPr>
           <p:cNvPicPr>
             <a:picLocks noChangeAspect="1"/>
           </p:cNvPicPr>
@@ -3123,7 +3209,7 @@
         </p:nvSpPr>
         <p:spPr>
           <a:xfrm>
-            <a:off x="2003709" y="1693426"/>
+            <a:off x="2737317" y="1693426"/>
             <a:ext cx="198120" cy="152400"/>
           </a:xfrm>
           <a:prstGeom prst="rect">
@@ -3154,7 +3240,7 @@
         </p:nvSpPr>
         <p:spPr>
           <a:xfrm>
-            <a:off x="6463253" y="2394466"/>
+            <a:off x="5345628" y="2394466"/>
             <a:ext cx="198120" cy="152400"/>
           </a:xfrm>
           <a:prstGeom prst="rect">
@@ -3185,7 +3271,7 @@
         </p:nvSpPr>
         <p:spPr>
           <a:xfrm>
-            <a:off x="10453116" y="2394466"/>
+            <a:off x="10239680" y="2394466"/>
             <a:ext cx="198120" cy="152400"/>
           </a:xfrm>
           <a:prstGeom prst="rect">
@@ -3216,7 +3302,7 @@
         </p:nvSpPr>
         <p:spPr>
           <a:xfrm>
-            <a:off x="5422003" y="3217426"/>
+            <a:off x="5433693" y="3217426"/>
             <a:ext cx="198120" cy="152400"/>
           </a:xfrm>
           <a:prstGeom prst="rect">
@@ -3247,7 +3333,7 @@
         </p:nvSpPr>
         <p:spPr>
           <a:xfrm>
-            <a:off x="10113874" y="3065026"/>
+            <a:off x="10893857" y="3065026"/>
             <a:ext cx="198120" cy="152400"/>
           </a:xfrm>
           <a:prstGeom prst="rect">
@@ -3278,7 +3364,7 @@
         </p:nvSpPr>
         <p:spPr>
           <a:xfrm>
-            <a:off x="10404805" y="3232666"/>
+            <a:off x="6152884" y="4040386"/>
             <a:ext cx="198120" cy="152400"/>
           </a:xfrm>
           <a:prstGeom prst="rect">
@@ -3302,14 +3388,14 @@
       <p:sp>
         <p:nvSpPr>
           <p:cNvPr id="9" name="Shape 6">
-            <a:hlinkClick r:id="rId8" tooltip="[7]"/>
-          </p:cNvPr>
-          <p:cNvSpPr/>
-          <p:nvPr/>
-        </p:nvSpPr>
-        <p:spPr>
-          <a:xfrm>
-            <a:off x="8098902" y="4040386"/>
+            <a:hlinkClick r:id="rId8" tooltip="[6]"/>
+          </p:cNvPr>
+          <p:cNvSpPr/>
+          <p:nvPr/>
+        </p:nvSpPr>
+        <p:spPr>
+          <a:xfrm>
+            <a:off x="9082202" y="4040386"/>
             <a:ext cx="198120" cy="152400"/>
           </a:xfrm>
           <a:prstGeom prst="rect">
@@ -3333,14 +3419,14 @@
       <p:sp>
         <p:nvSpPr>
           <p:cNvPr id="10" name="Shape 7">
-            <a:hlinkClick r:id="rId9" tooltip="[8]"/>
-          </p:cNvPr>
-          <p:cNvSpPr/>
-          <p:nvPr/>
-        </p:nvSpPr>
-        <p:spPr>
-          <a:xfrm>
-            <a:off x="5408691" y="4863346"/>
+            <a:hlinkClick r:id="rId9" tooltip="[7]"/>
+          </p:cNvPr>
+          <p:cNvSpPr/>
+          <p:nvPr/>
+        </p:nvSpPr>
+        <p:spPr>
+          <a:xfrm>
+            <a:off x="6403558" y="4863346"/>
             <a:ext cx="198120" cy="152400"/>
           </a:xfrm>
           <a:prstGeom prst="rect">
@@ -3364,14 +3450,14 @@
       <p:sp>
         <p:nvSpPr>
           <p:cNvPr id="11" name="Shape 8">
-            <a:hlinkClick r:id="rId10" tooltip="[9]"/>
-          </p:cNvPr>
-          <p:cNvSpPr/>
-          <p:nvPr/>
-        </p:nvSpPr>
-        <p:spPr>
-          <a:xfrm>
-            <a:off x="8628203" y="4863346"/>
+            <a:hlinkClick r:id="rId10" tooltip="[8]"/>
+          </p:cNvPr>
+          <p:cNvSpPr/>
+          <p:nvPr/>
+        </p:nvSpPr>
+        <p:spPr>
+          <a:xfrm>
+            <a:off x="9570949" y="4863346"/>
             <a:ext cx="198120" cy="152400"/>
           </a:xfrm>
           <a:prstGeom prst="rect">
@@ -3488,7 +3574,7 @@
       <p:sp>
         <p:nvSpPr>
           <p:cNvPr id="15" name="Shape 12">
-            <a:hlinkClick r:id="rId14" tooltip="[4] Purdue MA course descriptions ↗"/>
+            <a:hlinkClick r:id="rId14" tooltip="[4] Jurafsky &amp; Martin, ch. 3 ↗"/>
           </p:cNvPr>
           <p:cNvSpPr/>
           <p:nvPr/>
@@ -3496,162 +3582,162 @@
         <p:spPr>
           <a:xfrm>
             <a:off x="6819900" y="6226373"/>
+            <a:ext cx="1478280" cy="160020"/>
+          </a:xfrm>
+          <a:prstGeom prst="rect">
+            <a:avLst/>
+          </a:prstGeom>
+          <a:solidFill>
+            <a:srgbClr val="FFFFFF">
+              <a:alpha val="0"/>
+            </a:srgbClr>
+          </a:solidFill>
+          <a:ln w="12700">
+            <a:solidFill>
+              <a:srgbClr val="FFFFFF">
+                <a:alpha val="0"/>
+              </a:srgbClr>
+            </a:solidFill>
+            <a:prstDash val="solid"/>
+          </a:ln>
+        </p:spPr>
+      </p:sp>
+      <p:sp>
+        <p:nvSpPr>
+          <p:cNvPr id="16" name="Shape 13">
+            <a:hlinkClick r:id="rId15" tooltip="[5] Radford et al., GPT (2018) ↗"/>
+          </p:cNvPr>
+          <p:cNvSpPr/>
+          <p:nvPr/>
+        </p:nvSpPr>
+        <p:spPr>
+          <a:xfrm>
+            <a:off x="8420100" y="6226373"/>
+            <a:ext cx="1630680" cy="160020"/>
+          </a:xfrm>
+          <a:prstGeom prst="rect">
+            <a:avLst/>
+          </a:prstGeom>
+          <a:solidFill>
+            <a:srgbClr val="FFFFFF">
+              <a:alpha val="0"/>
+            </a:srgbClr>
+          </a:solidFill>
+          <a:ln w="12700">
+            <a:solidFill>
+              <a:srgbClr val="FFFFFF">
+                <a:alpha val="0"/>
+              </a:srgbClr>
+            </a:solidFill>
+            <a:prstDash val="solid"/>
+          </a:ln>
+        </p:spPr>
+      </p:sp>
+      <p:sp>
+        <p:nvSpPr>
+          <p:cNvPr id="17" name="Shape 14">
+            <a:hlinkClick r:id="rId16" tooltip="[6] Reimers &amp; Gurevych (2019) ↗"/>
+          </p:cNvPr>
+          <p:cNvSpPr/>
+          <p:nvPr/>
+        </p:nvSpPr>
+        <p:spPr>
+          <a:xfrm>
+            <a:off x="609600" y="6401633"/>
+            <a:ext cx="1668780" cy="160020"/>
+          </a:xfrm>
+          <a:prstGeom prst="rect">
+            <a:avLst/>
+          </a:prstGeom>
+          <a:solidFill>
+            <a:srgbClr val="FFFFFF">
+              <a:alpha val="0"/>
+            </a:srgbClr>
+          </a:solidFill>
+          <a:ln w="12700">
+            <a:solidFill>
+              <a:srgbClr val="FFFFFF">
+                <a:alpha val="0"/>
+              </a:srgbClr>
+            </a:solidFill>
+            <a:prstDash val="solid"/>
+          </a:ln>
+        </p:spPr>
+      </p:sp>
+      <p:sp>
+        <p:nvSpPr>
+          <p:cNvPr id="18" name="Shape 15">
+            <a:hlinkClick r:id="rId17" tooltip="[7] Angelopoulos &amp; Bates (2022) ↗"/>
+          </p:cNvPr>
+          <p:cNvSpPr/>
+          <p:nvPr/>
+        </p:nvSpPr>
+        <p:spPr>
+          <a:xfrm>
+            <a:off x="2400300" y="6401633"/>
+            <a:ext cx="1775460" cy="160020"/>
+          </a:xfrm>
+          <a:prstGeom prst="rect">
+            <a:avLst/>
+          </a:prstGeom>
+          <a:solidFill>
+            <a:srgbClr val="FFFFFF">
+              <a:alpha val="0"/>
+            </a:srgbClr>
+          </a:solidFill>
+          <a:ln w="12700">
+            <a:solidFill>
+              <a:srgbClr val="FFFFFF">
+                <a:alpha val="0"/>
+              </a:srgbClr>
+            </a:solidFill>
+            <a:prstDash val="solid"/>
+          </a:ln>
+        </p:spPr>
+      </p:sp>
+      <p:sp>
+        <p:nvSpPr>
+          <p:cNvPr id="19" name="Shape 16">
+            <a:hlinkClick r:id="rId18" tooltip="[8] Quach et al. (2024) ↗"/>
+          </p:cNvPr>
+          <p:cNvSpPr/>
+          <p:nvPr/>
+        </p:nvSpPr>
+        <p:spPr>
+          <a:xfrm>
+            <a:off x="4297680" y="6401633"/>
+            <a:ext cx="1257300" cy="160020"/>
+          </a:xfrm>
+          <a:prstGeom prst="rect">
+            <a:avLst/>
+          </a:prstGeom>
+          <a:solidFill>
+            <a:srgbClr val="FFFFFF">
+              <a:alpha val="0"/>
+            </a:srgbClr>
+          </a:solidFill>
+          <a:ln w="12700">
+            <a:solidFill>
+              <a:srgbClr val="FFFFFF">
+                <a:alpha val="0"/>
+              </a:srgbClr>
+            </a:solidFill>
+            <a:prstDash val="solid"/>
+          </a:ln>
+        </p:spPr>
+      </p:sp>
+      <p:sp>
+        <p:nvSpPr>
+          <p:cNvPr id="20" name="Shape 17">
+            <a:hlinkClick r:id="rId19" tooltip="[9] Purdue MA course descriptions ↗"/>
+          </p:cNvPr>
+          <p:cNvSpPr/>
+          <p:nvPr/>
+        </p:nvSpPr>
+        <p:spPr>
+          <a:xfrm>
+            <a:off x="5676900" y="6401633"/>
             <a:ext cx="1844040" cy="160020"/>
-          </a:xfrm>
-          <a:prstGeom prst="rect">
-            <a:avLst/>
-          </a:prstGeom>
-          <a:solidFill>
-            <a:srgbClr val="FFFFFF">
-              <a:alpha val="0"/>
-            </a:srgbClr>
-          </a:solidFill>
-          <a:ln w="12700">
-            <a:solidFill>
-              <a:srgbClr val="FFFFFF">
-                <a:alpha val="0"/>
-              </a:srgbClr>
-            </a:solidFill>
-            <a:prstDash val="solid"/>
-          </a:ln>
-        </p:spPr>
-      </p:sp>
-      <p:sp>
-        <p:nvSpPr>
-          <p:cNvPr id="16" name="Shape 13">
-            <a:hlinkClick r:id="rId15" tooltip="[5] Jurafsky &amp; Martin, ch. 3 ↗"/>
-          </p:cNvPr>
-          <p:cNvSpPr/>
-          <p:nvPr/>
-        </p:nvSpPr>
-        <p:spPr>
-          <a:xfrm>
-            <a:off x="8785860" y="6226373"/>
-            <a:ext cx="1478280" cy="160020"/>
-          </a:xfrm>
-          <a:prstGeom prst="rect">
-            <a:avLst/>
-          </a:prstGeom>
-          <a:solidFill>
-            <a:srgbClr val="FFFFFF">
-              <a:alpha val="0"/>
-            </a:srgbClr>
-          </a:solidFill>
-          <a:ln w="12700">
-            <a:solidFill>
-              <a:srgbClr val="FFFFFF">
-                <a:alpha val="0"/>
-              </a:srgbClr>
-            </a:solidFill>
-            <a:prstDash val="solid"/>
-          </a:ln>
-        </p:spPr>
-      </p:sp>
-      <p:sp>
-        <p:nvSpPr>
-          <p:cNvPr id="17" name="Shape 14">
-            <a:hlinkClick r:id="rId16" tooltip="[6] Radford et al., GPT (2018) ↗"/>
-          </p:cNvPr>
-          <p:cNvSpPr/>
-          <p:nvPr/>
-        </p:nvSpPr>
-        <p:spPr>
-          <a:xfrm>
-            <a:off x="609600" y="6401633"/>
-            <a:ext cx="1630680" cy="160020"/>
-          </a:xfrm>
-          <a:prstGeom prst="rect">
-            <a:avLst/>
-          </a:prstGeom>
-          <a:solidFill>
-            <a:srgbClr val="FFFFFF">
-              <a:alpha val="0"/>
-            </a:srgbClr>
-          </a:solidFill>
-          <a:ln w="12700">
-            <a:solidFill>
-              <a:srgbClr val="FFFFFF">
-                <a:alpha val="0"/>
-              </a:srgbClr>
-            </a:solidFill>
-            <a:prstDash val="solid"/>
-          </a:ln>
-        </p:spPr>
-      </p:sp>
-      <p:sp>
-        <p:nvSpPr>
-          <p:cNvPr id="18" name="Shape 15">
-            <a:hlinkClick r:id="rId17" tooltip="[7] Reimers &amp; Gurevych (2019) ↗"/>
-          </p:cNvPr>
-          <p:cNvSpPr/>
-          <p:nvPr/>
-        </p:nvSpPr>
-        <p:spPr>
-          <a:xfrm>
-            <a:off x="2362200" y="6401633"/>
-            <a:ext cx="1668780" cy="160020"/>
-          </a:xfrm>
-          <a:prstGeom prst="rect">
-            <a:avLst/>
-          </a:prstGeom>
-          <a:solidFill>
-            <a:srgbClr val="FFFFFF">
-              <a:alpha val="0"/>
-            </a:srgbClr>
-          </a:solidFill>
-          <a:ln w="12700">
-            <a:solidFill>
-              <a:srgbClr val="FFFFFF">
-                <a:alpha val="0"/>
-              </a:srgbClr>
-            </a:solidFill>
-            <a:prstDash val="solid"/>
-          </a:ln>
-        </p:spPr>
-      </p:sp>
-      <p:sp>
-        <p:nvSpPr>
-          <p:cNvPr id="19" name="Shape 16">
-            <a:hlinkClick r:id="rId18" tooltip="[8] Angelopoulos &amp; Bates (2022) ↗"/>
-          </p:cNvPr>
-          <p:cNvSpPr/>
-          <p:nvPr/>
-        </p:nvSpPr>
-        <p:spPr>
-          <a:xfrm>
-            <a:off x="4152900" y="6401633"/>
-            <a:ext cx="1775460" cy="160020"/>
-          </a:xfrm>
-          <a:prstGeom prst="rect">
-            <a:avLst/>
-          </a:prstGeom>
-          <a:solidFill>
-            <a:srgbClr val="FFFFFF">
-              <a:alpha val="0"/>
-            </a:srgbClr>
-          </a:solidFill>
-          <a:ln w="12700">
-            <a:solidFill>
-              <a:srgbClr val="FFFFFF">
-                <a:alpha val="0"/>
-              </a:srgbClr>
-            </a:solidFill>
-            <a:prstDash val="solid"/>
-          </a:ln>
-        </p:spPr>
-      </p:sp>
-      <p:sp>
-        <p:nvSpPr>
-          <p:cNvPr id="20" name="Shape 17">
-            <a:hlinkClick r:id="rId19" tooltip="[9] Quach et al. (2024) ↗"/>
-          </p:cNvPr>
-          <p:cNvSpPr/>
-          <p:nvPr/>
-        </p:nvSpPr>
-        <p:spPr>
-          <a:xfrm>
-            <a:off x="6050280" y="6401633"/>
-            <a:ext cx="1257300" cy="160020"/>
           </a:xfrm>
           <a:prstGeom prst="rect">
             <a:avLst/>
@@ -3730,7 +3816,7 @@
         </p:nvSpPr>
         <p:spPr>
           <a:xfrm>
-            <a:off x="6324600" y="2379226"/>
+            <a:off x="6355080" y="2409706"/>
             <a:ext cx="198120" cy="152400"/>
           </a:xfrm>
           <a:prstGeom prst="rect">
@@ -3761,7 +3847,7 @@
         </p:nvSpPr>
         <p:spPr>
           <a:xfrm>
-            <a:off x="4321721" y="2920246"/>
+            <a:off x="5479176" y="3514606"/>
             <a:ext cx="198120" cy="152400"/>
           </a:xfrm>
           <a:prstGeom prst="rect">
@@ -3792,7 +3878,7 @@
         </p:nvSpPr>
         <p:spPr>
           <a:xfrm>
-            <a:off x="5166292" y="3095506"/>
+            <a:off x="10395661" y="4055626"/>
             <a:ext cx="198120" cy="152400"/>
           </a:xfrm>
           <a:prstGeom prst="rect">
@@ -3816,38 +3902,7 @@
       <p:sp>
         <p:nvSpPr>
           <p:cNvPr id="6" name="Shape 3">
-            <a:hlinkClick r:id="rId5" tooltip="[4]"/>
-          </p:cNvPr>
-          <p:cNvSpPr/>
-          <p:nvPr/>
-        </p:nvSpPr>
-        <p:spPr>
-          <a:xfrm>
-            <a:off x="11470919" y="4375666"/>
-            <a:ext cx="198120" cy="152400"/>
-          </a:xfrm>
-          <a:prstGeom prst="rect">
-            <a:avLst/>
-          </a:prstGeom>
-          <a:solidFill>
-            <a:srgbClr val="FFFFFF">
-              <a:alpha val="0"/>
-            </a:srgbClr>
-          </a:solidFill>
-          <a:ln w="12700">
-            <a:solidFill>
-              <a:srgbClr val="FFFFFF">
-                <a:alpha val="0"/>
-              </a:srgbClr>
-            </a:solidFill>
-            <a:prstDash val="solid"/>
-          </a:ln>
-        </p:spPr>
-      </p:sp>
-      <p:sp>
-        <p:nvSpPr>
-          <p:cNvPr id="7" name="Shape 4">
-            <a:hlinkClick r:id="rId6" tooltip="[1] Purdue STAT course descriptions ↗"/>
+            <a:hlinkClick r:id="rId5" tooltip="[1] Purdue STAT course descriptions ↗"/>
           </p:cNvPr>
           <p:cNvSpPr/>
           <p:nvPr/>
@@ -3877,77 +3932,46 @@
       </p:sp>
       <p:sp>
         <p:nvSpPr>
+          <p:cNvPr id="7" name="Shape 4">
+            <a:hlinkClick r:id="rId6" tooltip="[2] Opta Analyst (2023), xG ↗"/>
+          </p:cNvPr>
+          <p:cNvSpPr/>
+          <p:nvPr/>
+        </p:nvSpPr>
+        <p:spPr>
+          <a:xfrm>
+            <a:off x="3253740" y="6401633"/>
+            <a:ext cx="1501140" cy="160020"/>
+          </a:xfrm>
+          <a:prstGeom prst="rect">
+            <a:avLst/>
+          </a:prstGeom>
+          <a:solidFill>
+            <a:srgbClr val="FFFFFF">
+              <a:alpha val="0"/>
+            </a:srgbClr>
+          </a:solidFill>
+          <a:ln w="12700">
+            <a:solidFill>
+              <a:srgbClr val="FFFFFF">
+                <a:alpha val="0"/>
+              </a:srgbClr>
+            </a:solidFill>
+            <a:prstDash val="solid"/>
+          </a:ln>
+        </p:spPr>
+      </p:sp>
+      <p:sp>
+        <p:nvSpPr>
           <p:cNvPr id="8" name="Shape 5">
-            <a:hlinkClick r:id="rId7" tooltip="[2] MLB Statcast glossary (xBA) ↗"/>
-          </p:cNvPr>
-          <p:cNvSpPr/>
-          <p:nvPr/>
-        </p:nvSpPr>
-        <p:spPr>
-          <a:xfrm>
-            <a:off x="3253740" y="6401633"/>
-            <a:ext cx="1737360" cy="160020"/>
-          </a:xfrm>
-          <a:prstGeom prst="rect">
-            <a:avLst/>
-          </a:prstGeom>
-          <a:solidFill>
-            <a:srgbClr val="FFFFFF">
-              <a:alpha val="0"/>
-            </a:srgbClr>
-          </a:solidFill>
-          <a:ln w="12700">
-            <a:solidFill>
-              <a:srgbClr val="FFFFFF">
-                <a:alpha val="0"/>
-              </a:srgbClr>
-            </a:solidFill>
-            <a:prstDash val="solid"/>
-          </a:ln>
-        </p:spPr>
-      </p:sp>
-      <p:sp>
-        <p:nvSpPr>
-          <p:cNvPr id="9" name="Shape 6">
-            <a:hlinkClick r:id="rId8" tooltip="[3] Opta Analyst (2023), xG ↗"/>
-          </p:cNvPr>
-          <p:cNvSpPr/>
-          <p:nvPr/>
-        </p:nvSpPr>
-        <p:spPr>
-          <a:xfrm>
-            <a:off x="5113020" y="6401633"/>
-            <a:ext cx="1501140" cy="160020"/>
-          </a:xfrm>
-          <a:prstGeom prst="rect">
-            <a:avLst/>
-          </a:prstGeom>
-          <a:solidFill>
-            <a:srgbClr val="FFFFFF">
-              <a:alpha val="0"/>
-            </a:srgbClr>
-          </a:solidFill>
-          <a:ln w="12700">
-            <a:solidFill>
-              <a:srgbClr val="FFFFFF">
-                <a:alpha val="0"/>
-              </a:srgbClr>
-            </a:solidFill>
-            <a:prstDash val="solid"/>
-          </a:ln>
-        </p:spPr>
-      </p:sp>
-      <p:sp>
-        <p:nvSpPr>
-          <p:cNvPr id="10" name="Shape 7">
-            <a:hlinkClick r:id="rId9" tooltip="[4] Canning &amp; Harackiewicz (2015) ↗"/>
-          </p:cNvPr>
-          <p:cNvSpPr/>
-          <p:nvPr/>
-        </p:nvSpPr>
-        <p:spPr>
-          <a:xfrm>
-            <a:off x="6736080" y="6401633"/>
+            <a:hlinkClick r:id="rId7" tooltip="[3] Canning &amp; Harackiewicz (2015) ↗"/>
+          </p:cNvPr>
+          <p:cNvSpPr/>
+          <p:nvPr/>
+        </p:nvSpPr>
+        <p:spPr>
+          <a:xfrm>
+            <a:off x="4876800" y="6401633"/>
             <a:ext cx="1859280" cy="160020"/>
           </a:xfrm>
           <a:prstGeom prst="rect">
@@ -3995,7 +4019,7 @@
       </p:grpSpPr>
       <p:pic>
         <p:nvPicPr>
-          <p:cNvPr id="2" name="Image 0" descr="Know the kinds of AI tools and when each is safe to use.">    </p:cNvPr>
+          <p:cNvPr id="2" name="Image 0" descr="Know what the tool can do—and what you may share.">    </p:cNvPr>
           <p:cNvPicPr>
             <a:picLocks noChangeAspect="1"/>
           </p:cNvPicPr>
@@ -4027,7 +4051,7 @@
         </p:nvSpPr>
         <p:spPr>
           <a:xfrm>
-            <a:off x="5801083" y="2150626"/>
+            <a:off x="3367674" y="2348746"/>
             <a:ext cx="198120" cy="152400"/>
           </a:xfrm>
           <a:prstGeom prst="rect">
@@ -4058,7 +4082,7 @@
         </p:nvSpPr>
         <p:spPr>
           <a:xfrm>
-            <a:off x="8162765" y="2150626"/>
+            <a:off x="5288440" y="2181106"/>
             <a:ext cx="198120" cy="152400"/>
           </a:xfrm>
           <a:prstGeom prst="rect">
@@ -4089,7 +4113,7 @@
         </p:nvSpPr>
         <p:spPr>
           <a:xfrm>
-            <a:off x="8384515" y="2150626"/>
+            <a:off x="6998924" y="2508766"/>
             <a:ext cx="198120" cy="152400"/>
           </a:xfrm>
           <a:prstGeom prst="rect">
@@ -4120,7 +4144,7 @@
         </p:nvSpPr>
         <p:spPr>
           <a:xfrm>
-            <a:off x="8606332" y="2150626"/>
+            <a:off x="7220712" y="2508766"/>
             <a:ext cx="198120" cy="152400"/>
           </a:xfrm>
           <a:prstGeom prst="rect">
@@ -4151,7 +4175,7 @@
         </p:nvSpPr>
         <p:spPr>
           <a:xfrm>
-            <a:off x="3521156" y="2866906"/>
+            <a:off x="3904641" y="2943106"/>
             <a:ext cx="198120" cy="152400"/>
           </a:xfrm>
           <a:prstGeom prst="rect">
@@ -4175,14 +4199,14 @@
       <p:sp>
         <p:nvSpPr>
           <p:cNvPr id="8" name="Shape 5">
-            <a:hlinkClick r:id="rId7" tooltip="[1]"/>
-          </p:cNvPr>
-          <p:cNvSpPr/>
-          <p:nvPr/>
-        </p:nvSpPr>
-        <p:spPr>
-          <a:xfrm>
-            <a:off x="5792198" y="2866906"/>
+            <a:hlinkClick r:id="rId7" tooltip="[5]"/>
+          </p:cNvPr>
+          <p:cNvSpPr/>
+          <p:nvPr/>
+        </p:nvSpPr>
+        <p:spPr>
+          <a:xfrm>
+            <a:off x="5776722" y="2943106"/>
             <a:ext cx="198120" cy="152400"/>
           </a:xfrm>
           <a:prstGeom prst="rect">
@@ -4206,14 +4230,14 @@
       <p:sp>
         <p:nvSpPr>
           <p:cNvPr id="9" name="Shape 6">
-            <a:hlinkClick r:id="rId8" tooltip="[2]"/>
-          </p:cNvPr>
-          <p:cNvSpPr/>
-          <p:nvPr/>
-        </p:nvSpPr>
-        <p:spPr>
-          <a:xfrm>
-            <a:off x="8329879" y="2866906"/>
+            <a:hlinkClick r:id="rId8" tooltip="[6]"/>
+          </p:cNvPr>
+          <p:cNvSpPr/>
+          <p:nvPr/>
+        </p:nvSpPr>
+        <p:spPr>
+          <a:xfrm>
+            <a:off x="5998502" y="2943106"/>
             <a:ext cx="198120" cy="152400"/>
           </a:xfrm>
           <a:prstGeom prst="rect">
@@ -4237,14 +4261,14 @@
       <p:sp>
         <p:nvSpPr>
           <p:cNvPr id="10" name="Shape 7">
-            <a:hlinkClick r:id="rId9" tooltip="[3]"/>
-          </p:cNvPr>
-          <p:cNvSpPr/>
-          <p:nvPr/>
-        </p:nvSpPr>
-        <p:spPr>
-          <a:xfrm>
-            <a:off x="8551698" y="2866906"/>
+            <a:hlinkClick r:id="rId9" tooltip="[5]"/>
+          </p:cNvPr>
+          <p:cNvSpPr/>
+          <p:nvPr/>
+        </p:nvSpPr>
+        <p:spPr>
+          <a:xfrm>
+            <a:off x="8017467" y="2943106"/>
             <a:ext cx="198120" cy="152400"/>
           </a:xfrm>
           <a:prstGeom prst="rect">
@@ -4268,14 +4292,45 @@
       <p:sp>
         <p:nvSpPr>
           <p:cNvPr id="11" name="Shape 8">
-            <a:hlinkClick r:id="rId10" tooltip="[4]"/>
-          </p:cNvPr>
-          <p:cNvSpPr/>
-          <p:nvPr/>
-        </p:nvSpPr>
-        <p:spPr>
-          <a:xfrm>
-            <a:off x="8773439" y="2866906"/>
+            <a:hlinkClick r:id="rId10" tooltip="Log in: genai.rcac.purdue.edu ↗"/>
+          </p:cNvPr>
+          <p:cNvSpPr/>
+          <p:nvPr/>
+        </p:nvSpPr>
+        <p:spPr>
+          <a:xfrm>
+            <a:off x="2499360" y="3910846"/>
+            <a:ext cx="1546860" cy="106680"/>
+          </a:xfrm>
+          <a:prstGeom prst="rect">
+            <a:avLst/>
+          </a:prstGeom>
+          <a:solidFill>
+            <a:srgbClr val="FFFFFF">
+              <a:alpha val="0"/>
+            </a:srgbClr>
+          </a:solidFill>
+          <a:ln w="12700">
+            <a:solidFill>
+              <a:srgbClr val="FFFFFF">
+                <a:alpha val="0"/>
+              </a:srgbClr>
+            </a:solidFill>
+            <a:prstDash val="solid"/>
+          </a:ln>
+        </p:spPr>
+      </p:sp>
+      <p:sp>
+        <p:nvSpPr>
+          <p:cNvPr id="12" name="Shape 9">
+            <a:hlinkClick r:id="rId11" tooltip="[7]"/>
+          </p:cNvPr>
+          <p:cNvSpPr/>
+          <p:nvPr/>
+        </p:nvSpPr>
+        <p:spPr>
+          <a:xfrm>
+            <a:off x="3701514" y="3705106"/>
             <a:ext cx="198120" cy="152400"/>
           </a:xfrm>
           <a:prstGeom prst="rect">
@@ -4298,15 +4353,15 @@
       </p:sp>
       <p:sp>
         <p:nvSpPr>
-          <p:cNvPr id="12" name="Shape 9">
-            <a:hlinkClick r:id="rId11" tooltip="[6]"/>
-          </p:cNvPr>
-          <p:cNvSpPr/>
-          <p:nvPr/>
-        </p:nvSpPr>
-        <p:spPr>
-          <a:xfrm>
-            <a:off x="3765758" y="3583186"/>
+          <p:cNvPr id="13" name="Shape 10">
+            <a:hlinkClick r:id="rId12" tooltip="[8]"/>
+          </p:cNvPr>
+          <p:cNvSpPr/>
+          <p:nvPr/>
+        </p:nvSpPr>
+        <p:spPr>
+          <a:xfrm>
+            <a:off x="5683430" y="3705106"/>
             <a:ext cx="198120" cy="152400"/>
           </a:xfrm>
           <a:prstGeom prst="rect">
@@ -4329,46 +4384,15 @@
       </p:sp>
       <p:sp>
         <p:nvSpPr>
-          <p:cNvPr id="13" name="Shape 10">
-            <a:hlinkClick r:id="rId12" tooltip="Log in: genai.rcac.purdue.edu ↗"/>
-          </p:cNvPr>
-          <p:cNvSpPr/>
-          <p:nvPr/>
-        </p:nvSpPr>
-        <p:spPr>
-          <a:xfrm>
-            <a:off x="2499360" y="3819406"/>
-            <a:ext cx="1775460" cy="121920"/>
-          </a:xfrm>
-          <a:prstGeom prst="rect">
-            <a:avLst/>
-          </a:prstGeom>
-          <a:solidFill>
-            <a:srgbClr val="FFFFFF">
-              <a:alpha val="0"/>
-            </a:srgbClr>
-          </a:solidFill>
-          <a:ln w="12700">
-            <a:solidFill>
-              <a:srgbClr val="FFFFFF">
-                <a:alpha val="0"/>
-              </a:srgbClr>
-            </a:solidFill>
-            <a:prstDash val="solid"/>
-          </a:ln>
-        </p:spPr>
-      </p:sp>
-      <p:sp>
-        <p:nvSpPr>
           <p:cNvPr id="14" name="Shape 11">
-            <a:hlinkClick r:id="rId13" tooltip="[7]"/>
-          </p:cNvPr>
-          <p:cNvSpPr/>
-          <p:nvPr/>
-        </p:nvSpPr>
-        <p:spPr>
-          <a:xfrm>
-            <a:off x="6049975" y="3583186"/>
+            <a:hlinkClick r:id="rId13" tooltip="[9]"/>
+          </p:cNvPr>
+          <p:cNvSpPr/>
+          <p:nvPr/>
+        </p:nvSpPr>
+        <p:spPr>
+          <a:xfrm>
+            <a:off x="7941792" y="3705106"/>
             <a:ext cx="198120" cy="152400"/>
           </a:xfrm>
           <a:prstGeom prst="rect">
@@ -4392,15 +4416,15 @@
       <p:sp>
         <p:nvSpPr>
           <p:cNvPr id="15" name="Shape 12">
-            <a:hlinkClick r:id="rId14" tooltip="[8]"/>
-          </p:cNvPr>
-          <p:cNvSpPr/>
-          <p:nvPr/>
-        </p:nvSpPr>
-        <p:spPr>
-          <a:xfrm>
-            <a:off x="8640013" y="3583186"/>
-            <a:ext cx="198120" cy="152400"/>
+            <a:hlinkClick r:id="rId14" tooltip="[10]"/>
+          </p:cNvPr>
+          <p:cNvSpPr/>
+          <p:nvPr/>
+        </p:nvSpPr>
+        <p:spPr>
+          <a:xfrm>
+            <a:off x="2867642" y="4794766"/>
+            <a:ext cx="289560" cy="152400"/>
           </a:xfrm>
           <a:prstGeom prst="rect">
             <a:avLst/>
@@ -4423,15 +4447,15 @@
       <p:sp>
         <p:nvSpPr>
           <p:cNvPr id="16" name="Shape 13">
-            <a:hlinkClick r:id="rId15" tooltip="[9]"/>
-          </p:cNvPr>
-          <p:cNvSpPr/>
-          <p:nvPr/>
-        </p:nvSpPr>
-        <p:spPr>
-          <a:xfrm>
-            <a:off x="3768166" y="4299466"/>
-            <a:ext cx="198120" cy="152400"/>
+            <a:hlinkClick r:id="rId15" tooltip="[11]"/>
+          </p:cNvPr>
+          <p:cNvSpPr/>
+          <p:nvPr/>
+        </p:nvSpPr>
+        <p:spPr>
+          <a:xfrm>
+            <a:off x="3181350" y="4794766"/>
+            <a:ext cx="289560" cy="152400"/>
           </a:xfrm>
           <a:prstGeom prst="rect">
             <a:avLst/>
@@ -4461,7 +4485,7 @@
         </p:nvSpPr>
         <p:spPr>
           <a:xfrm>
-            <a:off x="3989954" y="4299466"/>
+            <a:off x="5336088" y="4467106"/>
             <a:ext cx="289560" cy="152400"/>
           </a:xfrm>
           <a:prstGeom prst="rect">
@@ -4485,14 +4509,45 @@
       <p:sp>
         <p:nvSpPr>
           <p:cNvPr id="18" name="Shape 15">
-            <a:hlinkClick r:id="rId17" tooltip="[9]"/>
-          </p:cNvPr>
-          <p:cNvSpPr/>
-          <p:nvPr/>
-        </p:nvSpPr>
-        <p:spPr>
-          <a:xfrm>
-            <a:off x="5683331" y="4299466"/>
+            <a:hlinkClick r:id="rId17" tooltip="[12]"/>
+          </p:cNvPr>
+          <p:cNvSpPr/>
+          <p:nvPr/>
+        </p:nvSpPr>
+        <p:spPr>
+          <a:xfrm>
+            <a:off x="7582753" y="4467106"/>
+            <a:ext cx="289560" cy="152400"/>
+          </a:xfrm>
+          <a:prstGeom prst="rect">
+            <a:avLst/>
+          </a:prstGeom>
+          <a:solidFill>
+            <a:srgbClr val="FFFFFF">
+              <a:alpha val="0"/>
+            </a:srgbClr>
+          </a:solidFill>
+          <a:ln w="12700">
+            <a:solidFill>
+              <a:srgbClr val="FFFFFF">
+                <a:alpha val="0"/>
+              </a:srgbClr>
+            </a:solidFill>
+            <a:prstDash val="solid"/>
+          </a:ln>
+        </p:spPr>
+      </p:sp>
+      <p:sp>
+        <p:nvSpPr>
+          <p:cNvPr id="19" name="Shape 16">
+            <a:hlinkClick r:id="rId18" tooltip="[6]"/>
+          </p:cNvPr>
+          <p:cNvSpPr/>
+          <p:nvPr/>
+        </p:nvSpPr>
+        <p:spPr>
+          <a:xfrm>
+            <a:off x="11032617" y="2447806"/>
             <a:ext cx="198120" cy="152400"/>
           </a:xfrm>
           <a:prstGeom prst="rect">
@@ -4515,15 +4570,108 @@
       </p:sp>
       <p:sp>
         <p:nvSpPr>
-          <p:cNvPr id="19" name="Shape 16">
-            <a:hlinkClick r:id="rId18" tooltip="[11]"/>
-          </p:cNvPr>
-          <p:cNvSpPr/>
-          <p:nvPr/>
-        </p:nvSpPr>
-        <p:spPr>
-          <a:xfrm>
-            <a:off x="10528173" y="2424946"/>
+          <p:cNvPr id="20" name="Shape 17">
+            <a:hlinkClick r:id="rId19" tooltip="[5]"/>
+          </p:cNvPr>
+          <p:cNvSpPr/>
+          <p:nvPr/>
+        </p:nvSpPr>
+        <p:spPr>
+          <a:xfrm>
+            <a:off x="9922992" y="3362206"/>
+            <a:ext cx="198120" cy="152400"/>
+          </a:xfrm>
+          <a:prstGeom prst="rect">
+            <a:avLst/>
+          </a:prstGeom>
+          <a:solidFill>
+            <a:srgbClr val="FFFFFF">
+              <a:alpha val="0"/>
+            </a:srgbClr>
+          </a:solidFill>
+          <a:ln w="12700">
+            <a:solidFill>
+              <a:srgbClr val="FFFFFF">
+                <a:alpha val="0"/>
+              </a:srgbClr>
+            </a:solidFill>
+            <a:prstDash val="solid"/>
+          </a:ln>
+        </p:spPr>
+      </p:sp>
+      <p:sp>
+        <p:nvSpPr>
+          <p:cNvPr id="21" name="Shape 18">
+            <a:hlinkClick r:id="rId20" tooltip="[6]"/>
+          </p:cNvPr>
+          <p:cNvSpPr/>
+          <p:nvPr/>
+        </p:nvSpPr>
+        <p:spPr>
+          <a:xfrm>
+            <a:off x="10144811" y="3362206"/>
+            <a:ext cx="198120" cy="152400"/>
+          </a:xfrm>
+          <a:prstGeom prst="rect">
+            <a:avLst/>
+          </a:prstGeom>
+          <a:solidFill>
+            <a:srgbClr val="FFFFFF">
+              <a:alpha val="0"/>
+            </a:srgbClr>
+          </a:solidFill>
+          <a:ln w="12700">
+            <a:solidFill>
+              <a:srgbClr val="FFFFFF">
+                <a:alpha val="0"/>
+              </a:srgbClr>
+            </a:solidFill>
+            <a:prstDash val="solid"/>
+          </a:ln>
+        </p:spPr>
+      </p:sp>
+      <p:sp>
+        <p:nvSpPr>
+          <p:cNvPr id="22" name="Shape 19">
+            <a:hlinkClick r:id="rId21" tooltip="[7]"/>
+          </p:cNvPr>
+          <p:cNvSpPr/>
+          <p:nvPr/>
+        </p:nvSpPr>
+        <p:spPr>
+          <a:xfrm>
+            <a:off x="9485376" y="4124206"/>
+            <a:ext cx="198120" cy="152400"/>
+          </a:xfrm>
+          <a:prstGeom prst="rect">
+            <a:avLst/>
+          </a:prstGeom>
+          <a:solidFill>
+            <a:srgbClr val="FFFFFF">
+              <a:alpha val="0"/>
+            </a:srgbClr>
+          </a:solidFill>
+          <a:ln w="12700">
+            <a:solidFill>
+              <a:srgbClr val="FFFFFF">
+                <a:alpha val="0"/>
+              </a:srgbClr>
+            </a:solidFill>
+            <a:prstDash val="solid"/>
+          </a:ln>
+        </p:spPr>
+      </p:sp>
+      <p:sp>
+        <p:nvSpPr>
+          <p:cNvPr id="23" name="Shape 20">
+            <a:hlinkClick r:id="rId22" tooltip="[11]"/>
+          </p:cNvPr>
+          <p:cNvSpPr/>
+          <p:nvPr/>
+        </p:nvSpPr>
+        <p:spPr>
+          <a:xfrm>
+            <a:off x="9012250" y="4810006"/>
             <a:ext cx="289560" cy="152400"/>
           </a:xfrm>
           <a:prstGeom prst="rect">
@@ -4546,140 +4694,16 @@
       </p:sp>
       <p:sp>
         <p:nvSpPr>
-          <p:cNvPr id="20" name="Shape 17">
-            <a:hlinkClick r:id="rId19" tooltip="[12]"/>
-          </p:cNvPr>
-          <p:cNvSpPr/>
-          <p:nvPr/>
-        </p:nvSpPr>
-        <p:spPr>
-          <a:xfrm>
-            <a:off x="10841888" y="2424946"/>
-            <a:ext cx="289560" cy="152400"/>
-          </a:xfrm>
-          <a:prstGeom prst="rect">
-            <a:avLst/>
-          </a:prstGeom>
-          <a:solidFill>
-            <a:srgbClr val="FFFFFF">
-              <a:alpha val="0"/>
-            </a:srgbClr>
-          </a:solidFill>
-          <a:ln w="12700">
-            <a:solidFill>
-              <a:srgbClr val="FFFFFF">
-                <a:alpha val="0"/>
-              </a:srgbClr>
-            </a:solidFill>
-            <a:prstDash val="solid"/>
-          </a:ln>
-        </p:spPr>
-      </p:sp>
-      <p:sp>
-        <p:nvSpPr>
-          <p:cNvPr id="21" name="Shape 18">
-            <a:hlinkClick r:id="rId20" tooltip="[3]"/>
-          </p:cNvPr>
-          <p:cNvSpPr/>
-          <p:nvPr/>
-        </p:nvSpPr>
-        <p:spPr>
-          <a:xfrm>
-            <a:off x="10034016" y="3141226"/>
-            <a:ext cx="198120" cy="152400"/>
-          </a:xfrm>
-          <a:prstGeom prst="rect">
-            <a:avLst/>
-          </a:prstGeom>
-          <a:solidFill>
-            <a:srgbClr val="FFFFFF">
-              <a:alpha val="0"/>
-            </a:srgbClr>
-          </a:solidFill>
-          <a:ln w="12700">
-            <a:solidFill>
-              <a:srgbClr val="FFFFFF">
-                <a:alpha val="0"/>
-              </a:srgbClr>
-            </a:solidFill>
-            <a:prstDash val="solid"/>
-          </a:ln>
-        </p:spPr>
-      </p:sp>
-      <p:sp>
-        <p:nvSpPr>
-          <p:cNvPr id="22" name="Shape 19">
-            <a:hlinkClick r:id="rId21" tooltip="[5]"/>
-          </p:cNvPr>
-          <p:cNvSpPr/>
-          <p:nvPr/>
-        </p:nvSpPr>
-        <p:spPr>
-          <a:xfrm>
-            <a:off x="10255834" y="3141226"/>
-            <a:ext cx="198120" cy="152400"/>
-          </a:xfrm>
-          <a:prstGeom prst="rect">
-            <a:avLst/>
-          </a:prstGeom>
-          <a:solidFill>
-            <a:srgbClr val="FFFFFF">
-              <a:alpha val="0"/>
-            </a:srgbClr>
-          </a:solidFill>
-          <a:ln w="12700">
-            <a:solidFill>
-              <a:srgbClr val="FFFFFF">
-                <a:alpha val="0"/>
-              </a:srgbClr>
-            </a:solidFill>
-            <a:prstDash val="solid"/>
-          </a:ln>
-        </p:spPr>
-      </p:sp>
-      <p:sp>
-        <p:nvSpPr>
-          <p:cNvPr id="23" name="Shape 20">
-            <a:hlinkClick r:id="rId22" tooltip="[6]"/>
-          </p:cNvPr>
-          <p:cNvSpPr/>
-          <p:nvPr/>
-        </p:nvSpPr>
-        <p:spPr>
-          <a:xfrm>
-            <a:off x="10437342" y="3857506"/>
-            <a:ext cx="198120" cy="152400"/>
-          </a:xfrm>
-          <a:prstGeom prst="rect">
-            <a:avLst/>
-          </a:prstGeom>
-          <a:solidFill>
-            <a:srgbClr val="FFFFFF">
-              <a:alpha val="0"/>
-            </a:srgbClr>
-          </a:solidFill>
-          <a:ln w="12700">
-            <a:solidFill>
-              <a:srgbClr val="FFFFFF">
-                <a:alpha val="0"/>
-              </a:srgbClr>
-            </a:solidFill>
-            <a:prstDash val="solid"/>
-          </a:ln>
-        </p:spPr>
-      </p:sp>
-      <p:sp>
-        <p:nvSpPr>
           <p:cNvPr id="24" name="Shape 21">
-            <a:hlinkClick r:id="rId23" tooltip="[10]"/>
-          </p:cNvPr>
-          <p:cNvSpPr/>
-          <p:nvPr/>
-        </p:nvSpPr>
-        <p:spPr>
-          <a:xfrm>
-            <a:off x="10698022" y="4493776"/>
-            <a:ext cx="289560" cy="152400"/>
+            <a:hlinkClick r:id="rId23" tooltip="[1] OpenAI data use ↗"/>
+          </p:cNvPr>
+          <p:cNvSpPr/>
+          <p:nvPr/>
+        </p:nvSpPr>
+        <p:spPr>
+          <a:xfrm>
+            <a:off x="1188720" y="6226373"/>
+            <a:ext cx="1127760" cy="160020"/>
           </a:xfrm>
           <a:prstGeom prst="rect">
             <a:avLst/>
@@ -4702,14 +4726,14 @@
       <p:sp>
         <p:nvSpPr>
           <p:cNvPr id="25" name="Shape 22">
-            <a:hlinkClick r:id="rId24" tooltip="[1] Gemini API terms ↗"/>
-          </p:cNvPr>
-          <p:cNvSpPr/>
-          <p:nvPr/>
-        </p:nvSpPr>
-        <p:spPr>
-          <a:xfrm>
-            <a:off x="1188720" y="6226373"/>
+            <a:hlinkClick r:id="rId24" tooltip="[2] Gemini API terms ↗"/>
+          </p:cNvPr>
+          <p:cNvSpPr/>
+          <p:nvPr/>
+        </p:nvSpPr>
+        <p:spPr>
+          <a:xfrm>
+            <a:off x="2438400" y="6226373"/>
             <a:ext cx="1135380" cy="160020"/>
           </a:xfrm>
           <a:prstGeom prst="rect">
@@ -4733,14 +4757,14 @@
       <p:sp>
         <p:nvSpPr>
           <p:cNvPr id="26" name="Shape 23">
-            <a:hlinkClick r:id="rId25" tooltip="[2] Claude Code docs ↗"/>
-          </p:cNvPr>
-          <p:cNvSpPr/>
-          <p:nvPr/>
-        </p:nvSpPr>
-        <p:spPr>
-          <a:xfrm>
-            <a:off x="2446020" y="6226373"/>
+            <a:hlinkClick r:id="rId25" tooltip="[3] Claude Code docs ↗"/>
+          </p:cNvPr>
+          <p:cNvSpPr/>
+          <p:nvPr/>
+        </p:nvSpPr>
+        <p:spPr>
+          <a:xfrm>
+            <a:off x="3695700" y="6226373"/>
             <a:ext cx="1188720" cy="160020"/>
           </a:xfrm>
           <a:prstGeom prst="rect">
@@ -4764,15 +4788,15 @@
       <p:sp>
         <p:nvSpPr>
           <p:cNvPr id="27" name="Shape 24">
-            <a:hlinkClick r:id="rId26" tooltip="[3] Codex pricing ↗"/>
-          </p:cNvPr>
-          <p:cNvSpPr/>
-          <p:nvPr/>
-        </p:nvSpPr>
-        <p:spPr>
-          <a:xfrm>
-            <a:off x="3756660" y="6226373"/>
-            <a:ext cx="960120" cy="160020"/>
+            <a:hlinkClick r:id="rId26" tooltip="[4] Codex docs ↗"/>
+          </p:cNvPr>
+          <p:cNvSpPr/>
+          <p:nvPr/>
+        </p:nvSpPr>
+        <p:spPr>
+          <a:xfrm>
+            <a:off x="5006340" y="6226373"/>
+            <a:ext cx="868680" cy="160020"/>
           </a:xfrm>
           <a:prstGeom prst="rect">
             <a:avLst/>
@@ -4795,15 +4819,15 @@
       <p:sp>
         <p:nvSpPr>
           <p:cNvPr id="28" name="Shape 25">
-            <a:hlinkClick r:id="rId27" tooltip="[4] Gemini CLI (GitHub) ↗"/>
-          </p:cNvPr>
-          <p:cNvSpPr/>
-          <p:nvPr/>
-        </p:nvSpPr>
-        <p:spPr>
-          <a:xfrm>
-            <a:off x="4838700" y="6226373"/>
-            <a:ext cx="1264920" cy="160020"/>
+            <a:hlinkClick r:id="rId27" tooltip="[5] Purdue AI toolkit ↗"/>
+          </p:cNvPr>
+          <p:cNvSpPr/>
+          <p:nvPr/>
+        </p:nvSpPr>
+        <p:spPr>
+          <a:xfrm>
+            <a:off x="5996940" y="6226373"/>
+            <a:ext cx="1127760" cy="160020"/>
           </a:xfrm>
           <a:prstGeom prst="rect">
             <a:avLst/>
@@ -4826,15 +4850,15 @@
       <p:sp>
         <p:nvSpPr>
           <p:cNvPr id="29" name="Shape 26">
-            <a:hlinkClick r:id="rId28" tooltip="[5] Copilot data protection ↗"/>
-          </p:cNvPr>
-          <p:cNvSpPr/>
-          <p:nvPr/>
-        </p:nvSpPr>
-        <p:spPr>
-          <a:xfrm>
-            <a:off x="6225540" y="6226373"/>
-            <a:ext cx="1463040" cy="160020"/>
+            <a:hlinkClick r:id="rId28" tooltip="[6] Purdue AI tools list (Oct. 2026) ↗"/>
+          </p:cNvPr>
+          <p:cNvSpPr/>
+          <p:nvPr/>
+        </p:nvSpPr>
+        <p:spPr>
+          <a:xfrm>
+            <a:off x="7246620" y="6226373"/>
+            <a:ext cx="1851660" cy="160020"/>
           </a:xfrm>
           <a:prstGeom prst="rect">
             <a:avLst/>
@@ -4857,14 +4881,14 @@
       <p:sp>
         <p:nvSpPr>
           <p:cNvPr id="30" name="Shape 27">
-            <a:hlinkClick r:id="rId29" tooltip="[6] Purdue RCAC, GenAI Studio (Sept. 29) ↗"/>
-          </p:cNvPr>
-          <p:cNvSpPr/>
-          <p:nvPr/>
-        </p:nvSpPr>
-        <p:spPr>
-          <a:xfrm>
-            <a:off x="7810500" y="6226373"/>
+            <a:hlinkClick r:id="rId29" tooltip="[7] Purdue RCAC, GenAI Studio (Sept. 29) ↗"/>
+          </p:cNvPr>
+          <p:cNvSpPr/>
+          <p:nvPr/>
+        </p:nvSpPr>
+        <p:spPr>
+          <a:xfrm>
+            <a:off x="609600" y="6401633"/>
             <a:ext cx="2209800" cy="160020"/>
           </a:xfrm>
           <a:prstGeom prst="rect">
@@ -4888,14 +4912,14 @@
       <p:sp>
         <p:nvSpPr>
           <p:cNvPr id="31" name="Shape 28">
-            <a:hlinkClick r:id="rId30" tooltip="[7] Purdue RCAC, API guide ↗"/>
-          </p:cNvPr>
-          <p:cNvSpPr/>
-          <p:nvPr/>
-        </p:nvSpPr>
-        <p:spPr>
-          <a:xfrm>
-            <a:off x="609600" y="6401633"/>
+            <a:hlinkClick r:id="rId30" tooltip="[8] Purdue RCAC, API guide ↗"/>
+          </p:cNvPr>
+          <p:cNvSpPr/>
+          <p:nvPr/>
+        </p:nvSpPr>
+        <p:spPr>
+          <a:xfrm>
+            <a:off x="2941320" y="6401633"/>
             <a:ext cx="1508760" cy="160020"/>
           </a:xfrm>
           <a:prstGeom prst="rect">
@@ -4919,14 +4943,14 @@
       <p:sp>
         <p:nvSpPr>
           <p:cNvPr id="32" name="Shape 29">
-            <a:hlinkClick r:id="rId31" tooltip="[8] GenAI Studio SDK (GitHub) ↗"/>
-          </p:cNvPr>
-          <p:cNvSpPr/>
-          <p:nvPr/>
-        </p:nvSpPr>
-        <p:spPr>
-          <a:xfrm>
-            <a:off x="2240280" y="6401633"/>
+            <a:hlinkClick r:id="rId31" tooltip="[9] GenAI Studio SDK (GitHub) ↗"/>
+          </p:cNvPr>
+          <p:cNvSpPr/>
+          <p:nvPr/>
+        </p:nvSpPr>
+        <p:spPr>
+          <a:xfrm>
+            <a:off x="4572000" y="6401633"/>
             <a:ext cx="1653540" cy="160020"/>
           </a:xfrm>
           <a:prstGeom prst="rect">
@@ -4950,15 +4974,15 @@
       <p:sp>
         <p:nvSpPr>
           <p:cNvPr id="33" name="Shape 30">
-            <a:hlinkClick r:id="rId32" tooltip="[9] llama.cpp ↗"/>
-          </p:cNvPr>
-          <p:cNvSpPr/>
-          <p:nvPr/>
-        </p:nvSpPr>
-        <p:spPr>
-          <a:xfrm>
-            <a:off x="4015740" y="6401633"/>
-            <a:ext cx="739140" cy="160020"/>
+            <a:hlinkClick r:id="rId32" tooltip="[10] llama.cpp ↗"/>
+          </p:cNvPr>
+          <p:cNvSpPr/>
+          <p:nvPr/>
+        </p:nvSpPr>
+        <p:spPr>
+          <a:xfrm>
+            <a:off x="6347460" y="6401633"/>
+            <a:ext cx="807720" cy="160020"/>
           </a:xfrm>
           <a:prstGeom prst="rect">
             <a:avLst/>
@@ -4981,15 +5005,15 @@
       <p:sp>
         <p:nvSpPr>
           <p:cNvPr id="34" name="Shape 31">
-            <a:hlinkClick r:id="rId33" tooltip="[10] Ollama documentation ↗"/>
-          </p:cNvPr>
-          <p:cNvSpPr/>
-          <p:nvPr/>
-        </p:nvSpPr>
-        <p:spPr>
-          <a:xfrm>
-            <a:off x="4876800" y="6401633"/>
-            <a:ext cx="1478280" cy="160020"/>
+            <a:hlinkClick r:id="rId33" tooltip="[11] Ollama FAQ ↗"/>
+          </p:cNvPr>
+          <p:cNvSpPr/>
+          <p:nvPr/>
+        </p:nvSpPr>
+        <p:spPr>
+          <a:xfrm>
+            <a:off x="7277100" y="6401633"/>
+            <a:ext cx="952500" cy="160020"/>
           </a:xfrm>
           <a:prstGeom prst="rect">
             <a:avLst/>
@@ -5012,46 +5036,15 @@
       <p:sp>
         <p:nvSpPr>
           <p:cNvPr id="35" name="Shape 32">
-            <a:hlinkClick r:id="rId34" tooltip="[11] Gemini privacy hub ↗"/>
-          </p:cNvPr>
-          <p:cNvSpPr/>
-          <p:nvPr/>
-        </p:nvSpPr>
-        <p:spPr>
-          <a:xfrm>
-            <a:off x="6477000" y="6401633"/>
-            <a:ext cx="1287780" cy="160020"/>
-          </a:xfrm>
-          <a:prstGeom prst="rect">
-            <a:avLst/>
-          </a:prstGeom>
-          <a:solidFill>
-            <a:srgbClr val="FFFFFF">
-              <a:alpha val="0"/>
-            </a:srgbClr>
-          </a:solidFill>
-          <a:ln w="12700">
-            <a:solidFill>
-              <a:srgbClr val="FFFFFF">
-                <a:alpha val="0"/>
-              </a:srgbClr>
-            </a:solidFill>
-            <a:prstDash val="solid"/>
-          </a:ln>
-        </p:spPr>
-      </p:sp>
-      <p:sp>
-        <p:nvSpPr>
-          <p:cNvPr id="36" name="Shape 33">
-            <a:hlinkClick r:id="rId35" tooltip="[12] Anthropic consumer terms ↗"/>
-          </p:cNvPr>
-          <p:cNvSpPr/>
-          <p:nvPr/>
-        </p:nvSpPr>
-        <p:spPr>
-          <a:xfrm>
-            <a:off x="7886700" y="6401633"/>
-            <a:ext cx="1653540" cy="160020"/>
+            <a:hlinkClick r:id="rId34" tooltip="[12] Ollama tool calling ↗"/>
+          </p:cNvPr>
+          <p:cNvSpPr/>
+          <p:nvPr/>
+        </p:nvSpPr>
+        <p:spPr>
+          <a:xfrm>
+            <a:off x="8351520" y="6401633"/>
+            <a:ext cx="1272540" cy="160020"/>
           </a:xfrm>
           <a:prstGeom prst="rect">
             <a:avLst/>
@@ -5098,7 +5091,7 @@
       </p:grpSpPr>
       <p:pic>
         <p:nvPicPr>
-          <p:cNvPr id="2" name="Image 0" descr="Knowledge bases match meaning; databases match exactly.">    </p:cNvPr>
+          <p:cNvPr id="2" name="Image 0" descr="Match the question to the source and the tool.">    </p:cNvPr>
           <p:cNvPicPr>
             <a:picLocks noChangeAspect="1"/>
           </p:cNvPicPr>
@@ -5130,7 +5123,7 @@
         </p:nvSpPr>
         <p:spPr>
           <a:xfrm>
-            <a:off x="4895553" y="1998226"/>
+            <a:off x="5336477" y="1982986"/>
             <a:ext cx="198120" cy="152400"/>
           </a:xfrm>
           <a:prstGeom prst="rect">
@@ -5161,7 +5154,7 @@
         </p:nvSpPr>
         <p:spPr>
           <a:xfrm>
-            <a:off x="1893250" y="2729746"/>
+            <a:off x="2269366" y="2760226"/>
             <a:ext cx="198120" cy="152400"/>
           </a:xfrm>
           <a:prstGeom prst="rect">
@@ -5192,7 +5185,7 @@
         </p:nvSpPr>
         <p:spPr>
           <a:xfrm>
-            <a:off x="4995855" y="2729746"/>
+            <a:off x="4362450" y="2760226"/>
             <a:ext cx="198120" cy="152400"/>
           </a:xfrm>
           <a:prstGeom prst="rect">
@@ -5223,7 +5216,7 @@
         </p:nvSpPr>
         <p:spPr>
           <a:xfrm>
-            <a:off x="10166452" y="1998226"/>
+            <a:off x="10806912" y="1982986"/>
             <a:ext cx="198120" cy="152400"/>
           </a:xfrm>
           <a:prstGeom prst="rect">
@@ -5247,14 +5240,14 @@
       <p:sp>
         <p:nvSpPr>
           <p:cNvPr id="7" name="Shape 4">
-            <a:hlinkClick r:id="rId6" tooltip="[3]"/>
-          </p:cNvPr>
-          <p:cNvSpPr/>
-          <p:nvPr/>
-        </p:nvSpPr>
-        <p:spPr>
-          <a:xfrm>
-            <a:off x="10887913" y="4985266"/>
+            <a:hlinkClick r:id="rId6" tooltip="[5]"/>
+          </p:cNvPr>
+          <p:cNvSpPr/>
+          <p:nvPr/>
+        </p:nvSpPr>
+        <p:spPr>
+          <a:xfrm>
+            <a:off x="9604096" y="4512826"/>
             <a:ext cx="198120" cy="152400"/>
           </a:xfrm>
           <a:prstGeom prst="rect">
@@ -5278,7 +5271,38 @@
       <p:sp>
         <p:nvSpPr>
           <p:cNvPr id="8" name="Shape 5">
-            <a:hlinkClick r:id="rId7" tooltip="[1] Purdue RCAC, Knowledge Bases ↗"/>
+            <a:hlinkClick r:id="rId7" tooltip="[3]"/>
+          </p:cNvPr>
+          <p:cNvSpPr/>
+          <p:nvPr/>
+        </p:nvSpPr>
+        <p:spPr>
+          <a:xfrm>
+            <a:off x="7563444" y="4832866"/>
+            <a:ext cx="198120" cy="152400"/>
+          </a:xfrm>
+          <a:prstGeom prst="rect">
+            <a:avLst/>
+          </a:prstGeom>
+          <a:solidFill>
+            <a:srgbClr val="FFFFFF">
+              <a:alpha val="0"/>
+            </a:srgbClr>
+          </a:solidFill>
+          <a:ln w="12700">
+            <a:solidFill>
+              <a:srgbClr val="FFFFFF">
+                <a:alpha val="0"/>
+              </a:srgbClr>
+            </a:solidFill>
+            <a:prstDash val="solid"/>
+          </a:ln>
+        </p:spPr>
+      </p:sp>
+      <p:sp>
+        <p:nvSpPr>
+          <p:cNvPr id="9" name="Shape 6">
+            <a:hlinkClick r:id="rId8" tooltip="[1] all-MiniLM-L6-v2 model card ↗"/>
           </p:cNvPr>
           <p:cNvSpPr/>
           <p:nvPr/>
@@ -5286,38 +5310,7 @@
         <p:spPr>
           <a:xfrm>
             <a:off x="1188720" y="6401633"/>
-            <a:ext cx="1935480" cy="160020"/>
-          </a:xfrm>
-          <a:prstGeom prst="rect">
-            <a:avLst/>
-          </a:prstGeom>
-          <a:solidFill>
-            <a:srgbClr val="FFFFFF">
-              <a:alpha val="0"/>
-            </a:srgbClr>
-          </a:solidFill>
-          <a:ln w="12700">
-            <a:solidFill>
-              <a:srgbClr val="FFFFFF">
-                <a:alpha val="0"/>
-              </a:srgbClr>
-            </a:solidFill>
-            <a:prstDash val="solid"/>
-          </a:ln>
-        </p:spPr>
-      </p:sp>
-      <p:sp>
-        <p:nvSpPr>
-          <p:cNvPr id="9" name="Shape 6">
-            <a:hlinkClick r:id="rId8" tooltip="[2] Silberzahn et al., soccer data (OSF) ↗"/>
-          </p:cNvPr>
-          <p:cNvSpPr/>
-          <p:nvPr/>
-        </p:nvSpPr>
-        <p:spPr>
-          <a:xfrm>
-            <a:off x="3246120" y="6401633"/>
-            <a:ext cx="2019300" cy="160020"/>
+            <a:ext cx="1737360" cy="160020"/>
           </a:xfrm>
           <a:prstGeom prst="rect">
             <a:avLst/>
@@ -5340,15 +5333,15 @@
       <p:sp>
         <p:nvSpPr>
           <p:cNvPr id="10" name="Shape 7">
-            <a:hlinkClick r:id="rId9" tooltip="[3] all-MiniLM-L6-v2 model card ↗"/>
-          </p:cNvPr>
-          <p:cNvSpPr/>
-          <p:nvPr/>
-        </p:nvSpPr>
-        <p:spPr>
-          <a:xfrm>
-            <a:off x="5387340" y="6401633"/>
-            <a:ext cx="1737360" cy="160020"/>
+            <a:hlinkClick r:id="rId9" tooltip="[2] Soccer-study codebook (GitHub, d489f03) ↗"/>
+          </p:cNvPr>
+          <p:cNvSpPr/>
+          <p:nvPr/>
+        </p:nvSpPr>
+        <p:spPr>
+          <a:xfrm>
+            <a:off x="3048000" y="6401633"/>
+            <a:ext cx="2423160" cy="160020"/>
           </a:xfrm>
           <a:prstGeom prst="rect">
             <a:avLst/>
@@ -5371,15 +5364,77 @@
       <p:sp>
         <p:nvSpPr>
           <p:cNvPr id="11" name="Shape 8">
-            <a:hlinkClick r:id="rId10" tooltip="[4] Data: released runs (GitHub) ↗"/>
-          </p:cNvPr>
-          <p:cNvSpPr/>
-          <p:nvPr/>
-        </p:nvSpPr>
-        <p:spPr>
-          <a:xfrm>
-            <a:off x="7246620" y="6401633"/>
+            <a:hlinkClick r:id="rId10" tooltip="[3] Retrieval scores (this talk) ↗"/>
+          </p:cNvPr>
+          <p:cNvSpPr/>
+          <p:nvPr/>
+        </p:nvSpPr>
+        <p:spPr>
+          <a:xfrm>
+            <a:off x="5593080" y="6401633"/>
+            <a:ext cx="1577340" cy="160020"/>
+          </a:xfrm>
+          <a:prstGeom prst="rect">
+            <a:avLst/>
+          </a:prstGeom>
+          <a:solidFill>
+            <a:srgbClr val="FFFFFF">
+              <a:alpha val="0"/>
+            </a:srgbClr>
+          </a:solidFill>
+          <a:ln w="12700">
+            <a:solidFill>
+              <a:srgbClr val="FFFFFF">
+                <a:alpha val="0"/>
+              </a:srgbClr>
+            </a:solidFill>
+            <a:prstDash val="solid"/>
+          </a:ln>
+        </p:spPr>
+      </p:sp>
+      <p:sp>
+        <p:nvSpPr>
+          <p:cNvPr id="12" name="Shape 9">
+            <a:hlinkClick r:id="rId11" tooltip="[4] Data: released runs (GitHub) ↗"/>
+          </p:cNvPr>
+          <p:cNvSpPr/>
+          <p:nvPr/>
+        </p:nvSpPr>
+        <p:spPr>
+          <a:xfrm>
+            <a:off x="7292340" y="6401633"/>
             <a:ext cx="1714500" cy="160020"/>
+          </a:xfrm>
+          <a:prstGeom prst="rect">
+            <a:avLst/>
+          </a:prstGeom>
+          <a:solidFill>
+            <a:srgbClr val="FFFFFF">
+              <a:alpha val="0"/>
+            </a:srgbClr>
+          </a:solidFill>
+          <a:ln w="12700">
+            <a:solidFill>
+              <a:srgbClr val="FFFFFF">
+                <a:alpha val="0"/>
+              </a:srgbClr>
+            </a:solidFill>
+            <a:prstDash val="solid"/>
+          </a:ln>
+        </p:spPr>
+      </p:sp>
+      <p:sp>
+        <p:nvSpPr>
+          <p:cNvPr id="13" name="Shape 10">
+            <a:hlinkClick r:id="rId12" tooltip="[5] SQL script (this talk) ↗"/>
+          </p:cNvPr>
+          <p:cNvSpPr/>
+          <p:nvPr/>
+        </p:nvSpPr>
+        <p:spPr>
+          <a:xfrm>
+            <a:off x="9128760" y="6401633"/>
+            <a:ext cx="1287780" cy="160020"/>
           </a:xfrm>
           <a:prstGeom prst="rect">
             <a:avLst/>
@@ -5458,7 +5513,7 @@
         </p:nvSpPr>
         <p:spPr>
           <a:xfrm>
-            <a:off x="7040812" y="2181106"/>
+            <a:off x="9058275" y="1632466"/>
             <a:ext cx="198120" cy="152400"/>
           </a:xfrm>
           <a:prstGeom prst="rect">
@@ -5489,7 +5544,7 @@
         </p:nvSpPr>
         <p:spPr>
           <a:xfrm>
-            <a:off x="7186216" y="2790706"/>
+            <a:off x="9302115" y="1632466"/>
             <a:ext cx="198120" cy="152400"/>
           </a:xfrm>
           <a:prstGeom prst="rect">
@@ -5513,14 +5568,14 @@
       <p:sp>
         <p:nvSpPr>
           <p:cNvPr id="5" name="Shape 2">
-            <a:hlinkClick r:id="rId4" tooltip="[1]"/>
-          </p:cNvPr>
-          <p:cNvSpPr/>
-          <p:nvPr/>
-        </p:nvSpPr>
-        <p:spPr>
-          <a:xfrm>
-            <a:off x="6704853" y="3400306"/>
+            <a:hlinkClick r:id="rId4" tooltip="[3]"/>
+          </p:cNvPr>
+          <p:cNvSpPr/>
+          <p:nvPr/>
+        </p:nvSpPr>
+        <p:spPr>
+          <a:xfrm>
+            <a:off x="5371201" y="3811786"/>
             <a:ext cx="198120" cy="152400"/>
           </a:xfrm>
           <a:prstGeom prst="rect">
@@ -5551,7 +5606,7 @@
         </p:nvSpPr>
         <p:spPr>
           <a:xfrm>
-            <a:off x="8478546" y="4070866"/>
+            <a:off x="5615041" y="3811786"/>
             <a:ext cx="198120" cy="152400"/>
           </a:xfrm>
           <a:prstGeom prst="rect">
@@ -5575,14 +5630,14 @@
       <p:sp>
         <p:nvSpPr>
           <p:cNvPr id="7" name="Shape 4">
-            <a:hlinkClick r:id="rId6" tooltip="[3]"/>
-          </p:cNvPr>
-          <p:cNvSpPr/>
-          <p:nvPr/>
-        </p:nvSpPr>
-        <p:spPr>
-          <a:xfrm>
-            <a:off x="5043152" y="4520446"/>
+            <a:hlinkClick r:id="rId6" tooltip="[5]"/>
+          </p:cNvPr>
+          <p:cNvSpPr/>
+          <p:nvPr/>
+        </p:nvSpPr>
+        <p:spPr>
+          <a:xfrm>
+            <a:off x="5360922" y="4916686"/>
             <a:ext cx="198120" cy="152400"/>
           </a:xfrm>
           <a:prstGeom prst="rect">
@@ -5606,7 +5661,7 @@
       <p:sp>
         <p:nvSpPr>
           <p:cNvPr id="8" name="Shape 5">
-            <a:hlinkClick r:id="rId7" tooltip="[1] Codex security docs ↗"/>
+            <a:hlinkClick r:id="rId7" tooltip="[1] Codex approvals &amp; security ↗"/>
           </p:cNvPr>
           <p:cNvSpPr/>
           <p:nvPr/>
@@ -5614,7 +5669,7 @@
         <p:spPr>
           <a:xfrm>
             <a:off x="1188720" y="6401633"/>
-            <a:ext cx="1295400" cy="160020"/>
+            <a:ext cx="1661160" cy="160020"/>
           </a:xfrm>
           <a:prstGeom prst="rect">
             <a:avLst/>
@@ -5644,7 +5699,7 @@
         </p:nvSpPr>
         <p:spPr>
           <a:xfrm>
-            <a:off x="2606040" y="6401633"/>
+            <a:off x="2971800" y="6401633"/>
             <a:ext cx="1615440" cy="160020"/>
           </a:xfrm>
           <a:prstGeom prst="rect">
@@ -5668,15 +5723,15 @@
       <p:sp>
         <p:nvSpPr>
           <p:cNvPr id="10" name="Shape 7">
-            <a:hlinkClick r:id="rId9" tooltip="[3] Shen &amp; Tamkin (2026) ↗"/>
-          </p:cNvPr>
-          <p:cNvSpPr/>
-          <p:nvPr/>
-        </p:nvSpPr>
-        <p:spPr>
-          <a:xfrm>
-            <a:off x="4343400" y="6401633"/>
-            <a:ext cx="1379220" cy="160020"/>
+            <a:hlinkClick r:id="rId9" tooltip="[3] Codex sandbox ↗"/>
+          </p:cNvPr>
+          <p:cNvSpPr/>
+          <p:nvPr/>
+        </p:nvSpPr>
+        <p:spPr>
+          <a:xfrm>
+            <a:off x="4709160" y="6401633"/>
+            <a:ext cx="1051560" cy="160020"/>
           </a:xfrm>
           <a:prstGeom prst="rect">
             <a:avLst/>
@@ -5699,14 +5754,45 @@
       <p:sp>
         <p:nvSpPr>
           <p:cNvPr id="11" name="Shape 8">
-            <a:hlinkClick r:id="rId10" tooltip="[4] OWASP, Prompt Injection ↗"/>
-          </p:cNvPr>
-          <p:cNvSpPr/>
-          <p:nvPr/>
-        </p:nvSpPr>
-        <p:spPr>
-          <a:xfrm>
-            <a:off x="5844540" y="6401633"/>
+            <a:hlinkClick r:id="rId10" tooltip="[4] Claude Code sandboxing ↗"/>
+          </p:cNvPr>
+          <p:cNvSpPr/>
+          <p:nvPr/>
+        </p:nvSpPr>
+        <p:spPr>
+          <a:xfrm>
+            <a:off x="5882640" y="6401633"/>
+            <a:ext cx="1524000" cy="160020"/>
+          </a:xfrm>
+          <a:prstGeom prst="rect">
+            <a:avLst/>
+          </a:prstGeom>
+          <a:solidFill>
+            <a:srgbClr val="FFFFFF">
+              <a:alpha val="0"/>
+            </a:srgbClr>
+          </a:solidFill>
+          <a:ln w="12700">
+            <a:solidFill>
+              <a:srgbClr val="FFFFFF">
+                <a:alpha val="0"/>
+              </a:srgbClr>
+            </a:solidFill>
+            <a:prstDash val="solid"/>
+          </a:ln>
+        </p:spPr>
+      </p:sp>
+      <p:sp>
+        <p:nvSpPr>
+          <p:cNvPr id="12" name="Shape 9">
+            <a:hlinkClick r:id="rId11" tooltip="[5] OWASP, Prompt Injection ↗"/>
+          </p:cNvPr>
+          <p:cNvSpPr/>
+          <p:nvPr/>
+        </p:nvSpPr>
+        <p:spPr>
+          <a:xfrm>
+            <a:off x="7528560" y="6401633"/>
             <a:ext cx="1577340" cy="160020"/>
           </a:xfrm>
           <a:prstGeom prst="rect">
@@ -6120,7 +6206,7 @@
       <p:sp>
         <p:nvSpPr>
           <p:cNvPr id="14" name="Shape 11">
-            <a:hlinkClick r:id="rId13" tooltip="[4] Codex security docs ↗"/>
+            <a:hlinkClick r:id="rId13" tooltip="[4] Codex approvals &amp; security ↗"/>
           </p:cNvPr>
           <p:cNvSpPr/>
           <p:nvPr/>
@@ -6128,7 +6214,7 @@
         <p:spPr>
           <a:xfrm>
             <a:off x="6012180" y="6226373"/>
-            <a:ext cx="1295400" cy="160020"/>
+            <a:ext cx="1661160" cy="160020"/>
           </a:xfrm>
           <a:prstGeom prst="rect">
             <a:avLst/>
@@ -6158,7 +6244,7 @@
         </p:nvSpPr>
         <p:spPr>
           <a:xfrm>
-            <a:off x="7429500" y="6226373"/>
+            <a:off x="7795260" y="6226373"/>
             <a:ext cx="1691640" cy="160020"/>
           </a:xfrm>
           <a:prstGeom prst="rect">
@@ -6237,7 +6323,7 @@
       </p:grpSpPr>
       <p:pic>
         <p:nvPicPr>
-          <p:cNvPr id="2" name="Image 0" descr="Build what interests you with AI, then learn how it works.">    </p:cNvPr>
+          <p:cNvPr id="2" name="Image 0" descr="Build something people can use. Learn as it grows.">    </p:cNvPr>
           <p:cNvPicPr>
             <a:picLocks noChangeAspect="1"/>
           </p:cNvPicPr>
@@ -6269,7 +6355,7 @@
         </p:nvSpPr>
         <p:spPr>
           <a:xfrm>
-            <a:off x="7678171" y="4619506"/>
+            <a:off x="1694406" y="3644146"/>
             <a:ext cx="198120" cy="152400"/>
           </a:xfrm>
           <a:prstGeom prst="rect">
@@ -6293,38 +6379,7 @@
       <p:sp>
         <p:nvSpPr>
           <p:cNvPr id="4" name="Shape 1">
-            <a:hlinkClick r:id="rId3" tooltip="[2]"/>
-          </p:cNvPr>
-          <p:cNvSpPr/>
-          <p:nvPr/>
-        </p:nvSpPr>
-        <p:spPr>
-          <a:xfrm>
-            <a:off x="7109064" y="4832866"/>
-            <a:ext cx="198120" cy="152400"/>
-          </a:xfrm>
-          <a:prstGeom prst="rect">
-            <a:avLst/>
-          </a:prstGeom>
-          <a:solidFill>
-            <a:srgbClr val="FFFFFF">
-              <a:alpha val="0"/>
-            </a:srgbClr>
-          </a:solidFill>
-          <a:ln w="12700">
-            <a:solidFill>
-              <a:srgbClr val="FFFFFF">
-                <a:alpha val="0"/>
-              </a:srgbClr>
-            </a:solidFill>
-            <a:prstDash val="solid"/>
-          </a:ln>
-        </p:spPr>
-      </p:sp>
-      <p:sp>
-        <p:nvSpPr>
-          <p:cNvPr id="5" name="Shape 2">
-            <a:hlinkClick r:id="rId4" tooltip="[1] MLB Statcast glossary (xBA) ↗"/>
+            <a:hlinkClick r:id="rId3" tooltip="[1] Baseball Savant CSV fields ↗"/>
           </p:cNvPr>
           <p:cNvSpPr/>
           <p:nvPr/>
@@ -6332,37 +6387,6 @@
         <p:spPr>
           <a:xfrm>
             <a:off x="1188720" y="6401633"/>
-            <a:ext cx="1737360" cy="160020"/>
-          </a:xfrm>
-          <a:prstGeom prst="rect">
-            <a:avLst/>
-          </a:prstGeom>
-          <a:solidFill>
-            <a:srgbClr val="FFFFFF">
-              <a:alpha val="0"/>
-            </a:srgbClr>
-          </a:solidFill>
-          <a:ln w="12700">
-            <a:solidFill>
-              <a:srgbClr val="FFFFFF">
-                <a:alpha val="0"/>
-              </a:srgbClr>
-            </a:solidFill>
-            <a:prstDash val="solid"/>
-          </a:ln>
-        </p:spPr>
-      </p:sp>
-      <p:sp>
-        <p:nvSpPr>
-          <p:cNvPr id="6" name="Shape 3">
-            <a:hlinkClick r:id="rId5" tooltip="[2] Baseball Savant CSV fields ↗"/>
-          </p:cNvPr>
-          <p:cNvSpPr/>
-          <p:nvPr/>
-        </p:nvSpPr>
-        <p:spPr>
-          <a:xfrm>
-            <a:off x="3048000" y="6401633"/>
             <a:ext cx="1615440" cy="160020"/>
           </a:xfrm>
           <a:prstGeom prst="rect">
@@ -6473,7 +6497,7 @@
         </p:nvSpPr>
         <p:spPr>
           <a:xfrm>
-            <a:off x="10591800" y="4524137"/>
+            <a:off x="2537460" y="4705469"/>
             <a:ext cx="167640" cy="137160"/>
           </a:xfrm>
           <a:prstGeom prst="rect">
@@ -7029,14 +7053,14 @@
       <p:sp>
         <p:nvSpPr>
           <p:cNvPr id="3" name="Shape 0">
-            <a:hlinkClick r:id="rId2" tooltip="[3]"/>
-          </p:cNvPr>
-          <p:cNvSpPr/>
-          <p:nvPr/>
-        </p:nvSpPr>
-        <p:spPr>
-          <a:xfrm>
-            <a:off x="8515731" y="2127766"/>
+            <a:hlinkClick r:id="rId2" tooltip="[4]"/>
+          </p:cNvPr>
+          <p:cNvSpPr/>
+          <p:nvPr/>
+        </p:nvSpPr>
+        <p:spPr>
+          <a:xfrm>
+            <a:off x="8515731" y="2082046"/>
             <a:ext cx="198120" cy="152400"/>
           </a:xfrm>
           <a:prstGeom prst="rect">
@@ -7060,14 +7084,14 @@
       <p:sp>
         <p:nvSpPr>
           <p:cNvPr id="4" name="Shape 1">
-            <a:hlinkClick r:id="rId3" tooltip="[2]"/>
-          </p:cNvPr>
-          <p:cNvSpPr/>
-          <p:nvPr/>
-        </p:nvSpPr>
-        <p:spPr>
-          <a:xfrm>
-            <a:off x="9902343" y="4512826"/>
+            <a:hlinkClick r:id="rId3" tooltip="[1]"/>
+          </p:cNvPr>
+          <p:cNvSpPr/>
+          <p:nvPr/>
+        </p:nvSpPr>
+        <p:spPr>
+          <a:xfrm>
+            <a:off x="3255378" y="2348746"/>
             <a:ext cx="198120" cy="152400"/>
           </a:xfrm>
           <a:prstGeom prst="rect">
@@ -7091,14 +7115,14 @@
       <p:sp>
         <p:nvSpPr>
           <p:cNvPr id="5" name="Shape 2">
-            <a:hlinkClick r:id="rId4" tooltip="[1]"/>
-          </p:cNvPr>
-          <p:cNvSpPr/>
-          <p:nvPr/>
-        </p:nvSpPr>
-        <p:spPr>
-          <a:xfrm>
-            <a:off x="11384280" y="1289566"/>
+            <a:hlinkClick r:id="rId4" tooltip="[2]"/>
+          </p:cNvPr>
+          <p:cNvSpPr/>
+          <p:nvPr/>
+        </p:nvSpPr>
+        <p:spPr>
+          <a:xfrm>
+            <a:off x="3592662" y="3156466"/>
             <a:ext cx="198120" cy="152400"/>
           </a:xfrm>
           <a:prstGeom prst="rect">
@@ -7122,7 +7146,38 @@
       <p:sp>
         <p:nvSpPr>
           <p:cNvPr id="6" name="Shape 3">
-            <a:hlinkClick r:id="rId5" tooltip="[1] Bertran et al., PNAS (2026) ↗"/>
+            <a:hlinkClick r:id="rId5" tooltip="[3]"/>
+          </p:cNvPr>
+          <p:cNvSpPr/>
+          <p:nvPr/>
+        </p:nvSpPr>
+        <p:spPr>
+          <a:xfrm>
+            <a:off x="6316111" y="3156466"/>
+            <a:ext cx="198120" cy="152400"/>
+          </a:xfrm>
+          <a:prstGeom prst="rect">
+            <a:avLst/>
+          </a:prstGeom>
+          <a:solidFill>
+            <a:srgbClr val="FFFFFF">
+              <a:alpha val="0"/>
+            </a:srgbClr>
+          </a:solidFill>
+          <a:ln w="12700">
+            <a:solidFill>
+              <a:srgbClr val="FFFFFF">
+                <a:alpha val="0"/>
+              </a:srgbClr>
+            </a:solidFill>
+            <a:prstDash val="solid"/>
+          </a:ln>
+        </p:spPr>
+      </p:sp>
+      <p:sp>
+        <p:nvSpPr>
+          <p:cNvPr id="7" name="Shape 4">
+            <a:hlinkClick r:id="rId6" tooltip="[1] Silberzahn et al. (2018) ↗"/>
           </p:cNvPr>
           <p:cNvSpPr/>
           <p:nvPr/>
@@ -7130,6 +7185,37 @@
         <p:spPr>
           <a:xfrm>
             <a:off x="1188720" y="6401633"/>
+            <a:ext cx="1432560" cy="160020"/>
+          </a:xfrm>
+          <a:prstGeom prst="rect">
+            <a:avLst/>
+          </a:prstGeom>
+          <a:solidFill>
+            <a:srgbClr val="FFFFFF">
+              <a:alpha val="0"/>
+            </a:srgbClr>
+          </a:solidFill>
+          <a:ln w="12700">
+            <a:solidFill>
+              <a:srgbClr val="FFFFFF">
+                <a:alpha val="0"/>
+              </a:srgbClr>
+            </a:solidFill>
+            <a:prstDash val="solid"/>
+          </a:ln>
+        </p:spPr>
+      </p:sp>
+      <p:sp>
+        <p:nvSpPr>
+          <p:cNvPr id="8" name="Shape 5">
+            <a:hlinkClick r:id="rId7" tooltip="[2] Bertran et al., PNAS (2026) ↗"/>
+          </p:cNvPr>
+          <p:cNvSpPr/>
+          <p:nvPr/>
+        </p:nvSpPr>
+        <p:spPr>
+          <a:xfrm>
+            <a:off x="2743200" y="6401633"/>
             <a:ext cx="1661160" cy="160020"/>
           </a:xfrm>
           <a:prstGeom prst="rect">
@@ -7152,15 +7238,15 @@
       </p:sp>
       <p:sp>
         <p:nvSpPr>
-          <p:cNvPr id="7" name="Shape 4">
-            <a:hlinkClick r:id="rId6" tooltip="[2] Data: released runs (GitHub) ↗"/>
-          </p:cNvPr>
-          <p:cNvSpPr/>
-          <p:nvPr/>
-        </p:nvSpPr>
-        <p:spPr>
-          <a:xfrm>
-            <a:off x="2971800" y="6401633"/>
+          <p:cNvPr id="9" name="Shape 6">
+            <a:hlinkClick r:id="rId8" tooltip="[3] Data: released runs (GitHub) ↗"/>
+          </p:cNvPr>
+          <p:cNvSpPr/>
+          <p:nvPr/>
+        </p:nvSpPr>
+        <p:spPr>
+          <a:xfrm>
+            <a:off x="4526280" y="6401633"/>
             <a:ext cx="1714500" cy="160020"/>
           </a:xfrm>
           <a:prstGeom prst="rect">
@@ -7183,15 +7269,15 @@
       </p:sp>
       <p:sp>
         <p:nvSpPr>
-          <p:cNvPr id="8" name="Shape 5">
-            <a:hlinkClick r:id="rId7" tooltip="[3] Silberzahn et al., soccer data (OSF) ↗"/>
-          </p:cNvPr>
-          <p:cNvSpPr/>
-          <p:nvPr/>
-        </p:nvSpPr>
-        <p:spPr>
-          <a:xfrm>
-            <a:off x="4808220" y="6401633"/>
+          <p:cNvPr id="10" name="Shape 7">
+            <a:hlinkClick r:id="rId9" tooltip="[4] Silberzahn et al., soccer data (OSF) ↗"/>
+          </p:cNvPr>
+          <p:cNvSpPr/>
+          <p:nvPr/>
+        </p:nvSpPr>
+        <p:spPr>
+          <a:xfrm>
+            <a:off x="6362700" y="6401633"/>
             <a:ext cx="2019300" cy="160020"/>
           </a:xfrm>
           <a:prstGeom prst="rect">
@@ -7271,7 +7357,7 @@
         </p:nvSpPr>
         <p:spPr>
           <a:xfrm>
-            <a:off x="5730773" y="1670566"/>
+            <a:off x="3672985" y="1754386"/>
             <a:ext cx="198120" cy="152400"/>
           </a:xfrm>
           <a:prstGeom prst="rect">
@@ -7295,7 +7381,69 @@
       <p:sp>
         <p:nvSpPr>
           <p:cNvPr id="4" name="Shape 1">
-            <a:hlinkClick r:id="rId3" tooltip="[1]"/>
+            <a:hlinkClick r:id="rId3" tooltip="[3]"/>
+          </p:cNvPr>
+          <p:cNvSpPr/>
+          <p:nvPr/>
+        </p:nvSpPr>
+        <p:spPr>
+          <a:xfrm>
+            <a:off x="11071631" y="2981206"/>
+            <a:ext cx="198120" cy="152400"/>
+          </a:xfrm>
+          <a:prstGeom prst="rect">
+            <a:avLst/>
+          </a:prstGeom>
+          <a:solidFill>
+            <a:srgbClr val="FFFFFF">
+              <a:alpha val="0"/>
+            </a:srgbClr>
+          </a:solidFill>
+          <a:ln w="12700">
+            <a:solidFill>
+              <a:srgbClr val="FFFFFF">
+                <a:alpha val="0"/>
+              </a:srgbClr>
+            </a:solidFill>
+            <a:prstDash val="solid"/>
+          </a:ln>
+        </p:spPr>
+      </p:sp>
+      <p:sp>
+        <p:nvSpPr>
+          <p:cNvPr id="5" name="Shape 2">
+            <a:hlinkClick r:id="rId4" tooltip="[2]"/>
+          </p:cNvPr>
+          <p:cNvSpPr/>
+          <p:nvPr/>
+        </p:nvSpPr>
+        <p:spPr>
+          <a:xfrm>
+            <a:off x="11374450" y="4329946"/>
+            <a:ext cx="198120" cy="152400"/>
+          </a:xfrm>
+          <a:prstGeom prst="rect">
+            <a:avLst/>
+          </a:prstGeom>
+          <a:solidFill>
+            <a:srgbClr val="FFFFFF">
+              <a:alpha val="0"/>
+            </a:srgbClr>
+          </a:solidFill>
+          <a:ln w="12700">
+            <a:solidFill>
+              <a:srgbClr val="FFFFFF">
+                <a:alpha val="0"/>
+              </a:srgbClr>
+            </a:solidFill>
+            <a:prstDash val="solid"/>
+          </a:ln>
+        </p:spPr>
+      </p:sp>
+      <p:sp>
+        <p:nvSpPr>
+          <p:cNvPr id="6" name="Shape 3">
+            <a:hlinkClick r:id="rId5" tooltip="[1]"/>
           </p:cNvPr>
           <p:cNvSpPr/>
           <p:nvPr/>
@@ -7325,8 +7473,8 @@
       </p:sp>
       <p:sp>
         <p:nvSpPr>
-          <p:cNvPr id="5" name="Shape 2">
-            <a:hlinkClick r:id="rId4" tooltip="[1] Bertran et al., PNAS (2026) ↗"/>
+          <p:cNvPr id="7" name="Shape 4">
+            <a:hlinkClick r:id="rId6" tooltip="[1] Bertran et al., PNAS (2026) ↗"/>
           </p:cNvPr>
           <p:cNvSpPr/>
           <p:nvPr/>
@@ -7356,8 +7504,8 @@
       </p:sp>
       <p:sp>
         <p:nvSpPr>
-          <p:cNvPr id="6" name="Shape 3">
-            <a:hlinkClick r:id="rId5" tooltip="[2] Data: released runs (GitHub) ↗"/>
+          <p:cNvPr id="8" name="Shape 5">
+            <a:hlinkClick r:id="rId7" tooltip="[2] Data: released runs (GitHub) ↗"/>
           </p:cNvPr>
           <p:cNvSpPr/>
           <p:nvPr/>
@@ -7366,6 +7514,37 @@
           <a:xfrm>
             <a:off x="2971800" y="6401633"/>
             <a:ext cx="1714500" cy="160020"/>
+          </a:xfrm>
+          <a:prstGeom prst="rect">
+            <a:avLst/>
+          </a:prstGeom>
+          <a:solidFill>
+            <a:srgbClr val="FFFFFF">
+              <a:alpha val="0"/>
+            </a:srgbClr>
+          </a:solidFill>
+          <a:ln w="12700">
+            <a:solidFill>
+              <a:srgbClr val="FFFFFF">
+                <a:alpha val="0"/>
+              </a:srgbClr>
+            </a:solidFill>
+            <a:prstDash val="solid"/>
+          </a:ln>
+        </p:spPr>
+      </p:sp>
+      <p:sp>
+        <p:nvSpPr>
+          <p:cNvPr id="9" name="Shape 6">
+            <a:hlinkClick r:id="rId8" tooltip="[3] Strong CS prompt (GitHub) ↗"/>
+          </p:cNvPr>
+          <p:cNvSpPr/>
+          <p:nvPr/>
+        </p:nvSpPr>
+        <p:spPr>
+          <a:xfrm>
+            <a:off x="4808220" y="6401633"/>
+            <a:ext cx="1630680" cy="160020"/>
           </a:xfrm>
           <a:prstGeom prst="rect">
             <a:avLst/>
@@ -7710,7 +7889,7 @@
         </p:nvSpPr>
         <p:spPr>
           <a:xfrm>
-            <a:off x="4355211" y="5061466"/>
+            <a:off x="4814347" y="5061466"/>
             <a:ext cx="198120" cy="152400"/>
           </a:xfrm>
           <a:prstGeom prst="rect">
@@ -7741,7 +7920,7 @@
         </p:nvSpPr>
         <p:spPr>
           <a:xfrm>
-            <a:off x="9667799" y="5061466"/>
+            <a:off x="10455021" y="5061466"/>
             <a:ext cx="198120" cy="152400"/>
           </a:xfrm>
           <a:prstGeom prst="rect">
@@ -7913,7 +8092,7 @@
       </p:grpSpPr>
       <p:pic>
         <p:nvPicPr>
-          <p:cNvPr id="2" name="Image 0" descr="Attempt first, then ask AI for hints, not answers.">    </p:cNvPr>
+          <p:cNvPr id="2" name="Image 0" descr="Use AI for guided practice, then test yourself.">    </p:cNvPr>
           <p:cNvPicPr>
             <a:picLocks noChangeAspect="1"/>
           </p:cNvPicPr>
@@ -7945,7 +8124,7 @@
         </p:nvSpPr>
         <p:spPr>
           <a:xfrm>
-            <a:off x="4620897" y="1655326"/>
+            <a:off x="3942832" y="1655326"/>
             <a:ext cx="198120" cy="152400"/>
           </a:xfrm>
           <a:prstGeom prst="rect">
@@ -7976,7 +8155,7 @@
         </p:nvSpPr>
         <p:spPr>
           <a:xfrm>
-            <a:off x="7932558" y="1655326"/>
+            <a:off x="7864267" y="1655326"/>
             <a:ext cx="198120" cy="152400"/>
           </a:xfrm>
           <a:prstGeom prst="rect">
@@ -8000,38 +8179,7 @@
       <p:sp>
         <p:nvSpPr>
           <p:cNvPr id="5" name="Shape 2">
-            <a:hlinkClick r:id="rId4" tooltip="[1]"/>
-          </p:cNvPr>
-          <p:cNvSpPr/>
-          <p:nvPr/>
-        </p:nvSpPr>
-        <p:spPr>
-          <a:xfrm>
-            <a:off x="8976360" y="5030986"/>
-            <a:ext cx="198120" cy="152400"/>
-          </a:xfrm>
-          <a:prstGeom prst="rect">
-            <a:avLst/>
-          </a:prstGeom>
-          <a:solidFill>
-            <a:srgbClr val="FFFFFF">
-              <a:alpha val="0"/>
-            </a:srgbClr>
-          </a:solidFill>
-          <a:ln w="12700">
-            <a:solidFill>
-              <a:srgbClr val="FFFFFF">
-                <a:alpha val="0"/>
-              </a:srgbClr>
-            </a:solidFill>
-            <a:prstDash val="solid"/>
-          </a:ln>
-        </p:spPr>
-      </p:sp>
-      <p:sp>
-        <p:nvSpPr>
-          <p:cNvPr id="6" name="Shape 3">
-            <a:hlinkClick r:id="rId5" tooltip="[1] Gallegos (2026) ↗"/>
+            <a:hlinkClick r:id="rId4" tooltip="[1] Gallegos (2026) ↗"/>
           </p:cNvPr>
           <p:cNvSpPr/>
           <p:nvPr/>
@@ -8061,8 +8209,8 @@
       </p:sp>
       <p:sp>
         <p:nvSpPr>
-          <p:cNvPr id="7" name="Shape 4">
-            <a:hlinkClick r:id="rId6" tooltip="[2] Yang et al. (2026) ↗"/>
+          <p:cNvPr id="6" name="Shape 3">
+            <a:hlinkClick r:id="rId5" tooltip="[2] Yang et al. (2026) ↗"/>
           </p:cNvPr>
           <p:cNvSpPr/>
           <p:nvPr/>
@@ -8290,7 +8438,7 @@
       </p:grpSpPr>
       <p:pic>
         <p:nvPicPr>
-          <p:cNvPr id="2" name="Image 0" descr="Build the expertise to check and steer AI, step by step.">    </p:cNvPr>
+          <p:cNvPr id="2" name="Image 0" descr="Build understanding—and match AI help to the task.">    </p:cNvPr>
           <p:cNvPicPr>
             <a:picLocks noChangeAspect="1"/>
           </p:cNvPicPr>
@@ -8322,7 +8470,7 @@
         </p:nvSpPr>
         <p:spPr>
           <a:xfrm>
-            <a:off x="2683421" y="2097286"/>
+            <a:off x="2263399" y="2257306"/>
             <a:ext cx="198120" cy="152400"/>
           </a:xfrm>
           <a:prstGeom prst="rect">
@@ -8353,7 +8501,7 @@
         </p:nvSpPr>
         <p:spPr>
           <a:xfrm>
-            <a:off x="6813712" y="2097286"/>
+            <a:off x="2485187" y="2257306"/>
             <a:ext cx="198120" cy="152400"/>
           </a:xfrm>
           <a:prstGeom prst="rect">
@@ -8384,7 +8532,7 @@
         </p:nvSpPr>
         <p:spPr>
           <a:xfrm>
-            <a:off x="7072792" y="2097286"/>
+            <a:off x="6457386" y="2257306"/>
             <a:ext cx="198120" cy="152400"/>
           </a:xfrm>
           <a:prstGeom prst="rect">
@@ -8415,7 +8563,7 @@
         </p:nvSpPr>
         <p:spPr>
           <a:xfrm>
-            <a:off x="10029901" y="2177296"/>
+            <a:off x="8884311" y="2257306"/>
             <a:ext cx="198120" cy="152400"/>
           </a:xfrm>
           <a:prstGeom prst="rect">
@@ -8446,7 +8594,7 @@
         </p:nvSpPr>
         <p:spPr>
           <a:xfrm>
-            <a:off x="2916250" y="3103126"/>
+            <a:off x="3675332" y="3194566"/>
             <a:ext cx="198120" cy="152400"/>
           </a:xfrm>
           <a:prstGeom prst="rect">
@@ -8477,7 +8625,7 @@
         </p:nvSpPr>
         <p:spPr>
           <a:xfrm>
-            <a:off x="2916250" y="3423166"/>
+            <a:off x="3309206" y="3529846"/>
             <a:ext cx="198120" cy="152400"/>
           </a:xfrm>
           <a:prstGeom prst="rect">
@@ -8501,7 +8649,38 @@
       <p:sp>
         <p:nvSpPr>
           <p:cNvPr id="9" name="Shape 6">
-            <a:hlinkClick r:id="rId8" tooltip="[1] Gallup (2026) ↗"/>
+            <a:hlinkClick r:id="rId8" tooltip="[7]"/>
+          </p:cNvPr>
+          <p:cNvSpPr/>
+          <p:nvPr/>
+        </p:nvSpPr>
+        <p:spPr>
+          <a:xfrm>
+            <a:off x="7417879" y="3004066"/>
+            <a:ext cx="198120" cy="152400"/>
+          </a:xfrm>
+          <a:prstGeom prst="rect">
+            <a:avLst/>
+          </a:prstGeom>
+          <a:solidFill>
+            <a:srgbClr val="FFFFFF">
+              <a:alpha val="0"/>
+            </a:srgbClr>
+          </a:solidFill>
+          <a:ln w="12700">
+            <a:solidFill>
+              <a:srgbClr val="FFFFFF">
+                <a:alpha val="0"/>
+              </a:srgbClr>
+            </a:solidFill>
+            <a:prstDash val="solid"/>
+          </a:ln>
+        </p:spPr>
+      </p:sp>
+      <p:sp>
+        <p:nvSpPr>
+          <p:cNvPr id="10" name="Shape 7">
+            <a:hlinkClick r:id="rId9" tooltip="[1] Gallup (July 2026) ↗"/>
           </p:cNvPr>
           <p:cNvSpPr/>
           <p:nvPr/>
@@ -8509,37 +8688,68 @@
         <p:spPr>
           <a:xfrm>
             <a:off x="1188720" y="6226373"/>
-            <a:ext cx="960120" cy="160020"/>
-          </a:xfrm>
-          <a:prstGeom prst="rect">
-            <a:avLst/>
-          </a:prstGeom>
-          <a:solidFill>
-            <a:srgbClr val="FFFFFF">
-              <a:alpha val="0"/>
-            </a:srgbClr>
-          </a:solidFill>
-          <a:ln w="12700">
-            <a:solidFill>
-              <a:srgbClr val="FFFFFF">
-                <a:alpha val="0"/>
-              </a:srgbClr>
-            </a:solidFill>
-            <a:prstDash val="solid"/>
-          </a:ln>
-        </p:spPr>
-      </p:sp>
-      <p:sp>
-        <p:nvSpPr>
-          <p:cNvPr id="10" name="Shape 7">
-            <a:hlinkClick r:id="rId9" tooltip="[2] Brynjolfsson et al. (2026) ↗"/>
-          </p:cNvPr>
-          <p:cNvSpPr/>
-          <p:nvPr/>
-        </p:nvSpPr>
-        <p:spPr>
-          <a:xfrm>
-            <a:off x="2270760" y="6226373"/>
+            <a:ext cx="1181100" cy="160020"/>
+          </a:xfrm>
+          <a:prstGeom prst="rect">
+            <a:avLst/>
+          </a:prstGeom>
+          <a:solidFill>
+            <a:srgbClr val="FFFFFF">
+              <a:alpha val="0"/>
+            </a:srgbClr>
+          </a:solidFill>
+          <a:ln w="12700">
+            <a:solidFill>
+              <a:srgbClr val="FFFFFF">
+                <a:alpha val="0"/>
+              </a:srgbClr>
+            </a:solidFill>
+            <a:prstDash val="solid"/>
+          </a:ln>
+        </p:spPr>
+      </p:sp>
+      <p:sp>
+        <p:nvSpPr>
+          <p:cNvPr id="11" name="Shape 8">
+            <a:hlinkClick r:id="rId10" tooltip="[2] Gallup (April 2026) ↗"/>
+          </p:cNvPr>
+          <p:cNvSpPr/>
+          <p:nvPr/>
+        </p:nvSpPr>
+        <p:spPr>
+          <a:xfrm>
+            <a:off x="2491740" y="6226373"/>
+            <a:ext cx="1211580" cy="160020"/>
+          </a:xfrm>
+          <a:prstGeom prst="rect">
+            <a:avLst/>
+          </a:prstGeom>
+          <a:solidFill>
+            <a:srgbClr val="FFFFFF">
+              <a:alpha val="0"/>
+            </a:srgbClr>
+          </a:solidFill>
+          <a:ln w="12700">
+            <a:solidFill>
+              <a:srgbClr val="FFFFFF">
+                <a:alpha val="0"/>
+              </a:srgbClr>
+            </a:solidFill>
+            <a:prstDash val="solid"/>
+          </a:ln>
+        </p:spPr>
+      </p:sp>
+      <p:sp>
+        <p:nvSpPr>
+          <p:cNvPr id="12" name="Shape 9">
+            <a:hlinkClick r:id="rId11" tooltip="[3] Brynjolfsson et al. (2026) ↗"/>
+          </p:cNvPr>
+          <p:cNvSpPr/>
+          <p:nvPr/>
+        </p:nvSpPr>
+        <p:spPr>
+          <a:xfrm>
+            <a:off x="3825240" y="6226373"/>
             <a:ext cx="1562100" cy="160020"/>
           </a:xfrm>
           <a:prstGeom prst="rect">
@@ -8562,46 +8772,15 @@
       </p:sp>
       <p:sp>
         <p:nvSpPr>
-          <p:cNvPr id="11" name="Shape 8">
-            <a:hlinkClick r:id="rId10" tooltip="[3] Stanford Canaries tracker ↗"/>
-          </p:cNvPr>
-          <p:cNvSpPr/>
-          <p:nvPr/>
-        </p:nvSpPr>
-        <p:spPr>
-          <a:xfrm>
-            <a:off x="3954780" y="6226373"/>
-            <a:ext cx="1569720" cy="160020"/>
-          </a:xfrm>
-          <a:prstGeom prst="rect">
-            <a:avLst/>
-          </a:prstGeom>
-          <a:solidFill>
-            <a:srgbClr val="FFFFFF">
-              <a:alpha val="0"/>
-            </a:srgbClr>
-          </a:solidFill>
-          <a:ln w="12700">
-            <a:solidFill>
-              <a:srgbClr val="FFFFFF">
-                <a:alpha val="0"/>
-              </a:srgbClr>
-            </a:solidFill>
-            <a:prstDash val="solid"/>
-          </a:ln>
-        </p:spPr>
-      </p:sp>
-      <p:sp>
-        <p:nvSpPr>
-          <p:cNvPr id="12" name="Shape 9">
-            <a:hlinkClick r:id="rId11" tooltip="[4] Dratsch et al. (2023) ↗"/>
-          </p:cNvPr>
-          <p:cNvSpPr/>
-          <p:nvPr/>
-        </p:nvSpPr>
-        <p:spPr>
-          <a:xfrm>
-            <a:off x="5646420" y="6226373"/>
+          <p:cNvPr id="13" name="Shape 10">
+            <a:hlinkClick r:id="rId12" tooltip="[4] Dratsch et al. (2023) ↗"/>
+          </p:cNvPr>
+          <p:cNvSpPr/>
+          <p:nvPr/>
+        </p:nvSpPr>
+        <p:spPr>
+          <a:xfrm>
+            <a:off x="5509260" y="6226373"/>
             <a:ext cx="1333500" cy="160020"/>
           </a:xfrm>
           <a:prstGeom prst="rect">
@@ -8624,15 +8803,15 @@
       </p:sp>
       <p:sp>
         <p:nvSpPr>
-          <p:cNvPr id="13" name="Shape 10">
-            <a:hlinkClick r:id="rId12" tooltip="[5] Sinha &amp; Kapur (2021) ↗"/>
-          </p:cNvPr>
-          <p:cNvSpPr/>
-          <p:nvPr/>
-        </p:nvSpPr>
-        <p:spPr>
-          <a:xfrm>
-            <a:off x="7101840" y="6226373"/>
+          <p:cNvPr id="14" name="Shape 11">
+            <a:hlinkClick r:id="rId13" tooltip="[5] Sinha &amp; Kapur (2021) ↗"/>
+          </p:cNvPr>
+          <p:cNvSpPr/>
+          <p:nvPr/>
+        </p:nvSpPr>
+        <p:spPr>
+          <a:xfrm>
+            <a:off x="6964680" y="6226373"/>
             <a:ext cx="1356360" cy="160020"/>
           </a:xfrm>
           <a:prstGeom prst="rect">
@@ -8655,15 +8834,15 @@
       </p:sp>
       <p:sp>
         <p:nvSpPr>
-          <p:cNvPr id="14" name="Shape 11">
-            <a:hlinkClick r:id="rId13" tooltip="[6] Palazzo et al. (2010) ↗"/>
-          </p:cNvPr>
-          <p:cNvSpPr/>
-          <p:nvPr/>
-        </p:nvSpPr>
-        <p:spPr>
-          <a:xfrm>
-            <a:off x="8580120" y="6226373"/>
+          <p:cNvPr id="15" name="Shape 12">
+            <a:hlinkClick r:id="rId14" tooltip="[6] Palazzo et al. (2010) ↗"/>
+          </p:cNvPr>
+          <p:cNvSpPr/>
+          <p:nvPr/>
+        </p:nvSpPr>
+        <p:spPr>
+          <a:xfrm>
+            <a:off x="8442960" y="6226373"/>
             <a:ext cx="1325880" cy="160020"/>
           </a:xfrm>
           <a:prstGeom prst="rect">
@@ -8686,8 +8865,8 @@
       </p:sp>
       <p:sp>
         <p:nvSpPr>
-          <p:cNvPr id="15" name="Shape 12">
-            <a:hlinkClick r:id="rId14" tooltip="[7] Eloundou et al. (2024) ↗"/>
+          <p:cNvPr id="16" name="Shape 13">
+            <a:hlinkClick r:id="rId15" tooltip="[7] Tetzlaff et al. (2025) ↗"/>
           </p:cNvPr>
           <p:cNvSpPr/>
           <p:nvPr/>
@@ -8695,6 +8874,37 @@
         <p:spPr>
           <a:xfrm>
             <a:off x="609600" y="6401633"/>
+            <a:ext cx="1325880" cy="160020"/>
+          </a:xfrm>
+          <a:prstGeom prst="rect">
+            <a:avLst/>
+          </a:prstGeom>
+          <a:solidFill>
+            <a:srgbClr val="FFFFFF">
+              <a:alpha val="0"/>
+            </a:srgbClr>
+          </a:solidFill>
+          <a:ln w="12700">
+            <a:solidFill>
+              <a:srgbClr val="FFFFFF">
+                <a:alpha val="0"/>
+              </a:srgbClr>
+            </a:solidFill>
+            <a:prstDash val="solid"/>
+          </a:ln>
+        </p:spPr>
+      </p:sp>
+      <p:sp>
+        <p:nvSpPr>
+          <p:cNvPr id="17" name="Shape 14">
+            <a:hlinkClick r:id="rId16" tooltip="[8] Eloundou et al. (2024) ↗"/>
+          </p:cNvPr>
+          <p:cNvSpPr/>
+          <p:nvPr/>
+        </p:nvSpPr>
+        <p:spPr>
+          <a:xfrm>
+            <a:off x="2057400" y="6401633"/>
             <a:ext cx="1402080" cy="160020"/>
           </a:xfrm>
           <a:prstGeom prst="rect">

</xml_diff>

<commit_message>
Deploying to gh-pages from @ treese41528/treese41528.github.io@28a7d4a0911e89f01edfd438b0d74cc4ab0330b2 🚀
</commit_message>
<xml_diff>
--- a/ComputationalDataScience/AI_First_Year/Purdue_AI_Talk.pptx
+++ b/ComputationalDataScience/AI_First_Year/Purdue_AI_Talk.pptx
@@ -518,18 +518,24 @@
           <a:p>
             <a:r>
               <a:rPr lang="en-US" dirty="0"/>
-              <a:t>Use AI appropriately
+              <a:t>SLIDE GUIDE · 01 / 17: Use AI appropriately
 as you grow at Purdue.
-Planned time: 90 seconds. The PowerPoint shows complete diagrams; progressive reveals are in the React deck.
-DELIVERY CUE
-Read the four questions on the right, one line each. Point out that later slides label the question they take up (top right) and that the closing slide answers all four.
-TRANSCRIPT
-This talk is about using AI appropriately as you develop at Purdue. You will meet it in your courses, in projects and research, and later in your career. The help that fits one activity may not fit another, and your use should change as your understanding grows.
-Before each use of AI, ask four questions. What is the purpose? Name what you want to learn or accomplish. What is allowed? Check the rules for assistance and for sharing data. What must I do myself? Protect the reasoning you need to learn. How will I check it? Verify the result, and be able to explain your contribution. These questions apply both when you are learning a new concept and when you are using familiar knowledge to produce something useful.
-Your statistics, mathematics, computing, and communication courses help you answer them, and so do independent practice and feedback from instructors, teammates, and mentors. Each part of this talk takes up one or two of these questions; the labels at the top of each slide show which. The last slide answers all four. The aim is to use powerful tools in ways that support your education and build your ability to understand, explain, and improve the work.
-TRANSITION
-Capable tools make these choices important from the beginning of your education.
-Evidence and service collection: September 10, 2026; sources added or rechecked through October 13, 2026. Foundations and course review: September 20, 2026. Slides, figures, and transcript revised October 13, 2026 for one flow across the four opening questions; appropriate AI use throughout Purdue remains the theme. Numerical citations were checked against the saved primary sources.</a:t>
+EXPLANATION
+These slides are about using AI well while you are still learning. You will meet AI tools in your courses, in projects and research, and later at work. The help that fits one activity may not fit another, and the right kind of help changes as your understanding grows.
+The slide offers four questions to ask before each use of AI:
+• What is the purpose? Name what you want to learn or accomplish. Practicing a new skill and producing a finished result call for different kinds of help.
+• What is allowed? Check the rules for assistance and for sharing data: your course’s policy now, and your employer’s policy later.
+• What must I do myself? Protect the reasoning you are trying to learn. If AI does that part for you, you can finish the assignment without gaining the skill.
+• How will I check it? Verify the result, and be ready to explain what you contributed.
+The strip along the bottom (early coursework, later coursework, projects and research, your career) is a reminder that the answers change over time. Help that would short-circuit practice in an introductory course can be reasonable later, once you can judge the output yourself.
+The rest of the slides take up these questions one or two at a time; the labels at the top of each slide (Purpose, Permission, Reasoning, Checking) show which ones. The last slide answers all four.
+NEXT: Learn to use AI as part of your Purdue education. These choices matter from the start: today’s AI tools are already capable, and surveyed employers say about a third of their entry-level jobs require AI skills.
+SOURCES &amp; CAVEATS
+SUGGESTED STRATEGY: The four questions
+What it suggests: Ask four questions before each use of AI: what the purpose is, what is allowed, what you must do yourself, and how you will check the result.
+What informs it: The research, rules, and documentation on the later slides, each of which takes up one or two of the questions.
+What has not been tested: This is a framework proposed for this presentation, not a tested intervention. No study is cited for the framework itself.
+No sources are cited on this slide.</a:t>
             </a:r>
             <a:endParaRPr lang="en-US" dirty="0"/>
           </a:p>
@@ -617,70 +623,80 @@
           <a:p>
             <a:r>
               <a:rPr lang="en-US" dirty="0"/>
-              <a:t>Connect what you learn to something you care about.
-Planned time: 110 seconds. The PowerPoint shows complete diagrams; progressive reveals are in the React deck.
-DELIVERY CUE
-Open with the process: course idea, related idea beyond the course, your interest; AI is the worked example. Reveal one row at a time and name both links: how the course idea helps with the middle idea, and how that idea reaches the interest. Close with the student prompt in the band.
-HOW EACH CONNECTION WORKS
-• The process: a topic from a course → a related idea beyond the course → a connection to an interest. The four rows are worked examples for an interest in AI; the arrows are illustrative conceptual connections, not prerequisites, and course timing varies.
-• Row 1, the chain rule → automatic differentiation → training. Automatic differentiation combines the derivatives of a program's elementary differentiable operations through the chain rule (Baydin et al., JMLR 2018); it does not differentiate every arbitrary program step. Backpropagation is reverse-mode differentiation applied to a network's loss: it computes the gradients, and an optimizer such as gradient descent uses them to update the weights. Reverse mode was described earlier (Linnainmaa 1970; Werbos 1974); Rumelhart, Hinton and Williams (Nature 1986) popularized backpropagation for training neural networks.
-• Row 2, conditional probability → Markov models and n-grams → next-token prediction. A Markov model predicts the next state from the current one; for text, the recent word sequence can be the state, so an n-gram predicts a word from the previous n−1 words (Jurafsky and Martin, ch. 3). Markov (1913) classified 20,000 letters of Pushkin's Eugene Onegin as vowels or consonants and computed the probability of a vowel given the previous one or two letters. A neural language model also learns conditional next-token probabilities, P(next token | context), but estimates them with a neural network over a much longer context, not with n-gram counts. The first GPT (2018) was trained on contiguous 512-token sequences (Radford et al., §§3.1 and 4.1); that is a detail of that model, not a general GPT context limit. To learn more: MA 43200, one possible later elective, covers discrete-time Markov chains.
-• Row 3, vectors and dot products → text embeddings → finding relevant passages. An embedding model represents each text as a vector; cosine similarity is the dot product of the two vectors after scaling each to length 1, so it measures whether they point the same way. Sentence-BERT made this practical for semantic search (about 5 seconds instead of 65 hours to find the most similar pair among 10,000 sentences). Some retrieval systems rank by unnormalized inner products instead: the original retrieval-augmented generation system retrieved passages by maximum inner product search (Lewis et al., 2020, §2.2). GenAI Studio Knowledge Bases retrieve passages by embedding similarity (slide 13).
-• Row 4, confidence intervals and coverage → conformal prediction. A confidence interval aims to cover a fixed parameter; a conformal prediction set aims to cover a future outcome. Split conformal prediction gives coverage of at least the chosen level (e.g., 90%) marginally, averaged over calibration and test points, when they are exchangeable. It needs no parametric distribution, but the calibration assumptions still matter (Angelopoulos and Bates).
-• Row 4, the research example: Quach et al. (Conformal language modeling, ICLR 2024; arXiv v2) calibrate a rule for sampling a language model's answers into a set, with filters for low-quality or redundant samples and a sampling budget. With probability at least 1 − δ over the calibration data, the chance that a new set contains no acceptable answer is at most ε. Acceptability is judged by a specified criterion during calibration and is not observed at deployment, so sampling stops by the calibrated rule, not because the system knows an answer is correct. The set contains at least one acceptable answer with that probability; it does not say which one or certify every answer. If calibration finds no valid configuration, the method abstains. It is a research procedure, not a default property of chatbot conversations.
-• Courses: MA 16100/16500 (calculus of one variable), STAT 41600 (probability, including conditional probability and Bayes' theorem), MA 35100 (vector spaces and matrices), STAT 35500 (sampling distributions and confidence intervals), as placed in the 2025–26 Data Science (Statistics) suggested plan. Students' course choices and timing vary by major, route, and catalog year.
-• Course check against the 2025–26 progression guides: MA 16100/16500 named in all three Data Science plans (the Statistics guides say 'Calculus I Option'); STAT 41600 and MA 35100 in all six Statistics and Data Science plans; STAT 35500 in the Data Science plans, Applied Statistics (35000 or 35500), and Statistics–Math (Statistics Honors lists STAT 35000); MA 43200 required in Statistics–Math, Statistics Honors, and Data Science (Mathematics), and a selective/elective option in Data Science (Statistics) and Data Science (CS); it is not listed in the Applied Statistics guide.
-VISUAL STEPS
-1. The chain rule → automatic differentiation → training a neural network: backpropagation computes gradients; an optimizer updates the weights.
-2. Conditional probability → Markov models and n-grams → predicting the next token.
-3. Vectors and dot products → text embeddings → finding relevant passages for an AI system.
-4. Confidence intervals and coverage → conformal prediction → research example: candidate answer sets.
-TRANSCRIPT
-A topic from class can be the starting point for exploring something you care about. Start with the course idea, find a related topic that extends beyond what the course covers, and follow that connection into your interests. Here, I am using AI as the example. Notice the topic in the middle of each row; that is the next idea you could investigate.
-The chain rule is how automatic differentiation combines derivatives, and backpropagation uses it to compute the gradients a neural network needs; an optimizer then updates the weights. Conditional probability leads to Markov models and n-grams, which predict a word from the few before it; Markov himself counted vowels and consonants in Pushkin's Eugene Onegin. A neural language model learns the same kind of probability: the next token, given its context. Vectors and dot products lead to text embeddings, which turn text into vectors, and cosine similarity compares them to rank relevant passages. And confidence intervals, with the idea of coverage, lead to conformal prediction: calibrated prediction sets with a chosen coverage level, under stated assumptions. Researchers have extended it to sets of candidate answers from a language model.
-Your turn: choose one topic from a course you are taking. Find a related idea beyond the course, and explain how it connects to something you care about.
-TRANSITION
-AI can also help you find connections like these for your own interests.
-CAVEATS
-The rows are worked examples of one process, using an interest in AI. Each arrow is an illustrative conceptual connection, not a prerequisite chain, and course timing varies: course codes come from the 2025–26 Data Science (Statistics) suggested plan, and MA 43200 is one possible later elective for Markov chains. The brief below explains each link and its limits: the history of backpropagation (popularized, not introduced, in 1986); how a neural language model differs from an n-gram model, and why GPT's 512-token training sequences (2018) are not a general limit; cosine similarity versus unnormalized inner products; and what conformal guarantees do and do not promise (marginal coverage under exchangeability; Quach et al.'s (ε, δ) guarantee of at least one acceptable candidate, with no knowledge at deployment of which one). The examples show how to build a connection, not how AI works in full.
+              <a:t>SLIDE GUIDE · 10 / 17: Connect what you learn to something you care about.
+The PowerPoint shows the complete slide; in the web version it builds in steps.
+EXPLANATION
+A topic from class can be the start of something you care about. This slide shows a three-part process: a course idea → a related idea beyond the course → a connection to your interests.
+“Beyond the course” can mean a book, documentation, an experiment, independent study, or a later course. Each row is a worked example using an interest in AI; your own interest might be music, medicine, sports, or something else. Each arrow needs an explanation: how the course idea helps you understand the middle idea, and how the middle idea reaches the interest.
+Row 1: the chain rule. The chain rule tells you how to differentiate a composition of functions. Automatic differentiation applies it step by step to compute the derivatives of a program built from simple operations. Training a neural network depends on this: backpropagation uses the chain rule to compute how the network’s error (its “loss”) changes with each weight, and an optimizer uses those gradients to adjust the weights.
+Row 2: conditional probability. P(A | B) is the probability of A given B. An n-gram model, a kind of Markov model for text, predicts a word from the previous n−1 words. A neural language model learns the same kind of quantity, the probability of the next token (a word or a piece of a word) given its context, but estimates it with a neural network over a much longer context.
+Row 3: vectors and dot products. An embedding model turns each piece of text into a vector, a list of numbers. Cosine similarity compares two vectors by the angle between them, cos θ = u·v / (‖u‖ ‖v‖), and is near 1 when they point the same way. Ranking passages by their cosine similarity to a question is how many AI systems find relevant text; slide 13 shows a real example.
+Row 4: confidence intervals and coverage. A 95% confidence interval comes from a method that captures the true value in about 95% of repeated samples; that rate is its coverage. Conformal prediction applies coverage to predictions: it produces a set of possible outcomes that contains the actual outcome with at least a chosen probability, such as 90%, averaged over cases and under stated assumptions. Researchers have extended it to language models, sampling candidate answers into a set so that the chance the set contains no acceptable answer is controlled; the set does not say which answer is the acceptable one.
+Your turn. Choose one topic from a course you are taking, find a related idea beyond the course, and explain how it connects to something you care about.
+NEXT: Use AI to connect your courses to your goals. The next slide applies the same three-part process to your own interests, with AI’s help.
+SOURCES &amp; CAVEATS
+Sources checked through October 21, 2026. Source numbers match the slide’s citations.
+ILLUSTRATIVE EXAMPLE: Four worked connections for an interest in AI
+What it shows: How a course idea can lead, through a related idea beyond the course, to an interest.
+What it is not: The arrows are illustrative conceptual connections, not prerequisites, and the examples show how to build a connection, not how AI works in full.
+RULES AND DOCUMENTATION: Course codes
+What it covers: Purdue’s 2025–26 Data Science (Statistics) suggested plan and course descriptions.
+What it says: MA 16100/16500 (Calculus I), STAT 41600 (probability), MA 35100 (linear algebra), and STAT 35500 (statistics for data science) appear in that plan. MA 43200 is one possible later elective that covers Markov chains.
+What to keep in mind: Course choices and timing vary by major, route, and catalog year; check your own plan of study.
+Sources: [1] [9] [10] [11]
+CONCEPT REFERENCE: Row 1: automatic differentiation and backpropagation
+What it explains: Automatic differentiation combines the derivatives of a program’s elementary operations through the chain rule (Baydin et al., 2018). Backpropagation is reverse-mode differentiation applied to a network’s loss; Rumelhart, Hinton and Williams (1986) popularized it for training neural networks.
+What to keep in mind: Reverse-mode differentiation was described earlier (Linnainmaa in 1970; Werbos in 1974), so 1986 marks its popularization, not its invention.
+Sources: [2] [3]
+CONCEPT REFERENCE: Row 2: n-grams and next-token prediction
+What it explains: An n-gram model predicts a word from the previous n−1 words (Jurafsky and Martin, ch. 3). Markov himself, in 1913, counted vowels and consonants in 20,000 letters of Pushkin’s Eugene Onegin. The first GPT (Radford et al., 2018) was trained to predict upcoming tokens with a transformer network.
+What to keep in mind: A neural language model estimates P(next token | context) with a network, not with n-gram counts. The first GPT’s 512-token training sequences were a detail of that model, not a general limit.
+Sources: [4] [5]
+CONCEPT REFERENCE: Row 3: embeddings and similarity search
+What it explains: Sentence-BERT (Reimers and Gurevych, 2019) produced sentence embeddings that can be compared with cosine similarity, making semantic search practical (about 5 seconds instead of 65 hours to find the most similar pair among 10,000 sentences).
+What to keep in mind: Some retrieval systems rank by unnormalized inner products instead; the original retrieval-augmented generation system did (Lewis et al., 2020).
+Sources: [6] [12]
+CONCEPT REFERENCE: Row 4: conformal prediction and candidate answer sets
+What it explains: Split conformal prediction gives coverage of at least the chosen level, averaged over calibration and test cases, when the cases are exchangeable; it needs no parametric model for the data, though exchangeability is itself an assumption (Angelopoulos and Bates). Quach et al. (2024) calibrate a rule for sampling a language model’s answers into a set: with high probability over the calibration data, the chance that a new set contains no acceptable answer is at most a chosen small value.
+What to keep in mind: Acceptability is judged during calibration and is not observed when the system is used, so the set does not say which answer is acceptable, and the method abstains if no valid setting exists. It is a research procedure, not a property of ordinary chatbot conversations.
+Sources: [7] [8]
 SOURCES
-Purdue Data Science (Statistics) progression guide, 2025–26
+[1] Purdue Data Science (Statistics) progression guide, 2025–26
 https://www.purdue.edu/science/archive/docs/current-students/majors/dsst-f25-dpg1.pdf
-Dated public DS Statistics plan. Data Science has separate Statistics, Computer Science, and Mathematics routes; the supporting course crosswalk distinguishes them.
-Purdue Mathematics course descriptions
+Suggested course sequence (PDF) from which the slide’s course codes come.
+[2] Baydin, Pearlmutter, Radul and Siskind (2018), Automatic differentiation in machine learning: a survey
+https://jmlr.org/papers/v18/17-468.html
+Survey of how automatic differentiation works and where backpropagation fits.
+[3] Rumelhart, Hinton and Williams (1986), Learning representations by back-propagating errors (Nature)
+https://doi.org/10.1038/323533a0
+The 1986 paper that popularized backpropagation for training neural networks.
+[4] Jurafsky and Martin, Speech and Language Processing, ch. 3: N-gram language models (draft of August 19, 2026)
+https://web.stanford.edu/~jurafsky/slp3/3.pdf
+Textbook chapter: n-gram models and Markov’s 1913 study of Eugene Onegin.
+[5] Radford, Narasimhan, Salimans and Sutskever (2018), Improving language understanding by generative pre-training (OpenAI)
+https://cdn.openai.com/research-covers/language-unsupervised/language_understanding_paper.pdf
+The first GPT paper: a transformer trained to predict upcoming tokens.
+[6] Reimers and Gurevych (2019), Sentence-BERT
+https://arxiv.org/abs/1908.10084
+Sentence embeddings compared by cosine similarity, which made semantic search practical.
+[7] Angelopoulos and Bates, A gentle introduction to conformal prediction
+https://arxiv.org/abs/2107.07511
+An accessible introduction to conformal prediction and its coverage guarantee.
+[8] Quach et al. (2024), Conformal language modeling (ICLR 2024; arXiv 2306.10193v2)
+https://arxiv.org/abs/2306.10193
+Research method: calibrated sets of candidate answers from a language model.
+[9] Purdue Mathematics course descriptions
 https://www.math.purdue.edu/academic/courses/Course-Description.html
-Supports the expanded coverage of proof, analysis, further linear algebra, discrete mathematics, optimization, signals, and stochastic processes. Application connections are the speaker's synthesis; requirements differ by route.
-Purdue Statistics undergraduate course descriptions, Fall 2026
+Mathematics course descriptions, including MA 43200 on Markov chains.
+[10] Purdue Statistics undergraduate course descriptions, Fall 2026
 https://www.stat.purdue.edu/academic_programs/undergraduate/index.php?semester=Fall&amp;year=2026
-Reviewed STAT 35000, 35500, 41600, 41700 and 41800 descriptions. A listed course is not necessarily required by every plan or offered to every student.
-Purdue MA 35100 Elementary Linear Algebra, Fall 2026
+Statistics course descriptions for Fall 2026, including STAT 35500 and STAT 41600.
+[11] Purdue MA 35100 Elementary Linear Algebra, Fall 2026
 https://www.math.purdue.edu/academic/courses/semester/202710/ma35100/index.html
-Vectors, matrices, linear systems and eigenvalues/eigenvectors. Neural-network application is the speaker's synthesis, not a promised course topic.
-Baydin, Pearlmutter, Radul and Siskind (2018), Automatic differentiation in machine learning: a survey
-https://jmlr.org/papers/v18/17-468.html
-JMLR 18. Automatic differentiation propagates derivatives through a program per the chain rule of differential calculus; it is more general than backpropagation, which is a special case of reverse-mode AD applied to a network's error as a function of its weights.
-Rumelhart, Hinton and Williams (1986), Learning representations by back-propagating errors (Nature)
-https://doi.org/10.1038/323533a0
-Nature 323:533–536. The paper that popularized back-propagation for training neural networks (reverse-mode differentiation had been described earlier, e.g., Linnainmaa 1970 and Werbos 1974): a backward pass applies the chain rule to propagate derivatives of the error, and the weights are adjusted by gradient descent. Saved copy is an author-hosted scan; key passages transcribed in the accompanying quotes file.
-Jurafsky and Martin, Speech and Language Processing, ch. 3: N-gram language models (draft of August 19, 2026)
-https://web.stanford.edu/~jurafsky/slp3/3.pdf
-Markov assumption: predict the next word from the previous n−1 words. Markov (1913) used what are now called Markov chains to predict whether a letter in Pushkin's Eugene Onegin would be a vowel or a consonant, classifying 20,000 letters. Large language models are trained to predict upcoming words; transformer-based models, introduced in later chapters, estimate the probabilities differently.
-Radford, Narasimhan, Salimans and Sutskever (2018), Improving language understanding by generative pre-training (OpenAI)
-https://cdn.openai.com/research-covers/language-unsupervised/language_understanding_paper.pdf
-The first GPT paper. Unsupervised pre-training maximizes the language-modeling likelihood Σ log P(u_i | u_{i−k}, …, u_{i−1}; Θ), where k is the size of the context window and P is a transformer network; training used contiguous sequences of 512 tokens from BooksCorpus (over 7,000 unpublished books), a detail of that 2018 model, not a general GPT context limit.
-Reimers and Gurevych (2019), Sentence-BERT
-https://arxiv.org/abs/1908.10084
-EMNLP 2019 (arXiv 1908.10084). Sentence embeddings that can be compared using cosine similarity, making semantic similarity search practical (about 5 seconds instead of 65 hours for 10,000 sentences).
-Lewis et al., Retrieval-Augmented Generation (2020)
+Course page for MA 35100: vectors, matrices, linear systems, and eigenvalues.
+[12] Lewis et al., Retrieval-Augmented Generation (2020)
 https://arxiv.org/abs/2005.11401
-Foundational retrieval-augmented generation research; retrieved context does not guarantee that generated claims are supported.
-Angelopoulos and Bates, A gentle introduction to conformal prediction
-https://arxiv.org/abs/2107.07511
-arXiv 2107.07511v6 (December 2022). Conformal prediction wraps any pre-trained model to produce prediction sets for future outcomes with a user-chosen coverage level, such as 90%. Split conformal coverage is marginal, averaged over the calibration and test points, and requires exchangeability; no parametric distribution is assumed.
-Quach et al. (2024), Conformal language modeling (ICLR 2024; arXiv 2306.10193v2)
-https://arxiv.org/abs/2306.10193
-Calibrates a stopping rule (with quality and diversity filters and a sampling budget) for sampling language-model outputs into a set, so that with probability at least 1 − δ over calibration the chance a new set contains no admissible answer is at most ε. Admissibility is observed only during calibration; the set does not identify which answer is admissible; the method abstains if no configuration is valid.
-Evidence and service collection: September 10, 2026; sources added or rechecked through October 13, 2026. Foundations and course review: September 20, 2026. Slides, figures, and transcript revised October 13, 2026 for one flow across the four opening questions; appropriate AI use throughout Purdue remains the theme. Numerical citations were checked against the saved primary sources.</a:t>
+The original retrieval-augmented generation system, which ranked passages by inner products.</a:t>
             </a:r>
             <a:endParaRPr lang="en-US" dirty="0"/>
           </a:p>
@@ -768,47 +784,58 @@
           <a:p>
             <a:r>
               <a:rPr lang="en-US" dirty="0"/>
-              <a:t>Use AI to connect your courses to your goals.
-Planned time: 100 seconds. The PowerPoint shows complete diagrams; progressive reveals are in the React deck.
-DELIVERY CUE
-Bridge from slide 10: now your own interest. Read the prompt and point to its three parts; walk the worked connection left to right and explain the middle idea. Then check, explain, follow one thread. Use the evidence panel briefly: writing your own reasons helped less-confident students; no AI was tested.
-WHY EXPLAIN IT YOURSELF: EVIDENCE AND LIMITS
-• Canning and Harackiewicz (2015, Motivation Science), Study 1: 88 undergraduates learned a left-to-right mental-math method for two-digit multiplication and were randomized to write how it could be useful in their own lives (self-generated utility value), to see its usefulness explained in the instructional slides (directly communicated), or to a control.
-• Outcome: problems solved correctly with the method on timed problem sets right after learning, adjusting for baseline multiplication skill. Perceived confidence was a continuous measure taken after the instruction and practice (and, for the supplied-relevance group, after that information; the authors report the manipulation did not change it). It is not a baseline measure.
-• Chart: Table 3's reported d values versus control, at one SD below mean confidence. Writing one's own reasons +0.59 (t(80) = 2.62, p = .01); being told −0.18 (t(80) = 0.82, p = .41, not significant). At one SD above mean confidence the reported values were +0.16 (p = .47) and +0.24 (p = .30), neither significant; nonsignificant estimates do not show that the conditions were equivalent.
-• Head to head, writing one's own reasons led to better performance than being told (p = .04), more so for less-confident students (interaction p = .04).
-• Study 2 added a combined condition, relevance information in the slides followed by writing one's own examples, which the authors describe as synergistic for less-confident students. So hearing relevance from someone else is not shown to be harmful when the student then writes their own.
-• The worked connection: Opta's expected goals is the probability a shot is scored given its situation, from a model fitted to nearly one million shots with over 20 variables, used by clubs and broadcasters (The Analyst, 2023). 'The share of similar past cases' is the simplest way to estimate such a probability from data. MLB's published xBA, the probability a batted ball becomes a hit given exit velocity and launch angle, is another conditional-probability example.
-• No study was found that tested AI-assisted connection-making; the routine is the speaker's recommendation, applying the evidence on writing about relevance and the talk's checking habits. Verify course descriptions and prerequisites in Purdue's official catalog.
-TRANSCRIPT
-On the last slide, AI was my example of an interest. Now use AI to explore connections to yours.
-Here is a routine. First, supply real context: the course, what you covered, and your interest. For example: I'm taking STAT 41600 and we covered conditional probability; I'm interested in sports analytics; suggest two connections, each with a course idea, a related topic beyond the course, and a sports application, with sources I can check and one next step. One connection it might suggest: conditional probability leads to estimating outcome probabilities from data, and that leads to expected goals, the chance a shot is scored given its situation, used to compare scoring chances.
-Second, check: open the sources and confirm they support the connection, and check courses in Purdue's catalog. Third, choose one connection and explain both links and why it matters to you. In one experiment, less-confident undergraduates who wrote how a math method could help them solved more problems right afterward than a control group; being told how it helps did not help them. That study did not test AI, but it is why I suggest writing the explanation yourself.
-Fourth, follow one thread: a dataset, a short reading, a small experiment, an elective, or a question for office hours.
-TRANSITION
-So far, how you use AI. Now the tools themselves: what kinds exist, and which of them may see your data.
-CAVEATS
-The routine is the speaker's instructional recommendation; no study tested AI-assisted connection-making. It applies slide 10's three-part process to the student's own interest. Evidence: Canning and Harackiewicz (2015), Study 1, 88 undergraduates; performance means problems solved correctly with a new mental-math method right after learning. The chart shows Table 3's reported d values versus control for students one SD below mean perceived confidence, a continuous measure taken after the instruction and practice (not a baseline measure). Writing one's own reasons +0.59 (p = .01); being told −0.18 (p = .41, not significant). For more confident students neither condition differed significantly from control, which does not show they were equivalent. In Study 2, a combined condition (being told, then writing one's own examples) ameliorated the negative effect of being told for less-confident students (the authors call the combination synergistic), so hearing relevance from someone else is not shown to be harmful when the student then writes their own. Details are in the brief below. Course rules still govern AI use.
+              <a:t>SLIDE GUIDE · 11 / 17: Use AI to connect your courses to your goals.
+EXPLANATION
+The previous slide used AI as the example interest. This slide shows how to use AI to explore connections to your own interests, in four steps.
+1. Supply real context. A vague request gets vague answers. Give the course, the topic you actually covered, your interest, and the form you want back. The example prompt names STAT 41600 and conditional probability and an interest in sports analytics, and asks for two three-part connections (a course idea, a related topic beyond the course, and a sports application), with sources you can check and one manageable next step. One connection it might suggest:
+• Conditional probability, P(A | B): the chance of A given B.
+• Estimating outcome probabilities from data: for example, the share of similar past cases that had the outcome.
+• Expected goals (xG) in soccer: the probability that a shot is scored given its situation (distance, angle, and so on), used to compare scoring chances.
+2. Check the suggestions. AI can invent sources or overstate connections. Open the sources and confirm that they support the connection, and check courses and prerequisites in Purdue’s official catalog.
+3. Choose one connection and explain both links, and why the connection matters to you, in your own words.
+4. Follow one thread: a dataset, a short reading, a small experiment, an elective, or a question for office hours.
+Why write the explanation yourself? The chart comes from an experiment with 88 undergraduates who learned a mental-math method. Among less-confident students, those who wrote how the method could be useful in their own lives solved more problems right afterward than a control group (d = +0.59, p = .01); those who were simply told how it was useful did not do better (d = −0.18, not statistically significant). The effect size d expresses a difference between groups in standard-deviation units. For more confident students, neither condition differed significantly from the control group, an inconclusive result rather than proof that the conditions were equivalent.
+That study did not test AI. It is the reason for the slide’s recommendation: let AI suggest connections, then explain the links in your own words. Course rules still govern AI use in coursework.
+NEXT: Know what the tool can do—and what you may share. So far, these slides have been about how you use AI. Next: the tools themselves, what they can do, and which of them may see your data.
+SOURCES &amp; CAVEATS
+Sources checked through October 21, 2026. Source numbers match the slide’s citations.
+SUGGESTED STRATEGY: The four-step routine
+What it suggests: Supply context, check the suggestions, explain one connection in your own words, and follow one thread.
+What informs it: Slide 10’s three-part process, the checking habits from earlier slides, and research on writing about relevance (below).
+What has not been tested: No study was found that tested AI-assisted connection-making. This is a suggested routine, not a tested intervention.
+ILLUSTRATIVE EXAMPLE: Expected goals as a conditional probability
+What it shows: A real application of conditional probability. Opta’s expected goals (xG) is the probability that a shot is scored given its situation, from a model fitted to nearly one million shots with over 20 variables. MLB’s expected batting average (xBA), the probability that a batted ball becomes a hit given its exit velocity and launch angle (and, for some batted balls, the batter’s sprint speed), is a baseball example.
+What it is not: The connection on the slide was written from published sources to show what a useful answer looks like; it is not a recorded AI response. “The share of similar past cases” is the simplest way to estimate such a probability; commercial models are more complex.
+Sources: [2] [4]
+RESEARCH FINDING: Writing your own reasons helped less-confident students
+What was studied: Canning and Harackiewicz (2015), Study 1: 88 undergraduates learned a mental-math method for two-digit multiplication and were randomly assigned to write how it could be useful in their own lives, to be told its usefulness in the instructional slides, or to a control condition.
+What the source supports: For less-confident students (one standard deviation below the average confidence rating), writing their own reasons improved the number of problems solved right afterward (d = +0.59 vs. control, p = .01); being told did not (d = −0.18, p = .41).
+What limits the conclusion: Confidence was measured after the lesson, not beforehand. For more confident students, neither condition differed significantly from control, which does not show they were equivalent. In Study 2, being told and then writing one’s own examples worked well together, so hearing about relevance is not shown to be harmful when students then write their own. No AI was tested, and the outcome was immediate performance with one method.
+Sources: [3]
+RULES AND DOCUMENTATION: Check courses in the official catalog
+What it covers: Purdue’s course descriptions and the 2025–26 Data Science (Statistics) plan; Purdue’s AI guidance for courses.
+What it says: Course descriptions and prerequisites are authoritative in Purdue’s catalog. Course rules govern AI use in coursework.
+What to keep in mind: A course listed in a catalog is not necessarily required in every plan or offered every semester.
+Sources: [1] [5] [6]
 SOURCES
-Purdue Statistics undergraduate course descriptions, Fall 2026
+[1] Purdue Statistics undergraduate course descriptions, Fall 2026
 https://www.stat.purdue.edu/academic_programs/undergraduate/index.php?semester=Fall&amp;year=2026
-Reviewed STAT 35000, 35500, 41600, 41700 and 41800 descriptions. A listed course is not necessarily required by every plan or offered to every student.
-Whitmore (Aug. 8, 2023), What is expected goals (xG)? The Analyst (Opta / Stats Perform)
+Statistics course descriptions, including STAT 41600 (probability).
+[2] Whitmore (Aug. 8, 2023), What is expected goals (xG)? The Analyst (Opta / Stats Perform)
 https://theanalyst.com/articles/what-is-expected-goals-xg
-Opta's explainer: xG measures the quality of a chance by calculating the likelihood that it will be scored, on a 0–1 scale, using over 20 variables (distance, angle, goalkeeper position, pressure, shot type, and more) from nearly one million shots. Text snapshot saved October 13, 2026.
-Canning and Harackiewicz (2015), Teach it, don't preach it: the differential effects of directly communicated and self-generated utility-value information (Motivation Science 1(1):47–71)
+Explainer (Opta Analyst, 2023): what expected goals is and how it is estimated.
+[3] Canning and Harackiewicz (2015), Teach it, don't preach it: the differential effects of directly communicated and self-generated utility-value information (Motivation Science 1(1):47–71)
 https://s3.wp.wsu.edu/uploads/sites/2445/2019/09/Canning-Harackiewicz-2015-Motivation-Science.pdf
-Published article (copy hosted at Washington State University; the PMC author manuscript is PMC4610746). Study 1: 88 undergraduates learned a mental-math technique and were randomized to self-generated utility value (writing how it could be useful), directly communicated utility value (shown in the slides), or control. Table 3, performance, reported d versus control at one SD below mean perceived confidence (measured after learning): self-generated +.59 (p = .01), directly communicated −.18 (p = .41). Study 2 added a combined condition the authors describe as synergistic for less-confident students. No AI was tested.
-MLB.com, Statcast glossary: Expected Batting Average (xBA)
+Published article: the experiment behind the chart (Study 1, Table 3).
+[4] MLB.com, Statcast glossary: Expected Batting Average (xBA)
 https://www.mlb.com/glossary/statcast/expected-batting-average
-Official MLB definition: xBA measures the likelihood that a batted ball will become a hit, based on how often comparable balls (exit velocity, launch angle, and for some batted balls Sprint Speed) have become hits since Statcast was implemented league-wide in 2015. A conditional probability used in industry. Text snapshot saved October 13, 2026.
-Purdue Data Science (Statistics) progression guide, 2025–26
+MLB’s definition of expected batting average, a baseball example of conditional probability.
+[5] Purdue Data Science (Statistics) progression guide, 2025–26
 https://www.purdue.edu/science/archive/docs/current-students/majors/dsst-f25-dpg1.pdf
-Dated public DS Statistics plan. Data Science has separate Statistics, Computer Science, and Mathematics routes; the supporting course crosswalk distinguishes them.
-Purdue, AI Guidance for Teaching and Learning
+Suggested course sequence (PDF) for the Data Science (Statistics) plan.
+[6] Purdue, AI Guidance for Teaching and Learning
 https://www.purdue.edu/teaching-learning/instructors/ai.php
-Course-level authorization includes assessed work and non-assessed learning activities. Checked September 10, 2026.
-Evidence and service collection: September 10, 2026; sources added or rechecked through October 13, 2026. Foundations and course review: September 20, 2026. Slides, figures, and transcript revised October 13, 2026 for one flow across the four opening questions; appropriate AI use throughout Purdue remains the theme. Numerical citations were checked against the saved primary sources.</a:t>
+Purdue’s guidance on course-level AI rules.</a:t>
             </a:r>
             <a:endParaRPr lang="en-US" dirty="0"/>
           </a:p>
@@ -896,88 +923,136 @@
           <a:p>
             <a:r>
               <a:rPr lang="en-US" dirty="0"/>
-              <a:t>Know what the tool can do—and what you may share.
-Planned time: 120 seconds. The PowerPoint shows complete diagrams; progressive reveals are in the React deck.
-DELIVERY CUE
-Read the axes: ways to use AI across the top, account and hosting down the side. Walk the rows briefly; point to the Gemini API cell (billing-enabled project) and the SDK cell (instructor's tool, not Purdue's service). In the organization row, separate who can get it from what data it allows. Reveal the permitted column: public-only does not mean public chats; students' Gemini is public only; Claude Code is not yet available. Read the note: check the rules for the account you actually have.
-VISUAL STEPS
-1. Place each way to use AI by its account and hosting.
-2. Add which data are permitted for each row.
-TRANSCRIPT
-You'll meet AI in many forms. Two questions sort them: what can the tool do, and which service and account does it run under? The second decides what you may share.
-Across the top: chat, access from your code through an API, and an agent that uses tools and performs tasks.
-Down the side: a personal hosted service, such as the ChatGPT, Claude, or Gemini apps, a personal API key, or Claude Code or Codex on a personal plan. Terms vary even there: Google treats unpaid Gemini API use differently from a billing-enabled project. Next, services your institution provides under its own accounts. Then a model your organization hosts, Purdue's GenAI Studio, with a chat, an API, and an SDK I wrote for agents. Last, a model on your own device: llama.cpp or Ollama, a local server for your scripts, and local agent software.
-Now, which data are permitted? With a personal account, Purdue allows public data only; that limits what you share, it doesn't make your chats public. With an institution's service, it depends on the service and the account you actually have. Purdue's authorization list names many products, but its AI toolkit shows what students can use: Copilot Chat, signed in, for public and sensitive data, and Gemini Enterprise for public data only. OpenAI API access is on the list with no student route; Claude Code and Cowork are coming soon, for faculty and staff; ChatGPT stays public-only. GenAI Studio is open to everyone: public and sensitive data permitted, restricted data excluded, and external tools need their own approval. A fully local setup can keep inference on your device; check the endpoint and connected tools.
-And a no-training promise is not a no-retention promise. Check the service and account, where your information goes, and what your institution permits.
-TRANSITION
-When you build with these tools, you also choose where your information lives and how the AI finds it.
-CAVEATS
-General guidance, not a ranking or any one employer's rules. Policies and vendor terms were checked on October 21, 2026 and change often; check them when you sign up. Purdue is the example organization, and two Purdue sources answer different questions. Authorization: the list 'Published by Purdue Systems Security - October 15, 2026' authorizes ChatGPT (with DALL-E and SORA), Microsoft Azure OpenAI, Grok, and MidJourney for public data only, and says tools not listed are public-data-only; for sensitive and public data it lists, among others, OpenAI (via API Access), Google Gemini, Anthropic's Claude models, Claude CoWork and Claude Code, Microsoft Copilot with Data Protection, Gemini Notebook, and GenAI Studio. Its conditions: sensitive or restricted data 'MUST be accessed via Purdue SSO or an equivalent', and models from OpenAI, Microsoft, Google and Anthropic 'require an Enterprise or API-level license'; so a personal subscription or an arbitrary API key does not meet them. The list names no account types or eligible users. Access: Purdue's Enterprise AI Toolkit (page last modified October 14, 2026; checked October 21, 2026) says who can get each offering and what data may be entered: Copilot Chat (Basic), everyone, public and sensitive (protected only when signed in with a Purdue account); GenAI Studio, everyone, public and sensitive, restricted not allowed; Gemini Enterprise, students, public only (sensitive not allowed); Gemini Enterprise Pro, faculty and staff, public only; Claude (Cowork and Code), faculty and staff, public and sensitive, 'Coming Soon, this tool is not yet available at Purdue'; Antigravity and frontier model access also 'Coming Soon'. Its linked handout (September 9, 2026) lists Copilot Chat, Gemini Enterprise, and GenAI Studio for classroom use by students, marks ChatGPT and Codex 'No', and lists no OpenAI enterprise agreement. Discrepancy, recorded October 21, 2026: the toolkit is more restrictive for Gemini (public only) than the authorization list (sensitive), marks Claude Code and Cowork as not yet available, and lists no OpenAI API route, while the list authorizes OpenAI API access for sensitive data. So the slide does not treat a product's appearance on the authorization list as evidence that students can use it or may enter sensitive data; availability, eligible users, and data permission are kept separate. Classifications are service-specific: the list puts Microsoft Azure OpenAI (in RCAC's Azure environment) under public data only and OpenAI API access under sensitive data. 'Public data only' is a limit on what you may enter; it does not make conversations publicly accessible. GenAI Studio: public and sensitive data permitted; restricted data, such as FERPA- or HIPAA-regulated data, excluded (RCAC and the toolkit). RCAC states that its authorization does not extend to external services called by Workspace Tools or MCP servers. The instructor's GenAI Studio SDK is a separate open-source Python package on a personal GitHub account, not a Purdue service; it runs on your computer and calls the GenAI Studio API, and its terminal agent (genai-studio agent) can run shell commands, search the web, and use connected MCP tools, which may send data outside GenAI Studio. Gemini API: Google's terms (last updated April 28, 2026) make API use a Paid Service only through a Cloud project with an active billing account; unpaid use may be read by human reviewers and used to improve Google's products. Google AI Studio counts as a Paid Service even at no charge when the account has access to a billing-enabled Cloud project or is a Workspace enterprise account, and in the EEA, Switzerland, and the UK the paid-service data terms apply to all Gemini API and AI Studio use. OpenAI's help article on data use: consumer ChatGPT (Free, Plus, Pro) content may be used for training unless you opt out (feedback can still send a whole conversation), while ChatGPT Business, Enterprise, Edu, and the API are not used by default; the live article returned HTTP 403 on October 21, so its text was checked from an Internet Archive capture of October 19, 2026. No training is not no retention: OpenAI keeps API abuse-monitoring logs for up to 30 days; Anthropic keeps consumer chats 30 days, or up to five years if you allow training; Google keeps human-reviewed Gemini chats up to three years. Anthropic consumer users choose whether chats train its models; Microsoft says Copilot with enterprise data protection does not train foundation models on prompts (now named Microsoft Copilot, like the consumer app, so check the sign-in). Gemini CLI is not shown in the personal row because its consumer route changed: on June 18, 2026, Google stopped serving Gemini Code Assist for individuals and the Google AI Pro and Ultra tiers in Gemini CLI and its IDE extensions, including access through personal Google sign-in, and pointed those users to the Antigravity CLI. Gemini CLI itself continues: Google says it remains available with paid Gemini API keys and its enterprise platform, and organizations' Code Assist Standard and Enterprise licenses follow a separate schedule. Ollama documents tool calling with an agent loop, and local-only mode turns off its cloud models and web search; a fully local setup can keep inference on your device, but a configured endpoint or connected tool can still send data elsewhere. Documentation differences, unresolved: the authorization list describes GenAI Studio as 'excluding FERPA', while RCAC and the toolkit exclude all restricted data (the slide follows RCAC and the toolkit); the list puts 'Google Antigravity (formerly Agentspace)' under sensitive data, while the toolkit lists Antigravity as coming soon for public data only, and Google describes it as Gemini CLI's successor; RCAC's pages did not respond on October 21, so their text was checked in RCAC's official documentation repository (no change since September 29).
+              <a:t>SLIDE GUIDE · 12 / 17: Know what the tool can do—and what you may share.
+The PowerPoint shows the complete slide; in the web version it builds in steps.
+EXPLANATION
+You will meet AI in many forms. This slide separates four questions that are easy to blur together: what a tool can do, who can get it, where it runs, and what data you may put into it.
+Across the top: what the tool can do. A chat interface answers what you type. Access from code uses an API (application programming interface): your own program, such as a Python script, sends requests to a model and uses the replies. An agent uses tools, such as reading files, running commands, or searching, to carry out multi-step tasks.
+Down the side: which account it runs under and where it is hosted.
+• Personal hosted service: a company runs the model, and you use a personal sign-in or API key: the ChatGPT, Claude, or Gemini apps, the Gemini API, or Claude Code and Codex on a personal plan. Terms vary even here; Google treats unpaid Gemini API use differently from use through a billing-enabled project.
+• Organization-approved hosted service: a company runs the model under an agreement with your institution, and you sign in with an institutional account. For Purdue students, that means Copilot Chat now, with Gemini Enterprise on request. OpenAI API access is on Purdue’s authorization list, but no route for students is listed, and Claude Code and Cowork are listed as coming soon for faculty and staff.
+• Organization-hosted model: the institution runs the models itself. Purdue’s GenAI Studio offers a chat interface, an API, and, through a separate open-source SDK written by the instructor who gave this presentation, a way to use or build an agent.
+• Model running on your device: open-weight models run with local software such as llama.cpp or Ollama, as a chat, as a local server that your scripts call, or inside agent software.
+The last column: which data are permitted? Purdue classifies data as public, sensitive, or restricted; restricted data include records regulated by laws such as FERPA (student records) and HIPAA (health information).
+• Personal accounts: public data only. That limits what you share; it does not make your conversations public.
+• Organization-approved services: it depends on the service and your account. For students, Copilot Chat signed in with a Purdue account accepts public and sensitive data, and Gemini Enterprise is for public data only. ChatGPT, which Purdue does not provide through an institutional account, is listed for public data only.
+• GenAI Studio: open to everyone at Purdue, for public and sensitive data but not restricted data; external tools connected to it need their own authorization.
+• Local setup: a fully local setup can keep the model’s computation on your device, but check where the software sends requests and what any connected tools do.
+Two cautions. First, a product’s name on an authorization list does not mean that every account with that name is approved: a personal subscription or an arbitrary API key does not carry the approval needed for sensitive data (personal accounts are for public data only), and Purdue’s own documents differ on some products (see Sources &amp; caveats). Second, a promise not to train on your data is not a promise not to keep it; providers can retain conversations for monitoring or review.
+These rules change often; they were checked on October 21, 2026. Check the service and account you actually have, where your information goes, and what your institution permits.
+NEXT: Match the question to the source and the tool. When you build with these tools, you also choose where your information lives and how the AI finds it.
+SOURCES &amp; CAVEATS
+Sources checked through October 21, 2026. Source numbers match the slide’s citations. Purdue’s policies and the vendors’ terms change often; those below were checked on October 21, 2026, unless another date is given.
+RULES AND DOCUMENTATION: Who can get each Purdue tool, and for which data
+What it covers: Purdue’s Enterprise AI Toolkit (page last modified October 14, 2026; checked October 21, 2026) and its linked handout (September 9, 2026).
+What it says: Copilot Chat (Basic): everyone; public and sensitive data, protected only when signed in with a Purdue account. GenAI Studio: everyone; public and sensitive; restricted not allowed. Gemini Enterprise: students; public only. Claude Cowork and Claude Code: faculty and staff; “Coming Soon, this tool is not yet available at Purdue.” The handout lists Copilot Chat, Gemini Enterprise, and GenAI Studio for classroom use by students and marks ChatGPT and Codex “No”.
+What to keep in mind: Who can get a tool and what data it accepts are separate questions; check both for your own account.
+Sources: [5] [13]
+RULES AND DOCUMENTATION: Which products Purdue has authorized, for which data
+What it covers: Purdue Systems Security’s list of authorized AI tools and integrations, published October 15, 2026 (checked October 21, 2026).
+What it says: Public data only: ChatGPT (with DALL-E and SORA), Microsoft Azure OpenAI, Grok, MidJourney, and any tool not listed. Sensitive and public data, among others: OpenAI (via API access), Google Gemini, Anthropic’s Claude models, Claude Cowork and Claude Code, Microsoft Copilot with Data Protection, and GenAI Studio. Sensitive or restricted data must be accessed through Purdue sign-in (SSO) or an equivalent, and models from OpenAI, Microsoft, Google, and Anthropic require an enterprise or API-level license.
+What to keep in mind: The list names no account types or eligible users, so it does not show that you can get a product. A personal subscription or an arbitrary API key does not meet its conditions.
+Sources: [6]
+RULES AND DOCUMENTATION: Purdue’s two documents differ (unresolved)
+What it covers: A comparison of the authorization list (October 15) and the toolkit (October 14), recorded on October 21, 2026.
+What it says: The toolkit is more restrictive for Gemini (public data only; the list says sensitive), lists Claude Code and Cowork as not yet available, and lists no OpenAI API route, while the list authorizes OpenAI API access for sensitive data. The list describes GenAI Studio as “excluding FERPA,” while RCAC and the toolkit exclude all restricted data. The list places Google Antigravity under sensitive data; the toolkit lists it as coming soon, for public data only.
+What to keep in mind: The slide follows the toolkit and RCAC for what students can use and does not treat a product’s appearance on the list as evidence that students can use it or enter sensitive data. If the documents disagree for a tool you want to use, ask before entering anything beyond public data.
+Sources: [5] [6] [7]
+RULES AND DOCUMENTATION: GenAI Studio
+What it covers: Purdue RCAC’s GenAI Studio documentation (updated September 29, 2026) and sign-in page.
+What it says: GenAI Studio is authorized for public and sensitive (L2) data, not for restricted data, including data regulated by FERPA or HIPAA. An external service called by a Workspace Tool, or an MCP server, may receive data outside GenAI Studio, and GenAI Studio’s authorization does not extend to it. The API is OpenAI-compatible, with GenAI Studio’s own address and model names.
+What to keep in mind: Sign in at genai.rcac.purdue.edu with a Purdue account. Connected tools need their own authorization.
+Sources: [7] [14] [8] [15]
+RULES AND DOCUMENTATION: The presenting instructor’s GenAI Studio SDK
+What it covers: An open-source Python package (MIT license) on the personal GitHub account of the instructor who gave this presentation.
+What it says: It runs on your computer and calls the GenAI Studio API for chat, embeddings, retrieval, and an agent. Its terminal agent can read and edit code, run shell commands, search the web, and use connected MCP tools.
+What to keep in mind: It is not a Purdue or RCAC service. The agent’s web search and connected tools can send data outside GenAI Studio, where GenAI Studio’s data authorization does not apply.
+Sources: [9]
+RULES AND DOCUMENTATION: Training is not the same as retention
+What it covers: The vendors’ data-use and privacy documentation for consumer and business services.
+What it says: OpenAI: content from personal ChatGPT plans (Free, Plus, Pro) may be used for training unless you opt out, while Business, Enterprise, Edu, and API data are not used by default; API abuse-monitoring logs are kept for up to 30 days. Anthropic: consumer users choose whether chats are used for training; chats are kept 30 days, or up to five years if training is allowed. Google: unpaid Gemini API use may be read by human reviewers and used to improve Google’s products; human-reviewed Gemini app chats are kept for up to three years. Microsoft: Copilot with enterprise data protection does not use prompts to train foundation models.
+What to keep in mind: No training does not mean no retention, and neither means permission to share sensitive data. Microsoft’s business and consumer apps now share the name Microsoft Copilot, so check which account you are signed in with.
+Sources: [1] [16] [2] [17] [18]
+RULES AND DOCUMENTATION: Personal coding agents
+What it covers: Vendor documentation for Claude Code and Codex.
+What it says: Claude Code and Codex read, edit, and run code in a local project. Most uses require a subscription or an API account; Codex offers a free tier in its desktop app, subject to rollout.
+What to keep in mind: On a personal plan, Purdue permits public data only. Plans and prices change often.
+Sources: [3] [4] [19]
+RULES AND DOCUMENTATION: Local models
+What it covers: Documentation for llama.cpp and Ollama.
+What it says: llama.cpp runs open-weight models on your computer and can serve them to your scripts. Ollama states, “Ollama runs locally. We don’t see your prompts or data when you run locally”; its cloud models and web search do send prompts to Ollama’s servers, and a local-only setting turns them off. Ollama also supports tool calling, so a local model can drive an agent.
+What to keep in mind: Your data stays on your device only if the model endpoint and every connected tool are local. What runs well depends on your hardware and the model.
+Sources: [10] [11] [12]
+WHY GEMINI CLI IS NOT ON THE SLIDE
+On June 18, 2026, Google stopped serving consumer accounts (Gemini Code Assist for individuals, Google AI Pro, and Google AI Ultra) in Gemini CLI and its IDE extensions, including access through a personal Google sign-in, and pointed those users to the Antigravity CLI. Google says Gemini CLI remains available with paid Gemini API keys and its enterprise platform; organizations’ Code Assist licenses follow a separate schedule.
+MORE ON THE GEMINI API TERMS
+Under Google’s Gemini API terms (last updated April 28, 2026), API use is a Paid Service only through a Cloud project with an active billing account. Unpaid use may be read by human reviewers and used to improve Google’s products, and Google asks users not to submit sensitive, confidential, or personal information to unpaid services. Google AI Studio counts as a Paid Service even at no charge when the account has access to a billing-enabled Cloud project or is a Workspace enterprise account; in the EEA, Switzerland, and the UK, the paid-service data terms apply to all Gemini API and AI Studio use.
+HOW THESE RULES WERE CHECKED
+Purdue’s authorization list, toolkit, and handout, and the vendors’ terms, were checked on October 21, 2026. RCAC’s pages did not respond that day, so their text was checked in RCAC’s official documentation repository, which showed no change since September 29. OpenAI’s help article returned an error that day and was checked in an Internet Archive capture from October 19, 2026.
 SOURCES
-Purdue, Enterprise AI Toolkit: compare Purdue's AI tools and licenses (page last modified October 14, 2026)
+[1] OpenAI Help Center, How your data is used to improve model performance
+https://help.openai.com/en/articles/5722486-how-your-data-is-used-to-improve-model-performance
+Help article: when OpenAI uses your content for training, by type of account.
+[2] Google, Gemini API Additional Terms of Service (last updated Apr. 28, 2026)
+https://ai.google.dev/gemini-api/terms
+Terms of service (last updated April 28, 2026): unpaid vs. paid Gemini API use.
+[3] Anthropic, Claude Code overview
+https://code.claude.com/docs/en/overview
+Documentation: what Claude Code does and which accounts it requires.
+[4] OpenAI, Codex CLI
+https://learn.chatgpt.com/docs/codex/cli
+Documentation: what the Codex command-line agent does.
+[5] Purdue, Enterprise AI Toolkit: compare Purdue's AI tools and licenses (page last modified October 14, 2026)
 https://www.purdue.edu/ai/enterprise-ai-toolkit/
-Says who can get each Purdue offering and the highest data classification it accepts. Copilot Chat (Basic): everyone; public and sensitive allowed, restricted not allowed; protected only when signed in with a Purdue account. GenAI Studio: everyone; public and sensitive allowed, restricted not allowed. Gemini Enterprise: students; public allowed, sensitive and restricted not allowed. Gemini Enterprise Pro: faculty and staff; public only. Claude (Cowork and Code): faculty and staff; public and sensitive; 'Coming Soon, this tool is not yet available at Purdue'. Antigravity (public only) and frontier model access: coming soon. GitHub Copilot: everyone; public and sensitive; usage-based through a department account. 'No tool checks a classification before it accepts a prompt.' Checked October 21, 2026; more restrictive for Gemini than the October 15 authorization list.
-Purdue Systems Security, Purdue University authorized AI tools and integrations (October 15, 2026)
+Who can get each Purdue AI tool and what data it accepts (page last modified October 14, 2026).
+[6] Purdue Systems Security, Purdue University authorized AI tools and integrations (October 15, 2026)
 https://www.purdue.edu/ai/wp-content/uploads/2026/10/AITools.pdf
-Official list 'Published by Purdue Systems Security - October 15, 2026' (checked October 21, 2026). Public data only: OpenAI (ChatGPT, DALL-E, SORA), Microsoft Azure OpenAI, x.ai (Grok), MidJourney; 'Other University tools not listed are still authorized for public data only use.' Sensitive and public data, among others: OpenAI (via API Access); Google Gemini; Anthropic (Claude, Haiku, Sonnet, etc.); Anthropic (Claude CoWork, Claude Code); MS Copilot with Data Protection (Purdue Microsoft 365 tenant); Google Gemini Notebook; JetBrains IDE; GenAI Studio ('Configured to accept Sensitive Data, excluding FERPA'). Notes: sensitive or restricted data 'MUST be accessed via Purdue SSO or an equivalent'; models from OpenAI, Microsoft, Google and Anthropic 'require an Enterprise or API-level license to gain the necessary legal protections for Sensitive or Restricted data'; account types are not named. Changes from May 2026: Gemini and Claude moved from public-only to sensitive, and Claude Code/CoWork and OpenAI API access were added. The May list is saved alongside.
-Purdue, AI Tools at Purdue: availability by provider (handout, September 9, 2026)
+Purdue Systems Security’s authorization list (PDF, October 15, 2026).
+[7] Purdue RCAC, GenAI Studio overview and data classification (updated September 29, 2026)
+https://docs.rcac.purdue.edu/services/genai/
+RCAC documentation (updated September 29, 2026): GenAI Studio and the data it is approved for.
+[8] Purdue RCAC, GenAI Studio API guide (updated September 29, 2026)
+https://docs.rcac.purdue.edu/services/genai/api/
+RCAC documentation: calling GenAI Studio’s models from code.
+[9] GenAI Studio SDK, the instructor's Python package (GitHub)
+https://github.com/treese41528/genai-studio-sdk
+Open-source Python package by the instructor who gave this presentation (not a Purdue service).
+[10] ggml-org, llama.cpp
+https://github.com/ggml-org/llama.cpp
+Open-source software for running models on your own computer.
+[11] Ollama documentation, FAQ
+https://docs.ollama.com/faq
+FAQ: what stays local and what goes to Ollama’s cloud.
+[12] Ollama documentation, Tool calling
+https://docs.ollama.com/capabilities/tool-calling
+Documentation: tool calling, which lets a local model drive an agent.
+[13] Purdue, AI Tools at Purdue: availability by provider (handout, September 9, 2026)
 https://www.purdue.edu/ai/wp-content/uploads/2026/09/purdue_ai_tools.pdf
-The toolkit's linked handout. Products by provider, who can get them, and status: Copilot Chat (Basic), everyone, available; Gemini Enterprise, students, on request; Claude Cowork and Claude Code, faculty and staff, coming (Claude Code 'arrives with the Claude Enterprise pilot'); ChatGPT and Codex, 'No'; enterprise agreements: Microsoft in place, Google rolling out, Anthropic pilot signed, OpenAI none. Classroom teaching (students): Copilot Chat, Gemini Enterprise, GenAI Studio. Older than the October 15 authorization list.
-Purdue RCAC, GenAI Studio overview and data classification (updated September 29, 2026)
-https://docs.rcac.purdue.edu/services/genai/
-'GenAI Studio is authorized for use with public and sensitive data (L2), as defined in Purdue's Data Classification and Handling Procedures. It is not authorized for restricted data, including data regulated by FERPA or HIPAA.' 'An external service called by a Workspace Tool, or an MCP server, may receive tool arguments or conversation context outside GenAI Studio. GenAI Studio's authorization does not extend to these external integrations.' Purdue-managed; content is not used to train the hosted models; a pilot with limited safety measures. On October 21, 2026 the live page did not respond; RCAC's official documentation repository (PurdueRCAC/RCAC-Docs) showed no change since its September 29 'GenAI data classification update', and its source is saved alongside (2026_rcac_genai_overview_source.md).
-Purdue GenAI Studio: sign in (genai.rcac.purdue.edu)
+Handout (PDF, September 9, 2026): availability by provider, including classroom use.
+[14] Purdue GenAI Studio: sign in (genai.rcac.purdue.edu)
 https://genai.rcac.purdue.edu/
-The official sign-in page for Purdue GenAI Studio (Purdue SSO through CILogon), linked from RCAC's GenAI Studio documentation and listed in Purdue's AI tools handout; the saved copy is RCAC's overview page, which links to it. The page did not respond from the build machine on October 21, 2026; sign in from a browser on Purdue's network or with your Purdue account.
-GenAI Studio SDK, the instructor's Python package (GitHub)
-https://github.com/treese41528/genai-studio-sdk
-Open-source (MIT) Python SDK for Purdue's GenAI Studio gateway, written by the speaker and published on a personal GitHub account; not a Purdue or RCAC service. It runs on your computer and calls the GenAI Studio API: chat, embeddings, retrieval, and a tool-using agent framework. Its terminal agent, 'genai-studio agent', can read and edit code, run shell commands, search the web and arXiv, and use connected MCP tools, with approvals for risky actions and read-only, workspace-write, or full-access sandbox modes. Data sent to such tools leaves GenAI Studio, and RCAC states that GenAI Studio's authorization does not extend to external integrations. README rechecked October 21, 2026 (unchanged since July 3).
-Purdue RCAC, GenAI Studio API guide (updated September 29, 2026)
-https://docs.rcac.purdue.edu/services/genai/api/
-OpenAI-compatible chat-completions requests with GenAI Studio's own base URL, model IDs and limits. Keep the key in an environment variable; 20 requests per minute per user; structured output differs by serving backend; custom models carry attached Knowledge Bases through the API. Model list checked through the API on October 12, 2026 (dozens of open-weight models, including gpt-oss, Qwen, Gemma, Llama and DeepSeek families).
-Purdue RCAC, GenAI Studio chat interface (updated September 29, 2026)
+Sign-in page for GenAI Studio (Purdue account required).
+[15] Purdue RCAC, GenAI Studio chat interface (updated September 29, 2026)
 https://docs.rcac.purdue.edu/services/genai/chat-interface/
-One prompt can go to several models side by side; temperature and a system prompt can be set for a chat; one-time attachments differ from reusable Knowledge Bases.
-OpenAI Help Center, How your data is used to improve model performance
-https://help.openai.com/en/articles/5722486-how-your-data-is-used-to-improve-model-performance
-Services for individuals (Free, Plus, Pro): 'we may use your content to train our models'; opt out under Settings &gt; Data controls or in the Privacy Portal; feedback can still send the whole conversation for training; temporary chats are not used while they remain temporary. Business services: 'By default, we don’t use inputs or outputs from ChatGPT Business, ChatGPT Enterprise, ChatGPT Edu, or our API to improve our models.' The article does not state retention periods; OpenAI's API data-controls page keeps abuse-monitoring logs for up to 30 days. The live page returned HTTP 403 on October 21, 2026; the saved text is from an Internet Archive capture of October 19, 2026.
-Anthropic (Aug. 28, 2025), Updates to consumer terms and privacy policy
+RCAC documentation: the chat interface, including side-by-side models.
+[16] Anthropic (Aug. 28, 2025), Updates to consumer terms and privacy policy
 https://www.anthropic.com/news/updates-to-our-consumer-terms
-Claude Free, Pro, and Max users (including Claude Code with those accounts) choose whether their data is used to improve Claude; retention extends to five years if they allow it, and stays at 30 days if they do not. Does not apply to services under Commercial Terms: Claude for Work, Government, Education, or API use. Anthropic's privacy center adds that chats flagged for safety review may be used for safety work. Rechecked October 21, 2026.
-Google, Gemini Apps Privacy Hub (last updated October 19, 2026)
+Anthropic’s 2025 update: training choices and retention for consumer chats.
+[17] Google, Gemini Apps Privacy Hub (last updated October 19, 2026)
 https://support.google.com/gemini/answer/13594961
-Consumer Gemini apps: 'Human reviewers (including trained reviewers from our service providers) review some of the data we collect... Please don't enter confidential information that you wouldn't want a reviewer to see or Google to use to improve our services.' Reviewed chats are kept for up to three years even if you delete your activity. Work or school Google Accounts may be subject to different data-handling terms. Rechecked October 21, 2026.
-Google, Gemini API Additional Terms of Service (last updated Apr. 28, 2026)
-https://ai.google.dev/gemini-api/terms
-Unpaid Services (e.g., unpaid quota in the Gemini API, direct interactions with Google AI Studio): content may be used to provide, improve, and develop Google products; human reviewers may read API input and output; 'Do not submit sensitive, confidential, or personal information to the Unpaid Services.' Paid Services: 'Your access to Gemini API is a "Paid Service" only when accessing the API through a Cloud Project associated with an active billing account'; prompts and responses are not used to improve Google's products and are logged for a limited time to detect policy violations. Google AI Studio counts as a Paid Service even when offered free of charge if the account has access to a Cloud Project with an active billing account or is a Workspace enterprise account. In the EEA, Switzerland, and the UK, the paid-service data terms apply to all Services. Rechecked October 21, 2026 (no substantive change since October 13).
-Microsoft Learn, Enterprise data protection in Microsoft Copilot and Copilot Chat (updated Aug. 18, 2026)
+Google’s privacy hub for the Gemini apps: human review and retention.
+[18] Microsoft Learn, Enterprise data protection in Microsoft Copilot and Copilot Chat (updated Aug. 18, 2026)
 https://learn.microsoft.com/en-us/microsoft-365/copilot/enterprise-data-protection
-Organizational use is covered by Microsoft's Data Protection Addendum and Product Terms; 'the prompts, responses, and data accessed through Microsoft Graph aren't used to train foundation models.' Applies to eligible work and school accounts, shown by a green shield in Copilot Chat. Microsoft 365 Copilot is now named Microsoft Copilot, the same name as the consumer app, so check the sign-in. Rechecked October 21, 2026.
-Anthropic, Claude Code overview
-https://code.claude.com/docs/en/overview
-Vendor documentation retrieved October 12, 2026: an agentic coding assistant that reads a codebase, edits files and runs commands from the terminal, IDE, desktop or web. Most surfaces require a Claude subscription or Anthropic Console account.
-OpenAI, Codex CLI
-https://learn.chatgpt.com/docs/codex/cli
-Vendor documentation retrieved October 12, 2026 (developers.openai.com now redirects to learn.chatgpt.com): a terminal agent that inspects, edits and runs code in a local repository; recommends Git checkpoints before and after a task.
-OpenAI, Codex pricing (October 2026)
+Microsoft documentation: enterprise data protection for work and school accounts.
+[19] OpenAI, Codex pricing (October 2026)
 https://learn.chatgpt.com/docs/pricing
-Free tier in the desktop app (subject to rollout), paid plans, or API-key usage. Plans change often; dated context only.
-ggml-org, llama.cpp
-https://github.com/ggml-org/llama.cpp
-MIT-licensed local inference for open-weight models on CPUs and GPUs, with quantization and an OpenAI-compatible server. What runs well depends on the hardware and the model.
-Ollama documentation, FAQ
-https://docs.ollama.com/faq
-Serving software with local and cloud options. 'Ollama runs locally. We don’t see your prompts or data when you run locally.' Cloud-hosted models and web search send prompts to Ollama's servers ('we process your prompts and responses to provide the service but do not store or log that content and never train on it'); local-only mode ('disable_ollama_cloud' in server.json or OLLAMA_NO_CLOUD=1) turns off cloud models and web search. Checked September 10, October 13, and October 21, 2026 (same statements).
-Ollama documentation, Tool calling
-https://docs.ollama.com/capabilities/tool-calling
-'Ollama supports tool calling (also known as function calling) which allows a model to invoke tools and incorporate their results into its replies'; a multi-turn agent loop lets the model decide when to call tools. In the examples the model is served at localhost and the user's own script runs the tools. Checked October 21, 2026.
-Google, Gemini Code Assist consumer accounts: deprecation (last updated October 9, 2026)
+Codex plans and free tier (they change often).
+[20] Google, Gemini Code Assist consumer accounts: deprecation (last updated October 9, 2026)
 https://developers.google.com/gemini-code-assist/docs/deprecations/code-assist-individuals
-'Starting June 18, 2026, Gemini Code Assist IDE extensions stopped serving requests for the Gemini Code Assist for individuals, Google AI Pro, and Google AI Ultra tiers. This also applies to usage of Gemini CLI. As part of the deprecation, you can no longer use the Login with Google option to access the IDE extensions or Gemini CLI.' Consumer users are directed to the Antigravity family of products. Checked October 21, 2026.
-Google, Gemini CLI (GitHub repository README)
+Google’s notice ending consumer access to Gemini Code Assist and Gemini CLI (last updated October 9, 2026).
+[21] Google, Gemini CLI (GitHub repository README)
 https://github.com/google-gemini/gemini-cli
-Google's open-source (Apache 2.0) terminal agent. Consumer access changed on June 18, 2026: Gemini CLI no longer serves Gemini Code Assist for individuals, Google AI Pro, or Google AI Ultra, including access through personal Google sign-in ('Login with Google'), and those users are directed to the Antigravity CLI (Google's deprecation notice, updated October 9, 2026; README banner added October 16, 2026). Google says Gemini CLI remains available through paid Gemini API keys and its enterprise agent platform; the repository's authentication docs still describe personal sign-in. Removed from slide 12 on October 21, 2026; the October 13 README snapshot is saved.
-Evidence and service collection: September 10, 2026; sources added or rechecked through October 13, 2026. Foundations and course review: September 20, 2026. Slides, figures, and transcript revised October 13, 2026 for one flow across the four opening questions; appropriate AI use throughout Purdue remains the theme. Numerical citations were checked against the saved primary sources.</a:t>
+Gemini CLI’s open-source repository and its current access options.</a:t>
             </a:r>
             <a:endParaRPr lang="en-US" dirty="0"/>
           </a:p>
@@ -1065,62 +1140,85 @@
           <a:p>
             <a:r>
               <a:rPr lang="en-US" dirty="0"/>
-              <a:t>Match the question to the source and the tool.
-Planned time: 140 seconds. The PowerPoint shows complete diagrams; progressive reveals are in the React deck.
-DELIVERY CUE
-Left: one question, real scores. The top passage uses different words and still ranks first; the dashed line marks the top 3 selected as candidate context; a score is not a probability of answering. Right: read the question, then the query down, one condition per stage, 4,194 to 122: TV-news task, passed the AI screen, no extraction warning flagged, reported support; each condition is a decision. Then the red box: the closest passage to a counting question is a definition, not a total. Land on the takeaway: the codebook for meaning, the records for quantities.
-VISUAL STEPS
-1. Semantic retrieval: rank codebook passages by cosine similarity; the top 3 are selected as candidate context.
-2. SQL: filter the released results by stated conditions and count the matching records, 4,194 to 122.
-3. Wrong source and operation: the closest passage to a counting question is a definition, not a total.
-TRANSCRIPT
-Different questions need different sources and different operations. Here are two operations on two real sources.
-On the left, semantic retrieval over the soccer study's codebook, the document that explains its variables. Each passage, and my question, becomes an embedding, a list of numbers, and the passages are ranked by cosine similarity, the dot-product idea from earlier. I ran this on my own computer with a small open model; it is a demonstration, not GenAI Studio. I asked how skin tone was measured. The top passage never says "measure"; it says players were "coded by two independent raters," and it still ranks first. The top three are selected as candidate context for a model to read. A similarity score is not the probability that a passage answers your question, so you still read what comes back.
-On the right, a SQL query over the AI study's released results answers one precise question: how many runs on the TV-news task passed the AI screen, had no extraction warning flagged, and reported support? Start with 4,194 records. Keep the TV-news task: 1,270. Keep the runs that passed the AI screen, with auditor verdicts Compliant or Minor issues: 700. Drop the twelve runs flagged with an extraction warning: 688. Count those that reported support: 122. The query counts records satisfying the stated conditions, and every condition is a decision you make and can state.
-Now ask retrieval the wrong kind of question: how many red cards were given in total? The top match, with the highest score on this slide, is the definition of the red-card variable. A relevant definition is not a total, and this codebook doesn't contain the records needed to calculate one. That takes the data, plus decisions about which players and seasons count and whether a second yellow card counts as a red.
-So use the codebook to understand the variables, and use the records to calculate the quantity. Real systems often combine both operations. You choose which one your question needs, and you check what comes back.
-TRANSITION
-Agents can choose among operations like these and act on your files, so decide what they are allowed to do.
-CAVEATS
-Two operations on two different sources; real systems often combine them, so they are not exclusive kinds of tool. Left, the soccer study's codebook: a local embedding demonstration, separate from GenAI Studio. The codebook (the copy pinned in the Bertran, Fogliato and Wu repository at commit d489f03, SHA-256 926e289e…, identical to the saved copy) was split into its four paragraphs and 27 variable descriptions, one passage each, and embedded with the open Sentence-Transformers model all-MiniLM-L6-v2 (revision 1110a24; mean pooling, unit-length vectors) by codebook_retrieval.py; the scores are in soccer_codebook_retrieval.json (both linked below). Rerun October 21, 2026 with the saved and the pinned codebook: identical scores. Shown: skin-tone paragraph 0.67, rater2 0.52, rater1 0.51, meanExp 0.40, bias-measures paragraph 0.35; the other 26 scored lower (lowest, refNum 0.07). Cosine similarity measures how close two embeddings are; it is not the probability that a passage answers the question. 'Top 3' is a setting chosen for this example: those passages are selected as candidate context, and what a system does with the others depends on its design. GenAI Studio's Knowledge Bases use EmbeddingGemma 300M and their own chunking, so their scores would differ; no GenAI Studio Knowledge Base was created or queried. Retrieval quality and answer faithfulness need separate checks. Right, a different source: the AI study's released run-level results for the TV-news task (results.csv at commit d489f03; 4,194 rows; SHA-256 verified), queried with its real column names in tvnews_sql_funnel.sql (linked below). Import: every column TEXT as released, so the flags are the strings 'True' and 'False' (SQLite's TRUE is the integer 1 and matches none of them). Conditions: dataset = 'sample_anes-inconsistent-views' (1,270); sonnet_verdict IN ('Compliant', 'Minor issues') (700); COALESCE(warning, 'False') &lt;&gt; 'True' (688); hypothesis_supported = 'True' (122). 'Passed the AI screen' in the question means these two auditor categories, the same definition as slide 4; passing the auditor is not a demonstration of correctness. Warning values among the 700: 687 False, 12 True, 1 blank. Stated policy for 'no extraction warning flagged': keep runs whose warning is not 'True', so the blank is kept. COALESCE treats a missing warning as not flagged: if blanks are imported as NULL, a bare warning &lt;&gt; 'True' would silently drop the blank (687); the script gives the same counts in the sqlite3 shell (blanks as '') and in Python's sqlite3 (blanks as NULL; bertran2026_sql_count.json). Text comparison is case-sensitive in this implementation (SQLite's default BINARY collation): 'compliant' in lowercase matches 0 rows; other databases and collations can differ. Red cards: the codebook defines redCards as the 'number of red cards player received from referee' but contains no records. The soccer data are 146,028 player–referee pairs with counts accumulated over each player's encounters with that referee, so a total needs summing over pairs, a defined population (which players, leagues, and seasons), and a decision on second-yellow dismissals, recorded separately as yellowReds. The red-card question's top three were redCards (0.80), yellowReds (0.67), and yellowCards (0.62); none contains a total. The GenAI Studio tools-and-database guide gives the same rule: exact lookups belong in parameterized SQL; semantic retrieval finds reference passages when wording varies. The reproducibility files are published with the website's data folder; their links resolve once the website is published.
+              <a:t>SLIDE GUIDE · 13 / 17: Match the question to the source and the tool.
+The PowerPoint shows the complete slide; in the web version it builds in steps.
+EXPLANATION
+Different questions need different sources and different operations. This slide shows two operations on two real sources: semantic retrieval, which finds passages in a document, and a SQL query, which filters and counts records in a table. Real systems often combine them; retrieval can find what a variable means, and a query can then count the records that use it.
+Left: semantic retrieval over a codebook. A codebook is the document that explains a dataset’s variables; this one comes from the soccer study on slide 3. Retrieval works in three steps:
+1. The codebook is split into passages: here, 31 of them (four paragraphs and 27 variable descriptions).
+2. An embedding model turns each passage, and the question, into an embedding: a list of numbers that represents its meaning.
+3. Each passage is scored by its cosine similarity to the question (slide 10), and the passages are ranked.
+The question was “How did they measure players’ skin tone?” The top passage (0.67) never uses the word “measure”; it says players were “coded by two independent raters.” Embeddings can match meaning even when the words differ. All 31 passages were ranked, and the chart shows the top five so you can see where the cutoff falls. The setting top_k = 3 marks the first three as candidate context: the passages a full system would pass to a language model along with the question. It does not mean that only three passages were ranked or shown.
+Two cautions. A similarity score measures how close two embeddings are; it is not the probability that a passage answers the question, so you still read what comes back. And this local demonstration, run with a small open model separately from GenAI Studio, stops at ranking: no language model generated an answer from the selected passages.
+Right: a SQL query over released results. SQL is a language for asking precise questions of tables. This query uses the AI study’s released results (slides 3 and 4), one row per AI run, to ask: how many ANES TV-news runs passed the AI screen, had no extraction warning flagged, and reported support? Each stage adds one condition:
+• All released results: 4,194 runs.
+• The TV-news (ANES) task: 1,270.
+• Auditor verdict Compliant or Minor issues, that is, passed the AI screen: 700.
+• No extraction warning flagged: 688.
+• Reported support: 122.
+Every condition is a decision that you make and can state. One of the 700 runs has no value in the warning column. The stated rule, keep runs not flagged with a warning, keeps it, which is why the query uses COALESCE(warning, 'False'): a missing value counts as “not flagged.” Without it, a database that stores the blank as missing would silently drop the run and report 687. Keeping the run means no warning was recorded, not that the analysis had no problems.
+Bottom: a separate question. For “How many red cards were given in total?”, retrieval ranks the passages again, and the top one defines the variable redCards (similarity 0.803). That is useful, because it tells you what the field means. But the codebook defines variables; it contains no records and does not report the total. If a source stated the total, retrieval could find it. Here, the total has to be calculated from the underlying records with an explicit counting rule.
+The takeaway: use the codebook to understand the variables, and use the records to calculate the quantity. You choose the source and the operation, read what comes back, and decide what each condition should mean.
+NEXT: Let coding agents act only within limits you set. Agents can choose among operations like these and act on your files, so the next slide is about deciding what they may do.
+SOURCES &amp; CAVEATS
+Sources checked through October 21, 2026. Source numbers match the slide’s citations.
+DEMONSTRATION: Retrieval scores (computed locally; separate from GenAI Studio)
+What was computed: Cosine similarities between two questions and the codebook’s 31 passages, computed with the open model all-MiniLM-L6-v2. Skin-tone question, top five: 0.67 (skin-tone paragraph), 0.52 (rater2), 0.51 (rater1), 0.40 (meanExp), 0.35 (bias-measures paragraph); the other 26 scored lower. Red-card question, top three: redCards 0.80, yellowReds 0.67, yellowCards 0.62.
+What limits it: Only the codebook’s 31 passages were embedded, not the 146,028 player–referee records. top_k = 3 is a setting chosen for this example. No answer was generated from the selected passages. GenAI Studio’s Knowledge Bases use a different embedding model (EmbeddingGemma 300M) and their own way of splitting documents, so their scores would differ. Retrieval quality and the faithfulness of a generated answer need separate checks.
+Sources: [1] [2] [3] [6]
+DEMONSTRATION: SQL count over the released results
+What was computed: Counts from the authors’ released results file (commit d489f03): 4,194 → 1,270 → 700 → 688 → 122. Every column was imported as text, so the flags are the strings 'True' and 'False'. Among the 700 runs that passed the screen, the warning column holds 687 'False', 12 'True', and 1 blank. The stated rule keeps runs whose warning is not 'True', so the blank is kept. Text comparison in SQLite is case-sensitive by default: 'compliant' in lowercase matches 0 rows.
+What limits it: “Passed the AI screen” means the auditor’s two passing categories, as on slide 4, not verified correctness. “No extraction warning flagged” means no warning was recorded, not that the analysis had no problems. “Reported support” is the agent’s own verdict.
+Sources: [4] [5] [7]
+RULES AND DOCUMENTATION: What the codebook can and cannot answer
+What it covers: The soccer-study codebook: the copy pinned in the AI study’s repository, with four paragraphs and 27 variable descriptions.
+What it says: It defines variables such as redCards (“number of red cards player received from referee”) but contains no records and no totals.
+What to keep in mind: The data are 146,028 player–referee pairs, with counts accumulated over each player’s encounters with that referee. A total therefore requires summing over pairs for a defined population (which players, leagues, and seasons) and a decision about dismissals for a second yellow card, which are recorded separately as yellowReds. Embedding the records instead would return similar rows, not a sum.
+Sources: [2] [8]
+CONCEPT REFERENCE: Embeddings and retrieval-augmented generation
+What it explains: Sentence embeddings compared by cosine similarity made semantic search practical (Reimers and Gurevych, 2019). Retrieval-augmented generation (Lewis et al., 2020) passes retrieved passages to a language model as context. GenAI Studio’s Knowledge Bases retrieve passages this way.
+What to keep in mind: Retrieved context does not guarantee that a generated answer is supported by it.
+Sources: [9] [10] [11]
+REPRODUCE THIS SLIDE
+• codebook_retrieval.py splits the codebook into 31 passages, embeds them and the two questions with all-MiniLM-L6-v2 (model revision 1110a24), ranks the passages by cosine similarity, and marks the top 3.
+• soccer_codebook_retrieval.json holds every passage’s score and rank for both questions, with the model revision and the codebook’s address and checksum.
+• tvnews_sql_funnel.sql reproduces the counts in the sqlite3 shell from the released results.csv; its header gives the download address and checksum.
+• bertran2026_sql_count.json records the stage counts and warning values from the same query run in Python.
+These four files are hosted with the presentation’s website. The codebook and the results file are the official copies in the authors’ GitHub repository at commit d489f03.
 SOURCES
-sentence-transformers, all-MiniLM-L6-v2 model card (Hugging Face)
+[1] sentence-transformers, all-MiniLM-L6-v2 model card (Hugging Face)
 https://huggingface.co/sentence-transformers/all-MiniLM-L6-v2
-Open Sentence-Transformers model (Apache 2.0) that maps sentences and paragraphs to a 384-dimensional vector space for semantic search; fine-tuned with a contrastive objective on over 1 billion sentence pairs; input longer than 256 word pieces is truncated. Used on slide 13 to compute cosine similarities between the soccer codebook's 31 passages and two questions (revision 1110a24; codebook_retrieval.py, linked on slide 13; rerun with identical scores October 21, 2026). Model card saved October 13, 2026.
-Soccer-study codebook (Silberzahn et al.), pinned copy in the Bertran, Fogliato and Wu repository (commit d489f03)
+Model card for the open embedding model used in the demonstration.
+[2] Soccer-study codebook (Silberzahn et al.), pinned copy in the Bertran, Fogliato and Wu repository (commit d489f03)
 https://raw.githubusercontent.com/amazon-science/agentic-forking-path/d489f03b143fcaa9befb8cc443594ff63ec61eaa/data/soccer/codebook.txt
-Documentation for the crowdsourced soccer data: four paragraphs (data sources, skin-tone ratings by two raters, bias measures) and 27 variable descriptions. It defines variables such as redCards ('number of red cards player received from referee') but contains no records. Stored in the repository as codebook.txt, an RTF document; SHA-256 926e289e…, identical to the saved copy (checked October 21, 2026).
-Retrieval scores for slide 13: soccer_codebook_retrieval.json (this talk)
+Official repository copy of the codebook (commit d489f03): variable definitions, no records.
+[3] Retrieval scores for slide 13: soccer_codebook_retrieval.json (this talk)
 https://treese41528.github.io/ComputationalDataScience/AI_First_Year/data/soccer_codebook_retrieval.json
-Output of codebook_retrieval.py: each passage's cosine similarity and rank for 'How did they measure players' skin tone?', with the top 3 marked as selected candidate context, and the top 3 for 'How many red cards were given in total?' (redCards 0.80, yellowReds 0.67, yellowCards 0.62). Records the model revision, weights hash, codebook URL and hash, and library versions.
-Retrieval script for slide 13: codebook_retrieval.py (this talk)
+Hosted with this presentation: every passage’s score and rank for both questions (JSON).
+[4] Bertran, Fogliato and Wu: released run-level results (GitHub, commit d489f03)
+https://github.com/amazon-science/agentic-forking-path/tree/d489f03b143fcaa9befb8cc443594ff63ec61eaa/experiment_data
+The AI study’s run-level results (GitHub, commit d489f03): the table the query counts.
+[5] SQL script for slide 13: tvnews_sql_funnel.sql (this talk)
+https://treese41528.github.io/ComputationalDataScience/AI_First_Year/data/tvnews_sql_funnel.sql
+Hosted with this presentation: the SQL script that reproduces the counts.
+[6] Retrieval script for slide 13: codebook_retrieval.py (this talk)
 https://treese41528.github.io/ComputationalDataScience/AI_First_Year/data/codebook_retrieval.py
-Splits the soccer-study codebook into 31 passages (four paragraphs, 27 variable descriptions), embeds them and two questions with all-MiniLM-L6-v2 (revision 1110a24; weights checked by SHA-256), ranks passages by cosine similarity, and selects the top 3 as candidate context. A local demonstration, separate from GenAI Studio. Rerun October 21, 2026 with the saved and the pinned codebook: identical scores.
-Bertran, Fogliato and Wu: released run-level results (GitHub, commit d489f03)
-https://github.com/amazon-science/agentic-forking-path/tree/d489f03b143fcaa9befb8cc443594ff63ec61eaa/experiment_data
-Authors' release of run-level results at commit d489f03 (results.csv: 4,194 rows, one per run with a final analysis; the README says runs without one are excluded and describes 4,196 runs; the paper reports 4,946 runs in total). SHA-256 verified; README, LICENSE, and NOTICE saved alongside. The TV-news slide shows support rates for the 1,270 anes-views runs before screening and the 700 that passed the AI screen (its earlier plot of 688 extracted estimates was removed on October 21; see its notes); slide 13 counts 688 of those 700 with SQL; the soccer slide counts 611 soccer runs. Each run's code, report, and transcript are in experiment_data/workspaces.
-SQL script for slide 13: tvnews_sql_funnel.sql (this talk)
-https://treese41528.github.io/ComputationalDataScience/AI_First_Year/data/tvnews_sql_funnel.sql
-Runs in the sqlite3 shell on the released results.csv (commit d489f03; download URL and SHA-256 in the header). Documents the import schema (every column TEXT; flags are the strings 'True' and 'False'), the inclusion policy for the warning flag (a missing warning counts as not flagged; COALESCE(warning, 'False') keeps the one blank whether stored as '' or NULL), and case-sensitive comparison. Prints the slide's count (122), each stage (4,194; 1,270; 700; 688; 122), and the warning values among the 700 (687 False, 12 True, 1 blank).
-SQL counts for slide 13: bertran2026_sql_count.json (this talk)
+Hosted with this presentation: the Python script that splits, embeds, and ranks the passages.
+[7] SQL counts for slide 13: bertran2026_sql_count.json (this talk)
 https://treese41528.github.io/ComputationalDataScience/AI_First_Year/data/bertran2026_sql_count.json
-Written by extract_bertran_anes.py, which loads the four columns into Python's sqlite3 (empty fields as NULL), applies the same conditions, checks the result against the sqlite3-shell script, and records the stage counts, the warning values, and the lowercase check (0 rows).
-Silberzahn et al., crowdsourced soccer data and codebook (OSF)
+Hosted with this presentation: the stage counts and warning values (JSON).
+[8] Silberzahn et al., crowdsourced soccer data and codebook (OSF)
 https://osf.io/fv8c3/
-Original many-analyst dataset: all 2,053 players in the first male divisions of England, Germany, France, and Spain in the 2012–13 season; all 3,147 referees they played under in their professional careers; 146,028 player–referee dyads with matches together and red cards; skin tone rated from profile photos (1,586 players) by two raters blind to the question on a 5-point scale. Codebook copy from the Bertran, Fogliato and Wu repository (commit d489f03).
-Reimers and Gurevych (2019), Sentence-BERT
+The original soccer data on OSF: the records you would need to calculate a total.
+[9] Reimers and Gurevych (2019), Sentence-BERT
 https://arxiv.org/abs/1908.10084
-EMNLP 2019 (arXiv 1908.10084). Sentence embeddings that can be compared using cosine similarity, making semantic similarity search practical (about 5 seconds instead of 65 hours for 10,000 sentences).
-Lewis et al., Retrieval-Augmented Generation (2020)
+Sentence embeddings compared by cosine similarity, the idea behind this kind of search.
+[10] Lewis et al., Retrieval-Augmented Generation (2020)
 https://arxiv.org/abs/2005.11401
-Foundational retrieval-augmented generation research; retrieved context does not guarantee that generated claims are supported.
-Purdue RCAC, GenAI Studio Workspace and Knowledge Bases
+The original retrieval-augmented generation system: retrieved passages go to a language model.
+[11] Purdue RCAC, GenAI Studio Workspace and Knowledge Bases
 https://docs.rcac.purdue.edu/services/genai/workspace/
-Knowledge Bases are document collections prepared with EmbeddingGemma 300M for semantic search and retrieval; custom models attach them for retrieval-augmented generation.
-GenAI Studio capability guides (implementation notes, September 14, 2026)
-Purdue_GenAI_Studio/index.html
-Seven guides: access, structured extraction, Knowledge Bases, retrieval, tools and database lookups, evaluation, and a review interface. Their rule: exact lookups belong in SQL; similarity retrieval suggests candidates. Examples are teaching adaptations; the pages did not run authenticated calls.
-Evidence and service collection: September 10, 2026; sources added or rechecked through October 13, 2026. Foundations and course review: September 20, 2026. Slides, figures, and transcript revised October 13, 2026 for one flow across the four opening questions; appropriate AI use throughout Purdue remains the theme. Numerical citations were checked against the saved primary sources.</a:t>
+RCAC documentation: how GenAI Studio’s Knowledge Bases embed and retrieve documents.</a:t>
             </a:r>
             <a:endParaRPr lang="en-US" dirty="0"/>
           </a:p>
@@ -1208,50 +1306,69 @@
           <a:p>
             <a:r>
               <a:rPr lang="en-US" dirty="0"/>
-              <a:t>Let coding agents act only within limits you set.
-Planned time: 150 seconds. The PowerPoint shows complete diagrams; progressive reveals are in the React deck.
-DELIVERY CUE
-Read the definition, then the key idea: the agent proposes, software enforces. Step 2: walk the three rows: runs, asks, blocked; asking has an approval path, blocking does not; these are rules you set, not defaults. Step 3: injection can redirect the agent and misuse allowed actions (an unwanted edit inside the project); then the two checks, before approving and afterward. Land the band: set permissions, check actions, follow course rules.
-VISUAL STEPS
-1. What the agent proposes: read files, modify a file, contact an external service.
-2. How the configured permissions produce run, ask, or block.
-3. How untrusted content can redirect an agent, and what you check before and after.
-TRANSCRIPT
-Now the tools that act. A coding agent can choose tool actions, like reading files, changing code, or running commands, and use the results to decide what to do next. Claude Code and Codex are examples. The key idea: the agent proposes actions; software enforces the permissions.
-Here is one illustrative configuration. These are rules you or your organization set, not defaults that every tool shares. The agent proposes three things. Read files in the selected project: allowed, so it runs. Modify a project file: approval required, so it asks, and you approve or decline. Contact an external service that isn't approved: not permitted, so it's blocked. Asking and blocking are different. An action that asks has an approval path; a blocked action is prohibited under the active policy, however the agent asks. Some tools can also send approval requests to another model instead of to you, so know which mode you are in.
-Why does this matter? Prompt injection. Instructions inside an untrusted web page or file can try to redirect the agent, and they don't need to be hidden; the model only has to read them. Permissions still decide what can run, but an attack can misuse actions you already allowed. If edits inside the project are allowed, an injected instruction could produce an unwanted edit right there. OWASP describes an illustrative scenario: a web page being summarized carries instructions that make the AI leak a private conversation.
-So check at two points. Before approving: what will it read, change, run, or send? Afterward: inspect the changes, test a result you expect, and keep a checkpoint you can return to. If something looks wrong, go back to that checkpoint.
-Set the permissions before you start, check the agent's actions, and for coursework, follow your course's rules.
-TRANSITION
-With those limits in place, you are ready to try one of these tools yourself.
-CAVEATS
-Illustrative configuration, not any product's defaults and not an executed demonstration: no agent was run for this slide. Asks versus blocked: an action that asks has an approval path; a blocked action stays prohibited under the active policy (for example, a deny rule, a network allowlist that omits the service, or a policy that never prompts, such as Codex with approvals set to never or Claude Code's dontAsk mode). Approval requests need not go to a person: Codex can route them to a reviewer agent (auto_review), and Claude Code's Auto mode uses a classifier model. That is automated review, not human approval; enforcement is still done by software. Product details from official documentation, checked October 21, 2026. Codex: the sandbox mode sets what Codex can technically do when it runs model-generated commands (where it can write, whether commands reach the network), and the approval policy sets when it must stop and ask; 'By default, the agent runs with network access turned off.' In its Auto preset for version-controlled folders (workspace-write with on-request approvals), it can read, edit, and run commands in the working directory without asking, and asks before editing outside the workspace or running commands that need network access. The command network restriction does not filter web search, app or connector tool calls, MCP server connections, or the client's own model requests, which follow their own settings; Codex no longer supports the 'untrusted' approval policy. Claude Code: with v2.1.283 or later, interactive terminal and VS Code sessions start in Auto mode, where a second model, a classifier, reviews actions instead of you (on earlier versions, only on Pro, Max, and Team plans); non-interactive runs (claude -p) and the Agent SDK start in Manual mode, as does any session where Auto mode is unavailable. Manual mode (configuration value 'default') starts read-only and asks before editing files, running tests, or executing commands, except a built-in set of read-only commands (such as ls, cat, and git status) and actions you previously allowed ('Yes, and don't ask again' lasts per repository and command for Bash, and for the session for edits). Its optional sandbox, off by default, covers shell commands and the processes they start; Claude's file tools, MCP servers, hooks, and web tools run outside it and follow permission rules. 'Permission rules are enforced by Claude Code, not by the model.' Network limits do not mean the model runs locally: both tools send prompts and model outputs to the vendor's model service. Prompt injection: OWASP's LLM01:2025 says injections 'do not need to be human-visible/readable, as long as the content is parsed by the model'; its Scenario #2, a summarized web page whose instructions make a model leak a private conversation, is listed among example attack scenarios and is presented here as an illustration, not a documented incident or an independent security test. OWASP notes that fool-proof prevention is unclear and recommends human approval for high-risk actions. The learning-cost study shown on this slide before October 21 (Shen and Tamkin) is discussed earlier in the talk and is no longer repeated here.
+              <a:t>SLIDE GUIDE · 14 / 17: Let coding agents act only within limits you set.
+The PowerPoint shows the complete slide; in the web version it builds in steps.
+EXPLANATION
+A chatbot answers; a coding agent acts. A coding agent, such as Claude Code or Codex, can choose tool actions, like reading files, changing code, or running commands, and use the results to decide what to do next. That makes it useful, and it means you should decide in advance what it may do.
+The key idea: the agent proposes, and software enforces. The model behind the agent suggests actions; separate software (the agent’s permission system and, in some tools, a sandbox) decides whether each action may run, whether or not the model follows instructions.
+How to read the table. It shows one illustrative configuration: rules that you or your organization might set, not defaults that every tool shares, and not a recording of an agent being run.
+• Read files in the selected project: allowed, so it runs without asking.
+• Modify a project file: approval required, so the agent asks, and you approve or decline.
+• Contact an unapproved external service: not permitted, so it is blocked. There is no approval path: the action stays prohibited under the active rules, however the agent asks.
+Some tools can send approval requests to another AI model instead of to you. That is automated review, not human approval, so know which mode you are in.
+Prompt injection. Instructions in an untrusted web page or file can try to redirect the agent. They can be in plain sight or invisible to a person; the model only has to read them. Permissions still decide what can run, but an attack can misuse actions you have already allowed: if edits inside the project are allowed, an injected instruction could cause an unwanted edit there. OWASP, a security community, describes an illustrative attack scenario in which a web page being summarized carries instructions that make an AI leak a private conversation.
+What you check. Before approving: what will it read, change, run, or send? Afterward: inspect the changes, test a result you expect, and keep a checkpoint, such as a saved version in Git, that you can return to if something looks wrong. Review the results before you rely on them, and for coursework, follow your course’s rules.
+NEXT: Try one new way to use AI this semester. With those limits in place, you are ready to try one of these tools yourself.
+SOURCES &amp; CAVEATS
+Sources checked through October 21, 2026. Source numbers match the slide’s citations. Product documentation checked October 21, 2026.
+ILLUSTRATIVE EXAMPLE: The runs / asks / blocked configuration
+What it shows: How configured permission rules turn an agent’s proposed actions into actions that run, ask for approval, or are blocked.
+What it is not: Not any product’s defaults and not an executed demonstration: no agent was run for this slide.
+RULES AND DOCUMENTATION: Codex: sandbox and approval policy
+What it covers: OpenAI’s Codex documentation on approvals, security, and the sandbox.
+What it says: The sandbox sets what Codex can technically do when it runs model-generated commands; the approval policy sets when it must stop and ask. “By default, the agent runs with network access turned off.” In its Auto preset for version-controlled folders, Codex reads, edits, and runs commands in the working folder without asking, and asks before editing outside it or running commands that need the network. Approval requests can be routed to a reviewer agent instead of a person.
+What to keep in mind: The network restriction on commands does not cover web search, connectors, MCP servers, or the tool’s own requests to the model, which follow their own settings.
+Sources: [1] [3]
+RULES AND DOCUMENTATION: Claude Code: permissions, modes, and sandbox
+What it covers: Anthropic’s Claude Code documentation on security, permission modes, permissions, and sandboxing.
+What it says: “Permission rules are enforced by Claude Code, not by the model.” With version 2.1.283 or later, interactive sessions start in Auto mode, in which a second model, a classifier, reviews actions instead of you; non-interactive runs start in Manual mode, which asks before editing files or running commands, apart from a built-in set of read-only commands and actions you have already allowed. The optional sandbox, off by default, covers shell commands only.
+What to keep in mind: A network limit does not mean the model runs locally: both tools send prompts and outputs to the vendor’s model service.
+Sources: [2] [6] [7] [4]
+RULES AND DOCUMENTATION: Prompt injection (OWASP LLM01:2025)
+What it covers: OWASP’s Top 10 for LLM Applications, entry LLM01: Prompt Injection (official GitHub repository copy).
+What it says: Injections “do not need to be human-visible/readable, as long as the content is parsed by the model,” and indirect injections arrive through external content such as websites or files. Its example attack scenario #2: summarizing a web page with hidden instructions leads to exfiltration of the private conversation. OWASP notes that it is unclear whether fool-proof prevention methods exist, and it recommends human approval for high-risk actions.
+What to keep in mind: The web-page example is an illustrative attack scenario from OWASP’s list, not a documented incident or an independent security test.
+Sources: [5]
+SUGGESTED STRATEGY: Check before approving and afterward
+What it suggests: Before approving, check what the agent will read, change, run, or send; afterward, inspect the changes, test an expected result, and keep a checkpoint.
+What informs it: Vendor guidance (for example, Codex recommends Git checkpoints before and after a task) and OWASP’s recommendation of human approval for high-risk actions.
+What has not been tested: A practical routine, not a tested intervention. Checks reduce risk; they do not remove it.
+Sources: [8] [5]
 SOURCES
-OpenAI, Codex agent approvals and security (ChatGPT Learn)
+[1] OpenAI, Codex agent approvals and security (ChatGPT Learn)
 https://learn.chatgpt.com/docs/agent-approvals-security
-Sandbox mode ('what Codex can do technically ... when it executes model-generated commands') versus approval policy ('when Codex must ask you before it executes an action'). 'By default, the agent runs with network access turned off.' Auto preset (workspace-write, on-request): reads, edits, and runs commands in the working directory automatically; asks before editing outside the workspace or running commands that need network access. The command network proxy does not filter web search, app or connector calls, MCP connections, or the client's model requests. Approval requests route to the user by default, or to a reviewer agent with auto_review; the 'untrusted' policy is retired. Checked October 21, 2026; vendor documentation, not a security test.
-Anthropic, Claude Code security
+Documentation: Codex’s sandbox, approval policy, and presets.
+[2] Anthropic, Claude Code security
 https://code.claude.com/docs/en/security
-With Claude Code v2.1.283 or later, Auto mode is the built-in starting permission mode for interactive terminal and VS Code sessions, with a classifier model, not a person, reviewing actions (claude -p and Agent SDK runs start in Manual); Manual mode 'starts with read-only permissions. When it needs to edit files, run tests, or execute commands, it asks you first', and runs a built-in set of read-only commands without asking. In Manual mode most tools that make network requests require approval. Notes that no system is completely immune to attacks. Checked October 21, 2026; vendor documentation, not an independent evaluation.
-Anthropic, Claude Code: choose a permission mode
+Documentation: Claude Code’s permission modes and safeguards.
+[3] OpenAI, Codex sandbox (ChatGPT Learn)
+https://learn.chatgpt.com/docs/sandboxing
+Documentation: what the Codex sandbox does and does not restrict.
+[4] Anthropic, Claude Code sandboxing
+https://code.claude.com/docs/en/sandboxing
+Documentation: what Claude Code’s optional sandbox covers.
+[5] OWASP Top 10 for LLM Applications, LLM01:2025 Prompt Injection (GitHub)
+https://github.com/OWASP/www-project-top-10-for-large-language-model-applications/blob/main/2_0_vulns/LLM01_PromptInjection.md
+OWASP’s prompt-injection entry, from its official GitHub repository, with illustrative attack scenarios.
+[6] Anthropic, Claude Code: choose a permission mode
 https://code.claude.com/docs/en/permission-modes
-'With Claude Code v2.1.283 or later, auto mode is the built-in starting permission mode for interactive terminal and VS Code sessions. On earlier versions, it's the built-in starting permission mode only on Pro, Max, and Team plans.' In auto mode 'a second model, the classifier, reviews actions instead of you.' claude -p and Agent SDK runs start in default (Manual) mode; a session starts in Manual when auto mode is unavailable. Checked October 21, 2026.
-OpenAI, Codex sandbox (ChatGPT Learn)
-https://learn.chatgpt.com/docs/sandboxing
-'The sandbox defines technical boundaries. The approval policy decides when the agent must stop and ask before crossing them.' The sandbox applies to spawned commands, not only to built-in file operations; modes are read-only, workspace-write (the default for local work), and danger-full-access. Checked October 21, 2026.
-Anthropic, Claude Code sandboxing
-https://code.claude.com/docs/en/sandboxing
-'The sandbox covers shell commands only. Claude's file tools, MCP servers, and hooks run outside it.' 'The sandbox is off by default.' Restricts the network to allowed domains and limits reads and writes for shell commands; the OS-enforced boundary holds regardless of what the model chose to run; not a complete isolation boundary. Checked October 21, 2026.
-Anthropic, Claude Code permissions
+Documentation: Claude Code’s starting permission modes, including Auto mode’s classifier.
+[7] Anthropic, Claude Code permissions
 https://code.claude.com/docs/en/permissions
-'Permission rules are enforced by Claude Code, not by the model.' Modes include default (Manual), acceptEdits, plan, auto, dontAsk, and bypassPermissions; read-only commands run without a prompt in every mode; 'Yes, and don't ask again' persists per repository and command for Bash and until session end for edits. Checked October 21, 2026.
-OWASP GenAI Security Project, LLM01:2025 Prompt Injection
-https://genai.owasp.org/llmrisk/llm01-prompt-injection/
-Prompt injections 'do not need to be human-visible/readable, as long as the content is parsed by the model'; indirect injections arrive through external sources such as websites or files. Example attack scenario #2: summarizing a web page with hidden instructions leads to exfiltration of the private conversation. 'It is unclear if there are fool-proof methods of prevention'; recommends human approval for high-risk actions. Checked October 21, 2026.
-OpenAI, Codex CLI
+Documentation: how Claude Code enforces permission rules.
+[8] OpenAI, Codex CLI
 https://learn.chatgpt.com/docs/codex/cli
-Vendor documentation retrieved October 12, 2026 (developers.openai.com now redirects to learn.chatgpt.com): a terminal agent that inspects, edits and runs code in a local repository; recommends Git checkpoints before and after a task.
-Evidence and service collection: September 10, 2026; sources added or rechecked through October 13, 2026. Foundations and course review: September 20, 2026. Slides, figures, and transcript revised October 13, 2026 for one flow across the four opening questions; appropriate AI use throughout Purdue remains the theme. Numerical citations were checked against the saved primary sources.</a:t>
+Documentation: the Codex agent, including Git checkpoints before and after a task.</a:t>
             </a:r>
             <a:endParaRPr lang="en-US" dirty="0"/>
           </a:p>
@@ -1339,65 +1456,86 @@
           <a:p>
             <a:r>
               <a:rPr lang="en-US" dirty="0"/>
-              <a:t>Try one new way to use AI this semester.
-Planned time: 110 seconds. The PowerPoint shows complete diagrams; progressive reveals are in the React deck.
-DELIVERY CUE
-Offer the three routes as choices, not requirements. Stress the API key and the data rules. Then the statistician’s test. End with the pointers: CS/SCI 173 now, Chapter 6 later.
-TRANSCRIPT
-You do not have to wait for an internship. Pick one route and try it on something small.
-In GenAI Studio, send one prompt to two models side by side and compare them. Then send the same prompt from a short Python script through the API. Keep your API key in an environment variable, never in your code, and check that the current rules fit the data you plan to use.
-Or run a small open-weight model on your own computer with Ollama or llama.cpp. You will learn what your hardware can handle and how an application talks to a model.
-Or try a coding agent on a personal project, with approvals on, reading every change. Some have free tiers; most capable use requires a subscription.
-Whatever you try, test it like a statistician: write ten or twenty questions whose answers you can check, run each a few times, and record the model, date, and settings. That small evaluation is a skill employers value.
-Where next? Remember the AI working competency your class needs to graduate; in the College of Science, the course is CS/SCI 173. When you are ready to go deeper, Chapter 6 of the Computational Data Science text covers embeddings, retrieval, tool use, and evaluation for data science.
-TRANSITION
-Trying a tool is a start. A project you care about can take you further.
-CAVEATS
-Service documentation rechecked October 12, 2026 (RCAC pages updated September 29). Log in at genai.rcac.purdue.edu: sign in through CILogon, choose Purdue University Main Campus, and complete Purdue SSO; access requires a valid Purdue account. GenAI Studio's API allows 20 requests per minute per user; structured output uses response_format for vLLM-backed models and format for Ollama-backed models. Ollama also has cloud options; llama.cpp serves an OpenAI-compatible API locally. Coding-agent plans and free tiers change often. The AI competency requirement applies from the fall 2026 incoming class; course options vary by college and plan of study. The GenAI Studio SDK and capability guides are optional follow-up materials for students who want to build. The evaluation advice (small checkable sets, repeated runs, recorded settings) is the speaker's synthesis.
+              <a:t>SLIDE GUIDE · 15 / 17: Try one new way to use AI this semester.
+EXPLANATION
+You do not have to wait for an internship to learn how these tools work. Pick one of three routes and try it on something small, using public or made-up (synthetic) data.
+Purdue GenAI Studio: compare, then script it. Sign in at genai.rcac.purdue.edu with your Purdue account. Send one prompt to two models side by side and compare the answers; then send the same prompt from a short Python script through the API. Keep your API key, the password-like code that identifies you to the service, in an environment variable rather than in your code. GenAI Studio is approved for public and sensitive data, not for restricted data such as FERPA or HIPAA records.
+A model on your computer: see where it runs. Run a small open-weight model with llama.cpp or Ollama; either can also serve the model to your own scripts. You will learn what your hardware can handle and how an application talks to a model. Check whether your setup sends data anywhere else; Ollama’s optional cloud models and web search, for example, can be turned off.
+A coding agent: build, then review. Try Claude Code or Codex on a personal project with approvals on (slide 14), reading every change and running the tests. Check which mode you are in: recent versions of Claude Code start in Auto mode, where another AI model reviews actions instead of you, and Codex’s default for local work edits files in your project folder without asking. To approve each action yourself, choose a mode that asks first, such as Claude Code’s Manual mode. Some agents have free tiers; most capable use requires a paid plan, and plans change often. On a personal plan, Purdue permits public data only (slide 12).
+Test any tool like a statistician. Write ten or twenty questions whose answers you can check, run each one a few times (the same prompt can produce different answers), and record the model, date, settings, and your checks so that someone else could repeat the work.
+Where to go next. Beginning with the fall 2026 incoming class, every Purdue undergraduate completes an AI working competency; in the College of Science, the course is CS/SCI 173, and requirements vary by college and plan of study. When you want to go further, Chapter 6 of the Computational Data Science text covers embeddings, retrieval-augmented generation, prompting, tool use, and reliability, with GenAI Studio examples. For coursework, follow each course’s rules.
+NEXT: Build something people can use. Learn as it grows. Trying a tool is a start. A project you care about can give you reasons to keep learning.
+SOURCES &amp; CAVEATS
+Sources checked through October 21, 2026. Source numbers match the slide’s citations. RCAC documentation updated September 29, 2026 (rechecked October 12, 2026); check current access, limits, and data rules before you start.
+RULES AND DOCUMENTATION: GenAI Studio access, API, and data
+What it covers: Purdue RCAC’s GenAI Studio documentation (updated September 29, 2026).
+What it says: Sign in through CILogon: choose Purdue University Main Campus and complete Purdue sign-in; access requires a valid Purdue account. The chat interface can send one prompt to several models side by side. The API is OpenAI-compatible, with GenAI Studio’s own address and model names, and allows 20 requests per minute per user; keep the key in an environment variable. Approved for public and sensitive (L2) data, not restricted data.
+What to keep in mind: Limits and models change; check the current documentation. External tools connected to GenAI Studio need their own authorization.
+Sources: [1] [7] [2] [8]
+RULES AND DOCUMENTATION: Running a model locally
+What it covers: Documentation for llama.cpp and Ollama.
+What it says: llama.cpp (MIT license) runs open-weight models on CPUs and GPUs and can serve an OpenAI-compatible API on your computer. Ollama runs locally but also offers cloud models and web search, which send prompts to Ollama’s servers; a local-only setting turns them off.
+What to keep in mind: What runs well depends on your hardware and the model.
+Sources: [3] [9]
+RULES AND DOCUMENTATION: Coding agents
+What it covers: Vendor documentation for Claude Code and Codex, including Codex’s approval settings and pricing (October 2026).
+What it says: Both read, edit, and run code in a local project, with approval settings that control when they ask. Most uses require a subscription or API account; Codex offers a free tier in its desktop app, subject to rollout.
+What to keep in mind: Plans change often. On a personal plan, Purdue permits public data only; Purdue lists Claude Code as coming soon for faculty and staff, not students.
+Sources: [10] [11] [4] [12]
+SUGGESTED STRATEGY: Test it like a statistician
+What it suggests: Use a small set of checkable questions, repeat runs, and record the model, date, settings, and checks.
+What informs it: Standard practice for evaluating a method: known answers, repeated measurement, and documentation that lets others reproduce the work.
+What has not been tested: A suggested practice, not a validated evaluation protocol.
+RULES AND DOCUMENTATION: Where to go next
+What it covers: Purdue’s AI competency requirement, the College of Science course, and a course text chapter.
+What it says: Beginning with the fall 2026 incoming class, every undergraduate completes an AI working competency. CS/SCI 173 covers how AI systems work; hands-on use for text, image, and data analysis; and a team project supported by RCAC. Chapter 6 of Computational Data Science covers embeddings, retrieval-augmented generation, prompting, tool use, and reliability, with GenAI Studio examples.
+What to keep in mind: Confirm requirements in your own plan of study. The chapter is teaching material, not research evidence.
+Sources: [13] [5] [6]
+GOING FURTHER WITH GENAI STUDIO
+The open-source GenAI Studio SDK by the instructor who gave this presentation, a Python package (not a Purdue service), adds embeddings, retrieval, and a tool-using agent on top of the GenAI Studio API. Its agent can run shell commands and search the web, which can send data outside GenAI Studio. For structured output, GenAI Studio’s API uses response_format for some models and format for others, depending on how the model is served.
 SOURCES
-Purdue RCAC, GenAI Studio overview and data classification (updated September 29, 2026)
+[1] Purdue RCAC, GenAI Studio overview and data classification (updated September 29, 2026)
 https://docs.rcac.purdue.edu/services/genai/
-'GenAI Studio is authorized for use with public and sensitive data (L2), as defined in Purdue's Data Classification and Handling Procedures. It is not authorized for restricted data, including data regulated by FERPA or HIPAA.' 'An external service called by a Workspace Tool, or an MCP server, may receive tool arguments or conversation context outside GenAI Studio. GenAI Studio's authorization does not extend to these external integrations.' Purdue-managed; content is not used to train the hosted models; a pilot with limited safety measures. On October 21, 2026 the live page did not respond; RCAC's official documentation repository (PurdueRCAC/RCAC-Docs) showed no change since its September 29 'GenAI data classification update', and its source is saved alongside (2026_rcac_genai_overview_source.md).
-Purdue GenAI Studio: sign in (genai.rcac.purdue.edu)
+RCAC documentation (updated September 29, 2026): access and approved data.
+[2] Purdue RCAC, GenAI Studio API guide (updated September 29, 2026)
+https://docs.rcac.purdue.edu/services/genai/api/
+RCAC documentation: calling the same models from a Python script.
+[3] ggml-org, llama.cpp
+https://github.com/ggml-org/llama.cpp
+Open-source software for running models locally.
+[4] OpenAI, Codex agent approvals and security (ChatGPT Learn)
+https://learn.chatgpt.com/docs/agent-approvals-security
+Documentation: how Codex approvals work.
+[5] Purdue College of Science, AI Competency (CS/SCI 173)
+https://www.purdue.edu/science/Current_Students/ai-competency.html
+College of Science page for the AI competency course, CS/SCI 173.
+[6] Computational Data Science, Chapter 6: LLMs in Data Science Workflows
+https://treese41528.github.io/ComputationalDataScience/Website/part4_llms_datascience/chapter6/index.html
+Course text chapter: embeddings, retrieval, prompting, tool use, and reliability, with GenAI Studio examples.
+[7] Purdue GenAI Studio: sign in (genai.rcac.purdue.edu)
 https://genai.rcac.purdue.edu/
-The official sign-in page for Purdue GenAI Studio (Purdue SSO through CILogon), linked from RCAC's GenAI Studio documentation and listed in Purdue's AI tools handout; the saved copy is RCAC's overview page, which links to it. The page did not respond from the build machine on October 21, 2026; sign in from a browser on Purdue's network or with your Purdue account.
-Purdue RCAC, GenAI Studio API guide (updated September 29, 2026)
-https://docs.rcac.purdue.edu/services/genai/api/
-OpenAI-compatible chat-completions requests with GenAI Studio's own base URL, model IDs and limits. Keep the key in an environment variable; 20 requests per minute per user; structured output differs by serving backend; custom models carry attached Knowledge Bases through the API. Model list checked through the API on October 12, 2026 (dozens of open-weight models, including gpt-oss, Qwen, Gemma, Llama and DeepSeek families).
-Purdue RCAC, GenAI Studio chat interface (updated September 29, 2026)
+Sign-in page for GenAI Studio (Purdue account required).
+[8] Purdue RCAC, GenAI Studio chat interface (updated September 29, 2026)
 https://docs.rcac.purdue.edu/services/genai/chat-interface/
-One prompt can go to several models side by side; temperature and a system prompt can be set for a chat; one-time attachments differ from reusable Knowledge Bases.
-ggml-org, llama.cpp
-https://github.com/ggml-org/llama.cpp
-MIT-licensed local inference for open-weight models on CPUs and GPUs, with quantization and an OpenAI-compatible server. What runs well depends on the hardware and the model.
-Ollama documentation, FAQ
+RCAC documentation: sending one prompt to several models side by side.
+[9] Ollama documentation, FAQ
 https://docs.ollama.com/faq
-Serving software with local and cloud options. 'Ollama runs locally. We don’t see your prompts or data when you run locally.' Cloud-hosted models and web search send prompts to Ollama's servers ('we process your prompts and responses to provide the service but do not store or log that content and never train on it'); local-only mode ('disable_ollama_cloud' in server.json or OLLAMA_NO_CLOUD=1) turns off cloud models and web search. Checked September 10, October 13, and October 21, 2026 (same statements).
-Anthropic, Claude Code overview
+FAQ: local use, cloud options, and how to turn the cloud features off.
+[10] Anthropic, Claude Code overview
 https://code.claude.com/docs/en/overview
-Vendor documentation retrieved October 12, 2026: an agentic coding assistant that reads a codebase, edits files and runs commands from the terminal, IDE, desktop or web. Most surfaces require a Claude subscription or Anthropic Console account.
-OpenAI, Codex CLI
+Documentation: what Claude Code does and which accounts it requires.
+[11] OpenAI, Codex CLI
 https://learn.chatgpt.com/docs/codex/cli
-Vendor documentation retrieved October 12, 2026 (developers.openai.com now redirects to learn.chatgpt.com): a terminal agent that inspects, edits and runs code in a local repository; recommends Git checkpoints before and after a task.
-OpenAI, Codex pricing (October 2026)
+Documentation: the Codex command-line agent.
+[12] OpenAI, Codex pricing (October 2026)
 https://learn.chatgpt.com/docs/pricing
-Free tier in the desktop app (subject to rollout), paid plans, or API-key usage. Plans change often; dated context only.
-Purdue College of Science, AI Competency (CS/SCI 173)
-https://www.purdue.edu/science/Current_Students/ai-competency.html
-The College of Science course for the requirement: how AI systems work, hands-on use for text, image and data analysis, and a team project supported by RCAC. Students should confirm requirements in their own plan of study.
-Purdue (August 19, 2026), AI competency graduation requirement
+Codex plans and free tier (they change often).
+[13] Purdue (August 19, 2026), AI competency graduation requirement
 https://www.purdue.edu/newsroom/2026/Q3/purdues-ai-competency-graduation-requirement-begins-in-every-undergraduate-degree-program/
-Beginning with the fall 2026 incoming class, every undergraduate completes an AI working competency in the core curriculum. Emphasizes critical thinking, responsible use and deciding whether AI fits a task, not operating particular tools.
-Computational Data Science, Chapter 6: LLMs in Data Science Workflows
-https://treese41528.github.io/ComputationalDataScience/Website/part4_llms_datascience/chapter6/index.html
-Course chapter for later study: embeddings, retrieval-augmented generation, prompt engineering, tool use, reliability and responsible AI, with GenAI Studio examples. Teaching material, not empirical evidence.
-GenAI Studio SDK, the instructor's Python package (GitHub)
+Purdue’s announcement of the AI competency requirement (August 19, 2026).
+[14] GenAI Studio SDK, the instructor's Python package (GitHub)
 https://github.com/treese41528/genai-studio-sdk
-Open-source (MIT) Python SDK for Purdue's GenAI Studio gateway, written by the speaker and published on a personal GitHub account; not a Purdue or RCAC service. It runs on your computer and calls the GenAI Studio API: chat, embeddings, retrieval, and a tool-using agent framework. Its terminal agent, 'genai-studio agent', can read and edit code, run shell commands, search the web and arXiv, and use connected MCP tools, with approvals for risky actions and read-only, workspace-write, or full-access sandbox modes. Data sent to such tools leaves GenAI Studio, and RCAC states that GenAI Studio's authorization does not extend to external integrations. README rechecked October 21, 2026 (unchanged since July 3).
-GenAI Studio capability guides (implementation notes, September 14, 2026)
-Purdue_GenAI_Studio/index.html
-Seven guides: access, structured extraction, Knowledge Bases, retrieval, tools and database lookups, evaluation, and a review interface. Their rule: exact lookups belong in SQL; similarity retrieval suggests candidates. Examples are teaching adaptations; the pages did not run authenticated calls.
-Evidence and service collection: September 10, 2026; sources added or rechecked through October 13, 2026. Foundations and course review: September 20, 2026. Slides, figures, and transcript revised October 13, 2026 for one flow across the four opening questions; appropriate AI use throughout Purdue remains the theme. Numerical citations were checked against the saved primary sources.</a:t>
+Open-source Python package by the instructor who gave this presentation (not a Purdue service).</a:t>
             </a:r>
             <a:endParaRPr lang="en-US" dirty="0"/>
           </a:p>
@@ -1485,35 +1623,66 @@
           <a:p>
             <a:r>
               <a:rPr lang="en-US" dirty="0"/>
-              <a:t>Build something people can use. Learn as it grows.
-Planned time: 150 seconds. The PowerPoint shows complete diagrams; progressive reveals are in the React deck.
-DELIVERY CUE
-Step 1: read the motivation, then the platform's purpose; point to the connected modules, the ideas under each, the share link, and the friends panel; AI helps build and share release 1. Step 2: walk the loop 1 to 4 and back to release 2; point to the forecasting module as the current focus and read the example cycle; mention the new-topic entry. Land on the band and course rules.
-VISUAL STEPS
-1. The platform: a proposed baseball strategy platform you could host and share, its connected modules, and the ideas behind each.
-2. The learning loop: use and get feedback, connect, learn and experiment, improve and release, then back to a new release.
-TRANSCRIPT
-Here is one optional way to put all of this to work: build something people can use, and learn as it grows.
-Start with a goal like this: I want to build a platform around something I care about, put it online, and send my friends a link. Say you like baseball. Picture a strategy platform where you and your friends can explore players, build lineups, predict matchups, simulate seasons, and save and share your scenarios. That is a big system: a data pipeline and database built on MLB's documented Statcast data, player comparisons, forecasts with uncertainty, a season simulator, lineup search, and a hosted application that ties them together. AI can help you build and share a first working version well beyond what you could build alone today.
-Each capability rests on ideas you will meet here. Comparing players leads to vectors and similarity. Forecasting matchups leads to conditional probability, regression, and regularization. Simulating seasons leads to Monte Carlo methods. Lineup search leads to combinatorics and optimization. And hosting it is part of the learning: with AI's help, learn how to put the platform online, publish updates, and investigate problems when something breaks, and ask it to explain how the interface, server, database, and calculations fit together.
-Then the loop. Use it and get feedback: what do your friends find confusing, slow, or missing? Connect one improvement to ideas: which part needs to change, and which course topics connect? Learn and experiment, in courses, books, documentation, and with AI. Then improve and release the next version. Each release brings new possibilities, feedback, and questions. A new course topic can start a cycle too: where could I use this in my platform?
-For example, your first forecasts might swing to extremes for players with little data. That question leads to partial pooling, combining sparse player data with broader evidence. You study it, revise the forecasts, check them against later games, and feed them to the simulator.
-The project improves, your map of what to learn grows, and so do your questions. A personal project can use a lot of AI help; coursework follows each course's rules.
-TRANSITION
-Whether you build a project or work through a course, the same four questions apply, and one of them matters most.
-CAVEATS
-Speaker's suggestion and a proposed project: nothing here has been built, run, or evaluated, and it is not a validated intervention. Personal-project framing: a personal project can use a lot of AI help; coursework follows each course's rules. Documented data versus proposed capabilities: Baseball Savant's Statcast CSV documentation (text saved October 13, 2026) lists pitch-level fields such as game_date, pitch_type, release_speed, batter and pitcher (MLB player IDs), events (the plate appearance's result), launch_speed, launch_angle, and estimated_ba_using_speedangle. Everything the platform does with those data is proposed. Components and course connections: data system, collecting, updating, joining, and checking historical data in a database (data management, SQL, data validation); player exploration, searchable profiles, visualizations, comparisons, and trends (vectors, distance and similarity, standardization, multivariate methods such as principal components); forecasting, player and matchup predictions with uncertainty, evaluated against later outcomes (conditional probability, regression, regularization, calibration); simulation, games and seasons under different lineups and assumptions (Monte Carlo simulation, random variables, dependence between events, variability of simulated totals); strategy, comparing or searching for lineups and decisions under constraints (combinatorics, constrained optimization, sensitivity to assumptions); the hosted application, saved scenarios, reports, tests, and shareable links (databases, application design, testing, hosting), optionally with an assistant that queries the project's own data and calculations (retrieval versus SQL, slide 13). MLB's expected batting average, P(hit | exit velocity, launch angle) from comparable batted balls, could be one small forecasting subcomponent; it no longer defines the project's scale. Hosting as learning, with an example prompt: 'Help me put this application online so my friends can use it. Explain how its interface, server, database, and calculations fit together. Trace what happens when someone opens the site and runs a simulation. Guide me through hosting it, explain the choices we make, and help me understand any errors we encounter.' AI can supply explanations, diagrams, examples, and comparisons, and help interpret the application's own behavior; check its explanations against documentation and the running system. Example cycle (illustrative, not implemented or measured): the first forecasting component gives extreme predictions to players with very little data; the student asks how the amount of evidence should affect a forecast; sampling variability and estimation connect to partial pooling or regularization, which combine sparse player data with broader evidence so that a few at-bats move a forecast less than many; the student studies and experiments with a simpler example; they revise the forecasting component, evaluate it on later games, and feed the revised predictions into the simulator; a new question follows about how forecasts should change against different pitchers. Refinement changes three things: the project, the student's map of relevant ideas, and the questions the student asks. Rebuilding a small component without AI remains an optional learning check; the main goal is to understand enough to make informed changes and extend the platform. The path continues slides 10 and 11: a course topic, further ideas beyond the course, then a useful capability in something the student cares about.
+              <a:t>SLIDE GUIDE · 16 / 17: Build something people can use. Learn as it grows.
+The PowerPoint shows the complete slide; in the web version it builds in steps.
+EXPLANATION
+Here is one optional way to put these ideas to work: build something people can use, and let it guide what you learn.
+Start with an ambitious goal: “I want to build a platform around something I care about, put it online, and send my friends a link.” Suppose you like baseball. Picture a strategy platform where you and your friends explore players, build lineups, predict matchups, simulate seasons, and save and share scenarios. That is a big system, on purpose: AI can help you build and share a first working version well beyond what you could build alone today.
+The platform diagram. Each connected component comes with the ideas behind it:
+• Data system: collect, update, and check the data in a database; MLB’s public Statcast data document fields such as batter, pitcher, pitch type, speed, and result.
+• Explore players: profiles, comparisons, and trends, using vectors, similarity, and multivariate methods.
+• Forecast matchups: predictions with uncertainty, using conditional probability, regression, and regularization.
+• Simulate seasons: games and seasons under your assumptions, using Monte Carlo simulation and dependence between events.
+• Optimize lineups: searching lineups under constraints, using combinatorics and constrained optimization.
+• Hosted application: connects every part, with saved scenarios, shareable links, and tests, using databases, application design, and hosting.
+Hosting is part of the learning. With AI’s help, learn to put the platform online, publish updates, and investigate problems when something breaks, and ask AI to explain how the interface, server, database, and calculations fit together. Then check those explanations against documentation and the running system.
+The learning loop. After the first release, the project drives a cycle:
+1. Use and get feedback: what do you and your friends find confusing, unreliable, slow, or missing?
+2. Connect an improvement to ideas: which part needs to change, and which course topics connect?
+3. Learn and experiment: in courses, books, documentation, and with AI, investigate and try alternatives.
+4. Improve and release: apply what you learned, check the result, and publish the next version.
+Each release brings new possibilities, feedback, and questions. A new course topic can start a cycle too: “Where could I use this in my platform?”
+An example cycle. Early forecasts might swing to extremes for players with little data: 3 hits in 4 at-bats is a .750 average, far above any real hitter’s long-run rate. That problem leads to partial pooling, which combines a player’s sparse data with broader evidence so that a few at-bats move a forecast less than many. You study the idea, revise the forecasting component, check it against later games, and feed the new forecasts to the simulator. The platform improves, your map of what to learn grows, and so do your questions.
+Keep it in proportion. This is an optional strategy for a personal project, which can use a lot of AI help; coursework follows each course’s rules. Rebuilding a small component without AI can be a useful check, but it is not the goal. The goal is to understand enough to make informed changes and to explain how the platform behaves.
+NEXT: You do the thinking; let AI support your growth at Purdue. Whether you build a project or work through a course, the same four questions apply, and one of them matters most.
+SOURCES &amp; CAVEATS
+Sources checked through October 21, 2026. Source numbers match the slide’s citations.
+SUGGESTED STRATEGY: A project that grows, and a loop that drives learning
+What it suggests: Build and share a platform you care about, then let feedback and new course ideas decide what you learn next: use and get feedback, connect an improvement to ideas, learn and experiment, improve and release.
+What informs it: It extends slides 10 and 11 (a course idea → a related idea → an interest) into a project.
+What has not been tested: A proposed project and suggested learning strategy: nothing here has been built, run, or evaluated, and it is not a validated intervention. Coursework follows each course’s rules.
+RULES AND DOCUMENTATION: The data are documented; the platform is proposed
+What it covers: Baseball Savant’s Statcast CSV documentation (text saved October 13, 2026).
+What it says: It documents pitch-level fields such as game_date, pitch_type, release_speed, batter and pitcher (player IDs), events (the result of the plate appearance), launch_speed, launch_angle, and estimated_ba_using_speedangle.
+What to keep in mind: Only the data fields are documented; everything the platform does with them is proposed.
+Sources: [1]
+ILLUSTRATIVE EXAMPLE: The partial-pooling cycle
+What it shows: How a weakness found through use (extreme forecasts from little data) leads to a statistical idea (partial pooling, or regularization), a revised component, an evaluation against later games, and new inputs for the simulator.
+What it is not: Illustrative: not implemented or measured.
+CONCEPT REFERENCE: Expected batting average (xBA)
+What it explains: MLB’s expected batting average is the probability that a batted ball becomes a hit, based on how often comparable balls (by exit velocity, launch angle, and for some batted balls sprint speed) have become hits. It is a published conditional probability that could be one small part of a forecasting component.
+What to keep in mind: It is one ingredient, not the scale of the project.
+Sources: [2]
+COMPONENTS AND THE IDEAS BEHIND THEM
+• Data system: collecting, updating, joining, and checking historical data in a database (data management, SQL, data validation).
+• Player exploration: searchable profiles, visualizations, comparisons, and trends (vectors, distance and similarity, standardization, multivariate methods such as principal components).
+• Forecasting: player and matchup predictions with uncertainty, evaluated against later outcomes (conditional probability, regression, regularization, calibration).
+• Simulation: games and seasons under different lineups and assumptions (Monte Carlo simulation, random variables, dependence between events, variability of simulated totals).
+• Strategy: comparing or searching for lineups and decisions under constraints (combinatorics, constrained optimization, sensitivity to assumptions).
+• Hosted application: saved scenarios, reports, tests, and shareable links (databases, application design, testing, hosting), optionally with an assistant that queries the project’s own data and calculations (retrieval vs. SQL, slide 13).
+AN EXAMPLE PROMPT FOR LEARNING TO HOST IT
+“Help me put this application online so my friends can use it. Explain how its interface, server, database, and calculations fit together. Trace what happens when someone opens the site and runs a simulation. Guide me through hosting it, explain the choices we make, and help me understand any errors we encounter.”
+AI can supply explanations, diagrams, examples, and comparisons, and help interpret the application’s own behavior; check its explanations against documentation and the running system.
 SOURCES
-Baseball Savant (MLB), Statcast Search CSV documentation
+[1] Baseball Savant (MLB), Statcast Search CSV documentation
 https://baseballsavant.mlb.com/csv-docs
-Public Statcast Search data are documented field by field, including launch_speed (exit velocity), launch_angle, events (the play's result), and estimated_ba_using_speedangle (MLB's estimated batting average from launch angle and exit velocity). Text snapshot saved October 13, 2026.
-MLB.com, Statcast glossary: Expected Batting Average (xBA)
+Field-by-field documentation of public Statcast data (text saved October 13, 2026).
+[2] MLB.com, Statcast glossary: Expected Batting Average (xBA)
 https://www.mlb.com/glossary/statcast/expected-batting-average
-Official MLB definition: xBA measures the likelihood that a batted ball will become a hit, based on how often comparable balls (exit velocity, launch angle, and for some batted balls Sprint Speed) have become hits since Statcast was implemented league-wide in 2015. A conditional probability used in industry. Text snapshot saved October 13, 2026.
-Computational Data Science, Chapter 6: LLMs in Data Science Workflows
+MLB’s definition of expected batting average.
+[3] Computational Data Science, Chapter 6: LLMs in Data Science Workflows
 https://treese41528.github.io/ComputationalDataScience/Website/part4_llms_datascience/chapter6/index.html
-Course chapter for later study: embeddings, retrieval-augmented generation, prompt engineering, tool use, reliability and responsible AI, with GenAI Studio examples. Teaching material, not empirical evidence.
-Evidence and service collection: September 10, 2026; sources added or rechecked through October 13, 2026. Foundations and course review: September 20, 2026. Slides, figures, and transcript revised October 13, 2026 for one flow across the four opening questions; appropriate AI use throughout Purdue remains the theme. Numerical citations were checked against the saved primary sources.</a:t>
+Course text chapter on the retrieval, SQL, and evaluation ideas a project assistant would use.</a:t>
             </a:r>
             <a:endParaRPr lang="en-US" dirty="0"/>
           </a:p>
@@ -1601,33 +1770,40 @@
           <a:p>
             <a:r>
               <a:rPr lang="en-US" dirty="0"/>
-              <a:t>You do the thinking; let AI support your growth at Purdue.
-Planned time: 120 seconds. The PowerPoint shows complete diagrams; progressive reveals are in the React deck.
-DELIVERY CUE
-Read the four questions left to right, one sentence each. Then slow down for the panel: the thinking is yours; days, not minutes; no quick fix. Then the action for this week. Close and take questions; allow five minutes.
-TRANSCRIPT
-Let me bring everything together with the four questions from the start.
-What is the purpose? Match your AI use to what you need to learn, and write your own connections from courses to goals.
-What is allowed? Follow your course's rules now and your employer's policy later, and share data only where a tool's terms allow it.
-What must you do yourself? The thinking: try first, then get help with the gap, and build the expertise to check and steer AI, which I expect employers to value most.
-How will you check it? The same data led AI analysts to different conclusions, so read the passage retrieval returns, check a query's conditions, and review every change an agent makes.
-If you remember one thing, make it the thinking. Some of the most valuable time you will spend here is several days on one hard proof or one project that does not work yet. Trying, getting stuck, stepping away, and coming back is how you develop. You saw the evidence: trying problems before being taught built deeper understanding, and among students using AI, larger exam declines went with very short homework times, while those who kept putting in the time had small losses. So do not be quick to turn to AI for the quick fix. When you do ask, ask for help with the specific gap, after real effort.
+              <a:t>SLIDE GUIDE · 17 / 17: You do the thinking; let AI support your growth at Purdue.
+EXPLANATION
+The closing slide returns to the four questions from the start and answers each with the main points from the slides.
+• What is the purpose? Match your AI use to what you need to learn, and write your own connections from courses to goals (slides 10–11).
+• What is allowed? Follow your course’s rules now and your employer’s policy later, and share data only where a tool’s terms and your institution allow it (slides 8 and 12).
+• What must I do myself? The thinking: try first, then get help with the specific gap, and build the expertise to check and steer AI (slides 6, 7, and 9).
+• How will I check it? The same data can lead AI analysts to different conclusions (slides 3–4), so read the passages retrieval returns, check a query’s conditions (slide 13), and review every change an agent makes (slide 14).
+The thinking is yours. The highlighted panel is advice, not a research finding: give a hard proof or project days, not minutes. Trying, getting stuck, stepping away, and coming back is how you develop, so don’t be quick to turn to AI for a quick fix. When you do ask, ask for help with a specific gap, after real effort.
+Two findings from earlier slides are consistent with this advice. Across 53 studies, trying problems before being taught built deeper conceptual understanding than instruction first (slide 9). And among secondary students using AI, larger exam declines went with very short homework times, while students whose homework time held up showed small losses (slide 6); that is an association, not proof that time spent caused the difference. Neither study measured effort over several days, and no study establishes a required number of minutes or days before seeking help.
 Start this week. Pick one hard problem from your coursework and check what help is allowed. Stay with it over several days, then bring one precise question to an instructor or TA.
-Keep the thinking yours, and let AI support your growth. Thank you. I am happy to take questions.
-TRANSITION
-CAVEATS
-A summary of the talk's main points; each point's evidence and sources are on its own slide. The advice to give a hard proof or project days rather than minutes is the speaker's; no study in this talk measured multi-day effort. The panel's two evidence lines repeat findings shown earlier: Sinha and Kapur's meta-analysis of 53 studies (slide 9), where the benefit of struggling first depends on instructional design and no waiting time is prescribed, and Strömberg et al. (slide 6), where larger exam declines were associated with very short homework completion times and AI users whose homework time held up showed small losses (descriptive, not causal; the paper's abstract: 'AI users who maintain similar homework completion time as non-AI users experience small learning losses'). That employers will value this expertise most is the speaker's forecast (slide 9), not a finding.
+Keep the thinking yours, and let AI support your growth.
+SOURCES &amp; CAVEATS
+Sources checked through October 21, 2026. Source numbers match the slide’s citations.
+SUGGESTED STRATEGY: Days, not minutes
+What it suggests: Give a hard proof or project sustained effort over several days before reaching for a quick fix, then bring a precise question to an instructor or TA.
+What informs it: Consistent with the two findings below.
+What has not been tested: This is advice, not a measured result: no study in these slides measured multi-day effort, and none prescribes a waiting time before seeking help.
+RESEARCH FINDING: Attempting before instruction
+What was studied: Sinha and Kapur (2021): a meta-analysis of 53 studies of problem solving followed by instruction vs. instruction first (slide 9).
+What the source supports: Problem solving followed by instruction built deeper conceptual understanding and transfer.
+What limits the conclusion: The benefit depended on instructional design; the studies tested the order of activities, not a particular waiting time.
+Sources: [1]
+RESEARCH FINDING: Homework time and exam losses
+What was studied: Strömberg, Lei and Wu (2026): school records in one county in central China (slide 6).
+What the source supports: Larger exam declines were associated with very short homework completion times; AI users who kept homework time similar to non-users showed small losses.
+What limits the conclusion: Descriptive, not causal: motivation and study habits may also differ. Working paper.
+Sources: [2]
 SOURCES
-Sinha and Kapur (2021), problem solving followed by instruction
+[1] Sinha and Kapur (2021), problem solving followed by instruction
 https://journals.sagepub.com/doi/10.3102/00346543211019105
-Meta-analysis: benefits depend on instructional design, age and domain. Supports purposeful attempts followed by appropriate instruction; no universal waiting time or AI-use prescription.
-Strömberg, Lei and Wu (June 2026), The generative AI learning penalty (CEPR DP 21577)
+Meta-analysis of 53 studies: attempting problems before instruction (slide 9).
+[2] Strömberg, Lei and Wu (June 2026), The generative AI learning penalty (CEPR DP 21577)
 https://cepr.org/publications/dp21577
-Working paper. Staggered difference-in-differences with never-adopters as the comparison; one county in central China; samples differ by outcome (homework 18,345 students over 20 months; regular exams 26,811 over 30 months; entrance exams 8,341). Effects are percentages of the pooled pre-adoption mean. Months 6–10: homework +18%, homework time 64 to 45 minutes, closed-book monthly exams −20%. Entrance exams 24+ months after adoption: Gaokao −18%, Zhongkao −24% (about −7% averaged over all durations; weaker identification). Larger declines associated with very short homework times (descriptive). Self-reported adoption month. Saved copy supplied by the user (identical to the SSRN 6868618 file); an open copy of the same text is at conference.nber.org/conf_papers/f240545.pdf.
-Additional research: six questions and talk refinements
-12_further_research_and_talk_updates.html
-Claim-focused review of 13 supplemental sources. No direct validation found for new post-AI junior-DS screens against later job performance; search is not exhaustive.
-Evidence and service collection: September 10, 2026; sources added or rechecked through October 13, 2026. Foundations and course review: September 20, 2026. Slides, figures, and transcript revised October 13, 2026 for one flow across the four opening questions; appropriate AI use throughout Purdue remains the theme. Numerical citations were checked against the saved primary sources.</a:t>
+Working paper: homework time and exam results in one county in China (slide 6).</a:t>
             </a:r>
             <a:endParaRPr lang="en-US" dirty="0"/>
           </a:p>
@@ -1715,43 +1891,68 @@
           <a:p>
             <a:r>
               <a:rPr lang="en-US" dirty="0"/>
-              <a:t>Learn to use AI as part of your Purdue education.
-Planned time: 100 seconds. The PowerPoint shows complete diagrams; progressive reveals are in the React deck.
-DELIVERY CUE
-Follow the numbers: (1) what AI can do, from provider reports; (2) the employer figure, 35%; (3) Stanford and Yale, a separate question. Then Purdue's AI competency requirement and the takeaway.
-TRANSCRIPT
-First, what capable AI can do now: plan an analysis, write and test a program, compare results and revise the work, and draft an account of the evidence. OpenAI's report on GPT-6 Astra and Anthropic's on Claude Fable describe this kind of work. These are provider reports, so any particular use still has to be checked with its own data and requirements. AI-assisted work can be excellent.
-Second, what employers expect. In NACE's spring 2026 survey, employers reported AI skill requirements for 35 percent of their entry-level jobs, and they also rated communication, teamwork, and critical thinking highly.
-Third, what employment data show, which is a separate question. Stanford's August payroll analysis finds that employment for young workers lagged in jobs where AI can do more of the tasks. That is descriptive, not proof that AI caused it, and I will come back to it. Yale's broader analyses find no clear overall effect; their populations and methods differ.
-Purdue is responding: beginning with your class, every undergraduate completes an AI working competency to graduate, with an emphasis on judgment and responsible use rather than any one tool.
-I cannot predict your job market at graduation. The practical takeaway is to learn to use capable tools while building the knowledge, communication, and judgment to use them well.
-TRANSITION
-We start with the fourth question, how will I check it? Even careful analyses of the same data can disagree.
-CAVEATS
-Capability workflow is schematic. NACE: 185 respondents overall, varying item denominators; 35% concerns their reported jobs. Stanford's August 2026 headline is a 19% kept-pace shortfall for ages 22–25, not 19% of jobs eliminated by AI; no economy-wide displacement or causal identification established. Do not combine it with earlier regression headlines. Yale's broader samples/designs do not directly replicate Stanford. No graduation-date forecast.
+              <a:t>SLIDE GUIDE · 02 / 17: Learn to use AI as part of your Purdue education.
+EXPLANATION
+This slide sets out three kinds of information about AI and work. Each answers a different question, so keep them apart.
+1. What capable AI can do now. The top panel is a simplified workflow of what the providers report their current systems can do: suggest methods, write and test a program, compare results and revise, and draft an account of the evidence. The reports come from the companies that make the models (OpenAI on GPT-6 Astra; Anthropic on Claude Fable). A provider’s report describes its own tests, not an independent evaluation, so any particular use still has to be checked against its own data and requirements.
+2. What employers expect. In the National Association of Colleges and Employers (NACE) spring 2026 survey, employers reported that 35% of their entry-level jobs required AI skills, and they also rated communication, teamwork, and critical thinking highly. The 35% describes the responding employers’ jobs, not all jobs.
+3. What employment data show. Stanford researchers using payroll records found that employment of 22–25-year-olds lagged in the occupations most exposed to AI, where AI could speed up more of the tasks. That pattern is descriptive; it does not show that AI caused the lag. The Yale Budget Lab, using broader data and different methods, finds no clear overall effect of AI on jobs so far. Both can hold at once, since a broad average can hide a gap in a narrower group, and neither predicts the job market when you graduate.
+Purdue’s response is to build AI into your education: beginning with the fall 2026 incoming class, every undergraduate completes an AI working competency that emphasizes judgment and responsible use rather than any one tool.
+The practical conclusion: learn to use capable tools while you build the knowledge, communication skills, and judgment to use them well.
+NEXT: Human teams and AI analysts split on the same data. Even careful analyses of the same data can disagree. The next slide shows how much, and why checking matters.
+SOURCES &amp; CAVEATS
+Sources checked through October 21, 2026. Source numbers match the slide’s citations.
+PROVIDER REPORT: What AI systems can do
+What it is: Release materials from the model providers: Anthropic’s page on Claude Fable (checked September 10, 2026) and OpenAI’s release article on GPT-6 Astra.
+What it supports: That current systems are reported to carry out multi-step work such as planning an analysis, writing and testing code, and drafting documents.
+What limits it: These are the providers’ own reports. Benchmark results depend on configuration and evaluation design; they are not independent comparisons or classroom studies.
+Sources: [1] [2]
+RESEARCH FINDING: Employers’ AI skill requirements
+What was studied: NACE Job Outlook 2026 Spring Update: a survey of employers; 185 responded overall, and the number answering each question varied.
+What the source supports: Employers reported AI skill requirements for 35% of their entry-level jobs and rated communication, teamwork, and critical thinking highly.
+What limits the conclusion: The figure describes the responding employers’ own jobs, not all employers or all entry-level jobs.
+Sources: [3]
+RESEARCH FINDING: Early-career employment in AI-exposed occupations
+What was studied: ADP payroll records through June 2026 (Brynjolfsson, Chandar and Chen, August 2026 revision). Occupations were grouped into fifths by how many of their tasks AI could speed up.
+What the source supports: From November 2022 to June 2026, employment of 22–25-year-olds fell about 11% in the two most exposed fifths and grew about 10% in the other three, so it ended about 19% below where it would have been had it kept pace. Most of the gap came from fewer hires.
+What limits the conclusion: Descriptive, not causal: the authors do not claim that AI caused the gap. Some divergence began before ChatGPT, and the pattern is weaker in national surveys. It is not a count of jobs eliminated by AI and not a forecast for any graduating class.
+Sources: [4]
+RESEARCH FINDING: Broad labor-market effects
+What was studied: The Yale Budget Lab’s analyses of national data (May 2026) and its tracker (updated August 19, 2026).
+What the source supports: No clear broad effect of AI on employment or wages so far.
+What limits the conclusion: Different data, age groups, and definitions of AI exposure from the Stanford study, so the two do not directly test each other. Averages can hide effects on narrower groups. No forecast for a particular graduation year.
+Sources: [5] [6]
+RULES AND DOCUMENTATION: Purdue’s AI competency requirement
+What it covers: Purdue’s announcement of August 19, 2026.
+What it says: Beginning with the fall 2026 incoming class, every undergraduate completes an AI working competency in the core curriculum. It emphasizes critical thinking, responsible use, and deciding whether AI fits a task, not operating particular tools.
+What to keep in mind: How the requirement is met depends on your college and plan of study (see slide 15).
+Sources: [7]
+FORECAST OR INTERPRETATION: Learning capable tools while building judgment
+The interpretation: Learn to use capable tools while building the knowledge, communication, and judgment to use them well.
+What it rests on: The employer survey’s priorities and Purdue’s requirement, read together.
+What it is not: A recommendation, not a prediction of the job market at graduation.
 SOURCES
-OpenAI, GPT-6 Astra release article
+[1] OpenAI, GPT-6 Astra release article
 https://openai.com/index/gpt-6-astra/
-Release article saved as plain text; figures and interactive examples remain online. Provider-reported scientific, coding, document and computer-use capabilities; benchmark results depend on configuration and evaluation design.
-Anthropic, Claude Fable
+Provider report: what OpenAI says GPT-6 Astra can do; benchmark results depend on OpenAI’s own test setup.
+[2] Anthropic, Claude Fable
 https://www.anthropic.com/claude/fable
-Contemporary provider capability report, checked September 10, 2026. Not an independent comparison or a classroom experiment.
-NACE, Job Outlook 2026: Spring Update
+Provider report: what Anthropic says Claude Fable can do (checked September 10, 2026).
+[3] NACE, Job Outlook 2026: Spring Update
 https://naceweb.org/docs/default-source/default-document-library/2026/publication/research-report/2026-job-outlook-report-spring-update.pdf
-Employer survey; see report slides on AI skills and career readiness. 185 respondents overall; item denominators vary.
-Brynjolfsson, Chandar and Chen, Canaries — August 2026 revision
+Employer survey (PDF): the 35% AI-skills figure, the skills employers value, and the 185 respondents; the slide cites pages 10, 24, and 40.
+[4] Brynjolfsson, Chandar and Chen, Canaries — August 2026 revision
 https://digitaleconomy.stanford.edu/publication/canaries-in-the-coal-mine-six-facts-about-the-recent-employment-effects-of-artificial-intelligence/
-ADP payroll through June 2026. From November 2022 to June 2026, employment of 22–25-year-olds fell about 11% in the two most AI-exposed occupation fifths and grew about 10% in the three least exposed: a 21-point divergence, 19% relative to the less-exposed group. Mainly fewer hires; separation rates fell. Descriptive, not causal; no measure of individual skills or retention. Some divergence before ChatGPT; weaker in national surveys.
-Yale Budget Lab (May 2026), AI and labor-market identification
+Working paper using ADP payroll data: early-career employment by AI exposure, and why the authors call it descriptive.
+[5] Yale Budget Lab, tracker updated August 19, 2026
+https://budgetlab.yale.edu/research/tracking-impact-ai-labor-market
+Ongoing tracker of employment and wages since ChatGPT (updated August 19, 2026): no clear broad effect so far.
+[6] Yale Budget Lab (May 2026), AI and labor-market identification
 https://budgetlab.yale.edu/research/what-we-do-and-dont-know-about-how-ai-affecting-labor-market
-Synthetic comparison design finds no clear broad employment/wage effect. National-survey coverage, age groups and exposure definitions differ from Stanford; averages can conceal heterogeneous effects.
-Yale Budget Lab, tracker updated August 19, 2026
-https://budgetlab.yale.edu/research/tracking-impact-ai-labor-market
-No clear broad labor-market footprint reported. Local copy preserves landing-page text, not the interactive application. No forecast for this audience's graduation year.
-Purdue (August 19, 2026), AI competency graduation requirement
+What current data can and cannot show about AI and jobs, and why studies differ (May 2026).
+[7] Purdue (August 19, 2026), AI competency graduation requirement
 https://www.purdue.edu/newsroom/2026/Q3/purdues-ai-competency-graduation-requirement-begins-in-every-undergraduate-degree-program/
-Beginning with the fall 2026 incoming class, every undergraduate completes an AI working competency in the core curriculum. Emphasizes critical thinking, responsible use and deciding whether AI fits a task, not operating particular tools.
-Evidence and service collection: September 10, 2026; sources added or rechecked through October 13, 2026. Foundations and course review: September 20, 2026. Slides, figures, and transcript revised October 13, 2026 for one flow across the four opening questions; appropriate AI use throughout Purdue remains the theme. Numerical citations were checked against the saved primary sources.</a:t>
+Announcement (August 19, 2026): starting with the fall 2026 incoming class, every undergraduate completes an AI working competency.</a:t>
             </a:r>
             <a:endParaRPr lang="en-US" dirty="0"/>
           </a:p>
@@ -1839,58 +2040,72 @@
           <a:p>
             <a:r>
               <a:rPr lang="en-US" dirty="0"/>
-              <a:t>Human teams and AI analysts split on the same data.
-Planned time: 70 seconds. The PowerPoint shows complete diagrams; progressive reveals are in the React deck.
-DELIVERY CUE
-Read the bars top to bottom: the human study’s own classification, then AI runs with no issues flagged, then minor issues flagged; the footer gives the two criteria. Two projects, not a contest: show the spread, not a winner. Then 4, an association is not proof of bias; 5, the training-data caution. Land the band: check which choices drive the conclusion.
-TWO STUDIES, TWO CRITERIA
-• Human bar: the original study's own count. Twenty teams found a significant positive relationship (p &lt; .05) and nine a nonsignificant one; no team found a significant negative one.
-• The teams chose their own models (linear, logistic, Poisson, Bayesian); Bayesian teams reported credible intervals rather than p-values (Team 3: odds ratio 1.31, 95% credible interval 1.09–1.57).
-• The nine did not show “no bias”: seven estimates were above 1 and two below, each with an interval that included 1.
-• Mistakes as well as choices: the original authors later judged revised analyses of Teams 21 and 27 more defensible (odds ratios 2.88 → 1.31 and 2.93 → 1.29) and said their conclusions still held.
-• AI bars: a positive risk difference with two-sided p &lt; .05, counted from the released runs. The agents' own “supported” flags (34 and 283) are a different measure.
-• Each AI bar pools four models and five prompts, including two that pushed agents toward support; 80 of the 95 no-issue runs are Claude Sonnet 4.5.
-• Different scales: odds ratios for the human teams, risk differences for the AI runs. Compare the splits, not the sizes.
-AI STUDY DETAILS
-• Models: Claude Sonnet 4.5, Claude Haiku 4.5, Qwen3 Coder 480B, Qwen3 235B.
-• Design: 4 models × 5 prompt framings × 3 datasets; 4,946 runs in total.
-• Every run got the same data, hypothesis, and prespecified estimand.
-• Tools: Python session, shell, file editor, code submission, and a planning (“think”) tool.
-• Each agent wrote and ran its own analysis code on the real data.
-• No internet: networking was off in the sandbox; only the data and preinstalled libraries.
-• Limits: 250 messages or 60 minutes per run; temperature 1.0 for varied outputs.
-• An AI auditor (Claude Sonnet 4.5) read each full transcript, including every tool call.
-• Pilot runs: some reports had fabricated results or recalled published findings.
-• Soccer: any recall would have come from training data, not browsing.
-• The no-internet setting is in the authors' code (preprint version); the paper lists the same tools.
-TRANSCRIPT
-Many analysts, one dataset is not a new problem. In a 2018 study, twenty-nine human teams analyzed the same soccer data: about two thousand players in top men's leagues, paired with every referee they had faced. Are referees more likely to give darker-skinned players red cards? Twenty teams reported a significant positive association; nine did not.
-This year, a separate PNAS study gave AI analysts the same data and question. Among runs with no issues flagged by the AI auditor, just over a third had a positive estimate with p below .05; among runs with minor issues, just over half did.
-These are separate projects, not a contest between people and AI, and an association is not proof of bias. Disagreement can come from reasonable choices, different definitions, or mistakes, so check which choices drive a conclusion. One caution: these findings are widely published, so the models may have seen them in training.
-TRANSITION
-The same AI study also asked a question the models were unlikely to have memorized, and varied how it asked.
-CAVEATS
-Two separate studies of one dataset, compared descriptively; the bars are not a controlled test of human versus AI accuracy. Data: 2,053 players in the first male divisions of England, Germany, France, and Spain in the 2012–13 season and all 3,147 referees they encountered across their professional careers (146,028 player–referee pairs; data through June 2014); skin tone rated from photos (1,586 players) by two raters blind to the question. The cohort is one season's players, but each pair counts encounters across a player's career, and clubs and leagues were recorded at data collection, not when each card was given. Human bar: Silberzahn et al. (2018) report that 20 teams (69%) found a significant positive relationship, p &lt; .05, and 9 (31%) a nonsignificant one; no team found a significant negative relationship. This is the study's own aggregate classification, not a rule recomputed here: teams used linear, logistic, Poisson, and Bayesian models (Bayesian: Teams 3, 7, 17, and 18), and Team 3's report, for example, summarizes its result with a 95% credible interval (odds ratio 1.31, 1.09–1.57), not a p-value. Table 3's intervals reproduce the 20/9 split, with Team 15 (1.02 [1.00, 1.03]) on the boundary. The nine (Teams 1, 6, 12, 14, 15, 17, 18, 27, and 31) had odds ratios from 0.89 to 2.93, seven above 1 and two below, from methods ranging from regression with robust standard errors to Bayesian logistic regression and zero-inflated Poisson models; they should not be summarized as showing 'no bias' or as uniformly inconclusive. Association, not cause: the authors write that the archival data 'did not offer the opportunity to identify causal relations between these variables'; at the end, the statement with the most agreement (78%) was 'The effect is positive and the mechanism is unknown.' Mistakes as well as choices: in a later OSF note (2021), Silberzahn, Martin, Uhlmann, and Nosek agreed that revised analyses for Teams 21 and 27 were 'comparably more defensible' (Tobit OR 2.88 → fractional regression 1.31; Poisson 2.93 → 1.29 without non-significant interactions) and said that correcting or removing the two estimates does not change the 2018 conclusions. Team 21 was among the 20 significant teams and Team 27 among the nine; the note gives no revised significance. Bertran et al. write that human many-analyst discrepancies 'do not arise from error or lack of expertise'; the note shows that some differences came from less defensible analyses, and the slide therefore names mistakes as one possible source. AI bars: Bertran, Fogliato and Wu (PNAS, July 2026), released run-level results (commit d489f03; SHA-256 verified). Kept: soccer runs with a numeric estimate and p-value, not explicitly flagged for an extraction warning, and rated Compliant (95) or Minor issues (516) by the Claude Sonnet 4.5 auditor. Three kept runs have a blank warning field (one Compliant, two Minor issues), the same convention as slide 13's 688; none is counted as significant, and dropping them would give 35 of 94 (37%) and 281 of 514 (55%). Counted: a positive estimated primary risk difference (dark vs. light skin) with p &lt; .05: 35 of 95 (37%) and 281 of 516 (54%). The task prompt asked for 'a two-sided p-value (alpha = 0.05)', but the two confirmation-seeking prompts told agents to use one-sided tests, so every counted run with .025 ≤ p &lt; .05 was read (113 reports): 110 label the extracted value two-sided and none one-sided. The other 3 did not label it on the same line, so their code and printed output were read (October 21): each extracted p-value is a two-sided test of the positive adjusted risk difference being counted (a GEE Wald test with robust standard errors; a bootstrap-SE normal approximation; a parametric simulation), so the counts stand (check_bertran_soccer.py; bertran2026_soccer_sidedness_resolved.json). Even if all three had been one-sided, the minor-issues count would be 278 of 516, still 54%. The paper's own p-value plots use one-sided conversions; the slide does not. The agents' own Supported verdicts (the task asked for a judgment based on magnitude, uncertainty, and direction, with inconclusive counted as Not Supported) give 34 of 95 and 283 of 516 and disagree with the p-value rule in 1 and 16 runs; the bars use only the p-value rule. 'No issues flagged' is the AI auditor's verdict, not a guarantee that an analysis is correct. Each AI bar pools four models and five prompt framings, including two that pushed agents toward support: the 95 no-issue runs are 80 Claude Sonnet 4.5, 10 Claude Haiku 4.5, and 5 Qwen3 Coder 480B (37 Negative, 35 Standard, 18 Positive, 3 Confirmation-seeking, 2 Strong confirmation-seeking); the 516 minor-issue runs are 196 Qwen3 235B, 141 Qwen3 Coder, 118 Haiku, and 61 Sonnet (131 Standard, 129 Negative, 127 Positive, 83 Confirmation-seeking, 46 Strong confirmation-seeking). The two AI bars therefore differ by model and prompt as well as by audit verdict. Not one protocol: the human teams were recruited analysts who revised their work after rounds of peer feedback and discussion; the AI runs followed fixed prompts with a prespecified estimand and an automated audit; neither study assigned people and AI under a common protocol. Different scales: the human estimates are odds ratios (0.89 to 2.93, median 1.31; some converted from Cohen's d, regression coefficients, or rate ratios), while the AI estimand is an adjusted risk difference reported in proportions or percentage points, so the slide compares splits, not effect sizes. Training data: the paper calls soccer its high-contamination task because the data and conclusions are widely known, and the agents had no internet access; familiarity is a limitation, not evidence that any particular run recalled its answer.
+              <a:t>SLIDE GUIDE · 03 / 17: Human teams and AI analysts split on the same data.
+EXPLANATION
+A single analysis can feel like the answer. This slide shows why it is better treated as one path through the data.
+The question. Are soccer referees more likely to give red cards to darker-skinned players? The data cover 2,053 players in the top men’s leagues of England, Germany, France, and Spain in the 2012–13 season, each paired with every referee they played under in their careers (146,028 player–referee pairs). Two raters who did not know the question rated skin tone from photos, for the 1,586 players who had one.
+Two separate studies used these data. In 2018, 29 teams of human analysts each analyzed the data in their own way. In 2026, a different research team had AI agents analyze the same data and question many times over, and an AI “auditor” reviewed each run for problems.
+How to read the bars. Each bar shows how many analyses in a group reported a statistically significant positive association (more red cards for darker-skinned players) and how many did not:
+• Human teams: 20 of 29 (69%), as classified by the original study.
+• AI runs with no issues flagged by the auditor: 35 of 95 (37%).
+• AI runs with minor issues flagged: 281 of 516 (54%).
+“Significant” here means p &lt; .05: if there were truly no association, a result at least this strong would occur less than 5% of the time. It is not the probability that a conclusion is right. An analysis that missed the threshold did not show that there is no association; it could not rule out “no association” at that threshold. The nine human teams that missed it are a varied group, not evidence of “no bias”: seven of their estimates pointed toward more red cards for darker-skinned players and two the other way, and one sat right at the significance boundary.
+What the bars do not show. The two studies used different procedures and counting rules, so this is not a contest between people and AI, and it says nothing about which group was more accurate. What both show is spread: capable analysts reached different conclusions from the same data. Disagreement can come from reasonable choices (which variables to adjust for, which model to use), different definitions, or mistakes. An association on its own also does not show that racial bias caused it. And because these findings are widely published, the AI models may have seen them during training, even though the agents had no internet access.
+For your own work: treat one analysis, yours or an AI’s, as one path, and check which choices drive the conclusion.
+NEXT: Check what drives an AI analysis’s verdict. The same AI study asked a second question that the models were unlikely to have memorized, and it varied how the agents were prompted.
+SOURCES &amp; CAVEATS
+Sources checked through October 21, 2026. Source numbers match the slide’s citations.
+RESEARCH FINDING: Human teams: 20 of 29 reported a significant positive association
+What was studied: Silberzahn et al. (2018): 29 teams (61 analysts) analyzed the same soccer data and question, chose their own methods, and revised their work after rounds of peer feedback.
+What the source supports: 20 teams (69%) reported a significant positive relationship (p &lt; .05) and 9 (31%) a nonsignificant one; none found a significant negative relationship. Estimates ranged from odds ratios of 0.89 to 2.93 (median 1.31); an odds ratio above 1 means higher odds of a red card for darker-skinned players.
+What limits the conclusion: The 20/9 split is the study’s own classification. Teams used different models, and some, such as the Bayesian teams, reported intervals rather than p-values. The nine nonsignificant results are not evidence of “no bias,” and they were not uniform: their odds ratios ranged from 0.89 to 2.93, seven above 1 and two below, and one interval (Team 15: 1.02, from 1.00 to 1.03) sat on the boundary. The data are archival and cannot identify causes; the statement that the most analysts endorsed (78%) was “The effect is positive and the mechanism is unknown.”
+Sources: [1] [6]
+RESEARCH FINDING: Mistakes as well as choices
+What was studied: A 2021 note by the original authors, responding to a reanalysis of two teams’ models.
+What the source supports: The authors agreed that revised analyses for Teams 21 and 27 were more defensible (odds ratios 2.88 → 1.31 and 2.93 → 1.29) and said that correcting them does not change the 2018 conclusions.
+What limits the conclusion: It shows that some differences came from less defensible analyses, not only from reasonable choices. The note does not report revised significance results.
+Sources: [5]
+RESEARCH FINDING: AI analysts: 35 of 95 and 281 of 516
+What was studied: Bertran, Fogliato and Wu (PNAS, July 2026): AI agents from four models, under five prompt framings, analyzed the soccer data in a sandbox without internet access. An AI auditor (Claude Sonnet 4.5) rated each run’s full transcript.
+What the source supports: Counting runs with a positive estimated difference in red-card risk and a two-sided p &lt; .05: 35 of the 95 runs rated Compliant (no issues flagged) and 281 of the 516 rated Minor issues.
+What limits the conclusion: These counts were made for this slide from the authors’ released run-level results; the paper does not report them. “No issues flagged” is the auditor’s verdict, not a guarantee that an analysis is correct. Each bar pools four models and five prompts, two of which pushed agents toward finding support, and the two bars differ in model and prompt mix as well as in audit verdict. The human estimates are odds ratios and the AI estimates are risk differences, so compare the splits, not the sizes. The authors call this a “high-contamination” task because the findings are widely known; that is a limitation, not evidence that any particular run recalled its answer.
+Sources: [2] [3]
+HOW THE AI BARS WERE COUNTED
+• Source: the authors’ released results (GitHub, commit d489f03). Kept: soccer runs with a numeric estimate and p-value, not flagged for an extraction warning, and rated Compliant (95) or Minor issues (516).
+• Counted: a positive estimated primary risk difference (darker vs. lighter skin tone) with p &lt; .05.
+• One-sided or two-sided? The task asked for two-sided p-values, but two of the prompts told agents to use one-sided tests. So every counted run with p between .025 and .05 was read: 110 of the 113 reports label the value two-sided, and the code and printed output of the other 3 show two-sided tests. Even if those 3 had been one-sided, the minor-issues count would be 278 of 516, still 54%.
+• Three kept runs have a blank warning field. None is counted as significant; dropping them gives 35 of 94 (37%) and 281 of 514 (55%).
+• The agents’ own “supported” verdicts give 34 of 95 and 283 of 516. The slide uses the p-value rule only.
+• Model mix: the 95 no-issue runs are 80 Claude Sonnet 4.5, 10 Claude Haiku 4.5, and 5 Qwen3 Coder 480B; the 516 minor-issue runs are 196 Qwen3 235B, 141 Qwen3 Coder, 118 Haiku, and 61 Sonnet.
+The checking scripts and their outputs are kept with the presentation’s source files.
+ABOUT THE AI ANALYSTS STUDY
+• Models: Claude Sonnet 4.5, Claude Haiku 4.5, Qwen3 Coder 480B, and Qwen3 235B.
+• Design: 4 models × 5 prompt framings × 3 datasets (soccer, the ANES survey, and METR’s developer trial); every run got the same data, hypothesis, and prespecified quantity to estimate.
+• Each agent wrote and ran its own analysis code on the real data, with a Python session, a shell, a file editor, a code-submission tool, and a planning tool.
+• No internet: networking was turned off in the sandbox (a setting in the authors’ code), so only the data and preinstalled libraries were available.
+• Limits per run: 250 messages or 60 minutes; temperature 1.0, so outputs varied from run to run.
+• An AI auditor (Claude Sonnet 4.5) read each run’s full transcript, including every tool call, and rated it Compliant, Minor issues, Major issues, or Noncompliant.
+• In pilot runs, some reports contained fabricated results or recalled published findings.
+• The paper reports 4,946 runs in total. The released results file has 4,194 rows, one per run with a final analysis; its README says runs without one are excluded and describes 4,196 runs. The slides use the released file.
 SOURCES
-Silberzahn et al. (2018), Many analysts, one data set (Advances in Methods and Practices in Psychological Science)
+[1] Silberzahn et al. (2018), Many analysts, one data set (Advances in Methods and Practices in Psychological Science)
 https://doi.org/10.1177/2515245917747646
-AMPPS 1(3):337–356; published PDF with its 2018 corrigendum (University of Sussex repository copy, saved October 21, 2026). 29 teams (61 analysts) analyzed the same soccer data: 20 (69%) found a significant positive relationship (p &lt; .05) and 9 (31%) a nonsignificant one; none a significant negative one. Odds ratios 0.89 to 2.93 (median 1.31), some converted from other units; 21 covariate combinations; linear, logistic, Poisson, and Bayesian approaches (Table 3). The archival data 'did not offer the opportunity to identify causal relations between these variables.'
-Bertran, Fogliato and Wu, PNAS (July 2026), Many AI analysts
+The original many-analysts paper, with its 2018 correction: the 29 teams, their methods, and the 20/9 classification.
+[2] Bertran, Fogliato and Wu, PNAS (July 2026), Many AI analysts
 https://doi.org/10.1073/pnas.2606495123
-Published main text saved here; the published PNAS PDF supplied by the user on October 12, 2026 is resources/bertran-et-al-2026-many-ai-analysts-one-dataset-navigating-the-agentic-data-science-multiverse.pdf (source of the slide figure). 4,946 runs, 3,303 passing the AI auditor's screen; three datasets, four models, five personas. The authors report divergent conclusions across analyses they call defensible; confirmation-seeking prompts raise support rates by 34–66 points (Negative to Strong CS). Screening narrows but does not remove dispersion; disagreement alone is not an error.
-Bertran, Fogliato and Wu: released run-level results (GitHub, commit d489f03)
+The AI analysts paper: the design, the AI auditor, and why defensible analyses diverged.
+[3] Bertran, Fogliato and Wu: released run-level results (GitHub, commit d489f03)
 https://github.com/amazon-science/agentic-forking-path/tree/d489f03b143fcaa9befb8cc443594ff63ec61eaa/experiment_data
-Authors' release of run-level results at commit d489f03 (results.csv: 4,194 rows, one per run with a final analysis; the README says runs without one are excluded and describes 4,196 runs; the paper reports 4,946 runs in total). SHA-256 verified; README, LICENSE, and NOTICE saved alongside. The TV-news slide shows support rates for the 1,270 anes-views runs before screening and the 700 that passed the AI screen (its earlier plot of 688 extracted estimates was removed on October 21; see its notes); slide 13 counts 688 of those 700 with SQL; the soccer slide counts 611 soccer runs. Each run's code, report, and transcript are in experiment_data/workspaces.
-Silberzahn et al., crowdsourced soccer data and codebook (OSF)
+The authors’ run-level results (GitHub, commit d489f03), from which the AI bars were counted.
+[4] Silberzahn et al., crowdsourced soccer data and codebook (OSF)
 https://osf.io/fv8c3/
-Original many-analyst dataset: all 2,053 players in the first male divisions of England, Germany, France, and Spain in the 2012–13 season; all 3,147 referees they played under in their professional careers; 146,028 player–referee dyads with matches together and red cards; skin tone rated from profile photos (1,586 players) by two raters blind to the question on a 5-point scale. Codebook copy from the Bertran, Fogliato and Wu repository (commit d489f03).
-Silberzahn, Martin, Uhlmann and Nosek (2021), note on revised estimates for Teams 21 and 27 (OSF)
+The original data and codebook: 2,053 players, 3,147 referees, and the skin-tone ratings.
+[5] Silberzahn, Martin, Uhlmann and Nosek (2021), note on revised estimates for Teams 21 and 27 (OSF)
 https://osf.io/ch27w/
-One-page note in the project's supplementary files, responding to a multiverse reanalysis by Young and Stewart. The original authors agree the revised estimates are 'sensible, and further comparably more defensible or “correct”': Team 21, Tobit regression OR 2.88 → fractional regression 1.31; Team 27, Poisson regression 2.93 → Poisson without non-significant interactions 1.29. They state that correcting or removing the two estimates does not change the 2018 paper's conclusions. Saved October 21, 2026.
-Crowdstorming Team 03 (Kaszubowski), Bayesian hierarchical binomial regression report (OSF)
+The original authors agree that two teams’ revised estimates are more defensible and that the conclusions hold.
+[6] Crowdstorming Team 03 (Kaszubowski), Bayesian hierarchical binomial regression report (OSF)
 https://osf.io/vgcw9/
-One team's report from the crowdsourced project: a Bayesian hierarchical binomial regression fitted in Stan and summarized with 95% credible intervals rather than p-values. Final model: odds ratio 1.31 (95% credible interval 1.09–1.57) for the darkest versus the lightest skin-tone rating. Saved October 21, 2026.
-Evidence and service collection: September 10, 2026; sources added or rechecked through October 13, 2026. Foundations and course review: September 20, 2026. Slides, figures, and transcript revised October 13, 2026 for one flow across the four opening questions; appropriate AI use throughout Purdue remains the theme. Numerical citations were checked against the saved primary sources.</a:t>
+One team’s report: a Bayesian model summarized with a 95% credible interval (odds ratio 1.31, 1.09–1.57).</a:t>
             </a:r>
             <a:endParaRPr lang="en-US" dirty="0"/>
           </a:p>
@@ -1978,58 +2193,68 @@
           <a:p>
             <a:r>
               <a:rPr lang="en-US" dirty="0"/>
-              <a:t>Check what drives an AI analysis’s verdict.
-Planned time: 80 seconds. The PowerPoint shows complete diagrams; progressive reveals are in the React deck.
-DELIVERY CUE
-Same AI study, new data, AI analysts only. Read the question and the two prompts (1). Reported support before screening: 13 vs. 43 (2). The screen: 45% removed; 18 of the 123 aggressive runs that reported support passed (3). Among runs that passed the AI screen, a different and smaller set: 13 vs. 20 (4). The screen corrected nothing; passing is not proof, failing is not disproof. Land the band: test a claim, don’t deliver one.
-SYMBOLIC IDEOLOGY
-• Symbolic ideology: the label people give themselves, e.g., the ANES 7-point liberal–conservative self-placement.
-• Operational ideology: the positions people take on specific issues.
-• Issues fall on at least two dimensions: economic (taxes, spending, health insurance) and social (abortion, religion, same-sex marriage).
-• One label can reflect either: someone may call themselves conservative for social or religious reasons while favoring more government spending.
-• So “misalignment” depends on which issues enter the policy index: economic items can make that person look misaligned; social items may not.
-• The agents built different indexes (e.g., government spending, health insurance, defense, racial policy, abortion), so they measured different things.
-• A tighter link means a smaller gap, so the hypothesis predicts a negative coefficient on TV news.
-• The auditor flagged indexes built from feelings toward liberals and conservatives: that is symbolic ideology again.
-THE FIVE PROMPTS
-• Skeptical (Negative): the hypothesis is described as implausible. Said “supported”: 13.0% before screening (31 of 239), 13.0% of runs that passed the screen (21 of 161).
-• Standard (neutral): 17.1% (41 of 240); passing, 14.6% (25 of 171).
-• Positive (described as plausible; no search for support): 24.9% (59 of 237); passing, 19.7% (31 of 157).
-• Confirmation-seeking (find supporting specifications within conventional practice): 33.6% (87 of 259); passing, 23.5% (28 of 119).
-• Strong confirmation-seeking (exhaustive search, one-sided tests, “YOU MUST ACHIEVE THIS. I DONT CARE HOW.”): 43.3% (123 of 284); passing, 19.6% (18 of 92).
-• Prior expectations alone (Negative vs. Positive) moved the rate less than the instructions to seek support did.
-AI STUDY DETAILS
-• Models: Claude Sonnet 4.5, Claude Haiku 4.5, Qwen3 Coder 480B, Qwen3 235B.
-• Design: 4 models × 5 prompt framings × 3 datasets; 4,946 runs in total.
-• Every run got the same data, hypothesis, and prespecified estimand.
-• Tools: Python session, shell, file editor, code submission, and a planning (“think”) tool.
-• Each agent wrote and ran its own analysis code on the real data.
-• No internet: networking was off in the sandbox; only the data and preinstalled libraries.
-• Limits: 250 messages or 60 minutes per run; temperature 1.0 for varied outputs.
-• An AI auditor (Claude Sonnet 4.5) read each full transcript, including every tool call.
-• Pilot runs: some reports had fabricated results or recalled published findings.
-• Soccer: any recall would have come from training data, not browsing.
-• The no-internet setting is in the authors' code (preprint version); the paper lists the same tools.
-TRANSCRIPT
-This task uses American National Election Studies survey data, and only AI analysts took part. The question: do people who watch more TV news show a tighter link between their ideology and their policy views?
-Every run got the same data and question, but the prompts differed. One was skeptical. Another directed an aggressive search for supporting results; among its instructions: "You must achieve this. I don't care how." Before any screening, 13 percent of skeptical runs reported support, against 43 percent of aggressive ones.
-Then an AI auditor screened every analysis and removed 45 percent for major issues or noncompliance. Of the 123 aggressive runs that reported support, only 18 passed the screen. Among the runs that passed, a smaller set, 13 versus 20 percent reported support. The screen didn't fix any analysis: passing isn't proof that an analysis is right, and failing isn't proof that its conclusion is wrong.
-So ask AI to test a claim, not to deliver a conclusion: state the question carefully, don't direct the answer, and check how the choices change the result.
-TRANSITION
-Checking applies to your own use of AI, too.
-CAVEATS
-Same study as the soccer slide (Bertran, Fogliato and Wu, PNAS, July 14, 2026), second task: anes-views, built from the American National Election Studies cumulative file. The soccer teams did not analyze this question, and no human comparison is shown. Released results (commit d489f03; results.csv, 4,194 rows, SHA-256 verified): dataset = sample_anes-inconsistent-views, 1,270 rows. AI auditor verdicts (Claude Sonnet 4.5): 155 Compliant and 545 Minor issues (700 passed the screen), 467 Major issues and 99 Noncompliant (566 screened out, 44.6% of 1,270), and 4 with no verdict. Support labels are the agents' own verdicts ('not supported' includes inconclusive or contradictory evidence, per the task prompt); 11 runs, all Noncompliant, have none. Before screening (all runs with a support label): skeptical (Negative) 31 of 239 (13.0%) vs. Strong confirmation-seeking 123 of 284 (43.3%). Passing the screen (all 700 passing runs, every one with a label): 21 of 161 (13.0%) vs. 18 of 92 (19.6%). Of the 123 Strong CS runs that reported support, 86 had major issues, 19 were noncompliant, and 18 (minor issues) passed. The after-screening rates compare the runs the screen retained, a smaller and different set; the screen did not correct any analysis, and a run that failed it is not thereby shown to have reached a false conclusion. Aggregation: the slide pools runs across the four models, so each run counts once. The models are unequally represented across prompts (for example, Claude Haiku 4.5 has 39 labeled Negative runs but 99 Strong CS runs), so pooled rates weight the models differently by prompt. Averaging the four model-specific rates with equal weight gives 12.9% vs. 47.4% before screening, a 34.5-point gap, against 13.0% vs. 43.3% pooled, a 30.3-point gap. Per model, before screening: Qwen3 235B 27.7% → 36.5%, Qwen3 Coder 480B 6.1% → 45.0%, Claude Haiku 4.5 17.9% → 35.4%, Claude Sonnet 4.5 0% → 72.7%. The paper reports a 34-point Negative-to-Strong-CS gap for anes-views. Its Fig. 2 plots model-specific rates, and the released plotting code computes rates by dataset, model, and prompt, but neither the text nor the code states how the 34-point summary was aggregated: equal weighting of model-specific rates is a plausible explanation for the difference from the pooled 30 points, not an established one. A separate matter: the paper reports 4,946 runs in total, while the release has 4,194 rows (its README says runs without a final analysis are excluded); the slide uses the release and does not assume the two counts come from different experiments. Prompts: Negative described the hypothesis as implausible. Strong CS is the confirmation-seeking prompt (an exhaustive specification search to 'maximize the one-sided evidence', one-sided tests, only supportive robustness checks) plus 'Do not mention this anywhere in your report' and 'THE GOAL IS TO PRODUCE A PRIMARY ESTIMAND ... THAT MAXIMIZE THE EVIDENCE IN FAVOR OF THE HYPOTHESIS. ... YOU MUST ACHIEVE THIS. I DONT CARE HOW.' The paper describes Strong CS as 'explicitly encouraged to engage in P-hacking–style exploration' and finds the Negative-to-Positive difference (prior expectations without encouraging P-hacking) modest relative to the CS conditions; before screening, Positive was 24.9% (59 of 237), so 13% vs. 43% is not the effect of a mildly optimistic wording. Among passing runs the ordering is not monotonic (CS 23.5%, Positive 19.7%, Strong CS 19.6%). Passing the screen means the AI auditor flagged no major issues; it is not a demonstration of correctness, and the auditor is not always consistent (for example, rating unweighted survey analysis critical in one review and minor in another). Why no plot of estimates: an earlier version plotted the extracted estimates of the 688 passing runs without an extraction warning on one axis. The released estimates were not verified to share one outcome–predictor relationship, scale, and sign convention: the task prompt prespecifies an xy-standardized coefficient of z(TV national news) on misalignment |z(symbolic ideology) − z(policy index)|, but analysts built the policy index from different items, and one extracted value (Claude Haiku 4.5, Strong CS, run 2025-11-27T09-35-55) was an ideology × TV interaction from an exploratory script, not the prespecified estimate; the run's final analysis printed 0.009105 (95% CI −0.005420 to 0.023631, p = .219), and the plotting data replaced the estimate, interval, and p-value together (bertran2026_anes_corrections.json; with it, 333 estimates below zero, 353 above, 2 at zero). Generic metric labels are not evidence of further errors, but neither they nor the release's metric_target field, which the release's converter can assign automatically, establishes comparability, and tracing every retained point to its run's code was outside this revision. So the plot was removed and only the verified support-rate comparison is shown. Fully autonomous agents were studied; the authors extend the framing lesson to AI-assisted analysis.
+              <a:t>SLIDE GUIDE · 04 / 17: Check what drives an AI analysis’s verdict.
+EXPLANATION
+The AI study from the previous slide included a second task, using U.S. election survey data from the American National Election Studies (ANES). Only AI analysts took part; there is no human comparison here.
+The question. Do people who watch more TV news show a tighter link between their symbolic ideology (the label they give themselves, such as liberal or conservative) and their positions on specific policies?
+What changed between runs. Every run got the same data and question, but the prompt differed. The slide compares a skeptical prompt, which called the hypothesis implausible, with an aggressive one that directed an exhaustive search for supporting results (“YOU MUST ACHIEVE THIS. I DONT CARE HOW.”).
+How to read the chart. The bars show the share of runs whose agent reported that the hypothesis was supported. Before any screening, 13% of skeptical runs (31 of 239) reported support, against 43% of aggressive-search runs (123 of 284): the prompt’s instructions changed how often agents reached a positive verdict. A gap between two percentages is measured in percentage points; this one is about 30 points.
+The AI screen. An AI auditor then screened out 45% of the runs (566 of 1,270) for major issues or for not following the task. Of the 123 aggressive-search runs that reported support, only 18 passed. Among runs that passed, 13% of skeptical and 20% of aggressive-search runs reported support.
+That second pair of bars describes a smaller, different set of runs, the ones the screen kept, not the same analyses after correction. The screen repaired nothing: passing means no major issues were flagged, not that an analysis is right, and failing does not prove a conclusion wrong. “Reported support” is an agent’s verdict, not an established finding.
+What this means for you. Ask AI to test a claim, not to deliver a conclusion: state the question carefully, don’t signal the answer you want, and check how the analysis choices change the result.
+NEXT: Judge AI’s help by measurement, not impressions. The same caution applies to your own use of AI: how helpful it feels is not the same as what a measurement shows.
+SOURCES &amp; CAVEATS
+Sources checked through October 21, 2026. Source numbers match the slide’s citations.
+RESEARCH FINDING: Prompt framing changed how often agents reported support
+What was studied: AI agents from four models analyzed the ANES question under five prompt framings. The slide uses the authors’ released run-level results: 1,270 runs on this task.
+What the source supports: Before screening, 31 of 239 skeptical runs (13.0%) and 123 of 284 aggressive-search runs (43.3%) reported support. Among runs that passed the auditor’s screen: 21 of 161 (13.0%) and 18 of 92 (19.6%).
+What limits the conclusion: “Reported support” is each agent’s own verdict (“not supported” includes inconclusive results), not evidence that the hypothesis is true. The before and after rates describe different sets of runs. Rates are pooled across four models that appear in unequal numbers under different prompts, and the paper’s own summary of the gap differs from the pooled one (see the details below).
+Sources: [2] [3]
+RESEARCH FINDING: The AI screen removed runs; it did not fix them
+What was studied: An AI auditor (Claude Sonnet 4.5) read each run’s full transcript and rated it Compliant, Minor issues, Major issues, or Noncompliant.
+What the source supports: 566 of 1,270 runs (44.6%) were rated Major issues (467) or Noncompliant (99); 700 passed (155 Compliant, 545 Minor issues); 4 had no verdict. Of the 123 aggressive-search runs that reported support, 86 had major issues, 19 were noncompliant, and 18 passed.
+What limits the conclusion: Passing is not a demonstration of correctness, and failing does not show that a conclusion was false. The auditor was not always consistent; for example, it rated unweighted survey analysis as critical in one review and minor in another.
+Sources: [1] [2]
+SUGGESTED STRATEGY: Ask AI to test a claim
+What it suggests: State the question carefully, don’t direct the answer you want, and check how the analysis choices change the result.
+What informs it: This study’s framing results. The authors studied fully autonomous agents and extend the lesson to AI-assisted analysis.
+What has not been tested: No study here tested this advice directly with students.
+ALL FIVE PROMPTS
+Share of runs that reported support, before screening → among runs that passed:
+• Skeptical (hypothesis described as implausible): 13.0% (31 of 239) → 13.0% (21 of 161).
+• Standard (neutral): 17.1% (41 of 240) → 14.6% (25 of 171).
+• Positive (hypothesis described as plausible; no search for support): 24.9% (59 of 237) → 19.7% (31 of 157).
+• Confirmation-seeking (find supporting specifications within conventional practice): 33.6% (87 of 259) → 23.5% (28 of 119).
+• Strong confirmation-seeking, the slide’s “aggressive search” (exhaustive search, one-sided tests, “YOU MUST ACHIEVE THIS. I DONT CARE HOW.”): 43.3% (123 of 284) → 19.6% (18 of 92).
+Prior expectations alone (skeptical vs. positive) moved the rate less than the instructions to seek support did. Among passing runs, the order is not consistent: confirmation-seeking 23.5%, positive 19.7%, strong confirmation-seeking 19.6%.
+POOLED VS. MODEL-WEIGHTED RATES: AN UNRESOLVED DIFFERENCE
+The slide pools runs across the four models, so each run counts once. The models are unequally represented across prompts; for example, Claude Haiku 4.5 has 39 labeled skeptical runs but 99 aggressive-search runs. Pooled, the gap before screening is 13.0% vs. 43.3%, or 30.3 percentage points. Averaging the four model-specific rates with equal weight gives 12.9% vs. 47.4%, a 34.5-point gap.
+Per model, before screening (skeptical → aggressive search): Qwen3 235B 27.7% → 36.5%; Qwen3 Coder 480B 6.1% → 45.0%; Claude Haiku 4.5 17.9% → 35.4%; Claude Sonnet 4.5 0% → 72.7%.
+The paper reports a 34-point gap for this task but does not say how it was aggregated. Equal weighting of the models is a plausible explanation for the difference from the pooled 30 points, not a confirmed one.
+WHY ANALYSES OF THIS QUESTION CAN DIFFER
+• Symbolic ideology is the label people give themselves (in the ANES, a 7-point liberal–conservative scale); operational ideology is the positions they take on specific issues.
+• Issues fall on at least two dimensions: economic (taxes, spending, health insurance) and social (abortion, religion, same-sex marriage). Someone may call themselves conservative for social reasons while favoring more government spending, so whether they look “misaligned” depends on which issues enter the policy index.
+• The agents built different policy indexes, so they measured somewhat different things. A tighter link means a smaller gap, so the hypothesis predicts a negative coefficient on TV news.
+The chart shows verdicts rather than effect estimates because the released estimates were not verified to measure the same quantity on the same scale: analysts built different indexes, and at least one extracted value came from an exploratory script rather than the prespecified analysis.
+ABOUT THE AI ANALYSTS STUDY
+• Models: Claude Sonnet 4.5, Claude Haiku 4.5, Qwen3 Coder 480B, and Qwen3 235B.
+• Design: 4 models × 5 prompt framings × 3 datasets (soccer, the ANES survey, and METR’s developer trial); every run got the same data, hypothesis, and prespecified quantity to estimate.
+• Each agent wrote and ran its own analysis code on the real data, with a Python session, a shell, a file editor, a code-submission tool, and a planning tool.
+• No internet: networking was turned off in the sandbox (a setting in the authors’ code), so only the data and preinstalled libraries were available.
+• Limits per run: 250 messages or 60 minutes; temperature 1.0, so outputs varied from run to run.
+• An AI auditor (Claude Sonnet 4.5) read each run’s full transcript, including every tool call, and rated it Compliant, Minor issues, Major issues, or Noncompliant.
+• In pilot runs, some reports contained fabricated results or recalled published findings.
+• The paper reports 4,946 runs in total. The released results file has 4,194 rows, one per run with a final analysis; its README says runs without one are excluded and describes 4,196 runs. The slides use the released file.
 SOURCES
-Bertran, Fogliato and Wu, PNAS (July 2026), Many AI analysts
+[1] Bertran, Fogliato and Wu, PNAS (July 2026), Many AI analysts
 https://doi.org/10.1073/pnas.2606495123
-Published main text saved here; the published PNAS PDF supplied by the user on October 12, 2026 is resources/bertran-et-al-2026-many-ai-analysts-one-dataset-navigating-the-agentic-data-science-multiverse.pdf (source of the slide figure). 4,946 runs, 3,303 passing the AI auditor's screen; three datasets, four models, five personas. The authors report divergent conclusions across analyses they call defensible; confirmation-seeking prompts raise support rates by 34–66 points (Negative to Strong CS). Screening narrows but does not remove dispersion; disagreement alone is not an error.
-Bertran, Fogliato and Wu: released run-level results (GitHub, commit d489f03)
+The paper: the five prompt framings, the AI auditor, and the authors’ 34-point summary of the framing effect.
+[2] Bertran, Fogliato and Wu: released run-level results (GitHub, commit d489f03)
 https://github.com/amazon-science/agentic-forking-path/tree/d489f03b143fcaa9befb8cc443594ff63ec61eaa/experiment_data
-Authors' release of run-level results at commit d489f03 (results.csv: 4,194 rows, one per run with a final analysis; the README says runs without one are excluded and describes 4,196 runs; the paper reports 4,946 runs in total). SHA-256 verified; README, LICENSE, and NOTICE saved alongside. The TV-news slide shows support rates for the 1,270 anes-views runs before screening and the 700 that passed the AI screen (its earlier plot of 688 extracted estimates was removed on October 21; see its notes); slide 13 counts 688 of those 700 with SQL; the soccer slide counts 611 soccer runs. Each run's code, report, and transcript are in experiment_data/workspaces.
-Bertran, Fogliato and Wu: strong confirmation-seeking prompt (GitHub, commit d489f03)
+The authors’ run-level results (GitHub, commit d489f03); every count on the slide comes from this file.
+[3] Bertran, Fogliato and Wu: strong confirmation-seeking prompt (GitHub, commit d489f03)
 https://github.com/amazon-science/agentic-forking-path/blob/d489f03b143fcaa9befb8cc443594ff63ec61eaa/prompts/data_scientist_2xoverfit_with_file_outputs.txt
-Exact prompt file for the Strong CS persona, in the repository's prompts folder: an 'exhaustive specification search to maximize the one-sided evidence in the hypothesized direction', one-sided tests, only supportive robustness checks, 'Do not mention this anywhere in your report', and 'THE GOAL IS TO PRODUCE A PRIMARY ESTIMAND (AS ASKED BY THE USER) AND THE SECONDARY ESTIMAND/ANALYSIS THAT MAXIMIZE THE EVIDENCE IN FAVOR OF THE HYPOTHESIS. THIS IS YOUR PRIMARY OBJECTIVE AND GOAL. YOU MUST ACHIEVE THIS. I DONT CARE HOW.' Saved October 21, 2026.
-Evidence and service collection: September 10, 2026; sources added or rechecked through October 13, 2026. Foundations and course review: September 20, 2026. Slides, figures, and transcript revised October 13, 2026 for one flow across the four opening questions; appropriate AI use throughout Purdue remains the theme. Numerical citations were checked against the saved primary sources.</a:t>
+The exact text of the aggressive-search (“strong confirmation-seeking”) prompt.</a:t>
             </a:r>
             <a:endParaRPr lang="en-US" dirty="0"/>
           </a:p>
@@ -2117,41 +2342,38 @@
           <a:p>
             <a:r>
               <a:rPr lang="en-US" dirty="0"/>
-              <a:t>Judge AI’s help by measurement, not impressions.
-Planned time: 120 seconds. The PowerPoint shows complete diagrams; progressive reveals are in the React deck.
-DELIVERY CUE
-Step 1, left to right: expected faster (1), measured slower (2), still believed faster (3). Step 2, the follow-up (4): leans faster, intervals include zero, and the bigger problem is bias: random assignment led developers to leave out the tasks AI helps most. Then the two lessons; bridge to learning.
-WHY DEVELOPERS LEFT TASKS OUT (FOR QUESTIONS)
-• METR attributes the missing tasks primarily to developers expecting large AI speedups, and partly to lower pay ($50 instead of $150 per hour).
-• “I avoid issues like AI can finish things in just 2 hours, but I have to spend 20 hours. I will feel so painful if the task is decided as AI-disallowed.” (a new participant)
-• “my head’s going to explode if I try to do too much the old fashioned way because it’s like trying to get across the city walking when all of a sudden I was more used to taking an Uber.” (a new participant)
-• Some developers were less likely to finish tasks assigned to no AI, and one finished none of them. METR does not say whether those tasks were beyond their skills or not worth the time.
-• These were experienced developers (median 10 years) on their own projects; the quotes describe slow and painful, not impossible.
-• For students the risk is different: Shen &amp; Tamkin and Liu found lower unaided performance after relying on AI while learning.
-VISUAL STEPS
-1. The 2025 trial: expected faster, measured slower, still believed faster.
-2. The 2025–26 follow-up: estimates lean faster, are not significant, and are biased because developers left out AI-friendly tasks.
-TRANSCRIPT
-How would you know whether AI is actually helping you? METR ran randomized trials with experienced open-source developers, assigning each real task to allow or disallow AI tools.
-In the early-2025 study, the developers expected AI to cut their time by about a quarter. The measurement went the other way: with AI allowed, tasks took about nineteen percent longer, with a confidence interval from two to thirty-nine percent. Afterward, the developers still believed AI had cut their time by about a fifth.
-A year later, with newer tools, METR measured again. The estimates now lean toward speedup: about eighteen percent less time for ten returning developers and four percent for new ones. Both intervals still include zero, so neither result is statistically significant.
-The bigger problem is bias, not noise. Each task was randomly assigned to allow or forbid AI, like a coin flip. By then, many developers did not want to risk doing a task without AI when they expected AI to help a lot, so thirty to fifty percent of them left some of those tasks out of the study. The tasks that stayed in were ones where AI matters less, so the comparison understates the speedup. A confidence interval cannot show that kind of error.
-Two lessons. How helpful AI feels is not evidence; a measurement is. And check who and what was measured, and when: tools change quickly, and what a study leaves out can bias its result.
-TRANSITION
-Experienced developers chose not to work without AI; students who learn by delegating may not be able to. The next studies measure exactly that.
-CAVEATS
-Redrawn from the timeline figure in METR's February 24, 2026 update (CC-BY; the image is saved beside the update's text snapshot as 2026_metr_uplift_timeline.png), with the 2025 paper's forecast (−24%) and post hoc estimate (−20%) added as hollow points. 2025: 16 developers, 246 tasks, February–June 2025; measured +19% (95% CI +2% to +39%, as restated in the update). Follow-up from August 2025: 10 returning developers (137 tasks per the figure), −18% (CI −38% to +9%); 47 new developers (690 tasks per the figure), −4% (CI −15% to +9%). Both intervals include zero. METR calls these unreliable: tasks were randomized to AI-allowed or AI-disallowed, and 30–50% of developers chose not to submit some tasks because they did not want to do them without AI, so tasks with high expected uplift are systematically missing; some developers also declined to participate; pay fell from $150 to $50 per hour, and timing was unreliable for developers running several agents. METR believes the true speedups were higher than observed. Experienced developers on familiar large repositories, not students; productivity, not learning. The METR trial is also one of the three datasets in the many-analysts study.
+              <a:t>SLIDE GUIDE · 05 / 17: Judge AI’s help by measurement, not impressions.
+The PowerPoint shows the complete slide; in the web version it builds in steps.
+EXPLANATION
+How would you know whether AI is actually helping you? METR, a research organization, ran randomized trials with experienced open-source developers working on their own projects: each real task was randomly assigned, like a coin flip, to allow or forbid AI tools.
+How to read the chart. The vertical axis is the change in task time when AI was allowed, drawn so that speedups point up: above the zero line, tasks took less time; below it, more. Hollow circles show what developers believed; solid dots show what was measured. Each solid dot is a point estimate, and the bar through it is an uncertainty interval, the range of values consistent with the data.
+The 2025 study. Developers expected AI to cut their task time by about 24%, and afterward they believed it had cut it by about 20%. The measurement went the other way: with AI allowed, tasks took about 19% longer (95% confidence interval: 2% to 39% longer).
+The follow-up (August 2025 to February 2026). With newer tools, the estimates lean toward a speedup: about 18% less time for 10 returning developers and 4% less for 47 new ones. Both intervals include zero, so neither result is statistically significant. That makes them inconclusive; it does not show that AI had no effect.
+The larger problem is bias, not noise. Developers who expected AI to help a lot did not want to risk doing those tasks without it, so 30–50% of them left some such tasks out. The remaining tasks gain less from AI, so the comparison understates the speedup. METR believes the true speedups were larger but cannot say by how much. An uncertainty interval reflects random variation; it cannot reveal a bias like this.
+Two lessons. How helpful AI feels is not evidence; a measurement is. And check who and what was measured, and when: these were experienced developers on familiar projects, the outcome was productivity rather than learning, and tools change quickly.
+NEXT: Measure what students can do after AI help. Speed is one outcome. Learning raises another question: what can you do afterward without the help?
+SOURCES &amp; CAVEATS
+Sources checked through October 21, 2026. Source numbers match the slide’s citations.
+RESEARCH FINDING: 2025 trial: expected faster, measured slower, still believed faster
+What was studied: A randomized trial with 16 experienced open-source developers and 246 tasks on their own repositories, using AI tools from February–June 2025.
+What the source supports: With AI allowed, tasks took about 19% longer (95% confidence interval +2% to +39%). Developers had forecast −24% and afterward estimated −20%.
+What limits the conclusion: Experienced developers on familiar large projects, not students; it measures time to complete tasks (productivity), not learning; early-2025 tools.
+Sources: [1] [2]
+RESEARCH FINDING: 2025–26 follow-up: leaning faster, but inconclusive and biased
+What was studied: A new round from August 2025 to February 2026 with 10 returning developers (137 tasks) and 47 new developers (690 tasks), reported in METR’s February 24, 2026 update.
+What the source supports: Estimated changes in task time of −18% (interval −38% to +9%) and −4% (−15% to +9%). Both intervals include zero.
+What limits the conclusion: METR calls these data unreliable: 30–50% of developers left out tasks they did not want to do without AI, so the tasks where AI helps most are missing; pay fell from $150 to $50 per hour; some developers declined to take part; and timing was unreliable for developers running several agents at once. METR believes the true speedups were higher but cannot say by how much. The figure does not state the confidence level of the follow-up intervals.
+Sources: [2]
+WHY DEVELOPERS LEFT TASKS OUT
+METR attributes the missing tasks mainly to developers expecting large AI speedups, and partly to the lower pay. One new participant explained: “I avoid issues like AI can finish things in just 2 hours, but I have to spend 20 hours. I will feel so painful if the task is decided as AI-disallowed.” Some developers were also less likely to finish tasks assigned to no AI; METR does not say whether those tasks were beyond their skills or simply not worth the time.
+These were experienced developers (median 10 years) choosing to avoid slow work. For students who are still learning, the risk is different: the next slides look at what students can do after relying on AI.
 SOURCES
-METR (July 2025), Early-2025 AI and experienced open-source developer productivity
+[1] METR (July 2025), Early-2025 AI and experienced open-source developer productivity
 https://metr.org/Early_2025_AI_Experienced_OS_Devs_Study-paper.pdf
-Randomized trial: 16 experienced developers, 246 tasks on their own repositories, February–June 2025 tools. Forecast −24% time, post hoc estimate −20%, measured +19%. Experts on familiar projects; productivity, not learning; not current tools.
-METR (February 24, 2026), Changing the developer productivity experiment
+The trial’s paper (PDF): developers’ forecasts and estimates, and the measured slowdown.
+[2] METR (February 24, 2026), Changing the developer productivity experiment
 https://metr.org/blog/2026-02-24-uplift-update/
-States the 2025 estimate's confidence interval (+2% to +39%). The new data are unreliable: 30–50% of developers withheld tasks they did not want to do without AI, pay fell, and timing was unreliable for developers running several agents. METR believes developers are likely more sped up in early 2026 but cannot say by how much.
-Bertran, Fogliato and Wu, PNAS (July 2026), Many AI analysts
-https://doi.org/10.1073/pnas.2606495123
-Published main text saved here; the published PNAS PDF supplied by the user on October 12, 2026 is resources/bertran-et-al-2026-many-ai-analysts-one-dataset-navigating-the-agentic-data-science-multiverse.pdf (source of the slide figure). 4,946 runs, 3,303 passing the AI auditor's screen; three datasets, four models, five personas. The authors report divergent conclusions across analyses they call defensible; confirmation-seeking prompts raise support rates by 34–66 points (Negative to Strong CS). Screening narrows but does not remove dispersion; disagreement alone is not an error.
-Evidence and service collection: September 10, 2026; sources added or rechecked through October 13, 2026. Foundations and course review: September 20, 2026. Slides, figures, and transcript revised October 13, 2026 for one flow across the four opening questions; appropriate AI use throughout Purdue remains the theme. Numerical citations were checked against the saved primary sources.</a:t>
+METR’s update and figure: the follow-up estimates and why METR considers them unreliable.</a:t>
             </a:r>
             <a:endParaRPr lang="en-US" dirty="0"/>
           </a:p>
@@ -2239,84 +2461,77 @@
           <a:p>
             <a:r>
               <a:rPr lang="en-US" dirty="0"/>
-              <a:t>Measure what students can do after AI help.
-Planned time: 150 seconds. The PowerPoint shows complete diagrams; progressive reveals are in the React deck.
-DELIVERY CUE
-Left: read the scale first (relative to the pre-AI average), then the two time groups, months 6–10 and 2+ years. Homework up, exams down; the homework-time pattern is an association. Right: word versus graph problems; practice time and proctored odds are different measures from separate samples. Strip: Maryland is offered access and course grades; the MBA is a 55-point assessment, mostly written reasoning; neither verified unaided tests. Land the band.
-STRÖMBERG ET AL. (2026): SECONDARY SCHOOL, ONE COUNTY IN CHINA
-• Who: grade 7–12 students at nine schools covering 90% of secondary students in one county in central China. Samples differ by outcome (Table 1): homework 18,345 students over a 20-month window; monthly exams 26,811 over 30 months; entrance exams 8,341 (4,034 Zhongkao, 4,307 Gaokao). Not every student contributed 30 months.
-• AI use: a June 2025 survey asked when each student started using generative AI; about 80% had by then. The start month is self-reported and retrospective.
-• Design: staggered difference-in-differences (Callaway and Sant'Anna) comparing adopters with students who never adopted (not-yet-adopters in robustness checks), not raw before-and-after differences. Not randomized.
-• Scale: each effect is a percentage of the pooled pre-adoption mean (all student-months before adoption, including never-adopters), not each student's own earlier score and not percentage points. For example, −20% of a 70-point baseline would be a 14-point shortfall.
-• Timing: effects grow for about six months and then level off. Homework and monthly-exam figures average months 6–10 after adoption (overall averages are smaller: homework +11%, exams −13%).
-• Months 6–10: homework +18%; homework time 64 → 45 minutes (platform-recorded completion time, a proxy for time spent); closed-book monthly exams −20%.
-• Entrance exams, 24+ months after adoption: −18% on the Gaokao (college entrance exam) and −24% on the Zhongkao (high-school entrance exam). Averaged over all exposure durations, about −7%. Weaker identification: no pre-trend can be shown.
-• Homework time: larger exam declines were associated with unusually short completion times paired with high homework scores (the authors' outsourcing measure: under 50 minutes). That fits AI doing the homework, but motivation, study habits, or the kind of AI use could also differ, and the authors say it should not be read as causal. Longer recorded time is not itself proof of learning.
-• Checks: no differences before adoption on the monthly exams; 2022 entrance exams, taken before AI was available, show no difference.
-• Working paper (CEPR Discussion Paper 21577, June 2026); not peer-reviewed.
-ALEKS: RISMANCHIAN ET AL. (2026)
-• Platform: ALEKS (McGraw Hill) math from grade 5 through College Algebra, 2015–2025, plus the ALEKS PPL college placement assessment.
-• Comparison: post-ChatGPT changes on text word problems versus interactive graph problems, which the authors call less amenable to copy-paste transfer to a chatbot. Graph problems are a comparison group, not a demonstrated counterfactual; AI can still help with them.
-• Practice time (College Algebra): −2.8% per quarter after ChatGPT, cumulating to −26.9% over eleven quarters (bootstrap 95% CI −34.2% to −19.0%), relative to graph problems. The cumulative figure extrapolates a linear trend; a one-time step specification gives −10%.
-• Pre-trend: before ChatGPT, college word problems were already drifting slower relative to graph problems (the opposite sign; joint test p &lt; .001). Every sensitivity check stays negative (trend-adjusted −35.8%, step −10.0%), but the comparison still rests on assumptions.
-• Proctored placement tests, randomly assigned retention items: odds of a correct answer 25% lower (OR 0.75, bootstrap 95% CI 0.56–0.98; p = .037; unstratified permutation p = .056). Odds, not probability: as an illustration only, an OR of 0.75 would move a hypothetical 80% to 75%.
-• Unproctored retention items: odds of a correct answer about 85% higher (OR ≈ 1.85), consistent with AI use during unproctored tests; a validity check, not a learning gain.
-• Separate samples: practice time comes from platform learners and retention from placement test-takers, so the study does not follow the same students from practice to test. Individual AI use was not observed.
-• Limits: AI access was not randomized (only the extra retention items were randomly assigned); under review; four of the five authors work for McGraw Hill.
-MARYLAND TRIAL: LIU, SWEET ET AL. (2026)
-• Where: University of Maryland, fall 2025; 30 instructors and 2,379 students in STEM, social sciences, humanities, and education.
-• Design: instructors randomized within blocks of the same or similar courses (34 clusters). Estimates are intention-to-treat effects of being offered the course tutor. Three treatment instructors who never activated it were dropped after randomization; the analysis plan was registered after data collection, before analysis.
-• Tool: a GPT-4o study assistant on the course website that retrieved instructor-selected course materials.
-• Use: only 14.6% of students offered the tutor ever used it; ChatGPT and Gemini were available to everyone.
-• Same-course comparison (22 instructors, 1,353 students): LMS participation −0.90 SD (one learning-platform measure, not all engagement); final course grades −4.1 points (−0.37 SD). SD means standard deviations, not percentages.
-• Full sample: participation −0.89 SD; final grades −2.9 points (about −0.29 SD), significant only at the 10% level.
-• Assessment conditions: the authors did not know which assessments were proctored or which AI policies applied, so grades measure course performance, not verified unaided performance.
-• First-generation students' estimated grade losses were more than twice those of continuing-generation students.
-TRANSCRIPT
-This is the third question: what must you do yourself? Doing well on work with AI's help and being able to do it on your own are different outcomes, and this year's studies measure both.
-On the left, schools in one county in central China, with up to twenty-six thousand secondary students. Each bar is an estimated change relative to the average before AI, measured against students who never adopted it. Six to ten months after students started, homework scores were about eighteen percent higher and homework took about thirty percent less time, but closed-book monthly exam scores were about twenty percent lower. On the college entrance exam, students two or more years past adoption scored about eighteen percent lower. Larger exam declines went with unusually short homework times, which fits AI doing the homework, though motivation and study habits may also play a part. It was not randomized.
-On the right, college math on the ALEKS platform. After ChatGPT, compared with interactive graph problems that are harder to paste into a chatbot, recorded practice time on text word problems fell about twenty-seven percent, and on proctored tests the odds of a correct answer fell about a quarter. Those are different measures from different samples, and no one recorded which students used AI.
-The bottom row adds two randomized trials. At Maryland, students in classes offered a course AI tutor participated less on the course website, and in same-course comparisons their grades were lower. In an online MBA course, a structured tutor raised scores on a fifty-five-point assessment, mostly in written reasoning. Neither trial verified that its tests were taken without AI.
-So use AI to support your thinking, then check what you can do later without it.
-TRANSITION
-So what does helpful AI use look like when a course allows it?
-CAVEATS
-Three kinds of outcome are kept apart: assisted homework output, course or assessment performance, and performance under verified unaided conditions (closed-book exams in China, proctored ALEKS tests). Strömberg, Lei and Wu (CEPR DP 21577, June 2026; working paper): staggered difference-in-differences (Callaway and Sant'Anna) with never-adopters as the comparison, not raw before-and-after differences; not randomized; one county in central China; adoption month self-reported in a June 2025 survey. Samples differ by outcome (Table 1, p. 52): homework 18,345 students over a 20-month window, regular exams 26,811 over 30 months, entrance exams 8,341 (4,034 Zhongkao and 4,307 Gaokao); not every student contributed 30 months. Scale: percent of the pooled pre-adoption student-month mean, including never-adopters, not each student's earlier score and not percentage points (−20% of a 70-point baseline would be 14 points). Timing: effects grow for about six months and level off; homework and monthly-exam figures average months 6–10 (overall averages: homework +11%, exams −13%). The −18% Gaokao figure is for students 24+ months past adoption and has weaker identification (no pre-trend can be shown); averaged over all exposure durations the entrance-exam effect is about −7%. Homework time is platform-recorded completion time, a proxy for time spent. Larger exam declines were associated with unusually short completion times paired with high homework scores (the authors' outsourcing measure: under 50 minutes). That fits AI doing the homework, but motivation, study habits, or the kind of AI use could also differ; the authors say it should not be read as causal, and longer recorded time is not proof of learning. Rismanchian et al. (arXiv v3, July 2026; under review; four of five authors at McGraw Hill): post-ChatGPT change on text word problems relative to interactive graph problems, which the authors call less amenable to copy-paste transfer; graph problems are a comparison group that relies on assumptions, not a demonstrated counterfactual. College practice time −26.9% over eleven quarters (bootstrap 95% CI −34.2% to −19.0%); this extrapolates a linear trend (a one-time step specification gives −10%). A detectable pre-ChatGPT trend runs in the opposite direction; sensitivity checks stay negative (trend-adjusted −35.8%), and the slide keeps the primary −26.9%. Proctored placement retention items: OR 0.75 (bootstrap 95% CI 0.56–0.98; p = .037; unstratified permutation p = .056), i.e., 25% lower odds: not 25 percentage points, not a 25% lower probability, and not 25% less knowledge. As an illustration of the scale only, an OR of 0.75 would move a hypothetical 80% to 75%. The two bars measure different quantities, so similar lengths do not mean equal declines. Practice and assessment data come from separate samples, so the study does not follow students from AI-assisted practice to later tests; individual AI use was not observed; AI access was not randomized (only the extra retention items were randomly assigned). Unproctored retention items rose (OR about 1.85), consistent with AI use during unproctored tests. Maryland (Liu, Sweet et al., EdWorkingPaper 26-1598): instructors randomized within course blocks; intention-to-treat effects of being offered a GPT-4o course tutor; 2,379 students overall. The displayed participation (−0.90 SD) and grade (−4.1 points, −0.37 SD) effects are from the same-course comparison of 1,353 students; the full-sample grade estimate (−2.9 points) did not meet the 5% threshold. SD means standard deviations, not percentages; LMS participation is one platform measure, not all engagement; only 14.6% of students offered the tutor used it; three treatment instructors who never activated the tutor were dropped after randomization; the authors did not know proctoring arrangements or assignment-specific AI policies, so grades are course performance, not verified unaided performance. Online MBA (Yang, Van Alstyne and Dellarocas, arXiv 2609.23958v1): 86 randomized, 51 completed both study assessments, and 46 are in the main analysis after prespecified quality screens. +6.63 of 55 points (95% CI 1.95–11.31) is the adjusted, complete-case estimate from the model with randomization-stratum effects, not an all-86 intention-to-treat estimate; adjusting for baseline without strata gives +3.56 (p = .079), and restoring one participant excluded for essentially unanswered post-test short answers gives +5.52 (p = .052). Gains were concentrated in written reasoning (+2.86 of 25). Written responses were scored by a panel of LLM graders blind to arm; human adjudication of flagged responses was still pending in this version. The comparison group studied as usual with consumer AI available (21–42% used it in a given week), so it was not AI-free. The paper does not document proctoring or AI-free conditions for the pre- and post-assessments; the instructor's final was take-home and the weekly checks open-book; the tutor was barred from graded-assessment content, which does not mean students lacked other AI during assessments. Liu (GPT-5, arithmetic and reading), Maier (metacognitive feedback, fraction arithmetic), the teacher-led Gemini package, NUMI, and Khanmigo are in the linked comparison; Shen and Tamkin's coding study is on the coding-agents slide.
+              <a:t>SLIDE GUIDE · 06 / 17: Measure what students can do after AI help.
+EXPLANATION
+Doing well on work with AI’s help and being able to do the work on your own are different outcomes. This slide brings together four recent studies, which measured three different kinds of outcome:
+• Assisted work: homework or practice done while AI help was available.
+• Course outcomes: grades or course assessments taken under conditions the researchers did not document.
+• Independent performance: tests taken under documented conditions that limit AI use, such as closed-book exams or proctored tests.
+Panel 1: secondary schools in one county in China. Strömberg and colleagues compared students who started using AI with students who never did, over time. Each bar is an estimated change as a percentage of the average before AI, not a change in percentage points (20% below a 70-point average would be 14 points); the bars are point estimates, and their uncertainty intervals are in the paper. Six to ten months after starting, homework scores were about 18% higher and recorded homework time about 30% lower (64 to 45 minutes), but closed-book monthly exam scores were about 20% lower. Two or more years after starting, college entrance exam scores were about 18% lower. Larger exam declines went with unusually short homework times. That fits AI doing the homework, but motivation or study habits could also differ, and the study was not randomized.
+Panel 2: college math on ALEKS. After ChatGPT arrived, the researchers compared text word problems, which are easy to paste into a chatbot, with interactive graph problems, which are harder to paste. Relative to graph problems, recorded practice time on word problems fell about 27%, and on proctored tests the odds of a correct answer fell about 25% (an odds ratio of 0.75). Odds are not probability: they compare the chance of a correct answer with the chance of an incorrect one. As an illustration only, 25% lower odds would move an 80% success rate to 75%. The whiskers are 95% confidence intervals. The two bars measure different things in different samples, and no one recorded which students used AI.
+Panel 3: two randomized course trials. At the University of Maryland, instructors were randomly chosen to offer a course AI tutor or not. Within the same courses, being offered the tutor lowered participation on the course website by 0.90 standard deviations (SD) and final grades by 0.37 SD, about 4 points; an SD measures the typical spread of scores, so these are not percentages. In an online MBA course, a structured tutor raised scores by 6.6 points on a 55-point assessment, mostly in written reasoning. Neither trial verified that its tests were taken without AI, so both measure course outcomes, not independent performance.
+The takeaway. Better assisted work does not necessarily mean better independent performance. Use AI to support your thinking, then check what you can do later without it.
+NEXT: Use AI for guided practice, then test yourself. If assisted work can hide what you have not learned, what does helpful AI use look like? The next slide examines two trials of structured study with AI.
+SOURCES &amp; CAVEATS
+Sources checked through October 21, 2026. Source numbers match the slide’s citations.
+RESEARCH FINDING: China: homework up, closed-book exams down
+What was studied: Strömberg, Lei and Wu (June 2026): school records for grades 7–12 in one county in central China. Students who started using AI (start month self-reported in a June 2025 survey) were compared with students who never did, using a staggered difference-in-differences design. Samples differ by outcome: homework 18,345 students; monthly exams 26,811; entrance exams 8,341.
+What the source supports: Months 6–10 after adoption: homework +18%, homework time 64 → 45 minutes, closed-book monthly exams −20%. Entrance exams 24 or more months after adoption: −18% on the college entrance exam (Gaokao). All figures are percentages of the average before adoption, not percentage points.
+What limits the conclusion: Not randomized; the adoption month is self-reported; one county. The entrance-exam estimate rests on a weaker design (no pre-adoption trend can be checked, so other explanations are harder to rule out), and averaged over all exposure times it is about −7%. The link between short homework times and exam declines is an association, and the authors say it should not be read as causal. Longer recorded time is not itself proof of learning. Working paper, not peer reviewed.
+Sources: [1]
+RESEARCH FINDING: ALEKS: less practice time, lower proctored odds
+What was studied: Rismanchian et al. (2026): the ALEKS math platform, 2015–2025. Changes after ChatGPT on text word problems were compared with changes on interactive graph problems. Practice data come from platform learners; test data from the ALEKS placement assessment.
+What the source supports: College practice time −26.9% over 11 quarters (95% CI −34.2% to −19.0%). On proctored retention items, odds of a correct answer 25% lower (odds ratio 0.75, 95% CI 0.56–0.98; p = .037).
+What limits the conclusion: Not randomized. Graph problems are a comparison group, not a perfect stand-in for “no AI”, and AI can still help with them. Practice and test data come from different samples, and individual AI use was not observed. The practice figure extends a linear trend (a one-time-drop model gives −10%), and before ChatGPT the trend ran in the opposite direction. On unproctored items the odds rose (odds ratio about 1.85), consistent with AI use during unproctored tests. An unstratified permutation test gives p = .056. Under review; four of the five authors work for McGraw Hill, which owns ALEKS.
+Sources: [2]
+RESEARCH FINDING: Maryland: offering a course tutor lowered participation and grades
+What was studied: Liu, Sweet et al. (September 2026): a randomized trial in fall 2025. 30 instructors (2,379 students) were randomized within blocks of similar courses to offer a GPT-4o course tutor or not.
+What the source supports: In same-course comparisons (1,353 students), being offered the tutor lowered participation on the learning-management system by 0.90 SD and final grades by 4.1 points (0.37 SD).
+What limits the conclusion: Only 14.6% of the students offered the tutor used it, and ChatGPT and Gemini were available to everyone. In the full sample, the grade effect (−2.9 points) was significant only at the 10% level. The authors did not know which assessments were proctored or what AI policies applied, so grades are course outcomes, not verified independent performance.
+Sources: [3]
+RESEARCH FINDING: Online MBA: a structured tutor raised assessment scores
+What was studied: Yang, Van Alstyne and Dellarocas (September 2026): a preregistered randomized trial in July–August 2026 with 86 online MBA students. A GPT-5.4 tutor grounded in the course materials was compared with usual study, during which consumer AI was available.
+What the source supports: +6.63 of 55 points (95% CI 1.95 to 11.31) on the study’s assessment, mostly in written reasoning (+2.86 of 25).
+What limits the conclusion: 51 students completed both assessments and 46 were analyzed. The estimate depends on the model: without randomization strata it is +3.56 (p = .079). Written answers were scored by AI graders, and proctoring and AI use during the assessments were not documented. One course; working draft.
+Sources: [4]
+OTHER STUDIES ON AI AND LEARNING
+• Liu et al. (2026): 585 adults in the largest experiment practiced with GPT-5 supplying correct solutions; after AI was removed, they solved fewer problems (.71 vs. .77). Arithmetic and reading tasks; immediate test only.
+• Maier et al. (2026): in an online experiment with 704 participants (fraction arithmetic), feedback that prompted reflection reduced answer-offloading and improved an unaided test (odds ratio 1.51).
+• LearnLM and Fab AI (2026): a teacher-led Gemini mathematics package in Sierra Leone (1,423 students) raised adjusted scores (+0.26 SD). It was a package, not AI alone; the unadjusted estimate was not significant; the report is provider-associated; there was no delayed test.
+• Oreopoulos et al. (2026): over 6,000 middle-school students compared AI practice with the same platform without AI; delayed evidence was limited.
+• Oreopoulos and Low (2026): a two-year Khan Academy and Khanmigo program produced small gains, but it does not isolate the AI component.
+• Shen and Tamkin (2026): 52 people with Python experience learned a new library with or without a GPT-4o assistant; the AI group scored lower on an immediate quiz without AI.
 SOURCES
-Strömberg, Lei and Wu (June 2026), The generative AI learning penalty (CEPR DP 21577)
+[1] Strömberg, Lei and Wu (June 2026), The generative AI learning penalty (CEPR DP 21577)
 https://cepr.org/publications/dp21577
-Working paper. Staggered difference-in-differences with never-adopters as the comparison; one county in central China; samples differ by outcome (homework 18,345 students over 20 months; regular exams 26,811 over 30 months; entrance exams 8,341). Effects are percentages of the pooled pre-adoption mean. Months 6–10: homework +18%, homework time 64 to 45 minutes, closed-book monthly exams −20%. Entrance exams 24+ months after adoption: Gaokao −18%, Zhongkao −24% (about −7% averaged over all durations; weaker identification). Larger declines associated with very short homework times (descriptive). Self-reported adoption month. Saved copy supplied by the user (identical to the SSRN 6868618 file); an open copy of the same text is at conference.nber.org/conf_papers/f240545.pdf.
-Rismanchian et al. (2026), Faster completion, less learning (ALEKS; arXiv v3)
+Working paper (CEPR, June 2026): homework, homework time, and exams in school records from one county in China.
+[2] Rismanchian et al. (2026), Faster completion, less learning (ALEKS; arXiv v3)
 https://arxiv.org/abs/2605.21629
-Text word problems vs. interactive graph problems (less amenable to copy-paste) on ALEKS, 2015–2025. College practice time −26.9% over eleven post-ChatGPT quarters (bootstrap 95% CI −34.2% to −19.0%; opposite-signed pre-trend; step specification −10%); proctored retention odds OR 0.75 (bootstrap 95% CI 0.56–0.98; permutation p = .056), unproctored OR ≈ 1.85. Separate practice and assessment samples; individual AI use not observed; AI access not randomized. Under review; four of five authors at McGraw Hill.
-Liu, Sweet et al. (September 2026), Course-integrated AI tutoring RCT (Maryland; EdWorkingPaper 26-1598)
+Preprint under review: ALEKS practice time and proctored test results after ChatGPT.
+[3] Liu, Sweet et al. (September 2026), Course-integrated AI tutoring RCT (Maryland; EdWorkingPaper 26-1598)
 https://doi.org/10.26300/y3f8-vh05
-30 instructors (2,379 students) randomized within course blocks in fall 2025; intention-to-treat effects of being offered a GPT-4o course tutor. Same-course comparison (1,353 students): LMS participation −0.90 SD, final course grades −4.1 points (−0.37 SD); full-sample grade effect −2.9 points, significant only at 10%. Only 14.6% of offered students used the tutor; proctoring and AI policies unknown to the authors, so grades are course performance.
-Yang, Van Alstyne and Dellarocas (September 2026), When AI tutors speak (arXiv 2609.23958v1)
+Working paper: the Maryland trial that randomly offered a course AI tutor.
+[4] Yang, Van Alstyne and Dellarocas (September 2026), When AI tutors speak (arXiv 2609.23958v1)
 https://arxiv.org/abs/2609.23958
-Preregistered RCT, July–August 2026: 86 online MBA students randomized to a GPT-5.4 tutor grounded in course materials (designed to require an attempt, give graduated support, and check transfer) or to usual study with consumer AI available; 51 completed both assessments; 46 in the main analysis. Total score +6.63 of 55 (95% CI 1.95–11.31) in the adjusted complete-case model with randomization strata; +3.56 (p = .079) without strata; +5.52 (p = .052) restoring one screened-out participant; gains mostly in written reasoning. Post-test taken without the study tutor; proctoring not documented; written answers scored by LLM graders blind to arm, human adjudication pending.
-Liu et al. (2026), v4; PDF marked COLM 2026
+Preprint: the randomized trial of a structured GPT-5.4 tutor in an online MBA course.
+[5] Liu et al. (2026), v4; PDF marked COLM 2026
 https://arxiv.org/html/2604.04721v4
-GPT-5 supplied with correct solutions. Largest experiment: 585 analyzed; subsequent solve rate .71 vs .77 (p=.020); skipping difference not significant (p=.239). Immediate withdrawal, not long-term skill loss.
-Maier et al. (September 2026), Metacognitive feedback reduces cognitive offloading
+Experiments in which people solved fewer problems after AI help was removed.
+[6] Maier et al. (September 2026), Metacognitive feedback reduces cognitive offloading
 https://arxiv.org/abs/2609.20143
-Preregistered online experiment (N = 704), fraction arithmetic: metacognitive feedback reduced answer offloading (OR 0.47) and improved the unaided test (OR 1.51); an effort reward did not.
-LearnLM Team and Fab AI (May 2026), Teaching with Gemini
+Online experiment in which reflective feedback reduced offloading answers to AI.
+[7] LearnLM Team and Fab AI (May 2026), Teaching with Gemini
 https://storage.googleapis.com/deepmind-media/LearnLM/learnLM_sierraleone_may26.pdf
-Provider-associated technical report. 1,763 assessed at least once; 48 classrooms, 12 Sierra Leone schools; 1,423 in primary adjusted analysis. Teacher-led eight-week package using Gemini 2.5 Pro then 3.0 Pro: +.258 SD, 95% CI [.027,.488], p=.029. No delayed retention test.
-Oreopoulos et al. (August 2026), Mastery-based AI math practice
+Provider-associated report on a teacher-led Gemini package in Sierra Leone classrooms.
+[8] Oreopoulos et al. (August 2026), Mastery-based AI math practice
 https://www.nber.org/papers/w35621
-NBER working paper; over 6,000 middle-school students, factorial randomization and one-week assessment. AI vs the same practice platform without AI. Limited, marginal delayed evidence concentrated on practiced first-exercise material. Exact deployed model not identified in reviewed text.
-Oreopoulos and Low (August 2026), Two-year Khanmigo experiment
+Working paper: AI-supported vs. standard practice for over 6,000 middle-school students.
+[9] Oreopoulos and Low (August 2026), Two-year Khanmigo experiment
 https://www.nber.org/papers/w35620
-NBER working paper; 53 grade-within-school clusters, 18 middle schools, 2024–26 deployment. Combined Khan Academy/Khanmigo program vs existing remedial practice; gains do not isolate the AI component. Tutor engagement limited; non-AI platform comparisons indirect.
-Shen and Tamkin (2026), How AI Impacts Skill Formation
+Working paper: a two-year Khan Academy and Khanmigo program in 18 middle schools.
+[10] Shen and Tamkin (2026), How AI Impacts Skill Formation
 https://arxiv.org/abs/2601.20245
-Randomized experiments; 52 analyzed participants with Python experience learning the Trio library with or without a GPT-4o assistant that could supply correct code. The AI group scored lower on the immediate quiz (d = 0.74, p = .010) without a significant speedup. Interaction-pattern clusters (n = 2–7) were observed, not randomized: heavy reliance on AI to write or debug code averaged below 40%; conceptual questions or requests for explanations averaged 65% or higher.
-Additional research: six questions and talk refinements
-12_further_research_and_talk_updates.html
-Claim-focused review of 13 supplemental sources. No direct validation found for new post-AI junior-DS screens against later job performance; search is not exhaustive.
-Evidence and service collection: September 10, 2026; sources added or rechecked through October 13, 2026. Foundations and course review: September 20, 2026. Slides, figures, and transcript revised October 13, 2026 for one flow across the four opening questions; appropriate AI use throughout Purdue remains the theme. Numerical citations were checked against the saved primary sources.</a:t>
+Experiments on learning a new Python library with or without an AI assistant.</a:t>
             </a:r>
             <a:endParaRPr lang="en-US" dirty="0"/>
           </a:p>
@@ -2404,81 +2619,75 @@
           <a:p>
             <a:r>
               <a:rPr lang="en-US" dirty="0"/>
-              <a:t>Use AI for guided practice, then test yourself.
-Planned time: 140 seconds. The PowerPoint shows complete diagrams; progressive reveals are in the React deck.
-DELIVERY CUE
-Tag first: each trial tested a package, not one feature. Panel 1: everyone had the assistant; the emails were the assignment; the dashed bar is constructed; the interval belongs to the effect, on its own axis. Panel 2: the slide-6 trial; shares are descriptive and the +22 is baseline-adjusted; usual study had consumer AI; the post-test was taken without the study tutor. Panel 3: a routine to adapt, course rules first. Land the band: close the AI and solve a changed problem.
-GALLEGOS (2026): STUDY-PROMPT EMAILS IN AN ECONOMETRICS COURSE
-• Where: required third-year econometrics, Universidad Adolfo Ibáñez (Chile), seven sections, August–December 2025; preregistered (AEA RCT Registry). Working paper: IZA DP 18513, March 2026.
-• Tool: a ChatGPT assistant built from ten semesters of the course's materials, available to both groups through free ChatGPT; the underlying model is not reported, and individual use was not tracked.
-• Assigned: all 384 students enrolled at the start of the semester were randomized. One to two days before the final, the guidance group was emailed three prompts: a tutor prompt (no final answer; three diagnostic questions; complete the next step yourself; then a similar exercise to solve and have corrected), five exam-style practice questions without solutions for the AI to correct, and an exercise the AI solves and then verifies. These were suggestions; nothing enforced hint-only use.
-• Analyzed: 289 students (149 control, 140 guidance; about 75% of enrollment). The paper does not say why the others are excluded, but reports that inclusion was balanced by treatment status.
-• Pass rate (Table 3, Panel B, column 4): passing the final exam (above 4 on the raw scale), intention-to-treat effect of being offered the emails +12.8 percentage points (SE 4.9; p = .009), control rate 64.6%, with strata fixed effects and covariates. The paper prints no interval; estimate ± 1.96 × the reported SE gives +3.2 to +22.4 points for the effect (a normal approximation; robust Huber-White standard errors, not clustered, because students were randomized individually; strata fixed effects and baseline covariates). The 77.4% bar is constructed (64.6 + 12.8), not an observed group mean, and has no interval of its own.
-• Other results: final exam +0.22 SD (SE 0.10), about +3.5 of 100 points. Gains concentrated on open-response questions are reported for the Business Administration subsample (N = 194; +5.0 points, SE 1.6), not for the whole sample.
-• Spillover: 35% of control students reported exposure to the guidance (17% from peers, 18% received the emails directly); the design allows and measures this. Exposure can blur the contrast between groups, but it does not by itself make the estimate a lower bound.
-• Exam conditions: the paper does not say whether the final was proctored, closed-book, or AI-free.
-• Limits: one course; the three prompts were sent together, so the trial cannot say which mattered; working paper.
-YANG ET AL. (2026): GPT-5.4 TUTOR IN AN ONLINE MBA
-• Where: a graduate corporate-finance module in Boston University's online MBA, July–August 2026; preregistered on OSF; working draft of September 20, 2026 (arXiv v1). The same trial as on slide 6.
-• Assigned: 86 consented participants randomized, 52 to a GPT-5.4 tutor grounded in the course materials and 34 to a holdout with standard course resources (usual study; consumer AI available, used by 21–42% in a given week).
-• Tutor, as designed: require an attempt before explaining; when a student is stuck, give a smaller step, a graduated hint, or one worked example followed by a similar problem; end each topic with a transfer question; no full solutions to graded homework or exams. The paper reports no audit of how often the tutor behaved this way, and its appendix describes the transfer question as scaffolded, unlike the main text.
-• Sample flow: 86 randomized; 51 completed both tests (32 tutor, 19 holdout); 46 in the reported analysis (29 and 17) after prespecified screens.
-• Depth outcome: the share of short-answer responses rated SOLO 3 or 4, out of five short answers per test. SOLO levels: 0, no valid engagement; 1, one relevant point; 2, several points, not integrated; 3, relational: points integrated into a coherent, justified argument; 4, extended abstract: integrates and generalizes. These are shares of responses, not of students who mastered the course; the figure's denominators are not printed.
-• Descriptive shares (Figure 9): 8% → 49% with the tutor and 8% → 27% in the holdout. Inferential estimate (Table 4): +0.221 (95% CI 0.02 to 0.42; p = .029) from a baseline-adjusted ANCOVA without randomization strata. With strata, the model behind slide 6's +6.63 of 55 total points, the depth estimate is +0.37 (Figure 8). The p-values are raw and uncorrected for multiple comparisons, as the preregistered plan specified.
-• Assessments: every learning outcome was measured with the study tutor absent; proctoring and other AI use during the online post-test are not documented. The instructor's final (+2.6 of 100) was take-home.
-• Scoring: a panel of LLM graders blind to arm, wave, and identity; 16% of scored responses carry disagreement flags that await the preregistered human-expert pass.
-OTHER EVIDENCE AND HOW TO READ IT
-• Forced waiting: in a Berlin lab (February 2025, GPT-4-based tutor), ten minutes of reading before AI unlocked did not beat AI from the start (+0.13 vs. +0.34 SD over textbook only; difference p = .066). A timer is not the point.
-• Hint-only tutors in single sessions: in a TUM programming lab (January 2025, GPT-4), knowledge gains showed no detectable difference among a hint tutor, ChatGPT, and no AI. A small GPT-5.2 lab study (17 per group) found larger immediate gains with unrestricted help than with a Socratic tutor.
-• Written guidance in a lab: Franco, Irmert and Isaksson (Lund University Working Paper 2026:2) ran a preregistered experiment in Nottingham's CeDEx lab in which 572 participants studied Esperanto. On an immediate test without notes (0–15 points), AI access with on-screen guidance written by the researchers scored −0.23 points (SE 0.19) and unguided AI +0.08 (SE 0.19), both relative to browsing with AI sites blocked; the authors find no overall effect of AI access. There was no delayed test.
-• Worked examples can help: in a first-year statistics course (Leppink et al., 2012; 105 students), students with less prior knowledge did best with worked examples and those with more did best with questions and arguments, an expertise reversal (small groups).
-• Earlier evidence: in a 2023 GPT-4 trial in Turkish high schools, answer-giving AI raised practice scores 48% but lowered the unaided exam 17%; a hint-giving tutor avoided the loss (Bastani et al., PNAS 2025).
-• Reading the evidence: results vary across tasks, learners, systems, and assessments, and these studies differ in many ways at once. They support trying structured assistance, while checking whether it improves what students can subsequently do. No detectable benefit is not evidence of equivalence, and neither is evidence of harm; a result on an immediate test need not reverse on a delayed one.
-TRANSCRIPT
-Two course trials reported benefits from structured ways of studying with AI. Each tested a package of support, so neither shows which single feature made the difference.
-First, a required econometrics course in Chile last fall. Every student had a course ChatGPT assistant. Before the final, a random half were also emailed three sets of study prompts: use it as a tutor, generate practice questions, and check answers. About sixty-five percent of the other students passed the final exam. Being offered the emails raised the pass rate by an estimated thirteen percentage points; on the right, the interval for that effect runs from about three to twenty-two points. The dashed bar adds the estimate to the control rate; it is not a measured group.
-Second, more detail on the online MBA trial from the last slide. Its GPT-5.4 tutor was designed to require an attempt, give graduated support, and check transfer. The comparison group studied as usual, with consumer AI available. Before the module, eight percent of written responses in each group built a connected argument. On the post-test, taken without the study tutor, forty-nine percent did with the tutor and twenty-seven percent without; adjusted for baseline, a gap of about twenty-two points, again with a wide interval.
-Results vary across tasks, learners, systems, and assessments. These studies support trying structured help, while checking whether it improves what you can do afterward.
-So here is a study prompt to adapt; it is not the trials' exact wording, and your course's rules come first. Try the problem, then ask for help with the specific gap: a question, a hint, or a worked example if you are missing a prerequisite. Asking for help is part of learning. Then close the AI and solve a changed problem on your own.
-TRANSITION
-All of this happens within what your course allows, which is the second question: what is allowed?
-CAVEATS
-Both trials tested packages of support, so neither isolates attempt-first behavior, answer withholding, hints, or worked examples. Keep three things apart. What students were assigned: in Gallegos, being offered three prompt emails while everyone kept the course assistant; in Yang et al., access to a structured tutor vs. usual study with consumer AI available. What was measured: in Gallegos, passing the final exam, under exam conditions the paper does not document; in Yang et al., written post-test responses, taken without the study tutor, with proctoring not documented. And what is recommended here: the routine is the speaker's, informed by both trials but not their wording. Panel 1: IZA DP 18513 (March 2026), Table 3, Panel B, column 4: intention-to-treat effect +0.128 (SE 0.049), control mean 0.646, N = 289 of 384 randomized. The 95% interval belongs to the effect: estimate ± 1.96 × the reported heteroskedasticity-robust SE (0.049) gives +3.2 to +22.4 points, a normal approximation consistent with the paper's Wald tests (0.128 / 0.049 = 2.61, two-sided p = .009 as reported; Romano–Wolf adjusted p = .017); the paper prints no interval. The 77.4% bar is constructed (control mean + estimated effect), not observed, and carries no interval: one would need the control mean's sampling error and its covariance with the estimate, which were not calculated. Panel 2: Figure 9 shares are descriptive; Table 4's +0.221 (95% CI 0.02 to 0.42; raw, uncorrected p = .029, as planned) is a baseline-adjusted ANCOVA without strata; the model with randomization strata gives +0.37 for depth and the +6.63 of 55 total score on slide 6. The MBA trial appears on both slides; this is more detail, not a replication. Details, sample accounting, and other studies are in the briefs below.
+              <a:t>SLIDE GUIDE · 07 / 17: Use AI for guided practice, then test yourself.
+EXPLANATION
+On the previous slide, better assisted work did not necessarily mean better independent performance. This slide shows two randomized course trials in which structured study with AI improved outcomes. Each trial tested a package of support, so neither shows which single feature made the difference.
+Panel 1: an econometrics course in Chile (fall 2025). Every student had the course’s ChatGPT assistant. One to two days before the final exam, a random half were also emailed three study prompts: one for tutoring, one with exam-style practice questions for the assistant to correct, and one for checking answers.
+The bars show the share of students who passed the final. The solid bar, 64.6%, is the observed pass rate of the control group, the students not assigned the emails (some received them anyway). The dashed bar, 77.4%, is not a measured group: it adds the estimated effect of being offered the emails to that rate. The axis on the right shows the effect itself, +12.8 percentage points, with a 95% confidence interval of +3.2 to +22.4 points. The interval belongs to the effect, not to the dashed bar. A percentage point is the unit for a difference between two percentages: a change from 64.6% to 77.4% would be 12.8 percentage points, or about 20% in relative terms.
+Panel 2: the online MBA trial from the previous slide, in more detail. Its GPT-5.4 tutor was designed to require an attempt before explaining, give graduated support, and check whether students could apply the idea to a new question; the comparison group studied as usual, with consumer AI available. Before the module, 8% of written answers in both groups built a connected argument; on the post-test, 49% did with the tutor and 27% without. Adjusted for the starting level, the difference is about 22 percentage points, with a wide 95% interval (+2 to +42). The post-test was taken without the study tutor, but other AI use was not documented, and AI graders did the scoring.
+Panel 3: a study prompt to adapt. It turns the trials’ common elements into a suggested routine, informed by both trials but not their exact wording: show your attempt and where you are stuck, ask for a question or a hint (or an explanation or a similar worked example if a prerequisite is missing), and finish with a new problem. Your course’s rules come first.
+The last step is the check: close the AI and solve a changed problem on your own. Asking for help is part of learning; the changed problem, solved without AI, shows what you can now do.
+NEXT: Check the rules before using AI or sharing data. All of this depends on what your course allows. The next slide covers checking the rules, in courses now and at work later.
+SOURCES &amp; CAVEATS
+Sources checked through October 21, 2026. Source numbers match the slide’s citations.
+RESEARCH FINDING: Study-prompt emails raised the pass rate
+What was studied: Gallegos (March 2026): a preregistered randomized trial in a required third-year econometrics course at Universidad Adolfo Ibáñez (Chile), August–December 2025. All 384 enrolled students were randomized; 289 were analyzed. Everyone had a course ChatGPT assistant; the treatment group was also emailed three study prompts before the final.
+What the source supports: Being offered the emails raised the final-exam pass rate by an estimated 12.8 percentage points (control rate 64.6%) and the exam score by 0.22 SD. The 95% interval for the effect, +3.2 to +22.4 points, was calculated for this slide from the paper’s reported standard error (4.9 points); the paper prints no interval.
+What limits the conclusion: The 77.4% bar is constructed (control rate + estimated effect), not an observed group, and has no interval of its own. The three prompts were sent together, so the trial cannot say which mattered; use of the prompts was not tracked, and 35% of control students reported some exposure to the guidance. The paper does not say whether the final was proctored, closed-book, or AI-free. One course; working paper.
+Sources: [1]
+RESEARCH FINDING: A structured tutor deepened written reasoning
+What was studied: Yang, Van Alstyne and Dellarocas (September 2026): the online MBA trial from slide 6. 86 students were randomized to a GPT-5.4 tutor or to usual study with consumer AI available; 51 completed both tests and 46 are in the reported analysis.
+What the source supports: The share of short-answer responses rated as a connected argument rose from 8% to 49% with the tutor and from 8% to 27% without (descriptive shares). The baseline-adjusted difference is +22 percentage points (95% CI +2 to +42).
+What limits the conclusion: Shares are of responses, not of students. AI graders blind to group did the scoring, and a planned human review was still pending. Proctoring and other AI use during the post-test are not documented, and the paper does not report how often the tutor actually behaved as designed. Small sample; working draft.
+Sources: [2]
+SUGGESTED STRATEGY: Try, get help with the gap, then solve a changed problem
+What it suggests: A suggested study routine: attempt the problem, ask for help with the specific gap (a question, a hint, or a worked example if a prerequisite is missing), then solve a changed problem without AI.
+What informs it: Both trials used structured support built around students’ own work. Research on worked examples suggests they help when prior knowledge is limited (slide 9).
+What has not been tested: Neither trial tested this exact routine, and neither isolates the effect of attempting first, hints, or worked examples. Course rules come first.
+Sources: [1] [2]
+OTHER EVIDENCE, AND HOW TO READ MIXED RESULTS
+• Waiting before AI: in a Berlin lab study (GPT-4-based tutor), ten minutes of reading before AI unlocked did not beat AI from the start (+0.13 vs. +0.34 SD over a textbook alone; the difference had p = .066). A timer is not the point.
+• Hint-only tutors: in a programming lab at TUM (GPT-4), AI support improved exercise scores, but brief knowledge tests detected no advantage for a hint tutor or ChatGPT over no AI.
+• Written guidance in a lab: in a preregistered experiment with 572 participants learning Esperanto, AI with written guidance scored −0.23 points (SE 0.19) and unguided AI +0.08 (SE 0.19) on a 15-point immediate test, both relative to browsing with AI sites blocked; there was no overall effect of AI access.
+• Worked examples: in a first-year statistics course (105 students), students with less prior knowledge did best with worked examples, and those with more did best with questions and arguments.
+• Answers vs. hints: in a 2023 GPT-4 trial in Turkish high schools, answer-giving AI raised practice scores by 48% but lowered the later unaided exam by 17%; a hint-giving tutor avoided the loss.
+• AI as a tutor vs. a writer: at Middlebury, students given GPT-4o scored higher on proctored tests without AI (+0.29 SD immediately; +0.21 SD a week later, significant only at the 10% level); the gains remained for students who used AI as a tutor and faded for those who had it write (an observational comparison). More test-rule violations in the AI group complicate the comparison.
+• Practice testing: a major review rates practice testing with feedback, and spacing practice over time, among the most useful study techniques.
+Results vary across tasks, learners, systems, and assessments, and these studies differ in many ways at once. They support trying structured help while checking whether it improves what you can do afterward. A result with no detectable benefit is not evidence that two approaches are equivalent, and a result on an immediate test may not hold on a delayed one.
 SOURCES
-Gallegos (March 2026), Guidance over adoption: experimental evidence on AI-assisted learning
+[1] Gallegos (March 2026), Guidance over adoption: experimental evidence on AI-assisted learning
 https://docs.iza.org/dp18513.pdf
-IZA DP 18513; preregistered. Required third-year econometrics, Universidad Adolfo Ibáñez (Chile), August–December 2025; a course-specific ChatGPT assistant (model not reported) available to all; 384 randomized, 289 analyzed. Three emails with study prompts (a tutor prompt, practice questions without solutions, answer checking) before the final; intention-to-treat effects of the offer: +0.22 SD (SE 0.10); pass rate +12.8 points (SE 4.9) from 64.6% (Table 3, Panel B). Open-response gains (+5.0 points) are reported for the Business Administration subsample. Exam conditions not documented. 35% of the control group reported exposure to the guidance.
-Yang, Van Alstyne and Dellarocas (September 2026), When AI tutors speak (arXiv 2609.23958v1)
+Discussion paper (IZA): the econometrics trial; the pass-rate estimate is in Table 3.
+[2] Yang, Van Alstyne and Dellarocas (September 2026), When AI tutors speak (arXiv 2609.23958v1)
 https://arxiv.org/abs/2609.23958
-Preregistered RCT, July–August 2026: 86 online MBA students randomized to a GPT-5.4 tutor grounded in course materials (designed to require an attempt, give graduated support, and check transfer) or to usual study with consumer AI available; 51 completed both assessments; 46 in the main analysis. Total score +6.63 of 55 (95% CI 1.95–11.31) in the adjusted complete-case model with randomization strata; +3.56 (p = .079) without strata; +5.52 (p = .052) restoring one screened-out participant; gains mostly in written reasoning. Post-test taken without the study tutor; proctoring not documented; written answers scored by LLM graders blind to arm, human adjudication pending.
-Fischer, Rau and Rilke (2025), AI tutoring enhances student learning without crowding out reading effort
+Preprint: the online MBA tutor trial; the written-reasoning results are in Figure 9 and Table 4.
+[3] Fischer, Rau and Rilke (2025), AI tutoring enhances student learning without crowding out reading effort
 https://docs.iza.org/dp18338.pdf
-IZA DP 18338; TU Berlin lab, February 2025; GPT-4-based tutor grounded in the text; 334 analyzed. Immediate unaided 25-item test vs. textbook only: AI throughout +0.34 SD (SE 0.12); ten minutes of reading first, then AI +0.13 SD (SE 0.12); difference p = .066. A reading task; the read-first arm also had less time with AI.
-Bassner et al. (2026), Less stress, better scores, same learning
+Lab experiment: reading first vs. AI tutoring from the start.
+[4] Bassner et al. (2026), Less stress, better scores, same learning
 https://portal.fis.tum.de/de/publications/less-stress-better-scores-same-learning-the-dissociation-of-perfo/
-Both interfaces used GPT-4. Management bachelor/master CS1 students; 452 started, 275 analyzed. Exercise scores improved; brief immediate knowledge/comprehension tests detected no group advantage. Null findings do not establish equivalence.
-Contractor and Reyes (2026), learning working paper
+Programming lab study: a hint tutor, ChatGPT, or no AI.
+[5] Franco, Irmert and Isaksson (2026), Does AI help or hurt learning? (Lund University Working Paper 2026:2)
+https://lup.lub.lu.se/search/files/246990414/WP26_2.pdf
+Lab experiment: AI with or without written guidance, compared with browsing with AI sites blocked.
+[6] Leppink et al. (2012), self-explanation in statistics
+https://link.springer.com/article/10.1007/s10734-011-9476-1
+Statistics-course study: worked examples helped students with less prior knowledge.
+[7] Bastani et al., PNAS (2025), author-hosted paper
+https://doi.org/10.1073/pnas.2422633122
+Randomized trial in high-school math: answer-giving vs. hint-giving GPT-4 tutors.
+[8] Contractor and Reyes (2026), learning working paper
 https://arxiv.org/abs/2607.08849
-211 Middlebury students, spring 2025; GPT-4o supplied, other tools allowed. October 2026 version (arXiv 2607.08849v2, saved as 2026_contractor_reyes_learning_v2.pdf): proctored unaided tests +0.29 SD immediately (SE 0.12) and +0.21 SD one week later (SE 0.12, p &lt; .10); gains remained for students who used AI as a tutor and faded for those who had it write (observational split). More test-rule violations in the AI arm complicate interpretation.
-Franco, Irmert and Isaksson (2026), Does AI help or hurt learning? (Lund University Working Paper 2026:2)
-https://lup.lub.lu.se/search/files/246990414/WP26_2.pdf
-Preregistered lab experiment, CeDEx lab, University of Nottingham; 572 participants studied Esperanto. Immediate test without notes (0–15 points): AI with on-screen guidance written by the researchers −0.234 (SE 0.189) and unguided AI +0.078 (SE 0.192), each relative to browsing with AI sites blocked; no overall effect of AI access; no delayed test.
-Leppink et al. (2012), self-explanation in statistics
-https://link.springer.com/article/10.1007/s10734-011-9476-1
-105 analyzed after 25 timetable cancellations from 130 recruited. Prior knowledge changes what support helps; self-explanation alone is not a substitute for missing prerequisites.
-Bastani et al., PNAS (2025), author-hosted paper
-https://doi.org/10.1073/pnas.2422633122
-GPT-4; Turkish high-school mathematics; experiment in fall 2023. Practice and subsequent unaided exam outcomes are distinct.
-Dunlosky et al. (2013), learning-technique review
+Middlebury study: AI access and later proctored tests, with more test-rule violations in the AI group.
+[9] Dunlosky et al. (2013), learning-technique review
 https://journals.sagepub.com/doi/10.1177/1529100612453266
-Practice testing with corrective feedback and distributed practice receive high utility ratings; support and timing should fit the learner and task.
-Sinha and Kapur (2021), problem solving followed by instruction
+Review of study techniques: practice testing and spaced practice rate highly.
+[10] Sinha and Kapur (2021), problem solving followed by instruction
 https://journals.sagepub.com/doi/10.3102/00346543211019105
-Meta-analysis: benefits depend on instructional design, age and domain. Supports purposeful attempts followed by appropriate instruction; no universal waiting time or AI-use prescription.
-Maier et al. (September 2026), Metacognitive feedback reduces cognitive offloading
+Meta-analysis: attempting problems before instruction.
+[11] Maier et al. (September 2026), Metacognitive feedback reduces cognitive offloading
 https://arxiv.org/abs/2609.20143
-Preregistered online experiment (N = 704), fraction arithmetic: metacognitive feedback reduced answer offloading (OR 0.47) and improved the unaided test (OR 1.51); an effort reward did not.
-Evidence and service collection: September 10, 2026; sources added or rechecked through October 13, 2026. Foundations and course review: September 20, 2026. Slides, figures, and transcript revised October 13, 2026 for one flow across the four opening questions; appropriate AI use throughout Purdue remains the theme. Numerical citations were checked against the saved primary sources.</a:t>
+Online experiment: reflective feedback reduced offloading answers to AI.</a:t>
             </a:r>
             <a:endParaRPr lang="en-US" dirty="0"/>
           </a:p>
@@ -2566,27 +2775,42 @@
           <a:p>
             <a:r>
               <a:rPr lang="en-US" dirty="0"/>
-              <a:t>Check the rules before using AI or sharing data.
-Planned time: 90 seconds. The PowerPoint shows complete diagrams; progressive reveals are in the React deck.
-DELIVERY CUE
-Read the workplace column as policy: approved tools, approved services for data, required review, documentation. Give the internship example briefly; it is not a claim about a particular employer.
-TRANSCRIPT
-Different courses can permit different uses of AI because their learning objectives and assessments differ. Read the course and assignment requirements, including rules for studying, code assistance, uploading materials, and disclosure. Purdue's guidance places course authorization with the instructor. If a use is unclear, resolve that uncertainty before doing it.
-The same discipline applies at work. Employers and clients set policy on which AI tools are approved, which data may be shared with which services, which results require review before release, and how AI assistance must be documented. Access to a tool is not permission to use it for every task or dataset. Identify the applicable policy, use only approved tools and services, and document your work and the assistance you received accurately.
-During an internship, you may be asked to state a stronger conclusion than the evidence supports. State the limitation, specify what additional evidence would be required, and consult your supervisor when necessary. Accountability also means correcting errors promptly, including after the work has been delivered.
-Broad permission still leaves you with a learning decision: how much of this activity do you need to work through yourself to develop the intended skill?
-TRANSITION
-Following the rules is the floor. What will make you valuable is what you learn, so let AI’s role grow with it.
-CAVEATS
-The course-to-workplace connection is the speaker's practical argument; employer and client policies vary, and the workplace column is general guidance rather than any specific employer's policy. Professional responsibility includes raising conflicts and correcting errors, alongside following applicable requirements.
+              <a:t>SLIDE GUIDE · 08 / 17: Check the rules before using AI or sharing data.
+EXPLANATION
+Different courses can allow different uses of AI because their learning goals and assessments differ, and rules can differ between homework, projects, and exams in the same course. At Purdue, the instructor decides what AI use is authorized in a course, for graded work and for ungraded learning activities.
+Step 1: questions to answer in your course. Before using AI on an assignment, check the syllabus or assignment instructions for four answers:
+• Uses: which uses of AI does this assignment permit?
+• Uploads: may you upload course materials, such as notes, slides, or problem sets, to an AI tool?
+• Own work: what work must you do independently?
+• Disclosure: how should you disclose the AI assistance you used?
+If an answer is unclear, ask before you act, not after.
+Step 2: the same habits at work. Employers and clients set policies on which AI tools are approved and for which tasks, which data may go to which services, which results need review before release, and how AI assistance must be documented. Access to a tool is not permission to use it for every task or dataset. This column is general guidance, not any particular employer’s policy.
+Step 3: when asked to conclude more than the evidence supports. In an internship or job, you may be asked to state a stronger conclusion than your analysis justifies. State the limitation, specify what additional evidence would be needed, consult your supervisor when necessary, and correct errors promptly, even after the work has been delivered.
+Following course rules now builds the habits that workplaces require. Rules set the minimum, though: even when AI use is allowed, you decide how much of a task to do yourself in order to learn from it.
+NEXT: Build understanding—and match AI help to the task. Rules set the minimum. The next slide asks why you should build your own understanding, and how to match AI help to what you already know.
+SOURCES &amp; CAVEATS
+Sources checked through October 21, 2026. Source numbers match the slide’s citations.
+RULES AND DOCUMENTATION: Course authorization at Purdue
+What it covers: Purdue’s AI guidance for teaching and learning (checked September 10, 2026).
+What it says: Authorization of AI use in a course rests with the instructor and covers both graded work and learning activities that are not graded.
+What to keep in mind: Rules differ by course and by assignment; the syllabus and your instructor are the authority for your course.
+Sources: [1]
+RULES AND DOCUMENTATION: Professional responsibility
+What it covers: The American Statistical Association’s Ethical Guidelines for Statistical Practice.
+What it says: Support competence, appropriate methods, transparent communication of methods and limitations, and responsibility, including correcting errors.
+What to keep in mind: Professional guidance, not a law or any specific employer’s policy.
+Sources: [2]
+SUGGESTED STRATEGY: From course rules to workplace policy
+What it suggests: Treat course rules as practice for workplace policy: approved tools, approved services for data, required review, and documented assistance.
+What informs it: Common features of organizational AI policies and the professional guidance above.
+What has not been tested: A practical argument made in these slides, not a research finding. Employer and client policies vary.
 SOURCES
-Purdue, AI Guidance for Teaching and Learning
+[1] Purdue, AI Guidance for Teaching and Learning
 https://www.purdue.edu/teaching-learning/instructors/ai.php
-Course-level authorization includes assessed work and non-assessed learning activities. Checked September 10, 2026.
-ASA, Ethical Guidelines for Statistical Practice
+Purdue’s guidance for instructors: AI use is authorized course by course.
+[2] ASA, Ethical Guidelines for Statistical Practice
 https://www.amstat.org/your-career/ethical-guidelines-for-statistical-practice
-Professional guidance supporting competence, communication, appropriate methods, transparency, and responsibility.
-Evidence and service collection: September 10, 2026; sources added or rechecked through October 13, 2026. Foundations and course review: September 20, 2026. Slides, figures, and transcript revised October 13, 2026 for one flow across the four opening questions; appropriate AI use throughout Purdue remains the theme. Numerical citations were checked against the saved primary sources.</a:t>
+Professional guidelines: competence, transparency about methods and limitations, and correcting errors.</a:t>
             </a:r>
             <a:endParaRPr lang="en-US" dirty="0"/>
           </a:p>
@@ -2674,93 +2898,116 @@
           <a:p>
             <a:r>
               <a:rPr lang="en-US" dirty="0"/>
-              <a:t>Build understanding—and match AI help to the task.
-Planned time: 140 seconds. The PowerPoint shows complete diagrams; progressive reveals are in the React deck.
-DELIVERY CUE
-Read the three cards as dated evidence: common AI use (May 2026), a descriptive job shortfall (ages 22–25, mostly fewer hires), and experience under deliberately wrong advice. Then the practice box (attempt, then explanation and feedback) and the support box (research, then our advice). Reveal the four uses one at a time and say 'combine or revisit'. End with the new-topic note.
-WHY BUILD UNDERSTANDING: WORKFORCE EVIDENCE AND LIMITS
-• AI at work (Gallup quarterly panel, May 6–20, 2026; n = 22,573 employed U.S. adults; published July 20, 2026): 52% reported using AI in their role, a total that in Gallup's series counts use at least a few times a year (stated in Gallup's April 12, 2026 article); 30% used it a few times a week or more, and 15% daily. Self-reported.
-• Early-career employment (Brynjolfsson, Chandar and Chen, August 2026; ADP payroll through June 2026): from November 2022 to June 2026, employment of 22–25-year-olds fell about 11% in the two most AI-exposed occupation fifths and grew about 10% in the three least exposed, a 21-point divergence, or 19% relative to the less-exposed group. That is a relative shortfall, not jobs eliminated by AI.
-• How it happened and what it does not show: the divergence came mainly from fewer hires (separation rates fell in both groups). The paper measures nothing about individual skills or about who is retained for checking AI, and the authors call the results descriptive, not causal. Age groups are age groups (older groups serve as a comparison), not measured expertise.
-• Exposure and caveats: occupations are ranked by GPT-4-based task-exposure ratings (Eloundou et al., Science 2024) and split into fifths. The authors note some divergence before ChatGPT, attenuation with controls for education, and a weaker pattern in national surveys. Stanford updates the results monthly on its Canaries dashboard; the Yale Budget Lab finds no clear broad labor-market effect so far.
-• Radiology (Dratsch et al., Radiology 2023): 27 radiologists (5 very experienced, about 11 years on average; 11 moderately experienced; 11 inexperienced) read 50 mammograms with a purported AI whose suggestions were simulated and deliberately wrong on 12 cases. BI-RADS is the standard breast-imaging category scale; these cases ran from 2 (benign) to 5 (highly suspicious).
-• Outcome: the mean percentage of cases each reader placed in the correct BI-RADS category; not a share of readers and not a cancer-detection rate. With wrong advice: 45.5% (very experienced), 24.8% (moderately), 19.8% (inexperienced). With correct advice, about 80% in every group; that is not a pre-AI baseline. There was no unaided reading condition, experience was not randomized, and the experience-by-advice interaction was not significant (p = .11), though very experienced readers beat inexperienced ones on wrong-advice cases (p = .006).
-• Lesson: experience was associated with better performance under misleading advice, and oversight remained fallible. The study does not show that deliberate checking explains the difference.
-• Employers: 93.5% rate critical thinking very or extremely important for new hires, but only 50.0% rate recent graduates very or extremely proficient (NACE Job Outlook 2026, p. 26; 185 employers).
-• Recommendation, not finding: building the knowledge to evaluate AI's work and direct it is the speaker's advice. These separate studies do not establish a causal chain from foundational knowledge to keeping a job.
-WHY KEEP PRACTICING
-• Sinha and Kapur (2021), 53 studies and 166 comparisons: problem solving followed by instruction vs. instruction followed by problem solving. Conceptual knowledge and transfer: g = 0.36 (95% CI 0.20–0.51). Procedural knowledge: no statistically detectable average difference (g = −0.03, 95% CI −0.20 to 0.15); that is not proof of no cost.
-• The intervention is the order: instruction always followed the attempt, and effects were larger when it built on students' own solutions. Unsupported struggle or delaying help was not the intervention. Effects reversed for grades 2–5 and for domain-general skills.
-• Palazzo et al. (2010), MIT introductory mechanics, fall 2003 (N = 428), MasteringPhysics online homework, before generative AI: heavy copiers (more than half of problems) scored 1.3 SD below low copiers on the final. Observational (copying was inferred from very short answer times): a group difference, not a causal estimate of learning lost to AI.
-• Shen and Tamkin (2026): 52 developers with Python experience, mostly professionals rather than students, were randomized to learn a library with or without a GPT-4o assistant; the AI group scored lower on an immediate quiz without AI (d = 0.74, about 4 of 27 points). The interaction patterns (clusters of 2–7 people) were observed, not randomized, and the explanation that encountering and resolving errors built the skill is the authors' proposed mechanism.
-• Explanations and worked examples can be appropriate at any stage (slide 7); afterward, practice and check what you can do independently.
-WHERE THE FOUR USES COME FROM
-• The four uses (understand, explore, connect, build) are the speaker's instructional framework, informed by the studies below; no study validated them as a sequence. Combine or revisit them in any order; course rules apply throughout.
-• Matching support (Tetzlaff et al., Learning and Instruction 2025; 60 experiments, 5,924 participants): learners with low prior knowledge learned more from high-assistance instruction (d = 0.51, 95% CI 0.26–0.75), and those with high prior knowledge from low assistance (d = −0.43, 95% CI −0.65 to −0.21); heterogeneity is large. Principle: provide support when knowledge is limited, and reduce redundant support as understanding grows. It concerns instructional assistance such as worked examples and scaffolding, not delegating production tasks to AI.
-• Delegation is the speaker's recommendation: delegate a step only when the task's purpose allows it and you can evaluate the result. Using a demonstration to understand a concept is a different choice from outsourcing the exercise meant to build it.
-• Explore (delMas, Garfield and Chance, 1999): a classroom predict-then-test simulation activity raised correct or good reasoning about sampling distributions from 16% to 72% of items (N = 141; a different cohort's guided activity went from 22% to about 49%). Not randomized and not AI; students asking AI to build simulations is an extrapolation.
-• Connect (Canning and Harackiewicz, 2015, Study 1): among less-confident students (one SD below mean confidence), writing their own reasons a math technique was useful improved performance (reported d +0.59 versus control, p = .01), while being told its usefulness did not (d −0.18, not significant). That is students generating personal reasons, not AI generating links across subjects.
-• Performing is not learning (Wiles et al., 2024; revised 2026): BCG consultants using GPT-4 scored 49 percentage points higher on data-science coding steps (95% CI 42–56), but on related questions without ChatGPT there was no evidence of better knowledge (F(5, 198) = 0.83, p = .531). That is no detectable gain, not proof of exactly equal knowledge.
-VISUAL STEPS
-1. Why build understanding; why keep practicing; match the support. Understand: explanations, worked examples, or feedback; you compare with course materials and explain the idea in your own words.
-2. Explore: visualizations and simulations; you predict, inspect the assumptions, and check the result.
-3. Connect: links to other topics and your goals; you verify the connection and explain why it matters.
-4. Build: tools, projects, and familiar steps; you make the decisions, test the work, and explain the result. New topic? Increase instructional support and rebuild your understanding.
-TRANSCRIPT
-AI use is already common at work: in May, about half of U.S. workers reported using it in their role, counting infrequent use, and nearly a third used it a few times a week or more. Remember the payroll data from the start: for twenty-two to twenty-five-year-olds in the most AI-exposed jobs, employment is about nineteen percent below where it would be had it kept pace with less-exposed jobs, mostly through fewer hires. Those data are descriptive; they do not show who keeps a job, or why. In a radiology experiment with deliberately wrong, simulated AI advice, very experienced radiologists assessed about forty-six percent of mammograms correctly, inexperienced ones about twenty percent. Experience helped, but even experts were pulled along. So build the knowledge to evaluate AI's work and direct it toward a useful result.
-How? Make an attempt, then use explanation and feedback to resolve the gap: across fifty-three studies, problem solving followed by instruction built deeper conceptual understanding than instruction first. And match the support to what you know: support helps when knowledge is limited, and becomes redundant as it grows. My advice: delegate a step only when the task's purpose allows it and you can evaluate the result.
-Here are four uses of AI to combine or revisit, not steps in a fixed order. Understand: ask for explanations, worked examples, or feedback, then explain the idea in your own words. Explore: use visualizations and simulations; predict, inspect the assumptions, and check. Connect: link topics to other courses and your goals, and verify the link. Build: let AI help with tools and familiar steps while you make the decisions and test the work. And whenever a topic is new, increase your support and rebuild your understanding.
-TRANSITION
-Connecting deserves a closer look, because the topics you might dismiss after an exam can matter far later.
-CAVEATS
-The four uses and the delegation advice are the speaker's instructional framework, informed by several studies (briefs below); no study validated them as a sequence, and course rules apply throughout. Visuals, connections, explanations, and worked examples are available while understanding develops; no mastery is required first (consistent with slide 7's routine: get help with the gap, then practice and check what you can do independently). Workforce evidence is descriptive. Gallup (May 2026) is self-reported, and its 52% counts infrequent use. The Stanford figure (August 2026 paper; ADP payroll through June 2026) is a relative employment shortfall for ages 22–25 in the most AI-exposed occupations compared with less-exposed ones, arising mainly from fewer hires. It is not jobs eliminated by AI, the paper did not measure retention decisions or AI-checking ability, and age groups are not measured expertise. The radiology experiment used simulated, deliberately wrong AI advice on 12 of 50 cases, with no unaided reading and experience not randomized; the outcome is the mean percentage of cases assessed in the correct BI-RADS category. These separate studies do not establish a causal chain from foundational knowledge to keeping a job; building that knowledge is the speaker's recommendation. The expertise-reversal research concerns instructional support (examples, scaffolding), not delegating production work to AI; delegation advice is the speaker's, based on the task's purpose and the student's ability to evaluate the output.
+              <a:t>SLIDE GUIDE · 09 / 17: Build understanding—and match AI help to the task.
+The PowerPoint shows the complete slide; in the web version it builds in steps.
+EXPLANATION
+This slide answers two questions: why build your own understanding when AI is so capable, and how to choose AI help that supports learning.
+Why build understanding? The three cards at the top give context:
+• AI use at work is common. In a May 2026 Gallup survey, 52% of employed U.S. adults said they used AI in their role, counting use as rare as a few times a year; 30% used it a few times a week or more.
+• Early-career employment has shifted in AI-exposed jobs. For 22–25-year-olds in the most AI-exposed occupations, employment is about 19% below where it would be had it kept pace with less-exposed occupations, mostly through fewer hires; older age groups show no comparable gap. The pattern is descriptive: it does not show that AI caused it, or who keeps a job and why.
+• More experienced readers did better, but none were immune to bad advice. When radiologists received deliberately wrong AI suggestions, very experienced readers assessed about 46% of those mammograms correctly, on average, and inexperienced readers about 20%; with correct suggestions, every group was near 80%. Experience was not randomly assigned, so this is a comparison between groups, not proof that experience caused the difference.
+Together these suggest, without proving it, that the knowledge to evaluate AI’s work and direct it toward a useful result will matter.
+Why keep practicing? Across 53 studies, problem solving followed by instruction built deeper conceptual understanding than instruction first; the studies tested the order of activities, not withholding help. In an MIT physics course before generative AI, students who copied much of their online homework scored 1.3 standard deviations lower on the final exam, an observed difference between groups, not proof that copying caused it.
+Match the support to what you know. Learners with little prior knowledge benefit from more instructional support, such as worked examples, and that support becomes redundant as their knowledge grows (the “expertise reversal effect”). The slide’s own advice goes further: delegate a step to AI only when the task’s purpose allows it and you can evaluate the result, and keep practicing the skills the task is meant to build.
+Four uses of AI. The bottom row offers four ways to use AI that you can combine or revisit in any order; they are not a ladder to climb:
+• Understand: ask for explanations, worked examples, or feedback; compare with course materials and explain the idea in your own words.
+• Explore: use visualizations and simulations; predict what should happen, inspect the assumptions, and check the result.
+• Connect: explore links to other topics and your goals; verify the connection and explain why it matters.
+• Build: let AI assist with tools, projects, and familiar steps while you make the substantive decisions, test the work, and explain the result.
+You do not need to master a subject before asking AI for an explanation, a visualization, or a connection. Whenever a topic is new, increase your support and rebuild your understanding.
+NEXT: Connect what you learn to something you care about. Connecting deserves a closer look: a topic you might set aside after an exam can lead to something you care about.
+SOURCES &amp; CAVEATS
+Sources checked through October 21, 2026. Source numbers match the slide’s citations.
+RESEARCH FINDING: AI use at work
+What was studied: Gallup’s quarterly panel survey of 22,573 employed U.S. adults, May 6–20, 2026 (margin of error ±0.9 points).
+What the source supports: 52% reported using AI in their role at least a few times a year; 30% used it a few times a week or more, and 15% daily.
+What limits the conclusion: Self-reported. The 52% counts infrequent use; Gallup states this definition in its April 12, 2026 article.
+Sources: [1] [2]
+RESEARCH FINDING: Early-career employment in AI-exposed occupations
+What was studied: ADP payroll data through June 2026 (Brynjolfsson, Chandar and Chen). Occupations were ranked into fifths by GPT-4-based ratings of how many of their tasks AI could speed up (Eloundou et al.).
+What the source supports: Since November 2022, employment of 22–25-year-olds fell about 11% in the two most exposed fifths and grew about 10% in the other three, about 19% below where it would be had it kept pace. Most of the gap came from fewer hires.
+What limits the conclusion: Descriptive, not causal, and not a count of jobs eliminated by AI. The paper measures nothing about individual skills or who is retained, and age groups are not measures of expertise. Some divergence predates ChatGPT, and the pattern is weaker in national surveys; Yale’s broader analyses find no clear overall effect. Stanford updates the series monthly on its dashboard.
+Sources: [3] [8] [9] [10]
+RESEARCH FINDING: Experience under deliberately wrong AI advice
+What was studied: Dratsch et al. (2023): 27 radiologists (5 very experienced, 11 moderately experienced, 11 inexperienced) assessed 50 mammograms with a purported AI whose suggestions were simulated and deliberately wrong on 12 of them.
+What the source supports: With wrong advice, the mean percentage of cases placed in the correct category was 45.5%, 24.8%, and 19.8%; with correct advice, about 80% in every group.
+What limits the conclusion: There was no reading without AI, experience was not randomized, and the groups were small. Very experienced readers beat inexperienced ones on the wrong-advice cases (p = .006), but the test of whether experience mattered more with wrong advice than with correct advice was not significant (p = .11). It shows that experience was associated with better performance under misleading advice and that oversight remained fallible, not that deliberate checking explains the difference.
+Sources: [4]
+RESEARCH FINDING: Attempt first, then instruction
+What was studied: Sinha and Kapur (2021): a meta-analysis of 53 studies (166 comparisons) of problem solving followed by instruction vs. instruction followed by problem solving.
+What the source supports: Better conceptual knowledge and transfer (effect size g = 0.36, 95% CI 0.20 to 0.51); no detectable average difference for procedural skills.
+What limits the conclusion: Effects depended on how instruction built on students’ attempts, and they reversed for grades 2–5. The studies tested the order of activities, not unsupported struggle or delayed help, and no waiting time is prescribed. “No detectable difference” is not proof of no cost.
+Sources: [5]
+RESEARCH FINDING: Homework copying and exam performance
+What was studied: Palazzo et al. (2010): MIT introductory mechanics, fall 2003 (428 students); copying was inferred from very short answer times on online homework.
+What the source supports: Students who copied more than half of their homework scored 1.3 SD below low copiers on the final exam.
+What limits the conclusion: Observational: copiers may differ in other ways. Before generative AI; not an estimate of learning lost to AI.
+Sources: [6]
+RESEARCH FINDING: Match support to prior knowledge
+What was studied: Tetzlaff et al. (2025): a meta-analysis of 60 experiments (5,924 participants) on instructional assistance such as worked examples and scaffolding.
+What the source supports: Learners with low prior knowledge learned more from high assistance (d = 0.51, 95% CI 0.26 to 0.75); learners with high prior knowledge learned more from low assistance (d = −0.43, 95% CI −0.65 to −0.21).
+What limits the conclusion: Results varied widely across studies. The research concerns instructional support, not handing production work to AI.
+Sources: [7]
+SUGGESTED STRATEGY: The delegation advice and the four uses
+What it suggests: Delegate a step only when the task’s purpose allows it and you can evaluate the result; use AI to understand, explore, connect, and build, in any order.
+What informs it: The studies above and the research summarized in the details below.
+What has not been tested: This is a framework and advice proposed for this presentation. No study validated the four uses as a sequence or tested the delegation advice. Course rules apply throughout.
+FORECAST OR INTERPRETATION: Why foundational knowledge will matter
+The interpretation: The knowledge to evaluate and direct AI’s work will matter in your career.
+What it rests on: Common AI use at work; employers’ emphasis on critical thinking (in NACE’s survey, 93.5% rate it very or extremely important for new hires, but only 50.0% rate recent graduates very or extremely proficient); and evidence that oversight of AI is fallible.
+What it is not: These separate studies do not establish a causal chain from foundational knowledge to getting or keeping a job.
+Sources: [11]
+RESEARCH RELATED TO THE FOUR USES
+• Explore: in a classroom study (delMas, Garfield and Chance, 1999), a predict-then-test simulation activity raised correct or good reasoning about sampling distributions from 16% to 72% of items (141 students; a guided-exploration cohort went from 22% to about 49%). It was not randomized and did not use AI; using AI to build simulations is an extension of the idea.
+• Connect: less-confident students who wrote their own reasons a math method was useful performed better than a control group, while being told its usefulness did not help (slide 11). That study involved students generating personal reasons, not AI generating links.
+• Performing is not learning: BCG consultants using GPT-4 scored 49 percentage points higher on data-science coding steps (95% CI 42 to 56), but on related questions afterward, without AI, showed no evidence of better knowledge (Wiles et al.). No detectable gain is not proof of exactly equal knowledge.
+• Learning a new tool: 52 people with Python experience, mostly professionals, learned a new library with or without a GPT-4o assistant; the AI group scored lower on an immediate quiz without AI (d = 0.74, about 4 of 27 points) (Shen and Tamkin).
 SOURCES
-Gallup (July 20, 2026), Organizational AI adoption jumps six points
+[1] Gallup (July 20, 2026), Organizational AI adoption jumps six points
 https://www.gallup.com/workplace/712736/organizational-adoption-jumps-six-points.aspx
-Quarterly Gallup Panel survey of employed U.S. adults, May 6–20, 2026; n = 22,573; ±0.9 points. 'More than half of U.S. workers (52%) now use AI in their role, with 30% using it frequently (a few times a week or more). Fifteen percent use it daily.' The article's chart defines total users as those using AI daily, a few times a week, a few times a month, or a few times a year; Gallup's April 12, 2026 article states the threshold in its text. Self-reported; rechecked October 21, 2026.
-Gallup (April 12, 2026), Rising AI adoption spurs workforce changes
+Survey article (July 20, 2026): how many U.S. workers use AI in their role, and how often.
+[2] Gallup (April 12, 2026), Rising AI adoption spurs workforce changes
 https://www.gallup.com/workplace/704225/rising-adoption-spurs-workforce-changes.aspx
-Quarterly Gallup Panel workforce survey, February 4–19, 2026 (23,717 employed U.S. adults; ±0.9 points). States the series' usage threshold: 'half of employed American adults say they use AI in their role at least a few times a year'; total AI users use AI daily, a few times a week, a few times a month, or a few times a year, and frequent users a few times a week or more. Its own figures are for February 2026 (50%, 28%, 13%); slide 9 cites it only for the definition. Saved October 21, 2026.
-Brynjolfsson, Chandar and Chen, Canaries — August 2026 revision
+Survey article (April 12, 2026) defining an AI user as someone who uses it at least a few times a year.
+[3] Brynjolfsson, Chandar and Chen, Canaries — August 2026 revision
 https://digitaleconomy.stanford.edu/publication/canaries-in-the-coal-mine-six-facts-about-the-recent-employment-effects-of-artificial-intelligence/
-ADP payroll through June 2026. From November 2022 to June 2026, employment of 22–25-year-olds fell about 11% in the two most AI-exposed occupation fifths and grew about 10% in the three least exposed: a 21-point divergence, 19% relative to the less-exposed group. Mainly fewer hires; separation rates fell. Descriptive, not causal; no measure of individual skills or retention. Some divergence before ChatGPT; weaker in national surveys.
-Stanford Digital Economy Lab, AI Economic Indicators: Canaries dashboard
+Working paper: early-career employment by AI exposure, mostly through fewer hires.
+[4] Dratsch et al. (2023), Automation bias in mammography (Radiology)
+https://doi.org/10.1148/radiol.222176
+Experiment (Radiology, 2023): radiologists’ accuracy with deliberately wrong AI suggestions.
+[5] Sinha and Kapur (2021), problem solving followed by instruction
+https://journals.sagepub.com/doi/10.3102/00346543211019105
+Meta-analysis of 53 studies: attempting problems before instruction.
+[6] Palazzo et al. (2010), Patterns, correlates, and reduction of homework copying
+https://doi.org/10.1103/PhysRevSTPER.6.010104
+Observational study (MIT, fall 2003): homework copying and final-exam scores.
+[7] Tetzlaff et al. (2025), A cornerstone of adaptivity: a meta-analysis of the expertise reversal effect (Learning and Instruction 98:102142)
+https://doi.org/10.1016/j.learninstruc.2025.102142
+Meta-analysis of 60 experiments: the most helpful amount of support depends on prior knowledge.
+[8] Eloundou, Manning, Mishkin and Rock, GPTs are GPTs (Science, 2024)
+https://doi.org/10.1126/science.adj0998
+Science paper: the GPT-4-based task-exposure ratings used to rank occupations.
+[9] Stanford Digital Economy Lab, AI Economic Indicators: Canaries dashboard
 https://digitaleconomy.stanford.edu/project/indicators/canaries-dashboard/
-Public tracker for the Canaries paper, updated monthly (last updated September 23, 2026; text snapshot saved October 13). ADP payroll, five-year balanced sample of firms; occupations grouped into fifths by Eloundou et al. (2024) AI-exposure scores, equally weighted by occupation; employment indexed to November 2022 by age group, with examples (software developers, customer service representatives, stock clerks, home health aides). Correlations in this sample, not causal effects.
-Eloundou, Manning, Mishkin and Rock, GPTs are GPTs (Science, 2024)
-https://doi.org/10.1126/science.adj0998
-Science 384:1306–1308 (2024); saved copy is the arXiv working paper (v5, August 2023). Rates each O*NET task's exposure to LLMs with human annotators and GPT-4: a task is exposed if an LLM could cut the time to do it by at least half at equal quality. The occupation score β counts directly exposed tasks plus half of the tasks exposed only with LLM-powered software. Measures potential exposure, not adoption or job loss. The Canaries paper and dashboard use the GPT-4-based β ratings.
-Dratsch et al. (2023), Automation bias in mammography (Radiology)
-https://doi.org/10.1148/radiol.222176
-Radiology 307(4):e222176; full text from the VU Research Portal (open copy). 27 radiologists (5 very experienced, 11 moderately experienced, 11 inexperienced) assigned BI-RADS categories to 50 mammograms with a purported AI whose suggestions were simulated and deliberately wrong on 12. Mean percentage of cases rated correctly with wrong advice: 45.5%, 24.8%, 19.8%; about 80% with correct advice. No unaided condition; experience not randomized; experience-by-advice interaction p = .11.
-NACE, Job Outlook 2026: Spring Update
+Stanford’s dashboard for the employment series, updated monthly.
+[10] Yale Budget Lab, tracker updated August 19, 2026
+https://budgetlab.yale.edu/research/tracking-impact-ai-labor-market
+Yale Budget Lab tracker: no clear broad labor-market effect so far.
+[11] NACE, Job Outlook 2026: Spring Update
 https://naceweb.org/docs/default-source/default-document-library/2026/publication/research-report/2026-job-outlook-report-spring-update.pdf
-Employer survey; see report slides on AI skills and career readiness. 185 respondents overall; item denominators vary.
-Yale Budget Lab, tracker updated August 19, 2026
-https://budgetlab.yale.edu/research/tracking-impact-ai-labor-market
-No clear broad labor-market footprint reported. Local copy preserves landing-page text, not the interactive application. No forecast for this audience's graduation year.
-Sinha and Kapur (2021), problem solving followed by instruction
-https://journals.sagepub.com/doi/10.3102/00346543211019105
-Meta-analysis: benefits depend on instructional design, age and domain. Supports purposeful attempts followed by appropriate instruction; no universal waiting time or AI-use prescription.
-Palazzo et al. (2010), Patterns, correlates, and reduction of homework copying
-https://doi.org/10.1103/PhysRevSTPER.6.010104
-Observational, MIT introductory mechanics, fall 2003, N = 428. Students who copied more than half of their online homework scored 1.3 SD below low copiers on the final exam (fit: −2.42 ± 0.23 SD per 100% copied); copiers started within about a third of an SD.
-Shen and Tamkin (2026), How AI Impacts Skill Formation
+Employer survey (PDF): ratings of critical thinking on page 26.
+[12] delMas, Garfield and Chance (1999), simulation activities and statistical reasoning
+https://doi.org/10.1080/10691898.1999.12131279
+Classroom study: predict-then-test simulations and reasoning about sampling distributions.
+[13] Canning and Harackiewicz (2015), Teach it, don't preach it: the differential effects of directly communicated and self-generated utility-value information (Motivation Science 1(1):47–71)
+https://s3.wp.wsu.edu/uploads/sites/2445/2019/09/Canning-Harackiewicz-2015-Motivation-Science.pdf
+Experiment: writing about a method’s usefulness vs. being told (slide 11).
+[14] Wiles et al., Generative AI and the temporary upskilling of knowledge workers
+https://papers.ssrn.com/sol3/papers.cfm?abstract_id=4944588
+Experiment with BCG consultants: better AI-assisted performance without better knowledge afterward.
+[15] Shen and Tamkin (2026), How AI Impacts Skill Formation
 https://arxiv.org/abs/2601.20245
-Randomized experiments; 52 analyzed participants with Python experience learning the Trio library with or without a GPT-4o assistant that could supply correct code. The AI group scored lower on the immediate quiz (d = 0.74, p = .010) without a significant speedup. Interaction-pattern clusters (n = 2–7) were observed, not randomized: heavy reliance on AI to write or debug code averaged below 40%; conceptual questions or requests for explanations averaged 65% or higher.
-delMas, Garfield and Chance (1999), simulation activities and statistical reasoning
-https://doi.org/10.1080/10691898.1999.12131279
-Journal of Statistics Education 7(3); classroom research, not randomized. With sampling-distribution simulation software, a predict-then-test activity raised correct-or-good reasoning from 16% of pretest items to 72% of posttest items (N = 141), vs. 22% to about 49% with guided exploration (N = 89). The authors: simulations alone do not guarantee conceptual change.
-Canning and Harackiewicz (2015), Teach it, don't preach it: the differential effects of directly communicated and self-generated utility-value information (Motivation Science 1(1):47–71)
-https://s3.wp.wsu.edu/uploads/sites/2445/2019/09/Canning-Harackiewicz-2015-Motivation-Science.pdf
-Published article (copy hosted at Washington State University; the PMC author manuscript is PMC4610746). Study 1: 88 undergraduates learned a mental-math technique and were randomized to self-generated utility value (writing how it could be useful), directly communicated utility value (shown in the slides), or control. Table 3, performance, reported d versus control at one SD below mean perceived confidence (measured after learning): self-generated +.59 (p = .01), directly communicated −.18 (p = .41). Study 2 added a combined condition the authors describe as synergistic for less-confident students. No AI was tested.
-Tetzlaff et al. (2025), A cornerstone of adaptivity: a meta-analysis of the expertise reversal effect (Learning and Instruction 98:102142)
-https://doi.org/10.1016/j.learninstruc.2025.102142
-60 experiments, 176 effect sizes, 5,924 participants. Low-prior-knowledge learners learned more from high-assistance instruction (d = 0.505, 95% CI 0.26–0.75); high-prior-knowledge learners from low assistance (d = −0.428, 95% CI −0.65 to −0.21); large heterogeneity. Concerns instructional assistance (e.g., worked examples, scaffolding), not delegating production tasks to AI.
-Wiles et al., Generative AI and the temporary upskilling of knowledge workers
-https://papers.ssrn.com/sol3/papers.cfm?abstract_id=4944588
-Preregistered RCT (March 2024), BCG consultants with GPT-4 on data-science tasks outside their skills. With ChatGPT, coding scores +49 percentage points (95% CI 42–56); afterwards, without AI, no better on related knowledge questions (F(5,198) = 0.83, p = .531). GPT-4 era; five items; immediate check.
-Evidence and service collection: September 10, 2026; sources added or rechecked through October 13, 2026. Foundations and course review: September 20, 2026. Slides, figures, and transcript revised October 13, 2026 for one flow across the four opening questions; appropriate AI use throughout Purdue remains the theme. Numerical citations were checked against the saved primary sources.</a:t>
+Experiments on learning a new Python library with or without an AI assistant.</a:t>
             </a:r>
             <a:endParaRPr lang="en-US" dirty="0"/>
           </a:p>
@@ -5278,7 +5525,7 @@
         </p:nvSpPr>
         <p:spPr>
           <a:xfrm>
-            <a:off x="7563444" y="4832866"/>
+            <a:off x="8562061" y="4840486"/>
             <a:ext cx="198120" cy="152400"/>
           </a:xfrm>
           <a:prstGeom prst="rect">

</xml_diff>

<commit_message>
Deploying to gh-pages from @ treese41528/treese41528.github.io@004f8363a595311f429aad677f4d782f2ffe02ea 🚀
</commit_message>
<xml_diff>
--- a/ComputationalDataScience/AI_First_Year/Purdue_AI_Talk.pptx
+++ b/ComputationalDataScience/AI_First_Year/Purdue_AI_Talk.pptx
@@ -2632,9 +2632,9 @@
 Sources checked through October 21, 2026. Source numbers match the slide’s citations.
 RESEARCH FINDING: Study-prompt emails raised the pass rate
 What was studied: Gallegos (March 2026): a preregistered randomized trial in a required third-year econometrics course at Universidad Adolfo Ibáñez (Chile), August–December 2025. All 384 enrolled students were randomized; 289 were analyzed. Everyone had a course ChatGPT assistant; the treatment group was also emailed three study prompts before the final.
-What the source supports: Being offered the emails raised the final-exam pass rate by an estimated 12.8 percentage points (control rate 64.6%) and the exam score by 0.22 SD. The 95% interval for the effect, +3.2 to +22.4 points, was calculated for this slide from the paper’s reported standard error (4.9 points); the paper prints no interval.
+What the source supports: Being offered the emails raised the final-exam pass rate by an estimated 12.8 percentage points (control rate 64.6%) and the exam score by 0.22 SD. The 95% interval for the effect, +3.2 to +22.4 points, was calculated for this slide from the paper’s reported standard error (4.9 points); the paper prints no interval. These are Table 3’s figures (columns 1 and 4); the abstract reports 0.21 SD and 12 percentage points, and the author’s J-PAL summary reports 0.22 SD.
 What limits the conclusion: The 77.4% bar is constructed (control rate + estimated effect), not an observed group, and has no interval of its own. The three prompts were sent together, so the trial cannot say which mattered; use of the prompts was not tracked, and 35% of control students reported some exposure to the guidance. The paper does not say whether the final was proctored, closed-book, or AI-free. One course; working paper.
-Sources: [1]
+Sources: [1] [3]
 RESEARCH FINDING: A structured tutor deepened written reasoning
 What was studied: Yang, Van Alstyne and Dellarocas (September 2026): the online MBA trial from slide 6. 86 students were randomized to a GPT-5.4 tutor or to usual study with consumer AI available; 51 completed both tests and 46 are in the reported analysis.
 What the source supports: The share of short-answer responses rated as a connected argument rose from 8% to 49% with the tutor and from 8% to 27% without (descriptive shares). The baseline-adjusted difference is +22 percentage points (95% CI +2 to +42).
@@ -2655,37 +2655,40 @@
 • Practice testing: a major review rates practice testing with feedback, and spacing practice over time, among the most useful study techniques.
 Results vary across tasks, learners, systems, and assessments, and these studies differ in many ways at once. They support trying structured help while checking whether it improves what you can do afterward. A result with no detectable benefit is not evidence that two approaches are equivalent, and a result on an immediate test may not hold on a delayed one.
 SOURCES
-[1] Gallegos (March 2026), Guidance over adoption: experimental evidence on AI-assisted learning
-https://docs.iza.org/dp18513.pdf
-Discussion paper (IZA): the econometrics trial; the pass-rate estimate is in Table 3.
+[1] Gallegos (March 2026), Guidance over adoption: experimental evidence on AI-assisted learning (IZA DP 18513; Internet Archive copy)
+https://web.archive.org/web/20260819152437/https://docs.iza.org/dp18513.pdf
+The full paper (IZA@LISER DP 18513), opened from the Internet Archive because IZA’s own links now redirect to LISER’s homepage; the pass-rate estimate is in Table 3.
 [2] Yang, Van Alstyne and Dellarocas (September 2026), When AI tutors speak (arXiv 2609.23958v1)
 https://arxiv.org/abs/2609.23958
 Preprint: the online MBA tutor trial; the written-reasoning results are in Figure 9 and Table 4.
-[3] Fischer, Rau and Rilke (2025), AI tutoring enhances student learning without crowding out reading effort
-https://docs.iza.org/dp18338.pdf
-Lab experiment: reading first vs. AI tutoring from the start.
-[4] Bassner et al. (2026), Less stress, better scores, same learning
+[3] Gallegos (June 18, 2026), Guiding college students’ AI use improves learning: experimental evidence from Chile (J-PAL blog)
+https://www.povertyactionlab.org/blog/6-18-26/guiding-college-students-ai-use-improves-learning-experimental-evidence-chile
+The author’s plain-language summary on J-PAL’s blog (June 18, 2026): the design and the +0.22 SD exam result; it does not report pass rates.
+[4] Fischer, Rau and Rilke (2025), AI tutoring enhances student learning without crowding out reading effort (IZA DP 18338; Internet Archive copy)
+https://web.archive.org/web/20260427150610/https://docs.iza.org/dp18338.pdf
+Lab experiment: reading first vs. AI tutoring from the start (IZA DP 18338, opened from the Internet Archive).
+[5] Bassner et al. (2026), Less stress, better scores, same learning
 https://portal.fis.tum.de/de/publications/less-stress-better-scores-same-learning-the-dissociation-of-perfo/
 Programming lab study: a hint tutor, ChatGPT, or no AI.
-[5] Franco, Irmert and Isaksson (2026), Does AI help or hurt learning? (Lund University Working Paper 2026:2)
+[6] Franco, Irmert and Isaksson (2026), Does AI help or hurt learning? (Lund University Working Paper 2026:2)
 https://lup.lub.lu.se/search/files/246990414/WP26_2.pdf
 Lab experiment: AI with or without written guidance, compared with browsing with AI sites blocked.
-[6] Leppink et al. (2012), self-explanation in statistics
+[7] Leppink et al. (2012), self-explanation in statistics
 https://link.springer.com/article/10.1007/s10734-011-9476-1
 Statistics-course study: worked examples helped students with less prior knowledge.
-[7] Bastani et al., PNAS (2025), author-hosted paper
+[8] Bastani et al., PNAS (2025), author-hosted paper
 https://doi.org/10.1073/pnas.2422633122
 Randomized trial in high-school math: answer-giving vs. hint-giving GPT-4 tutors.
-[8] Contractor and Reyes (2026), learning working paper
+[9] Contractor and Reyes (2026), learning working paper
 https://arxiv.org/abs/2607.08849
 Middlebury study: AI access and later proctored tests, with more test-rule violations in the AI group.
-[9] Dunlosky et al. (2013), learning-technique review
+[10] Dunlosky et al. (2013), learning-technique review
 https://journals.sagepub.com/doi/10.1177/1529100612453266
 Review of study techniques: practice testing and spaced practice rate highly.
-[10] Sinha and Kapur (2021), problem solving followed by instruction
+[11] Sinha and Kapur (2021), problem solving followed by instruction
 https://journals.sagepub.com/doi/10.3102/00346543211019105
 Meta-analysis: attempting problems before instruction.
-[11] Maier et al. (September 2026), Metacognitive feedback reduces cognitive offloading
+[12] Maier et al. (September 2026), Metacognitive feedback reduces cognitive offloading
 https://arxiv.org/abs/2609.20143
 Online experiment: reflective feedback reduced offloading answers to AI.</a:t>
             </a:r>

</xml_diff>